<commit_message>
docs: title update - "with Human-in-the-Loop Governance" on orchestration architecture slide
Co-authored-by: Cursor <cursoragent@cursor.com>
</commit_message>
<xml_diff>
--- a/demo/Order-Creation-Orchestration-Architecture.pptx
+++ b/demo/Order-Creation-Orchestration-Architecture.pptx
@@ -3228,7 +3228,7 @@
         </p:nvSpPr>
         <p:spPr>
           <a:xfrm>
-            <a:off x="411480" y="146304"/>
+            <a:off x="411480" y="128016"/>
             <a:ext cx="8686800" cy="365760"/>
           </a:xfrm>
           <a:prstGeom prst="rect">
@@ -3273,8 +3273,8 @@
         </p:nvSpPr>
         <p:spPr>
           <a:xfrm>
-            <a:off x="411480" y="384048"/>
-            <a:ext cx="10789920" cy="457200"/>
+            <a:off x="411480" y="347472"/>
+            <a:ext cx="11430000" cy="502920"/>
           </a:xfrm>
           <a:prstGeom prst="rect">
             <a:avLst/>
@@ -3299,87 +3299,29 @@
               </a:spcAft>
             </a:pPr>
             <a:r>
-              <a:rPr sz="2500" b="1" i="0">
+              <a:rPr sz="2200" b="1" i="0">
                 <a:solidFill>
                   <a:srgbClr val="FFFFFF"/>
                 </a:solidFill>
                 <a:latin typeface="Segoe UI"/>
               </a:rPr>
-              <a:t>Order Creation &amp; Orchestration — Architecture</a:t>
-            </a:r>
-          </a:p>
-        </p:txBody>
-      </p:sp>
-      <p:sp>
-        <p:nvSpPr>
-          <p:cNvPr id="7" name="TextBox 6"/>
-          <p:cNvSpPr txBox="1"/>
-          <p:nvPr/>
-        </p:nvSpPr>
-        <p:spPr>
-          <a:xfrm>
-            <a:off x="8869680" y="182880"/>
-            <a:ext cx="3108960" cy="640080"/>
-          </a:xfrm>
-          <a:prstGeom prst="rect">
-            <a:avLst/>
-          </a:prstGeom>
-          <a:noFill/>
-        </p:spPr>
-        <p:txBody>
-          <a:bodyPr wrap="square" anchor="t" lIns="0" rIns="0" tIns="0" bIns="0">
-            <a:spAutoFit/>
-          </a:bodyPr>
-          <a:lstStyle/>
-          <a:p>
-            <a:pPr algn="r">
-              <a:lnSpc>
-                <a:spcPct val="105000"/>
-              </a:lnSpc>
-              <a:spcBef>
-                <a:spcPts val="0"/>
-              </a:spcBef>
-              <a:spcAft>
-                <a:spcPts val="100"/>
-              </a:spcAft>
-            </a:pPr>
-            <a:r>
-              <a:rPr sz="950" b="0" i="1">
-                <a:solidFill>
-                  <a:srgbClr val="8A8A99"/>
+              <a:t>Order Creation &amp; Orchestration — Architecture </a:t>
+            </a:r>
+            <a:r>
+              <a:rPr sz="2200" b="1" i="0">
+                <a:solidFill>
+                  <a:srgbClr val="FFE600"/>
                 </a:solidFill>
                 <a:latin typeface="Segoe UI"/>
               </a:rPr>
-              <a:t>Upstream  →  Orchestration  →</a:t>
-            </a:r>
-          </a:p>
-          <a:p>
-            <a:pPr algn="r">
-              <a:lnSpc>
-                <a:spcPct val="105000"/>
-              </a:lnSpc>
-              <a:spcBef>
-                <a:spcPts val="0"/>
-              </a:spcBef>
-              <a:spcAft>
-                <a:spcPts val="100"/>
-              </a:spcAft>
-            </a:pPr>
-            <a:r>
-              <a:rPr sz="950" b="0" i="1">
-                <a:solidFill>
-                  <a:srgbClr val="8A8A99"/>
-                </a:solidFill>
-                <a:latin typeface="Segoe UI"/>
-              </a:rPr>
-              <a:t>Order creation  →  Downstream</a:t>
-            </a:r>
-          </a:p>
-        </p:txBody>
-      </p:sp>
-      <p:sp>
-        <p:nvSpPr>
-          <p:cNvPr id="8" name="Rounded Rectangle 7"/>
+              <a:t>with Human-in-the-Loop Governance</a:t>
+            </a:r>
+          </a:p>
+        </p:txBody>
+      </p:sp>
+      <p:sp>
+        <p:nvSpPr>
+          <p:cNvPr id="7" name="Rounded Rectangle 6"/>
           <p:cNvSpPr/>
           <p:nvPr/>
         </p:nvSpPr>
@@ -3460,7 +3402,7 @@
       </p:sp>
       <p:sp>
         <p:nvSpPr>
-          <p:cNvPr id="9" name="Rectangle 8"/>
+          <p:cNvPr id="8" name="Rectangle 7"/>
           <p:cNvSpPr/>
           <p:nvPr/>
         </p:nvSpPr>
@@ -3504,7 +3446,7 @@
       </p:sp>
       <p:sp>
         <p:nvSpPr>
-          <p:cNvPr id="10" name="Rounded Rectangle 9"/>
+          <p:cNvPr id="9" name="Rounded Rectangle 8"/>
           <p:cNvSpPr/>
           <p:nvPr/>
         </p:nvSpPr>
@@ -3566,7 +3508,7 @@
       </p:sp>
       <p:sp>
         <p:nvSpPr>
-          <p:cNvPr id="11" name="Rectangle 10"/>
+          <p:cNvPr id="10" name="Rectangle 9"/>
           <p:cNvSpPr/>
           <p:nvPr/>
         </p:nvSpPr>
@@ -3610,7 +3552,7 @@
       </p:sp>
       <p:sp>
         <p:nvSpPr>
-          <p:cNvPr id="12" name="Rounded Rectangle 11"/>
+          <p:cNvPr id="11" name="Rounded Rectangle 10"/>
           <p:cNvSpPr/>
           <p:nvPr/>
         </p:nvSpPr>
@@ -3672,7 +3614,7 @@
       </p:sp>
       <p:sp>
         <p:nvSpPr>
-          <p:cNvPr id="13" name="Rectangle 12"/>
+          <p:cNvPr id="12" name="Rectangle 11"/>
           <p:cNvSpPr/>
           <p:nvPr/>
         </p:nvSpPr>
@@ -3716,7 +3658,7 @@
       </p:sp>
       <p:sp>
         <p:nvSpPr>
-          <p:cNvPr id="14" name="Rounded Rectangle 13"/>
+          <p:cNvPr id="13" name="Rounded Rectangle 12"/>
           <p:cNvSpPr/>
           <p:nvPr/>
         </p:nvSpPr>
@@ -3797,7 +3739,7 @@
       </p:sp>
       <p:sp>
         <p:nvSpPr>
-          <p:cNvPr id="15" name="Rectangle 14"/>
+          <p:cNvPr id="14" name="Rectangle 13"/>
           <p:cNvSpPr/>
           <p:nvPr/>
         </p:nvSpPr>
@@ -3841,7 +3783,7 @@
       </p:sp>
       <p:sp>
         <p:nvSpPr>
-          <p:cNvPr id="16" name="Rounded Rectangle 15"/>
+          <p:cNvPr id="15" name="Rounded Rectangle 14"/>
           <p:cNvSpPr/>
           <p:nvPr/>
         </p:nvSpPr>
@@ -3922,7 +3864,7 @@
       </p:sp>
       <p:sp>
         <p:nvSpPr>
-          <p:cNvPr id="17" name="Rectangle 16"/>
+          <p:cNvPr id="16" name="Rectangle 15"/>
           <p:cNvSpPr/>
           <p:nvPr/>
         </p:nvSpPr>
@@ -3966,7 +3908,7 @@
       </p:sp>
       <p:sp>
         <p:nvSpPr>
-          <p:cNvPr id="18" name="TextBox 17"/>
+          <p:cNvPr id="17" name="TextBox 16"/>
           <p:cNvSpPr txBox="1"/>
           <p:nvPr/>
         </p:nvSpPr>
@@ -4011,7 +3953,7 @@
       </p:sp>
       <p:sp>
         <p:nvSpPr>
-          <p:cNvPr id="19" name="Rounded Rectangle 18"/>
+          <p:cNvPr id="18" name="Rounded Rectangle 17"/>
           <p:cNvSpPr/>
           <p:nvPr/>
         </p:nvSpPr>
@@ -4075,7 +4017,7 @@
       </p:sp>
       <p:sp>
         <p:nvSpPr>
-          <p:cNvPr id="20" name="Rounded Rectangle 19"/>
+          <p:cNvPr id="19" name="Rounded Rectangle 18"/>
           <p:cNvSpPr/>
           <p:nvPr/>
         </p:nvSpPr>
@@ -4139,7 +4081,7 @@
       </p:sp>
       <p:sp>
         <p:nvSpPr>
-          <p:cNvPr id="21" name="Rounded Rectangle 20"/>
+          <p:cNvPr id="20" name="Rounded Rectangle 19"/>
           <p:cNvSpPr/>
           <p:nvPr/>
         </p:nvSpPr>
@@ -4203,7 +4145,7 @@
       </p:sp>
       <p:sp>
         <p:nvSpPr>
-          <p:cNvPr id="22" name="Rounded Rectangle 21"/>
+          <p:cNvPr id="21" name="Rounded Rectangle 20"/>
           <p:cNvSpPr/>
           <p:nvPr/>
         </p:nvSpPr>
@@ -4267,7 +4209,7 @@
       </p:sp>
       <p:sp>
         <p:nvSpPr>
-          <p:cNvPr id="23" name="Chevron 22"/>
+          <p:cNvPr id="22" name="Chevron 21"/>
           <p:cNvSpPr/>
           <p:nvPr/>
         </p:nvSpPr>
@@ -4311,7 +4253,7 @@
       </p:sp>
       <p:sp>
         <p:nvSpPr>
-          <p:cNvPr id="24" name="Rounded Rectangle 23"/>
+          <p:cNvPr id="23" name="Rounded Rectangle 22"/>
           <p:cNvSpPr/>
           <p:nvPr/>
         </p:nvSpPr>
@@ -4394,7 +4336,7 @@
       </p:sp>
       <p:sp>
         <p:nvSpPr>
-          <p:cNvPr id="25" name="Rounded Rectangle 24"/>
+          <p:cNvPr id="24" name="Rounded Rectangle 23"/>
           <p:cNvSpPr/>
           <p:nvPr/>
         </p:nvSpPr>
@@ -4467,7 +4409,7 @@
       </p:sp>
       <p:sp>
         <p:nvSpPr>
-          <p:cNvPr id="26" name="Rounded Rectangle 25"/>
+          <p:cNvPr id="25" name="Rounded Rectangle 24"/>
           <p:cNvSpPr/>
           <p:nvPr/>
         </p:nvSpPr>
@@ -4515,7 +4457,7 @@
       </p:sp>
       <p:sp>
         <p:nvSpPr>
-          <p:cNvPr id="27" name="TextBox 26"/>
+          <p:cNvPr id="26" name="TextBox 25"/>
           <p:cNvSpPr txBox="1"/>
           <p:nvPr/>
         </p:nvSpPr>
@@ -4569,7 +4511,7 @@
       </p:sp>
       <p:sp>
         <p:nvSpPr>
-          <p:cNvPr id="28" name="Rounded Rectangle 27"/>
+          <p:cNvPr id="27" name="Rounded Rectangle 26"/>
           <p:cNvSpPr/>
           <p:nvPr/>
         </p:nvSpPr>
@@ -4652,7 +4594,7 @@
       </p:sp>
       <p:sp>
         <p:nvSpPr>
-          <p:cNvPr id="29" name="Chevron 28"/>
+          <p:cNvPr id="28" name="Chevron 27"/>
           <p:cNvSpPr/>
           <p:nvPr/>
         </p:nvSpPr>
@@ -4696,7 +4638,7 @@
       </p:sp>
       <p:sp>
         <p:nvSpPr>
-          <p:cNvPr id="30" name="Rounded Rectangle 29"/>
+          <p:cNvPr id="29" name="Rounded Rectangle 28"/>
           <p:cNvSpPr/>
           <p:nvPr/>
         </p:nvSpPr>
@@ -4798,7 +4740,7 @@
       </p:sp>
       <p:sp>
         <p:nvSpPr>
-          <p:cNvPr id="31" name="Chevron 30"/>
+          <p:cNvPr id="30" name="Chevron 29"/>
           <p:cNvSpPr/>
           <p:nvPr/>
         </p:nvSpPr>
@@ -4842,7 +4784,7 @@
       </p:sp>
       <p:sp>
         <p:nvSpPr>
-          <p:cNvPr id="32" name="Rounded Rectangle 31"/>
+          <p:cNvPr id="31" name="Rounded Rectangle 30"/>
           <p:cNvSpPr/>
           <p:nvPr/>
         </p:nvSpPr>
@@ -4944,7 +4886,7 @@
       </p:sp>
       <p:sp>
         <p:nvSpPr>
-          <p:cNvPr id="33" name="Chevron 32"/>
+          <p:cNvPr id="32" name="Chevron 31"/>
           <p:cNvSpPr/>
           <p:nvPr/>
         </p:nvSpPr>
@@ -4988,7 +4930,7 @@
       </p:sp>
       <p:sp>
         <p:nvSpPr>
-          <p:cNvPr id="34" name="Rounded Rectangle 33"/>
+          <p:cNvPr id="33" name="Rounded Rectangle 32"/>
           <p:cNvSpPr/>
           <p:nvPr/>
         </p:nvSpPr>
@@ -5090,7 +5032,7 @@
       </p:sp>
       <p:sp>
         <p:nvSpPr>
-          <p:cNvPr id="35" name="Chevron 34"/>
+          <p:cNvPr id="34" name="Chevron 33"/>
           <p:cNvSpPr/>
           <p:nvPr/>
         </p:nvSpPr>
@@ -5134,7 +5076,7 @@
       </p:sp>
       <p:sp>
         <p:nvSpPr>
-          <p:cNvPr id="36" name="Rounded Rectangle 35"/>
+          <p:cNvPr id="35" name="Rounded Rectangle 34"/>
           <p:cNvSpPr/>
           <p:nvPr/>
         </p:nvSpPr>
@@ -5217,7 +5159,7 @@
       </p:sp>
       <p:sp>
         <p:nvSpPr>
-          <p:cNvPr id="37" name="Chevron 36"/>
+          <p:cNvPr id="36" name="Chevron 35"/>
           <p:cNvSpPr/>
           <p:nvPr/>
         </p:nvSpPr>
@@ -5261,7 +5203,7 @@
       </p:sp>
       <p:sp>
         <p:nvSpPr>
-          <p:cNvPr id="38" name="Rounded Rectangle 37"/>
+          <p:cNvPr id="37" name="Rounded Rectangle 36"/>
           <p:cNvSpPr/>
           <p:nvPr/>
         </p:nvSpPr>
@@ -5344,7 +5286,7 @@
       </p:sp>
       <p:sp>
         <p:nvSpPr>
-          <p:cNvPr id="39" name="Chevron 38"/>
+          <p:cNvPr id="38" name="Chevron 37"/>
           <p:cNvSpPr/>
           <p:nvPr/>
         </p:nvSpPr>
@@ -5388,7 +5330,7 @@
       </p:sp>
       <p:sp>
         <p:nvSpPr>
-          <p:cNvPr id="40" name="Rounded Rectangle 39"/>
+          <p:cNvPr id="39" name="Rounded Rectangle 38"/>
           <p:cNvSpPr/>
           <p:nvPr/>
         </p:nvSpPr>
@@ -5471,7 +5413,7 @@
       </p:sp>
       <p:sp>
         <p:nvSpPr>
-          <p:cNvPr id="41" name="Chevron 40"/>
+          <p:cNvPr id="40" name="Chevron 39"/>
           <p:cNvSpPr/>
           <p:nvPr/>
         </p:nvSpPr>
@@ -5515,7 +5457,7 @@
       </p:sp>
       <p:sp>
         <p:nvSpPr>
-          <p:cNvPr id="42" name="Rounded Rectangle 41"/>
+          <p:cNvPr id="41" name="Rounded Rectangle 40"/>
           <p:cNvSpPr/>
           <p:nvPr/>
         </p:nvSpPr>
@@ -5598,7 +5540,7 @@
       </p:sp>
       <p:sp>
         <p:nvSpPr>
-          <p:cNvPr id="43" name="Rounded Rectangle 42"/>
+          <p:cNvPr id="42" name="Rounded Rectangle 41"/>
           <p:cNvSpPr/>
           <p:nvPr/>
         </p:nvSpPr>
@@ -5646,7 +5588,7 @@
       </p:sp>
       <p:sp>
         <p:nvSpPr>
-          <p:cNvPr id="44" name="Rectangle 43"/>
+          <p:cNvPr id="43" name="Rectangle 42"/>
           <p:cNvSpPr/>
           <p:nvPr/>
         </p:nvSpPr>
@@ -5690,7 +5632,7 @@
       </p:sp>
       <p:sp>
         <p:nvSpPr>
-          <p:cNvPr id="45" name="TextBox 44"/>
+          <p:cNvPr id="44" name="TextBox 43"/>
           <p:cNvSpPr txBox="1"/>
           <p:nvPr/>
         </p:nvSpPr>
@@ -5735,7 +5677,7 @@
       </p:sp>
       <p:sp>
         <p:nvSpPr>
-          <p:cNvPr id="46" name="TextBox 45"/>
+          <p:cNvPr id="45" name="TextBox 44"/>
           <p:cNvSpPr txBox="1"/>
           <p:nvPr/>
         </p:nvSpPr>
@@ -5780,7 +5722,7 @@
       </p:sp>
       <p:sp>
         <p:nvSpPr>
-          <p:cNvPr id="47" name="Rounded Rectangle 46"/>
+          <p:cNvPr id="46" name="Rounded Rectangle 45"/>
           <p:cNvSpPr/>
           <p:nvPr/>
         </p:nvSpPr>
@@ -5828,7 +5770,7 @@
       </p:sp>
       <p:sp>
         <p:nvSpPr>
-          <p:cNvPr id="48" name="Rectangle 47"/>
+          <p:cNvPr id="47" name="Rectangle 46"/>
           <p:cNvSpPr/>
           <p:nvPr/>
         </p:nvSpPr>
@@ -5872,7 +5814,7 @@
       </p:sp>
       <p:sp>
         <p:nvSpPr>
-          <p:cNvPr id="49" name="TextBox 48"/>
+          <p:cNvPr id="48" name="TextBox 47"/>
           <p:cNvSpPr txBox="1"/>
           <p:nvPr/>
         </p:nvSpPr>
@@ -5917,7 +5859,7 @@
       </p:sp>
       <p:sp>
         <p:nvSpPr>
-          <p:cNvPr id="50" name="TextBox 49"/>
+          <p:cNvPr id="49" name="TextBox 48"/>
           <p:cNvSpPr txBox="1"/>
           <p:nvPr/>
         </p:nvSpPr>
@@ -5962,7 +5904,7 @@
       </p:sp>
       <p:cxnSp>
         <p:nvCxnSpPr>
-          <p:cNvPr id="51" name="Connector 50"/>
+          <p:cNvPr id="50" name="Connector 49"/>
           <p:cNvCxnSpPr/>
           <p:nvPr/>
         </p:nvCxnSpPr>
@@ -5999,7 +5941,7 @@
       </p:cxnSp>
       <p:sp>
         <p:nvSpPr>
-          <p:cNvPr id="52" name="TextBox 51"/>
+          <p:cNvPr id="51" name="TextBox 50"/>
           <p:cNvSpPr txBox="1"/>
           <p:nvPr/>
         </p:nvSpPr>
@@ -6044,7 +5986,7 @@
       </p:sp>
       <p:cxnSp>
         <p:nvCxnSpPr>
-          <p:cNvPr id="53" name="Connector 52"/>
+          <p:cNvPr id="52" name="Connector 51"/>
           <p:cNvCxnSpPr/>
           <p:nvPr/>
         </p:nvCxnSpPr>
@@ -6081,7 +6023,7 @@
       </p:cxnSp>
       <p:sp>
         <p:nvSpPr>
-          <p:cNvPr id="54" name="TextBox 53"/>
+          <p:cNvPr id="53" name="TextBox 52"/>
           <p:cNvSpPr txBox="1"/>
           <p:nvPr/>
         </p:nvSpPr>
@@ -6126,14 +6068,51 @@
       </p:sp>
       <p:cxnSp>
         <p:nvCxnSpPr>
+          <p:cNvPr id="54" name="Connector 53"/>
+          <p:cNvCxnSpPr/>
+          <p:nvPr/>
+        </p:nvCxnSpPr>
+        <p:spPr>
+          <a:xfrm>
+            <a:off x="9948672" y="4096511"/>
+            <a:ext cx="164592" cy="0"/>
+          </a:xfrm>
+          <a:prstGeom prst="line">
+            <a:avLst/>
+          </a:prstGeom>
+          <a:ln w="13970">
+            <a:solidFill>
+              <a:srgbClr val="FFB020"/>
+            </a:solidFill>
+            <a:prstDash val="dash"/>
+          </a:ln>
+          <a:effectLst/>
+        </p:spPr>
+        <p:style>
+          <a:lnRef idx="2">
+            <a:schemeClr val="accent1"/>
+          </a:lnRef>
+          <a:fillRef idx="0">
+            <a:schemeClr val="accent1"/>
+          </a:fillRef>
+          <a:effectRef idx="1">
+            <a:schemeClr val="accent1"/>
+          </a:effectRef>
+          <a:fontRef idx="minor">
+            <a:schemeClr val="tx1"/>
+          </a:fontRef>
+        </p:style>
+      </p:cxnSp>
+      <p:cxnSp>
+        <p:nvCxnSpPr>
           <p:cNvPr id="55" name="Connector 54"/>
           <p:cNvCxnSpPr/>
           <p:nvPr/>
         </p:nvCxnSpPr>
         <p:spPr>
-          <a:xfrm>
-            <a:off x="9948672" y="4096511"/>
-            <a:ext cx="164592" cy="0"/>
+          <a:xfrm flipV="1">
+            <a:off x="10113264" y="3282696"/>
+            <a:ext cx="0" cy="813815"/>
           </a:xfrm>
           <a:prstGeom prst="line">
             <a:avLst/>
@@ -6168,43 +6147,6 @@
           <p:nvPr/>
         </p:nvCxnSpPr>
         <p:spPr>
-          <a:xfrm flipV="1">
-            <a:off x="10113264" y="3282696"/>
-            <a:ext cx="0" cy="813815"/>
-          </a:xfrm>
-          <a:prstGeom prst="line">
-            <a:avLst/>
-          </a:prstGeom>
-          <a:ln w="13970">
-            <a:solidFill>
-              <a:srgbClr val="FFB020"/>
-            </a:solidFill>
-            <a:prstDash val="dash"/>
-          </a:ln>
-          <a:effectLst/>
-        </p:spPr>
-        <p:style>
-          <a:lnRef idx="2">
-            <a:schemeClr val="accent1"/>
-          </a:lnRef>
-          <a:fillRef idx="0">
-            <a:schemeClr val="accent1"/>
-          </a:fillRef>
-          <a:effectRef idx="1">
-            <a:schemeClr val="accent1"/>
-          </a:effectRef>
-          <a:fontRef idx="minor">
-            <a:schemeClr val="tx1"/>
-          </a:fontRef>
-        </p:style>
-      </p:cxnSp>
-      <p:cxnSp>
-        <p:nvCxnSpPr>
-          <p:cNvPr id="57" name="Connector 56"/>
-          <p:cNvCxnSpPr/>
-          <p:nvPr/>
-        </p:nvCxnSpPr>
-        <p:spPr>
           <a:xfrm flipH="1">
             <a:off x="9948672" y="3282696"/>
             <a:ext cx="164592" cy="0"/>
@@ -6238,7 +6180,7 @@
       </p:cxnSp>
       <p:sp>
         <p:nvSpPr>
-          <p:cNvPr id="58" name="TextBox 57"/>
+          <p:cNvPr id="57" name="TextBox 56"/>
           <p:cNvSpPr txBox="1"/>
           <p:nvPr/>
         </p:nvSpPr>
@@ -6283,7 +6225,7 @@
       </p:sp>
       <p:sp>
         <p:nvSpPr>
-          <p:cNvPr id="59" name="Rounded Rectangle 58"/>
+          <p:cNvPr id="58" name="Rounded Rectangle 57"/>
           <p:cNvSpPr/>
           <p:nvPr/>
         </p:nvSpPr>
@@ -6366,7 +6308,7 @@
       </p:sp>
       <p:sp>
         <p:nvSpPr>
-          <p:cNvPr id="60" name="Chevron 59"/>
+          <p:cNvPr id="59" name="Chevron 58"/>
           <p:cNvSpPr/>
           <p:nvPr/>
         </p:nvSpPr>
@@ -6410,7 +6352,7 @@
       </p:sp>
       <p:sp>
         <p:nvSpPr>
-          <p:cNvPr id="61" name="Rounded Rectangle 60"/>
+          <p:cNvPr id="60" name="Rounded Rectangle 59"/>
           <p:cNvSpPr/>
           <p:nvPr/>
         </p:nvSpPr>
@@ -6474,7 +6416,7 @@
       </p:sp>
       <p:sp>
         <p:nvSpPr>
-          <p:cNvPr id="62" name="Rounded Rectangle 61"/>
+          <p:cNvPr id="61" name="Rounded Rectangle 60"/>
           <p:cNvSpPr/>
           <p:nvPr/>
         </p:nvSpPr>
@@ -6557,7 +6499,7 @@
       </p:sp>
       <p:sp>
         <p:nvSpPr>
-          <p:cNvPr id="63" name="Rounded Rectangle 62"/>
+          <p:cNvPr id="62" name="Rounded Rectangle 61"/>
           <p:cNvSpPr/>
           <p:nvPr/>
         </p:nvSpPr>
@@ -6640,7 +6582,7 @@
       </p:sp>
       <p:sp>
         <p:nvSpPr>
-          <p:cNvPr id="64" name="Rounded Rectangle 63"/>
+          <p:cNvPr id="63" name="Rounded Rectangle 62"/>
           <p:cNvSpPr/>
           <p:nvPr/>
         </p:nvSpPr>
@@ -6723,7 +6665,7 @@
       </p:sp>
       <p:sp>
         <p:nvSpPr>
-          <p:cNvPr id="65" name="Rounded Rectangle 64"/>
+          <p:cNvPr id="64" name="Rounded Rectangle 63"/>
           <p:cNvSpPr/>
           <p:nvPr/>
         </p:nvSpPr>
@@ -6806,7 +6748,7 @@
       </p:sp>
       <p:sp>
         <p:nvSpPr>
-          <p:cNvPr id="66" name="TextBox 65"/>
+          <p:cNvPr id="65" name="TextBox 64"/>
           <p:cNvSpPr txBox="1"/>
           <p:nvPr/>
         </p:nvSpPr>
@@ -6851,7 +6793,7 @@
       </p:sp>
       <p:sp>
         <p:nvSpPr>
-          <p:cNvPr id="67" name="Rounded Rectangle 66"/>
+          <p:cNvPr id="66" name="Rounded Rectangle 65"/>
           <p:cNvSpPr/>
           <p:nvPr/>
         </p:nvSpPr>
@@ -6899,7 +6841,7 @@
       </p:sp>
       <p:sp>
         <p:nvSpPr>
-          <p:cNvPr id="68" name="TextBox 67"/>
+          <p:cNvPr id="67" name="TextBox 66"/>
           <p:cNvSpPr txBox="1"/>
           <p:nvPr/>
         </p:nvSpPr>
@@ -6953,7 +6895,7 @@
       </p:sp>
       <p:sp>
         <p:nvSpPr>
-          <p:cNvPr id="69" name="Rounded Rectangle 68"/>
+          <p:cNvPr id="68" name="Rounded Rectangle 67"/>
           <p:cNvSpPr/>
           <p:nvPr/>
         </p:nvSpPr>
@@ -7017,7 +6959,7 @@
       </p:sp>
       <p:sp>
         <p:nvSpPr>
-          <p:cNvPr id="70" name="Rounded Rectangle 69"/>
+          <p:cNvPr id="69" name="Rounded Rectangle 68"/>
           <p:cNvSpPr/>
           <p:nvPr/>
         </p:nvSpPr>
@@ -7081,7 +7023,7 @@
       </p:sp>
       <p:sp>
         <p:nvSpPr>
-          <p:cNvPr id="71" name="Rounded Rectangle 70"/>
+          <p:cNvPr id="70" name="Rounded Rectangle 69"/>
           <p:cNvSpPr/>
           <p:nvPr/>
         </p:nvSpPr>
@@ -7145,7 +7087,7 @@
       </p:sp>
       <p:sp>
         <p:nvSpPr>
-          <p:cNvPr id="72" name="Rounded Rectangle 71"/>
+          <p:cNvPr id="71" name="Rounded Rectangle 70"/>
           <p:cNvSpPr/>
           <p:nvPr/>
         </p:nvSpPr>
@@ -7209,7 +7151,7 @@
       </p:sp>
       <p:sp>
         <p:nvSpPr>
-          <p:cNvPr id="73" name="Rounded Rectangle 72"/>
+          <p:cNvPr id="72" name="Rounded Rectangle 71"/>
           <p:cNvSpPr/>
           <p:nvPr/>
         </p:nvSpPr>
@@ -7273,7 +7215,7 @@
       </p:sp>
       <p:sp>
         <p:nvSpPr>
-          <p:cNvPr id="74" name="Rounded Rectangle 73"/>
+          <p:cNvPr id="73" name="Rounded Rectangle 72"/>
           <p:cNvSpPr/>
           <p:nvPr/>
         </p:nvSpPr>
@@ -7337,7 +7279,7 @@
       </p:sp>
       <p:sp>
         <p:nvSpPr>
-          <p:cNvPr id="75" name="Rounded Rectangle 74"/>
+          <p:cNvPr id="74" name="Rounded Rectangle 73"/>
           <p:cNvSpPr/>
           <p:nvPr/>
         </p:nvSpPr>
@@ -7401,7 +7343,7 @@
       </p:sp>
       <p:sp>
         <p:nvSpPr>
-          <p:cNvPr id="76" name="Rounded Rectangle 75"/>
+          <p:cNvPr id="75" name="Rounded Rectangle 74"/>
           <p:cNvSpPr/>
           <p:nvPr/>
         </p:nvSpPr>
@@ -7465,7 +7407,7 @@
       </p:sp>
       <p:sp>
         <p:nvSpPr>
-          <p:cNvPr id="77" name="Rounded Rectangle 76"/>
+          <p:cNvPr id="76" name="Rounded Rectangle 75"/>
           <p:cNvSpPr/>
           <p:nvPr/>
         </p:nvSpPr>
@@ -7529,7 +7471,7 @@
       </p:sp>
       <p:sp>
         <p:nvSpPr>
-          <p:cNvPr id="78" name="Rounded Rectangle 77"/>
+          <p:cNvPr id="77" name="Rounded Rectangle 76"/>
           <p:cNvSpPr/>
           <p:nvPr/>
         </p:nvSpPr>
@@ -7593,7 +7535,7 @@
       </p:sp>
       <p:sp>
         <p:nvSpPr>
-          <p:cNvPr id="79" name="Down Arrow 78"/>
+          <p:cNvPr id="78" name="Down Arrow 77"/>
           <p:cNvSpPr/>
           <p:nvPr/>
         </p:nvSpPr>
@@ -7637,7 +7579,7 @@
       </p:sp>
       <p:sp>
         <p:nvSpPr>
-          <p:cNvPr id="80" name="Down Arrow 79"/>
+          <p:cNvPr id="79" name="Down Arrow 78"/>
           <p:cNvSpPr/>
           <p:nvPr/>
         </p:nvSpPr>
@@ -7681,7 +7623,7 @@
       </p:sp>
       <p:sp>
         <p:nvSpPr>
-          <p:cNvPr id="81" name="Down Arrow 80"/>
+          <p:cNvPr id="80" name="Down Arrow 79"/>
           <p:cNvSpPr/>
           <p:nvPr/>
         </p:nvSpPr>
@@ -7725,7 +7667,7 @@
       </p:sp>
       <p:cxnSp>
         <p:nvCxnSpPr>
-          <p:cNvPr id="82" name="Connector 81"/>
+          <p:cNvPr id="81" name="Connector 80"/>
           <p:cNvCxnSpPr/>
           <p:nvPr/>
         </p:nvCxnSpPr>
@@ -7763,7 +7705,7 @@
       </p:cxnSp>
       <p:sp>
         <p:nvSpPr>
-          <p:cNvPr id="83" name="TextBox 82"/>
+          <p:cNvPr id="82" name="TextBox 81"/>
           <p:cNvSpPr txBox="1"/>
           <p:nvPr/>
         </p:nvSpPr>
@@ -7808,7 +7750,7 @@
       </p:sp>
       <p:sp>
         <p:nvSpPr>
-          <p:cNvPr id="84" name="Rounded Rectangle 83"/>
+          <p:cNvPr id="83" name="Rounded Rectangle 82"/>
           <p:cNvSpPr/>
           <p:nvPr/>
         </p:nvSpPr>
@@ -7854,7 +7796,7 @@
       </p:sp>
       <p:sp>
         <p:nvSpPr>
-          <p:cNvPr id="85" name="Rectangle 84"/>
+          <p:cNvPr id="84" name="Rectangle 83"/>
           <p:cNvSpPr/>
           <p:nvPr/>
         </p:nvSpPr>
@@ -7898,7 +7840,7 @@
       </p:sp>
       <p:sp>
         <p:nvSpPr>
-          <p:cNvPr id="86" name="TextBox 85"/>
+          <p:cNvPr id="85" name="TextBox 84"/>
           <p:cNvSpPr txBox="1"/>
           <p:nvPr/>
         </p:nvSpPr>
@@ -7943,7 +7885,7 @@
       </p:sp>
       <p:sp>
         <p:nvSpPr>
-          <p:cNvPr id="87" name="Rounded Rectangle 86"/>
+          <p:cNvPr id="86" name="Rounded Rectangle 85"/>
           <p:cNvSpPr/>
           <p:nvPr/>
         </p:nvSpPr>
@@ -8026,7 +7968,7 @@
       </p:sp>
       <p:sp>
         <p:nvSpPr>
-          <p:cNvPr id="88" name="Rectangle 87"/>
+          <p:cNvPr id="87" name="Rectangle 86"/>
           <p:cNvSpPr/>
           <p:nvPr/>
         </p:nvSpPr>
@@ -8070,7 +8012,7 @@
       </p:sp>
       <p:sp>
         <p:nvSpPr>
-          <p:cNvPr id="89" name="Rounded Rectangle 88"/>
+          <p:cNvPr id="88" name="Rounded Rectangle 87"/>
           <p:cNvSpPr/>
           <p:nvPr/>
         </p:nvSpPr>
@@ -8153,7 +8095,7 @@
       </p:sp>
       <p:sp>
         <p:nvSpPr>
-          <p:cNvPr id="90" name="Rectangle 89"/>
+          <p:cNvPr id="89" name="Rectangle 88"/>
           <p:cNvSpPr/>
           <p:nvPr/>
         </p:nvSpPr>
@@ -8197,7 +8139,7 @@
       </p:sp>
       <p:sp>
         <p:nvSpPr>
-          <p:cNvPr id="91" name="Rounded Rectangle 90"/>
+          <p:cNvPr id="90" name="Rounded Rectangle 89"/>
           <p:cNvSpPr/>
           <p:nvPr/>
         </p:nvSpPr>
@@ -8280,7 +8222,7 @@
       </p:sp>
       <p:sp>
         <p:nvSpPr>
-          <p:cNvPr id="92" name="Rectangle 91"/>
+          <p:cNvPr id="91" name="Rectangle 90"/>
           <p:cNvSpPr/>
           <p:nvPr/>
         </p:nvSpPr>
@@ -8324,7 +8266,7 @@
       </p:sp>
       <p:sp>
         <p:nvSpPr>
-          <p:cNvPr id="93" name="Rounded Rectangle 92"/>
+          <p:cNvPr id="92" name="Rounded Rectangle 91"/>
           <p:cNvSpPr/>
           <p:nvPr/>
         </p:nvSpPr>
@@ -8407,7 +8349,7 @@
       </p:sp>
       <p:sp>
         <p:nvSpPr>
-          <p:cNvPr id="94" name="Rectangle 93"/>
+          <p:cNvPr id="93" name="Rectangle 92"/>
           <p:cNvSpPr/>
           <p:nvPr/>
         </p:nvSpPr>
@@ -8451,7 +8393,7 @@
       </p:sp>
       <p:sp>
         <p:nvSpPr>
-          <p:cNvPr id="95" name="TextBox 94"/>
+          <p:cNvPr id="94" name="TextBox 93"/>
           <p:cNvSpPr txBox="1"/>
           <p:nvPr/>
         </p:nvSpPr>

</xml_diff>

<commit_message>
docs: show all 4 PO intake methods (Email, PDF, Excel, Scanned) in architecture slide
</commit_message>
<xml_diff>
--- a/demo/Order-Creation-Orchestration-Architecture.pptx
+++ b/demo/Order-Creation-Orchestration-Architecture.pptx
@@ -4110,8 +4110,8 @@
         </p:nvSpPr>
         <p:spPr>
           <a:xfrm>
-            <a:off x="1709928" y="1024127"/>
-            <a:ext cx="2286000" cy="603504"/>
+            <a:off x="1709928" y="1005840"/>
+            <a:ext cx="2468880" cy="658368"/>
           </a:xfrm>
           <a:prstGeom prst="roundRect">
             <a:avLst>
@@ -4158,8 +4158,8 @@
         </p:nvSpPr>
         <p:spPr>
           <a:xfrm>
-            <a:off x="1709928" y="1024127"/>
-            <a:ext cx="2286000" cy="45720"/>
+            <a:off x="1709928" y="1005840"/>
+            <a:ext cx="2468880" cy="45720"/>
           </a:xfrm>
           <a:prstGeom prst="rect">
             <a:avLst/>
@@ -4202,8 +4202,8 @@
         </p:nvSpPr>
         <p:spPr>
           <a:xfrm>
-            <a:off x="1801368" y="1106424"/>
-            <a:ext cx="2103120" cy="182880"/>
+            <a:off x="1801368" y="1088136"/>
+            <a:ext cx="2286000" cy="182880"/>
           </a:xfrm>
           <a:prstGeom prst="rect">
             <a:avLst/>
@@ -4234,7 +4234,7 @@
                 </a:solidFill>
                 <a:latin typeface="Segoe UI"/>
               </a:rPr>
-              <a:t>PO INTAKE</a:t>
+              <a:t>PO INTAKE  —  4 methods</a:t>
             </a:r>
           </a:p>
         </p:txBody>
@@ -4247,8 +4247,8 @@
         </p:nvSpPr>
         <p:spPr>
           <a:xfrm>
-            <a:off x="1801368" y="1307592"/>
-            <a:ext cx="2103120" cy="283464"/>
+            <a:off x="1801368" y="1289304"/>
+            <a:ext cx="2286000" cy="338328"/>
           </a:xfrm>
           <a:prstGeom prst="rect">
             <a:avLst/>
@@ -4279,7 +4279,7 @@
                 </a:solidFill>
                 <a:latin typeface="Segoe UI"/>
               </a:rPr>
-              <a:t>• PO text / email (paste)</a:t>
+              <a:t>• Email PO      • PDF PO</a:t>
             </a:r>
           </a:p>
           <a:p>
@@ -4301,7 +4301,29 @@
                 </a:solidFill>
                 <a:latin typeface="Segoe UI"/>
               </a:rPr>
-              <a:t>• Excel PO (.xlsx / .xls)</a:t>
+              <a:t>• Excel PO (.xlsx/.xls)</a:t>
+            </a:r>
+          </a:p>
+          <a:p>
+            <a:pPr algn="l">
+              <a:lnSpc>
+                <a:spcPct val="104000"/>
+              </a:lnSpc>
+              <a:spcBef>
+                <a:spcPts val="0"/>
+              </a:spcBef>
+              <a:spcAft>
+                <a:spcPts val="0"/>
+              </a:spcAft>
+            </a:pPr>
+            <a:r>
+              <a:rPr sz="660" b="0" i="0">
+                <a:solidFill>
+                  <a:srgbClr val="C2C2D0"/>
+                </a:solidFill>
+                <a:latin typeface="Segoe UI"/>
+              </a:rPr>
+              <a:t>• Scanned PO</a:t>
             </a:r>
           </a:p>
         </p:txBody>
@@ -4314,7 +4336,7 @@
         </p:nvSpPr>
         <p:spPr>
           <a:xfrm>
-            <a:off x="4041648" y="1234440"/>
+            <a:off x="4224528" y="1261872"/>
             <a:ext cx="292608" cy="182880"/>
           </a:xfrm>
           <a:prstGeom prst="chevron">
@@ -4358,8 +4380,8 @@
         </p:nvSpPr>
         <p:spPr>
           <a:xfrm>
-            <a:off x="4407408" y="1024127"/>
-            <a:ext cx="5605272" cy="603504"/>
+            <a:off x="4590288" y="1005840"/>
+            <a:ext cx="5422392" cy="658368"/>
           </a:xfrm>
           <a:prstGeom prst="roundRect">
             <a:avLst>
@@ -4406,8 +4428,8 @@
         </p:nvSpPr>
         <p:spPr>
           <a:xfrm>
-            <a:off x="4407408" y="1024127"/>
-            <a:ext cx="5605272" cy="45720"/>
+            <a:off x="4590288" y="1005840"/>
+            <a:ext cx="5422392" cy="45720"/>
           </a:xfrm>
           <a:prstGeom prst="rect">
             <a:avLst/>
@@ -4450,8 +4472,8 @@
         </p:nvSpPr>
         <p:spPr>
           <a:xfrm>
-            <a:off x="4517136" y="1106424"/>
-            <a:ext cx="5376672" cy="182880"/>
+            <a:off x="4700016" y="1088136"/>
+            <a:ext cx="5193792" cy="182880"/>
           </a:xfrm>
           <a:prstGeom prst="rect">
             <a:avLst/>
@@ -4495,8 +4517,8 @@
         </p:nvSpPr>
         <p:spPr>
           <a:xfrm>
-            <a:off x="4517136" y="1298448"/>
-            <a:ext cx="5376672" cy="310896"/>
+            <a:off x="4700016" y="1298448"/>
+            <a:ext cx="5193792" cy="347472"/>
           </a:xfrm>
           <a:prstGeom prst="rect">
             <a:avLst/>

</xml_diff>

<commit_message>
docs: scope Intake Agent to field extraction (SKU, qty, ship-to ZIP, delivery date, etc.)
</commit_message>
<xml_diff>
--- a/demo/Order-Creation-Orchestration-Architecture.pptx
+++ b/demo/Order-Creation-Orchestration-Architecture.pptx
@@ -4097,7 +4097,7 @@
                 </a:solidFill>
                 <a:latin typeface="Segoe UI"/>
               </a:rPr>
-              <a:t> reads, extracts and resolves every PO</a:t>
+              <a:t> reads every PO and extracts the order fields</a:t>
             </a:r>
           </a:p>
         </p:txBody>
@@ -4549,16 +4549,16 @@
                 </a:solidFill>
                 <a:latin typeface="Segoe UI"/>
               </a:rPr>
-              <a:t>extract (rule-based · confidence-scored) · resolve identity / account / ship-to · </a:t>
+              <a:t>extracts order fields (rule-based · confidence-scored): </a:t>
             </a:r>
             <a:r>
               <a:rPr sz="670" b="0" i="0">
                 <a:solidFill>
-                  <a:srgbClr val="FFB020"/>
-                </a:solidFill>
-                <a:latin typeface="Segoe UI"/>
-              </a:rPr>
-              <a:t>intake gates for CSR: obsolete→substitute · SKU · qty · UOM · buyer · ship-to</a:t>
+                  <a:srgbClr val="FFFFFF"/>
+                </a:solidFill>
+                <a:latin typeface="Segoe UI"/>
+              </a:rPr>
+              <a:t>SKU · qty · UOM · ship-to ZIP · requested delivery date · PO number · customer / buyer</a:t>
             </a:r>
           </a:p>
         </p:txBody>

</xml_diff>

<commit_message>
docs: rename left-side experience band to Decision Layer in architecture slide
</commit_message>
<xml_diff>
--- a/demo/Order-Creation-Orchestration-Architecture.pptx
+++ b/demo/Order-Creation-Orchestration-Architecture.pptx
@@ -3466,7 +3466,7 @@
                 </a:solidFill>
                 <a:latin typeface="Segoe UI"/>
               </a:rPr>
-              <a:t>EXPERIENCE</a:t>
+              <a:t>DECISION</a:t>
             </a:r>
           </a:p>
           <a:p>
@@ -3488,7 +3488,7 @@
                 </a:solidFill>
                 <a:latin typeface="Segoe UI"/>
               </a:rPr>
-              <a:t>CSR WORKSPACE</a:t>
+              <a:t>LAYER</a:t>
             </a:r>
           </a:p>
         </p:txBody>

</xml_diff>

<commit_message>
docs: add Optimization Agent to orchestration layer in architecture slide
</commit_message>
<xml_diff>
--- a/demo/Order-Creation-Orchestration-Architecture.pptx
+++ b/demo/Order-Creation-Orchestration-Architecture.pptx
@@ -4816,7 +4816,7 @@
         <p:spPr>
           <a:xfrm>
             <a:off x="1773936" y="2798064"/>
-            <a:ext cx="1097279" cy="932688"/>
+            <a:ext cx="949832" cy="932688"/>
           </a:xfrm>
           <a:prstGeom prst="roundRect">
             <a:avLst>
@@ -4958,7 +4958,7 @@
         <p:spPr>
           <a:xfrm>
             <a:off x="1773936" y="2798064"/>
-            <a:ext cx="1097279" cy="36576"/>
+            <a:ext cx="949832" cy="36576"/>
           </a:xfrm>
           <a:prstGeom prst="rect">
             <a:avLst/>
@@ -5001,7 +5001,7 @@
         </p:nvSpPr>
         <p:spPr>
           <a:xfrm>
-            <a:off x="2852927" y="3182112"/>
+            <a:off x="2705481" y="3182112"/>
             <a:ext cx="128016" cy="164592"/>
           </a:xfrm>
           <a:prstGeom prst="chevron">
@@ -5045,8 +5045,8 @@
         </p:nvSpPr>
         <p:spPr>
           <a:xfrm>
-            <a:off x="2953511" y="2798064"/>
-            <a:ext cx="1097279" cy="932688"/>
+            <a:off x="2806064" y="2798064"/>
+            <a:ext cx="949832" cy="932688"/>
           </a:xfrm>
           <a:prstGeom prst="roundRect">
             <a:avLst>
@@ -5187,8 +5187,8 @@
         </p:nvSpPr>
         <p:spPr>
           <a:xfrm>
-            <a:off x="2953511" y="2798064"/>
-            <a:ext cx="1097279" cy="36576"/>
+            <a:off x="2806064" y="2798064"/>
+            <a:ext cx="949832" cy="36576"/>
           </a:xfrm>
           <a:prstGeom prst="rect">
             <a:avLst/>
@@ -5231,7 +5231,7 @@
         </p:nvSpPr>
         <p:spPr>
           <a:xfrm>
-            <a:off x="4032504" y="3182112"/>
+            <a:off x="3737610" y="3182112"/>
             <a:ext cx="128016" cy="164592"/>
           </a:xfrm>
           <a:prstGeom prst="chevron">
@@ -5275,8 +5275,8 @@
         </p:nvSpPr>
         <p:spPr>
           <a:xfrm>
-            <a:off x="4133087" y="2798064"/>
-            <a:ext cx="1097279" cy="932688"/>
+            <a:off x="3838194" y="2798064"/>
+            <a:ext cx="949832" cy="932688"/>
           </a:xfrm>
           <a:prstGeom prst="roundRect">
             <a:avLst>
@@ -5417,8 +5417,8 @@
         </p:nvSpPr>
         <p:spPr>
           <a:xfrm>
-            <a:off x="4133087" y="2798064"/>
-            <a:ext cx="1097279" cy="36576"/>
+            <a:off x="3838194" y="2798064"/>
+            <a:ext cx="949832" cy="36576"/>
           </a:xfrm>
           <a:prstGeom prst="rect">
             <a:avLst/>
@@ -5461,7 +5461,7 @@
         </p:nvSpPr>
         <p:spPr>
           <a:xfrm>
-            <a:off x="5212079" y="3182112"/>
+            <a:off x="4769739" y="3182112"/>
             <a:ext cx="128016" cy="164592"/>
           </a:xfrm>
           <a:prstGeom prst="chevron">
@@ -5505,8 +5505,8 @@
         </p:nvSpPr>
         <p:spPr>
           <a:xfrm>
-            <a:off x="5312663" y="2798064"/>
-            <a:ext cx="1097279" cy="932688"/>
+            <a:off x="4870323" y="2798064"/>
+            <a:ext cx="949832" cy="932688"/>
           </a:xfrm>
           <a:prstGeom prst="roundRect">
             <a:avLst>
@@ -5647,8 +5647,8 @@
         </p:nvSpPr>
         <p:spPr>
           <a:xfrm>
-            <a:off x="5312663" y="2798064"/>
-            <a:ext cx="1097279" cy="36576"/>
+            <a:off x="4870323" y="2798064"/>
+            <a:ext cx="949832" cy="36576"/>
           </a:xfrm>
           <a:prstGeom prst="rect">
             <a:avLst/>
@@ -5691,7 +5691,7 @@
         </p:nvSpPr>
         <p:spPr>
           <a:xfrm>
-            <a:off x="6391655" y="3182112"/>
+            <a:off x="5801868" y="3182112"/>
             <a:ext cx="128016" cy="164592"/>
           </a:xfrm>
           <a:prstGeom prst="chevron">
@@ -5735,8 +5735,8 @@
         </p:nvSpPr>
         <p:spPr>
           <a:xfrm>
-            <a:off x="6492240" y="2798064"/>
-            <a:ext cx="1097279" cy="932688"/>
+            <a:off x="5902452" y="2798064"/>
+            <a:ext cx="949832" cy="932688"/>
           </a:xfrm>
           <a:prstGeom prst="roundRect">
             <a:avLst>
@@ -5877,8 +5877,8 @@
         </p:nvSpPr>
         <p:spPr>
           <a:xfrm>
-            <a:off x="6492240" y="2798064"/>
-            <a:ext cx="1097279" cy="36576"/>
+            <a:off x="5902452" y="2798064"/>
+            <a:ext cx="949832" cy="36576"/>
           </a:xfrm>
           <a:prstGeom prst="rect">
             <a:avLst/>
@@ -5921,7 +5921,7 @@
         </p:nvSpPr>
         <p:spPr>
           <a:xfrm>
-            <a:off x="7571231" y="3182112"/>
+            <a:off x="6833997" y="3182112"/>
             <a:ext cx="128016" cy="164592"/>
           </a:xfrm>
           <a:prstGeom prst="chevron">
@@ -5965,8 +5965,8 @@
         </p:nvSpPr>
         <p:spPr>
           <a:xfrm>
-            <a:off x="7671815" y="2798064"/>
-            <a:ext cx="1097279" cy="932688"/>
+            <a:off x="6934581" y="2798064"/>
+            <a:ext cx="949832" cy="932688"/>
           </a:xfrm>
           <a:prstGeom prst="roundRect">
             <a:avLst>
@@ -6107,8 +6107,8 @@
         </p:nvSpPr>
         <p:spPr>
           <a:xfrm>
-            <a:off x="7671815" y="2798064"/>
-            <a:ext cx="1097279" cy="36576"/>
+            <a:off x="6934581" y="2798064"/>
+            <a:ext cx="949832" cy="36576"/>
           </a:xfrm>
           <a:prstGeom prst="rect">
             <a:avLst/>
@@ -6151,7 +6151,7 @@
         </p:nvSpPr>
         <p:spPr>
           <a:xfrm>
-            <a:off x="8750807" y="3182112"/>
+            <a:off x="7866126" y="3182112"/>
             <a:ext cx="128016" cy="164592"/>
           </a:xfrm>
           <a:prstGeom prst="chevron">
@@ -6195,8 +6195,8 @@
         </p:nvSpPr>
         <p:spPr>
           <a:xfrm>
-            <a:off x="8851391" y="2798064"/>
-            <a:ext cx="1097279" cy="932688"/>
+            <a:off x="7966709" y="2798064"/>
+            <a:ext cx="949832" cy="932688"/>
           </a:xfrm>
           <a:prstGeom prst="roundRect">
             <a:avLst>
@@ -6258,7 +6258,7 @@
                 </a:solidFill>
                 <a:latin typeface="Segoe UI"/>
               </a:rPr>
-              <a:t>Approvals</a:t>
+              <a:t>Optimization</a:t>
             </a:r>
           </a:p>
           <a:p>
@@ -6302,7 +6302,7 @@
                 </a:solidFill>
                 <a:latin typeface="Segoe UI"/>
               </a:rPr>
-              <a:t>budget · matrix (last)</a:t>
+              <a:t>plan A/B/C · freight · split</a:t>
             </a:r>
           </a:p>
           <a:p>
@@ -6324,7 +6324,7 @@
                 </a:solidFill>
                 <a:latin typeface="Segoe UI"/>
               </a:rPr>
-              <a:t>budget · approval</a:t>
+              <a:t>least-cost plan</a:t>
             </a:r>
           </a:p>
         </p:txBody>
@@ -6337,8 +6337,8 @@
         </p:nvSpPr>
         <p:spPr>
           <a:xfrm>
-            <a:off x="8851391" y="2798064"/>
-            <a:ext cx="1097279" cy="36576"/>
+            <a:off x="7966709" y="2798064"/>
+            <a:ext cx="949832" cy="36576"/>
           </a:xfrm>
           <a:prstGeom prst="rect">
             <a:avLst/>
@@ -6375,7 +6375,237 @@
       </p:sp>
       <p:sp>
         <p:nvSpPr>
-          <p:cNvPr id="52" name="Rounded Rectangle 51"/>
+          <p:cNvPr id="52" name="Chevron 51"/>
+          <p:cNvSpPr/>
+          <p:nvPr/>
+        </p:nvSpPr>
+        <p:spPr>
+          <a:xfrm>
+            <a:off x="8898255" y="3182112"/>
+            <a:ext cx="128016" cy="164592"/>
+          </a:xfrm>
+          <a:prstGeom prst="chevron">
+            <a:avLst/>
+          </a:prstGeom>
+          <a:solidFill>
+            <a:srgbClr val="FFE600"/>
+          </a:solidFill>
+          <a:ln>
+            <a:noFill/>
+          </a:ln>
+          <a:effectLst/>
+        </p:spPr>
+        <p:style>
+          <a:lnRef idx="1">
+            <a:schemeClr val="accent1"/>
+          </a:lnRef>
+          <a:fillRef idx="3">
+            <a:schemeClr val="accent1"/>
+          </a:fillRef>
+          <a:effectRef idx="2">
+            <a:schemeClr val="accent1"/>
+          </a:effectRef>
+          <a:fontRef idx="minor">
+            <a:schemeClr val="lt1"/>
+          </a:fontRef>
+        </p:style>
+        <p:txBody>
+          <a:bodyPr rtlCol="0" anchor="ctr"/>
+          <a:lstStyle/>
+          <a:p>
+            <a:pPr algn="ctr"/>
+          </a:p>
+        </p:txBody>
+      </p:sp>
+      <p:sp>
+        <p:nvSpPr>
+          <p:cNvPr id="53" name="Rounded Rectangle 52"/>
+          <p:cNvSpPr/>
+          <p:nvPr/>
+        </p:nvSpPr>
+        <p:spPr>
+          <a:xfrm>
+            <a:off x="8998838" y="2798064"/>
+            <a:ext cx="949832" cy="932688"/>
+          </a:xfrm>
+          <a:prstGeom prst="roundRect">
+            <a:avLst>
+              <a:gd name="adj" fmla="val 6000"/>
+            </a:avLst>
+          </a:prstGeom>
+          <a:solidFill>
+            <a:srgbClr val="222230"/>
+          </a:solidFill>
+          <a:ln w="10160">
+            <a:solidFill>
+              <a:srgbClr val="FFE600"/>
+            </a:solidFill>
+          </a:ln>
+          <a:effectLst/>
+        </p:spPr>
+        <p:style>
+          <a:lnRef idx="1">
+            <a:schemeClr val="accent1"/>
+          </a:lnRef>
+          <a:fillRef idx="3">
+            <a:schemeClr val="accent1"/>
+          </a:fillRef>
+          <a:effectRef idx="2">
+            <a:schemeClr val="accent1"/>
+          </a:effectRef>
+          <a:fontRef idx="minor">
+            <a:schemeClr val="lt1"/>
+          </a:fontRef>
+        </p:style>
+        <p:txBody>
+          <a:bodyPr rtlCol="0" anchor="ctr" wrap="square" lIns="27432" rIns="27432" tIns="9144" bIns="9144"/>
+          <a:lstStyle/>
+          <a:p>
+            <a:pPr algn="ctr">
+              <a:lnSpc>
+                <a:spcPct val="98000"/>
+              </a:lnSpc>
+              <a:spcBef>
+                <a:spcPts val="0"/>
+              </a:spcBef>
+              <a:spcAft>
+                <a:spcPts val="0"/>
+              </a:spcAft>
+            </a:pPr>
+            <a:r>
+              <a:rPr sz="850" b="1" i="0">
+                <a:solidFill>
+                  <a:srgbClr val="FFE600"/>
+                </a:solidFill>
+                <a:latin typeface="Segoe UI"/>
+              </a:rPr>
+              <a:t>🤖 </a:t>
+            </a:r>
+            <a:r>
+              <a:rPr sz="720" b="1" i="0">
+                <a:solidFill>
+                  <a:srgbClr val="FFFFFF"/>
+                </a:solidFill>
+                <a:latin typeface="Segoe UI"/>
+              </a:rPr>
+              <a:t>Approvals</a:t>
+            </a:r>
+          </a:p>
+          <a:p>
+            <a:pPr algn="ctr">
+              <a:lnSpc>
+                <a:spcPct val="98000"/>
+              </a:lnSpc>
+              <a:spcBef>
+                <a:spcPts val="0"/>
+              </a:spcBef>
+              <a:spcAft>
+                <a:spcPts val="0"/>
+              </a:spcAft>
+            </a:pPr>
+            <a:r>
+              <a:rPr sz="720" b="1" i="0">
+                <a:solidFill>
+                  <a:srgbClr val="FFFFFF"/>
+                </a:solidFill>
+                <a:latin typeface="Segoe UI"/>
+              </a:rPr>
+              <a:t>Agent</a:t>
+            </a:r>
+          </a:p>
+          <a:p>
+            <a:pPr algn="ctr">
+              <a:lnSpc>
+                <a:spcPct val="98000"/>
+              </a:lnSpc>
+              <a:spcBef>
+                <a:spcPts val="0"/>
+              </a:spcBef>
+              <a:spcAft>
+                <a:spcPts val="0"/>
+              </a:spcAft>
+            </a:pPr>
+            <a:r>
+              <a:rPr sz="570" b="0" i="0">
+                <a:solidFill>
+                  <a:srgbClr val="C2C2D0"/>
+                </a:solidFill>
+                <a:latin typeface="Segoe UI"/>
+              </a:rPr>
+              <a:t>budget · matrix (last)</a:t>
+            </a:r>
+          </a:p>
+          <a:p>
+            <a:pPr algn="ctr">
+              <a:lnSpc>
+                <a:spcPct val="98000"/>
+              </a:lnSpc>
+              <a:spcBef>
+                <a:spcPts val="0"/>
+              </a:spcBef>
+              <a:spcAft>
+                <a:spcPts val="0"/>
+              </a:spcAft>
+            </a:pPr>
+            <a:r>
+              <a:rPr sz="560" b="0" i="1">
+                <a:solidFill>
+                  <a:srgbClr val="8C8C9B"/>
+                </a:solidFill>
+                <a:latin typeface="Segoe UI"/>
+              </a:rPr>
+              <a:t>budget · approval</a:t>
+            </a:r>
+          </a:p>
+        </p:txBody>
+      </p:sp>
+      <p:sp>
+        <p:nvSpPr>
+          <p:cNvPr id="54" name="Rectangle 53"/>
+          <p:cNvSpPr/>
+          <p:nvPr/>
+        </p:nvSpPr>
+        <p:spPr>
+          <a:xfrm>
+            <a:off x="8998838" y="2798064"/>
+            <a:ext cx="949832" cy="36576"/>
+          </a:xfrm>
+          <a:prstGeom prst="rect">
+            <a:avLst/>
+          </a:prstGeom>
+          <a:solidFill>
+            <a:srgbClr val="FFE600"/>
+          </a:solidFill>
+          <a:ln>
+            <a:noFill/>
+          </a:ln>
+          <a:effectLst/>
+        </p:spPr>
+        <p:style>
+          <a:lnRef idx="1">
+            <a:schemeClr val="accent1"/>
+          </a:lnRef>
+          <a:fillRef idx="3">
+            <a:schemeClr val="accent1"/>
+          </a:fillRef>
+          <a:effectRef idx="2">
+            <a:schemeClr val="accent1"/>
+          </a:effectRef>
+          <a:fontRef idx="minor">
+            <a:schemeClr val="lt1"/>
+          </a:fontRef>
+        </p:style>
+        <p:txBody>
+          <a:bodyPr rtlCol="0" anchor="ctr" wrap="square"/>
+          <a:lstStyle/>
+          <a:p>
+            <a:pPr algn="ctr"/>
+          </a:p>
+        </p:txBody>
+      </p:sp>
+      <p:sp>
+        <p:nvSpPr>
+          <p:cNvPr id="55" name="Rounded Rectangle 54"/>
           <p:cNvSpPr/>
           <p:nvPr/>
         </p:nvSpPr>
@@ -6423,7 +6653,7 @@
       </p:sp>
       <p:sp>
         <p:nvSpPr>
-          <p:cNvPr id="53" name="Rectangle 52"/>
+          <p:cNvPr id="56" name="Rectangle 55"/>
           <p:cNvSpPr/>
           <p:nvPr/>
         </p:nvSpPr>
@@ -6467,7 +6697,7 @@
       </p:sp>
       <p:sp>
         <p:nvSpPr>
-          <p:cNvPr id="54" name="TextBox 53"/>
+          <p:cNvPr id="57" name="TextBox 56"/>
           <p:cNvSpPr txBox="1"/>
           <p:nvPr/>
         </p:nvSpPr>
@@ -6521,7 +6751,7 @@
       </p:sp>
       <p:sp>
         <p:nvSpPr>
-          <p:cNvPr id="55" name="Rounded Rectangle 54"/>
+          <p:cNvPr id="58" name="Rounded Rectangle 57"/>
           <p:cNvSpPr/>
           <p:nvPr/>
         </p:nvSpPr>
@@ -6569,7 +6799,7 @@
       </p:sp>
       <p:sp>
         <p:nvSpPr>
-          <p:cNvPr id="56" name="Rectangle 55"/>
+          <p:cNvPr id="59" name="Rectangle 58"/>
           <p:cNvSpPr/>
           <p:nvPr/>
         </p:nvSpPr>
@@ -6613,7 +6843,7 @@
       </p:sp>
       <p:sp>
         <p:nvSpPr>
-          <p:cNvPr id="57" name="TextBox 56"/>
+          <p:cNvPr id="60" name="TextBox 59"/>
           <p:cNvSpPr txBox="1"/>
           <p:nvPr/>
         </p:nvSpPr>
@@ -6667,7 +6897,7 @@
       </p:sp>
       <p:sp>
         <p:nvSpPr>
-          <p:cNvPr id="58" name="Rounded Rectangle 57"/>
+          <p:cNvPr id="61" name="Rounded Rectangle 60"/>
           <p:cNvSpPr/>
           <p:nvPr/>
         </p:nvSpPr>
@@ -6743,7 +6973,7 @@
       </p:sp>
       <p:sp>
         <p:nvSpPr>
-          <p:cNvPr id="59" name="Rectangle 58"/>
+          <p:cNvPr id="62" name="Rectangle 61"/>
           <p:cNvSpPr/>
           <p:nvPr/>
         </p:nvSpPr>
@@ -6787,7 +7017,7 @@
       </p:sp>
       <p:sp>
         <p:nvSpPr>
-          <p:cNvPr id="60" name="TextBox 59"/>
+          <p:cNvPr id="63" name="TextBox 62"/>
           <p:cNvSpPr txBox="1"/>
           <p:nvPr/>
         </p:nvSpPr>
@@ -6841,7 +7071,7 @@
       </p:sp>
       <p:sp>
         <p:nvSpPr>
-          <p:cNvPr id="61" name="Rounded Rectangle 60"/>
+          <p:cNvPr id="64" name="Rounded Rectangle 63"/>
           <p:cNvSpPr/>
           <p:nvPr/>
         </p:nvSpPr>
@@ -6930,7 +7160,7 @@
       </p:sp>
       <p:sp>
         <p:nvSpPr>
-          <p:cNvPr id="62" name="Chevron 61"/>
+          <p:cNvPr id="65" name="Chevron 64"/>
           <p:cNvSpPr/>
           <p:nvPr/>
         </p:nvSpPr>
@@ -6974,7 +7204,7 @@
       </p:sp>
       <p:sp>
         <p:nvSpPr>
-          <p:cNvPr id="63" name="Rounded Rectangle 62"/>
+          <p:cNvPr id="66" name="Rounded Rectangle 65"/>
           <p:cNvSpPr/>
           <p:nvPr/>
         </p:nvSpPr>
@@ -7063,7 +7293,7 @@
       </p:sp>
       <p:sp>
         <p:nvSpPr>
-          <p:cNvPr id="64" name="Rounded Rectangle 63"/>
+          <p:cNvPr id="67" name="Rounded Rectangle 66"/>
           <p:cNvSpPr/>
           <p:nvPr/>
         </p:nvSpPr>
@@ -7152,7 +7382,7 @@
       </p:sp>
       <p:sp>
         <p:nvSpPr>
-          <p:cNvPr id="65" name="Rounded Rectangle 64"/>
+          <p:cNvPr id="68" name="Rounded Rectangle 67"/>
           <p:cNvSpPr/>
           <p:nvPr/>
         </p:nvSpPr>
@@ -7241,7 +7471,7 @@
       </p:sp>
       <p:sp>
         <p:nvSpPr>
-          <p:cNvPr id="66" name="Rounded Rectangle 65"/>
+          <p:cNvPr id="69" name="Rounded Rectangle 68"/>
           <p:cNvSpPr/>
           <p:nvPr/>
         </p:nvSpPr>
@@ -7330,7 +7560,7 @@
       </p:sp>
       <p:sp>
         <p:nvSpPr>
-          <p:cNvPr id="67" name="Rounded Rectangle 66"/>
+          <p:cNvPr id="70" name="Rounded Rectangle 69"/>
           <p:cNvSpPr/>
           <p:nvPr/>
         </p:nvSpPr>
@@ -7419,7 +7649,7 @@
       </p:sp>
       <p:sp>
         <p:nvSpPr>
-          <p:cNvPr id="68" name="Rounded Rectangle 67"/>
+          <p:cNvPr id="71" name="Rounded Rectangle 70"/>
           <p:cNvSpPr/>
           <p:nvPr/>
         </p:nvSpPr>
@@ -7508,7 +7738,7 @@
       </p:sp>
       <p:sp>
         <p:nvSpPr>
-          <p:cNvPr id="69" name="Rounded Rectangle 68"/>
+          <p:cNvPr id="72" name="Rounded Rectangle 71"/>
           <p:cNvSpPr/>
           <p:nvPr/>
         </p:nvSpPr>
@@ -7556,7 +7786,7 @@
       </p:sp>
       <p:sp>
         <p:nvSpPr>
-          <p:cNvPr id="70" name="TextBox 69"/>
+          <p:cNvPr id="73" name="TextBox 72"/>
           <p:cNvSpPr txBox="1"/>
           <p:nvPr/>
         </p:nvSpPr>
@@ -7610,7 +7840,7 @@
       </p:sp>
       <p:sp>
         <p:nvSpPr>
-          <p:cNvPr id="71" name="Rounded Rectangle 70"/>
+          <p:cNvPr id="74" name="Rounded Rectangle 73"/>
           <p:cNvSpPr/>
           <p:nvPr/>
         </p:nvSpPr>
@@ -7699,7 +7929,7 @@
       </p:sp>
       <p:sp>
         <p:nvSpPr>
-          <p:cNvPr id="72" name="Rounded Rectangle 71"/>
+          <p:cNvPr id="75" name="Rounded Rectangle 74"/>
           <p:cNvSpPr/>
           <p:nvPr/>
         </p:nvSpPr>
@@ -7788,7 +8018,7 @@
       </p:sp>
       <p:sp>
         <p:nvSpPr>
-          <p:cNvPr id="73" name="Rounded Rectangle 72"/>
+          <p:cNvPr id="76" name="Rounded Rectangle 75"/>
           <p:cNvSpPr/>
           <p:nvPr/>
         </p:nvSpPr>
@@ -7855,7 +8085,7 @@
       </p:sp>
       <p:sp>
         <p:nvSpPr>
-          <p:cNvPr id="74" name="Rounded Rectangle 73"/>
+          <p:cNvPr id="77" name="Rounded Rectangle 76"/>
           <p:cNvSpPr/>
           <p:nvPr/>
         </p:nvSpPr>
@@ -7922,7 +8152,7 @@
       </p:sp>
       <p:sp>
         <p:nvSpPr>
-          <p:cNvPr id="75" name="Rounded Rectangle 74"/>
+          <p:cNvPr id="78" name="Rounded Rectangle 77"/>
           <p:cNvSpPr/>
           <p:nvPr/>
         </p:nvSpPr>
@@ -7989,7 +8219,7 @@
       </p:sp>
       <p:sp>
         <p:nvSpPr>
-          <p:cNvPr id="76" name="Rounded Rectangle 75"/>
+          <p:cNvPr id="79" name="Rounded Rectangle 78"/>
           <p:cNvSpPr/>
           <p:nvPr/>
         </p:nvSpPr>
@@ -8056,7 +8286,7 @@
       </p:sp>
       <p:sp>
         <p:nvSpPr>
-          <p:cNvPr id="77" name="Rounded Rectangle 76"/>
+          <p:cNvPr id="80" name="Rounded Rectangle 79"/>
           <p:cNvSpPr/>
           <p:nvPr/>
         </p:nvSpPr>
@@ -8123,7 +8353,7 @@
       </p:sp>
       <p:sp>
         <p:nvSpPr>
-          <p:cNvPr id="78" name="Rounded Rectangle 77"/>
+          <p:cNvPr id="81" name="Rounded Rectangle 80"/>
           <p:cNvSpPr/>
           <p:nvPr/>
         </p:nvSpPr>
@@ -8212,7 +8442,7 @@
       </p:sp>
       <p:sp>
         <p:nvSpPr>
-          <p:cNvPr id="79" name="Rounded Rectangle 78"/>
+          <p:cNvPr id="82" name="Rounded Rectangle 81"/>
           <p:cNvSpPr/>
           <p:nvPr/>
         </p:nvSpPr>
@@ -8301,7 +8531,7 @@
       </p:sp>
       <p:sp>
         <p:nvSpPr>
-          <p:cNvPr id="80" name="Rounded Rectangle 79"/>
+          <p:cNvPr id="83" name="Rounded Rectangle 82"/>
           <p:cNvSpPr/>
           <p:nvPr/>
         </p:nvSpPr>
@@ -8390,7 +8620,7 @@
       </p:sp>
       <p:sp>
         <p:nvSpPr>
-          <p:cNvPr id="81" name="Rounded Rectangle 80"/>
+          <p:cNvPr id="84" name="Rounded Rectangle 83"/>
           <p:cNvSpPr/>
           <p:nvPr/>
         </p:nvSpPr>
@@ -8479,7 +8709,7 @@
       </p:sp>
       <p:sp>
         <p:nvSpPr>
-          <p:cNvPr id="82" name="Down Arrow 81"/>
+          <p:cNvPr id="85" name="Down Arrow 84"/>
           <p:cNvSpPr/>
           <p:nvPr/>
         </p:nvSpPr>
@@ -8523,7 +8753,7 @@
       </p:sp>
       <p:sp>
         <p:nvSpPr>
-          <p:cNvPr id="83" name="Down Arrow 82"/>
+          <p:cNvPr id="86" name="Down Arrow 85"/>
           <p:cNvSpPr/>
           <p:nvPr/>
         </p:nvSpPr>
@@ -8567,7 +8797,7 @@
       </p:sp>
       <p:sp>
         <p:nvSpPr>
-          <p:cNvPr id="84" name="Down Arrow 83"/>
+          <p:cNvPr id="87" name="Down Arrow 86"/>
           <p:cNvSpPr/>
           <p:nvPr/>
         </p:nvSpPr>
@@ -8611,7 +8841,7 @@
       </p:sp>
       <p:sp>
         <p:nvSpPr>
-          <p:cNvPr id="85" name="Down Arrow 84"/>
+          <p:cNvPr id="88" name="Down Arrow 87"/>
           <p:cNvSpPr/>
           <p:nvPr/>
         </p:nvSpPr>
@@ -8655,7 +8885,7 @@
       </p:sp>
       <p:cxnSp>
         <p:nvCxnSpPr>
-          <p:cNvPr id="86" name="Connector 85"/>
+          <p:cNvPr id="89" name="Connector 88"/>
           <p:cNvCxnSpPr/>
           <p:nvPr/>
         </p:nvCxnSpPr>
@@ -8693,7 +8923,7 @@
       </p:cxnSp>
       <p:sp>
         <p:nvSpPr>
-          <p:cNvPr id="87" name="Rounded Rectangle 86"/>
+          <p:cNvPr id="90" name="Rounded Rectangle 89"/>
           <p:cNvSpPr/>
           <p:nvPr/>
         </p:nvSpPr>
@@ -8739,7 +8969,7 @@
       </p:sp>
       <p:sp>
         <p:nvSpPr>
-          <p:cNvPr id="88" name="Rectangle 87"/>
+          <p:cNvPr id="91" name="Rectangle 90"/>
           <p:cNvSpPr/>
           <p:nvPr/>
         </p:nvSpPr>
@@ -8783,7 +9013,7 @@
       </p:sp>
       <p:sp>
         <p:nvSpPr>
-          <p:cNvPr id="89" name="TextBox 88"/>
+          <p:cNvPr id="92" name="TextBox 91"/>
           <p:cNvSpPr txBox="1"/>
           <p:nvPr/>
         </p:nvSpPr>
@@ -8828,7 +9058,7 @@
       </p:sp>
       <p:sp>
         <p:nvSpPr>
-          <p:cNvPr id="90" name="Rounded Rectangle 89"/>
+          <p:cNvPr id="93" name="Rounded Rectangle 92"/>
           <p:cNvSpPr/>
           <p:nvPr/>
         </p:nvSpPr>
@@ -8917,7 +9147,7 @@
       </p:sp>
       <p:sp>
         <p:nvSpPr>
-          <p:cNvPr id="91" name="Rectangle 90"/>
+          <p:cNvPr id="94" name="Rectangle 93"/>
           <p:cNvSpPr/>
           <p:nvPr/>
         </p:nvSpPr>
@@ -8961,7 +9191,7 @@
       </p:sp>
       <p:sp>
         <p:nvSpPr>
-          <p:cNvPr id="92" name="Rounded Rectangle 91"/>
+          <p:cNvPr id="95" name="Rounded Rectangle 94"/>
           <p:cNvSpPr/>
           <p:nvPr/>
         </p:nvSpPr>
@@ -9050,7 +9280,7 @@
       </p:sp>
       <p:sp>
         <p:nvSpPr>
-          <p:cNvPr id="93" name="Rectangle 92"/>
+          <p:cNvPr id="96" name="Rectangle 95"/>
           <p:cNvSpPr/>
           <p:nvPr/>
         </p:nvSpPr>
@@ -9094,7 +9324,7 @@
       </p:sp>
       <p:sp>
         <p:nvSpPr>
-          <p:cNvPr id="94" name="Rounded Rectangle 93"/>
+          <p:cNvPr id="97" name="Rounded Rectangle 96"/>
           <p:cNvSpPr/>
           <p:nvPr/>
         </p:nvSpPr>
@@ -9183,7 +9413,7 @@
       </p:sp>
       <p:sp>
         <p:nvSpPr>
-          <p:cNvPr id="95" name="Rectangle 94"/>
+          <p:cNvPr id="98" name="Rectangle 97"/>
           <p:cNvSpPr/>
           <p:nvPr/>
         </p:nvSpPr>
@@ -9227,7 +9457,7 @@
       </p:sp>
       <p:sp>
         <p:nvSpPr>
-          <p:cNvPr id="96" name="Rounded Rectangle 95"/>
+          <p:cNvPr id="99" name="Rounded Rectangle 98"/>
           <p:cNvSpPr/>
           <p:nvPr/>
         </p:nvSpPr>
@@ -9316,7 +9546,7 @@
       </p:sp>
       <p:sp>
         <p:nvSpPr>
-          <p:cNvPr id="97" name="Rectangle 96"/>
+          <p:cNvPr id="100" name="Rectangle 99"/>
           <p:cNvSpPr/>
           <p:nvPr/>
         </p:nvSpPr>
@@ -9360,7 +9590,7 @@
       </p:sp>
       <p:sp>
         <p:nvSpPr>
-          <p:cNvPr id="98" name="Rounded Rectangle 97"/>
+          <p:cNvPr id="101" name="Rounded Rectangle 100"/>
           <p:cNvSpPr/>
           <p:nvPr/>
         </p:nvSpPr>
@@ -9449,7 +9679,7 @@
       </p:sp>
       <p:sp>
         <p:nvSpPr>
-          <p:cNvPr id="99" name="Rectangle 98"/>
+          <p:cNvPr id="102" name="Rectangle 101"/>
           <p:cNvSpPr/>
           <p:nvPr/>
         </p:nvSpPr>
@@ -9493,7 +9723,7 @@
       </p:sp>
       <p:sp>
         <p:nvSpPr>
-          <p:cNvPr id="100" name="TextBox 99"/>
+          <p:cNvPr id="103" name="TextBox 102"/>
           <p:cNvSpPr txBox="1"/>
           <p:nvPr/>
         </p:nvSpPr>

</xml_diff>

<commit_message>
docs: wire CSR decision layer (Approve/Reject/Escalate) to every agent in architecture slide
</commit_message>
<xml_diff>
--- a/demo/Order-Creation-Orchestration-Architecture.pptx
+++ b/demo/Order-Creation-Orchestration-Architecture.pptx
@@ -3415,7 +3415,7 @@
         <p:spPr>
           <a:xfrm>
             <a:off x="301752" y="1737360"/>
-            <a:ext cx="1225296" cy="384048"/>
+            <a:ext cx="1225296" cy="2578608"/>
           </a:xfrm>
           <a:prstGeom prst="roundRect">
             <a:avLst>
@@ -3466,7 +3466,7 @@
                 </a:solidFill>
                 <a:latin typeface="Segoe UI"/>
               </a:rPr>
-              <a:t>DECISION</a:t>
+              <a:t>ORCHESTRATION</a:t>
             </a:r>
           </a:p>
           <a:p>
@@ -3488,7 +3488,29 @@
                 </a:solidFill>
                 <a:latin typeface="Segoe UI"/>
               </a:rPr>
-              <a:t>LAYER</a:t>
+              <a:t>&amp; CSR</a:t>
+            </a:r>
+          </a:p>
+          <a:p>
+            <a:pPr algn="ctr">
+              <a:lnSpc>
+                <a:spcPct val="98000"/>
+              </a:lnSpc>
+              <a:spcBef>
+                <a:spcPts val="0"/>
+              </a:spcBef>
+              <a:spcAft>
+                <a:spcPts val="0"/>
+              </a:spcAft>
+            </a:pPr>
+            <a:r>
+              <a:rPr sz="830" b="1" i="0">
+                <a:solidFill>
+                  <a:srgbClr val="FFFFFF"/>
+                </a:solidFill>
+                <a:latin typeface="Segoe UI"/>
+              </a:rPr>
+              <a:t>DECISIONS</a:t>
             </a:r>
           </a:p>
         </p:txBody>
@@ -3502,13 +3524,13 @@
         <p:spPr>
           <a:xfrm>
             <a:off x="301752" y="1737360"/>
-            <a:ext cx="54864" cy="384048"/>
+            <a:ext cx="54864" cy="2578608"/>
           </a:xfrm>
           <a:prstGeom prst="rect">
             <a:avLst/>
           </a:prstGeom>
           <a:solidFill>
-            <a:srgbClr val="33C9C9"/>
+            <a:srgbClr val="FFE600"/>
           </a:solidFill>
           <a:ln>
             <a:noFill/>
@@ -3545,8 +3567,8 @@
         </p:nvSpPr>
         <p:spPr>
           <a:xfrm>
-            <a:off x="301752" y="2176272"/>
-            <a:ext cx="1225296" cy="2121408"/>
+            <a:off x="301752" y="4352544"/>
+            <a:ext cx="1225296" cy="365760"/>
           </a:xfrm>
           <a:prstGeom prst="roundRect">
             <a:avLst>
@@ -3597,9 +3619,96 @@
                 </a:solidFill>
                 <a:latin typeface="Segoe UI"/>
               </a:rPr>
-              <a:t>ORCHESTRATION</a:t>
-            </a:r>
-          </a:p>
+              <a:t>GOVERNANCE</a:t>
+            </a:r>
+          </a:p>
+        </p:txBody>
+      </p:sp>
+      <p:sp>
+        <p:nvSpPr>
+          <p:cNvPr id="11" name="Rectangle 10"/>
+          <p:cNvSpPr/>
+          <p:nvPr/>
+        </p:nvSpPr>
+        <p:spPr>
+          <a:xfrm>
+            <a:off x="301752" y="4352544"/>
+            <a:ext cx="54864" cy="365760"/>
+          </a:xfrm>
+          <a:prstGeom prst="rect">
+            <a:avLst/>
+          </a:prstGeom>
+          <a:solidFill>
+            <a:srgbClr val="FF5A5A"/>
+          </a:solidFill>
+          <a:ln>
+            <a:noFill/>
+          </a:ln>
+          <a:effectLst/>
+        </p:spPr>
+        <p:style>
+          <a:lnRef idx="1">
+            <a:schemeClr val="accent1"/>
+          </a:lnRef>
+          <a:fillRef idx="3">
+            <a:schemeClr val="accent1"/>
+          </a:fillRef>
+          <a:effectRef idx="2">
+            <a:schemeClr val="accent1"/>
+          </a:effectRef>
+          <a:fontRef idx="minor">
+            <a:schemeClr val="lt1"/>
+          </a:fontRef>
+        </p:style>
+        <p:txBody>
+          <a:bodyPr rtlCol="0" anchor="ctr" wrap="square"/>
+          <a:lstStyle/>
+          <a:p>
+            <a:pPr algn="ctr"/>
+          </a:p>
+        </p:txBody>
+      </p:sp>
+      <p:sp>
+        <p:nvSpPr>
+          <p:cNvPr id="12" name="Rounded Rectangle 11"/>
+          <p:cNvSpPr/>
+          <p:nvPr/>
+        </p:nvSpPr>
+        <p:spPr>
+          <a:xfrm>
+            <a:off x="301752" y="4773168"/>
+            <a:ext cx="1225296" cy="786384"/>
+          </a:xfrm>
+          <a:prstGeom prst="roundRect">
+            <a:avLst>
+              <a:gd name="adj" fmla="val 6000"/>
+            </a:avLst>
+          </a:prstGeom>
+          <a:solidFill>
+            <a:srgbClr val="222230"/>
+          </a:solidFill>
+          <a:ln>
+            <a:noFill/>
+          </a:ln>
+          <a:effectLst/>
+        </p:spPr>
+        <p:style>
+          <a:lnRef idx="1">
+            <a:schemeClr val="accent1"/>
+          </a:lnRef>
+          <a:fillRef idx="3">
+            <a:schemeClr val="accent1"/>
+          </a:fillRef>
+          <a:effectRef idx="2">
+            <a:schemeClr val="accent1"/>
+          </a:effectRef>
+          <a:fontRef idx="minor">
+            <a:schemeClr val="lt1"/>
+          </a:fontRef>
+        </p:style>
+        <p:txBody>
+          <a:bodyPr rtlCol="0" anchor="ctr" wrap="square" lIns="27432" rIns="27432" tIns="9144" bIns="9144"/>
+          <a:lstStyle/>
           <a:p>
             <a:pPr algn="ctr">
               <a:lnSpc>
@@ -3619,27 +3728,49 @@
                 </a:solidFill>
                 <a:latin typeface="Segoe UI"/>
               </a:rPr>
-              <a:t>AGENT TEAM</a:t>
-            </a:r>
-          </a:p>
-        </p:txBody>
-      </p:sp>
-      <p:sp>
-        <p:nvSpPr>
-          <p:cNvPr id="11" name="Rectangle 10"/>
+              <a:t>ORDER CREATION</a:t>
+            </a:r>
+          </a:p>
+          <a:p>
+            <a:pPr algn="ctr">
+              <a:lnSpc>
+                <a:spcPct val="98000"/>
+              </a:lnSpc>
+              <a:spcBef>
+                <a:spcPts val="0"/>
+              </a:spcBef>
+              <a:spcAft>
+                <a:spcPts val="0"/>
+              </a:spcAft>
+            </a:pPr>
+            <a:r>
+              <a:rPr sz="830" b="1" i="0">
+                <a:solidFill>
+                  <a:srgbClr val="FFFFFF"/>
+                </a:solidFill>
+                <a:latin typeface="Segoe UI"/>
+              </a:rPr>
+              <a:t>&amp; DOWNSTREAM</a:t>
+            </a:r>
+          </a:p>
+        </p:txBody>
+      </p:sp>
+      <p:sp>
+        <p:nvSpPr>
+          <p:cNvPr id="13" name="Rectangle 12"/>
           <p:cNvSpPr/>
           <p:nvPr/>
         </p:nvSpPr>
         <p:spPr>
           <a:xfrm>
-            <a:off x="301752" y="2176272"/>
-            <a:ext cx="54864" cy="2121408"/>
+            <a:off x="301752" y="4773168"/>
+            <a:ext cx="54864" cy="786384"/>
           </a:xfrm>
           <a:prstGeom prst="rect">
             <a:avLst/>
           </a:prstGeom>
           <a:solidFill>
-            <a:srgbClr val="FFE600"/>
+            <a:srgbClr val="35C759"/>
           </a:solidFill>
           <a:ln>
             <a:noFill/>
@@ -3670,14 +3801,14 @@
       </p:sp>
       <p:sp>
         <p:nvSpPr>
-          <p:cNvPr id="12" name="Rounded Rectangle 11"/>
+          <p:cNvPr id="14" name="Rounded Rectangle 13"/>
           <p:cNvSpPr/>
           <p:nvPr/>
         </p:nvSpPr>
         <p:spPr>
           <a:xfrm>
-            <a:off x="301752" y="4352544"/>
-            <a:ext cx="1225296" cy="365760"/>
+            <a:off x="301752" y="5614416"/>
+            <a:ext cx="1225296" cy="841248"/>
           </a:xfrm>
           <a:prstGeom prst="roundRect">
             <a:avLst>
@@ -3728,27 +3859,49 @@
                 </a:solidFill>
                 <a:latin typeface="Segoe UI"/>
               </a:rPr>
-              <a:t>GOVERNANCE</a:t>
-            </a:r>
-          </a:p>
-        </p:txBody>
-      </p:sp>
-      <p:sp>
-        <p:nvSpPr>
-          <p:cNvPr id="13" name="Rectangle 12"/>
+              <a:t>DATA</a:t>
+            </a:r>
+          </a:p>
+          <a:p>
+            <a:pPr algn="ctr">
+              <a:lnSpc>
+                <a:spcPct val="98000"/>
+              </a:lnSpc>
+              <a:spcBef>
+                <a:spcPts val="0"/>
+              </a:spcBef>
+              <a:spcAft>
+                <a:spcPts val="0"/>
+              </a:spcAft>
+            </a:pPr>
+            <a:r>
+              <a:rPr sz="830" b="1" i="0">
+                <a:solidFill>
+                  <a:srgbClr val="FFFFFF"/>
+                </a:solidFill>
+                <a:latin typeface="Segoe UI"/>
+              </a:rPr>
+              <a:t>FOUNDATION</a:t>
+            </a:r>
+          </a:p>
+        </p:txBody>
+      </p:sp>
+      <p:sp>
+        <p:nvSpPr>
+          <p:cNvPr id="15" name="Rectangle 14"/>
           <p:cNvSpPr/>
           <p:nvPr/>
         </p:nvSpPr>
         <p:spPr>
           <a:xfrm>
-            <a:off x="301752" y="4352544"/>
-            <a:ext cx="54864" cy="365760"/>
+            <a:off x="301752" y="5614416"/>
+            <a:ext cx="54864" cy="841248"/>
           </a:xfrm>
           <a:prstGeom prst="rect">
             <a:avLst/>
           </a:prstGeom>
           <a:solidFill>
-            <a:srgbClr val="FF5A5A"/>
+            <a:srgbClr val="A97BFF"/>
           </a:solidFill>
           <a:ln>
             <a:noFill/>
@@ -3779,269 +3932,7 @@
       </p:sp>
       <p:sp>
         <p:nvSpPr>
-          <p:cNvPr id="14" name="Rounded Rectangle 13"/>
-          <p:cNvSpPr/>
-          <p:nvPr/>
-        </p:nvSpPr>
-        <p:spPr>
-          <a:xfrm>
-            <a:off x="301752" y="4773168"/>
-            <a:ext cx="1225296" cy="786384"/>
-          </a:xfrm>
-          <a:prstGeom prst="roundRect">
-            <a:avLst>
-              <a:gd name="adj" fmla="val 6000"/>
-            </a:avLst>
-          </a:prstGeom>
-          <a:solidFill>
-            <a:srgbClr val="222230"/>
-          </a:solidFill>
-          <a:ln>
-            <a:noFill/>
-          </a:ln>
-          <a:effectLst/>
-        </p:spPr>
-        <p:style>
-          <a:lnRef idx="1">
-            <a:schemeClr val="accent1"/>
-          </a:lnRef>
-          <a:fillRef idx="3">
-            <a:schemeClr val="accent1"/>
-          </a:fillRef>
-          <a:effectRef idx="2">
-            <a:schemeClr val="accent1"/>
-          </a:effectRef>
-          <a:fontRef idx="minor">
-            <a:schemeClr val="lt1"/>
-          </a:fontRef>
-        </p:style>
-        <p:txBody>
-          <a:bodyPr rtlCol="0" anchor="ctr" wrap="square" lIns="27432" rIns="27432" tIns="9144" bIns="9144"/>
-          <a:lstStyle/>
-          <a:p>
-            <a:pPr algn="ctr">
-              <a:lnSpc>
-                <a:spcPct val="98000"/>
-              </a:lnSpc>
-              <a:spcBef>
-                <a:spcPts val="0"/>
-              </a:spcBef>
-              <a:spcAft>
-                <a:spcPts val="0"/>
-              </a:spcAft>
-            </a:pPr>
-            <a:r>
-              <a:rPr sz="830" b="1" i="0">
-                <a:solidFill>
-                  <a:srgbClr val="FFFFFF"/>
-                </a:solidFill>
-                <a:latin typeface="Segoe UI"/>
-              </a:rPr>
-              <a:t>ORDER CREATION</a:t>
-            </a:r>
-          </a:p>
-          <a:p>
-            <a:pPr algn="ctr">
-              <a:lnSpc>
-                <a:spcPct val="98000"/>
-              </a:lnSpc>
-              <a:spcBef>
-                <a:spcPts val="0"/>
-              </a:spcBef>
-              <a:spcAft>
-                <a:spcPts val="0"/>
-              </a:spcAft>
-            </a:pPr>
-            <a:r>
-              <a:rPr sz="830" b="1" i="0">
-                <a:solidFill>
-                  <a:srgbClr val="FFFFFF"/>
-                </a:solidFill>
-                <a:latin typeface="Segoe UI"/>
-              </a:rPr>
-              <a:t>&amp; DOWNSTREAM</a:t>
-            </a:r>
-          </a:p>
-        </p:txBody>
-      </p:sp>
-      <p:sp>
-        <p:nvSpPr>
-          <p:cNvPr id="15" name="Rectangle 14"/>
-          <p:cNvSpPr/>
-          <p:nvPr/>
-        </p:nvSpPr>
-        <p:spPr>
-          <a:xfrm>
-            <a:off x="301752" y="4773168"/>
-            <a:ext cx="54864" cy="786384"/>
-          </a:xfrm>
-          <a:prstGeom prst="rect">
-            <a:avLst/>
-          </a:prstGeom>
-          <a:solidFill>
-            <a:srgbClr val="35C759"/>
-          </a:solidFill>
-          <a:ln>
-            <a:noFill/>
-          </a:ln>
-          <a:effectLst/>
-        </p:spPr>
-        <p:style>
-          <a:lnRef idx="1">
-            <a:schemeClr val="accent1"/>
-          </a:lnRef>
-          <a:fillRef idx="3">
-            <a:schemeClr val="accent1"/>
-          </a:fillRef>
-          <a:effectRef idx="2">
-            <a:schemeClr val="accent1"/>
-          </a:effectRef>
-          <a:fontRef idx="minor">
-            <a:schemeClr val="lt1"/>
-          </a:fontRef>
-        </p:style>
-        <p:txBody>
-          <a:bodyPr rtlCol="0" anchor="ctr" wrap="square"/>
-          <a:lstStyle/>
-          <a:p>
-            <a:pPr algn="ctr"/>
-          </a:p>
-        </p:txBody>
-      </p:sp>
-      <p:sp>
-        <p:nvSpPr>
-          <p:cNvPr id="16" name="Rounded Rectangle 15"/>
-          <p:cNvSpPr/>
-          <p:nvPr/>
-        </p:nvSpPr>
-        <p:spPr>
-          <a:xfrm>
-            <a:off x="301752" y="5614416"/>
-            <a:ext cx="1225296" cy="841248"/>
-          </a:xfrm>
-          <a:prstGeom prst="roundRect">
-            <a:avLst>
-              <a:gd name="adj" fmla="val 6000"/>
-            </a:avLst>
-          </a:prstGeom>
-          <a:solidFill>
-            <a:srgbClr val="222230"/>
-          </a:solidFill>
-          <a:ln>
-            <a:noFill/>
-          </a:ln>
-          <a:effectLst/>
-        </p:spPr>
-        <p:style>
-          <a:lnRef idx="1">
-            <a:schemeClr val="accent1"/>
-          </a:lnRef>
-          <a:fillRef idx="3">
-            <a:schemeClr val="accent1"/>
-          </a:fillRef>
-          <a:effectRef idx="2">
-            <a:schemeClr val="accent1"/>
-          </a:effectRef>
-          <a:fontRef idx="minor">
-            <a:schemeClr val="lt1"/>
-          </a:fontRef>
-        </p:style>
-        <p:txBody>
-          <a:bodyPr rtlCol="0" anchor="ctr" wrap="square" lIns="27432" rIns="27432" tIns="9144" bIns="9144"/>
-          <a:lstStyle/>
-          <a:p>
-            <a:pPr algn="ctr">
-              <a:lnSpc>
-                <a:spcPct val="98000"/>
-              </a:lnSpc>
-              <a:spcBef>
-                <a:spcPts val="0"/>
-              </a:spcBef>
-              <a:spcAft>
-                <a:spcPts val="0"/>
-              </a:spcAft>
-            </a:pPr>
-            <a:r>
-              <a:rPr sz="830" b="1" i="0">
-                <a:solidFill>
-                  <a:srgbClr val="FFFFFF"/>
-                </a:solidFill>
-                <a:latin typeface="Segoe UI"/>
-              </a:rPr>
-              <a:t>DATA</a:t>
-            </a:r>
-          </a:p>
-          <a:p>
-            <a:pPr algn="ctr">
-              <a:lnSpc>
-                <a:spcPct val="98000"/>
-              </a:lnSpc>
-              <a:spcBef>
-                <a:spcPts val="0"/>
-              </a:spcBef>
-              <a:spcAft>
-                <a:spcPts val="0"/>
-              </a:spcAft>
-            </a:pPr>
-            <a:r>
-              <a:rPr sz="830" b="1" i="0">
-                <a:solidFill>
-                  <a:srgbClr val="FFFFFF"/>
-                </a:solidFill>
-                <a:latin typeface="Segoe UI"/>
-              </a:rPr>
-              <a:t>FOUNDATION</a:t>
-            </a:r>
-          </a:p>
-        </p:txBody>
-      </p:sp>
-      <p:sp>
-        <p:nvSpPr>
-          <p:cNvPr id="17" name="Rectangle 16"/>
-          <p:cNvSpPr/>
-          <p:nvPr/>
-        </p:nvSpPr>
-        <p:spPr>
-          <a:xfrm>
-            <a:off x="301752" y="5614416"/>
-            <a:ext cx="54864" cy="841248"/>
-          </a:xfrm>
-          <a:prstGeom prst="rect">
-            <a:avLst/>
-          </a:prstGeom>
-          <a:solidFill>
-            <a:srgbClr val="A97BFF"/>
-          </a:solidFill>
-          <a:ln>
-            <a:noFill/>
-          </a:ln>
-          <a:effectLst/>
-        </p:spPr>
-        <p:style>
-          <a:lnRef idx="1">
-            <a:schemeClr val="accent1"/>
-          </a:lnRef>
-          <a:fillRef idx="3">
-            <a:schemeClr val="accent1"/>
-          </a:fillRef>
-          <a:effectRef idx="2">
-            <a:schemeClr val="accent1"/>
-          </a:effectRef>
-          <a:fontRef idx="minor">
-            <a:schemeClr val="lt1"/>
-          </a:fontRef>
-        </p:style>
-        <p:txBody>
-          <a:bodyPr rtlCol="0" anchor="ctr" wrap="square"/>
-          <a:lstStyle/>
-          <a:p>
-            <a:pPr algn="ctr"/>
-          </a:p>
-        </p:txBody>
-      </p:sp>
-      <p:sp>
-        <p:nvSpPr>
-          <p:cNvPr id="18" name="TextBox 17"/>
+          <p:cNvPr id="16" name="TextBox 15"/>
           <p:cNvSpPr txBox="1"/>
           <p:nvPr/>
         </p:nvSpPr>
@@ -4104,7 +3995,7 @@
       </p:sp>
       <p:sp>
         <p:nvSpPr>
-          <p:cNvPr id="19" name="Rounded Rectangle 18"/>
+          <p:cNvPr id="17" name="Rounded Rectangle 16"/>
           <p:cNvSpPr/>
           <p:nvPr/>
         </p:nvSpPr>
@@ -4152,7 +4043,7 @@
       </p:sp>
       <p:sp>
         <p:nvSpPr>
-          <p:cNvPr id="20" name="Rectangle 19"/>
+          <p:cNvPr id="18" name="Rectangle 17"/>
           <p:cNvSpPr/>
           <p:nvPr/>
         </p:nvSpPr>
@@ -4196,7 +4087,7 @@
       </p:sp>
       <p:sp>
         <p:nvSpPr>
-          <p:cNvPr id="21" name="TextBox 20"/>
+          <p:cNvPr id="19" name="TextBox 18"/>
           <p:cNvSpPr txBox="1"/>
           <p:nvPr/>
         </p:nvSpPr>
@@ -4241,7 +4132,7 @@
       </p:sp>
       <p:sp>
         <p:nvSpPr>
-          <p:cNvPr id="22" name="TextBox 21"/>
+          <p:cNvPr id="20" name="TextBox 19"/>
           <p:cNvSpPr txBox="1"/>
           <p:nvPr/>
         </p:nvSpPr>
@@ -4330,7 +4221,7 @@
       </p:sp>
       <p:sp>
         <p:nvSpPr>
-          <p:cNvPr id="23" name="Chevron 22"/>
+          <p:cNvPr id="21" name="Chevron 20"/>
           <p:cNvSpPr/>
           <p:nvPr/>
         </p:nvSpPr>
@@ -4374,7 +4265,7 @@
       </p:sp>
       <p:sp>
         <p:nvSpPr>
-          <p:cNvPr id="24" name="Rounded Rectangle 23"/>
+          <p:cNvPr id="22" name="Rounded Rectangle 21"/>
           <p:cNvSpPr/>
           <p:nvPr/>
         </p:nvSpPr>
@@ -4422,7 +4313,7 @@
       </p:sp>
       <p:sp>
         <p:nvSpPr>
-          <p:cNvPr id="25" name="Rectangle 24"/>
+          <p:cNvPr id="23" name="Rectangle 22"/>
           <p:cNvSpPr/>
           <p:nvPr/>
         </p:nvSpPr>
@@ -4466,7 +4357,7 @@
       </p:sp>
       <p:sp>
         <p:nvSpPr>
-          <p:cNvPr id="26" name="TextBox 25"/>
+          <p:cNvPr id="24" name="TextBox 23"/>
           <p:cNvSpPr txBox="1"/>
           <p:nvPr/>
         </p:nvSpPr>
@@ -4511,7 +4402,7 @@
       </p:sp>
       <p:sp>
         <p:nvSpPr>
-          <p:cNvPr id="27" name="TextBox 26"/>
+          <p:cNvPr id="25" name="TextBox 24"/>
           <p:cNvSpPr txBox="1"/>
           <p:nvPr/>
         </p:nvSpPr>
@@ -4565,90 +4456,14 @@
       </p:sp>
       <p:sp>
         <p:nvSpPr>
-          <p:cNvPr id="28" name="Rounded Rectangle 27"/>
+          <p:cNvPr id="26" name="Rounded Rectangle 25"/>
           <p:cNvSpPr/>
           <p:nvPr/>
         </p:nvSpPr>
         <p:spPr>
           <a:xfrm>
             <a:off x="1664208" y="1737360"/>
-            <a:ext cx="8394192" cy="384048"/>
-          </a:xfrm>
-          <a:prstGeom prst="roundRect">
-            <a:avLst>
-              <a:gd name="adj" fmla="val 6000"/>
-            </a:avLst>
-          </a:prstGeom>
-          <a:solidFill>
-            <a:srgbClr val="2E2E40"/>
-          </a:solidFill>
-          <a:ln w="12700">
-            <a:solidFill>
-              <a:srgbClr val="33C9C9"/>
-            </a:solidFill>
-          </a:ln>
-          <a:effectLst/>
-        </p:spPr>
-        <p:style>
-          <a:lnRef idx="1">
-            <a:schemeClr val="accent1"/>
-          </a:lnRef>
-          <a:fillRef idx="3">
-            <a:schemeClr val="accent1"/>
-          </a:fillRef>
-          <a:effectRef idx="2">
-            <a:schemeClr val="accent1"/>
-          </a:effectRef>
-          <a:fontRef idx="minor">
-            <a:schemeClr val="lt1"/>
-          </a:fontRef>
-        </p:style>
-        <p:txBody>
-          <a:bodyPr rtlCol="0" anchor="ctr" wrap="square" lIns="27432" rIns="27432" tIns="9144" bIns="9144"/>
-          <a:lstStyle/>
-          <a:p>
-            <a:pPr algn="ctr">
-              <a:lnSpc>
-                <a:spcPct val="100000"/>
-              </a:lnSpc>
-              <a:spcBef>
-                <a:spcPts val="0"/>
-              </a:spcBef>
-              <a:spcAft>
-                <a:spcPts val="0"/>
-              </a:spcAft>
-            </a:pPr>
-            <a:r>
-              <a:rPr sz="950" b="1" i="0">
-                <a:solidFill>
-                  <a:srgbClr val="FFFFFF"/>
-                </a:solidFill>
-                <a:latin typeface="Segoe UI"/>
-              </a:rPr>
-              <a:t>DECISION LAYER  </a:t>
-            </a:r>
-            <a:r>
-              <a:rPr sz="800" b="0" i="0">
-                <a:solidFill>
-                  <a:srgbClr val="C2C2D0"/>
-                </a:solidFill>
-                <a:latin typeface="Segoe UI"/>
-              </a:rPr>
-              <a:t>· Approve · Reject · Escalate</a:t>
-            </a:r>
-          </a:p>
-        </p:txBody>
-      </p:sp>
-      <p:sp>
-        <p:nvSpPr>
-          <p:cNvPr id="29" name="Rounded Rectangle 28"/>
-          <p:cNvSpPr/>
-          <p:nvPr/>
-        </p:nvSpPr>
-        <p:spPr>
-          <a:xfrm>
-            <a:off x="1664208" y="2176272"/>
-            <a:ext cx="8394192" cy="2121408"/>
+            <a:ext cx="8394192" cy="2578608"/>
           </a:xfrm>
           <a:prstGeom prst="roundRect">
             <a:avLst>
@@ -4689,14 +4504,14 @@
       </p:sp>
       <p:sp>
         <p:nvSpPr>
-          <p:cNvPr id="30" name="Rounded Rectangle 29"/>
+          <p:cNvPr id="27" name="Rounded Rectangle 26"/>
           <p:cNvSpPr/>
           <p:nvPr/>
         </p:nvSpPr>
         <p:spPr>
           <a:xfrm>
-            <a:off x="1773936" y="2231136"/>
-            <a:ext cx="8174736" cy="365760"/>
+            <a:off x="1773936" y="1792224"/>
+            <a:ext cx="8174736" cy="329184"/>
           </a:xfrm>
           <a:prstGeom prst="roundRect">
             <a:avLst>
@@ -4752,26 +4567,26 @@
               <a:t>🤖  ORCHESTRATOR  </a:t>
             </a:r>
             <a:r>
-              <a:rPr sz="740" b="0" i="0">
+              <a:rPr sz="730" b="0" i="0">
                 <a:solidFill>
                   <a:srgbClr val="C2C2D0"/>
                 </a:solidFill>
                 <a:latin typeface="Segoe UI"/>
               </a:rPr>
-              <a:t>coordinates a team of specialist AI agents over a shared context · resumable pipeline / state machine · pauses on exception, resumes on CSR decision · Approvals runs last</a:t>
-            </a:r>
-          </a:p>
-        </p:txBody>
-      </p:sp>
-      <p:sp>
-        <p:nvSpPr>
-          <p:cNvPr id="31" name="Down Arrow 30"/>
+              <a:t>coordinates a team of specialist AI agents over a shared context · resumable pipeline / state machine · Approvals runs last</a:t>
+            </a:r>
+          </a:p>
+        </p:txBody>
+      </p:sp>
+      <p:sp>
+        <p:nvSpPr>
+          <p:cNvPr id="28" name="Down Arrow 27"/>
           <p:cNvSpPr/>
           <p:nvPr/>
         </p:nvSpPr>
         <p:spPr>
           <a:xfrm>
-            <a:off x="5733288" y="2606039"/>
+            <a:off x="5733288" y="2139696"/>
             <a:ext cx="256032" cy="109728"/>
           </a:xfrm>
           <a:prstGeom prst="downArrow">
@@ -4809,13 +4624,13 @@
       </p:sp>
       <p:sp>
         <p:nvSpPr>
-          <p:cNvPr id="32" name="Rounded Rectangle 31"/>
+          <p:cNvPr id="29" name="Rounded Rectangle 28"/>
           <p:cNvSpPr/>
           <p:nvPr/>
         </p:nvSpPr>
         <p:spPr>
           <a:xfrm>
-            <a:off x="1773936" y="2798064"/>
+            <a:off x="1773936" y="2304288"/>
             <a:ext cx="949832" cy="932688"/>
           </a:xfrm>
           <a:prstGeom prst="roundRect">
@@ -4951,13 +4766,13 @@
       </p:sp>
       <p:sp>
         <p:nvSpPr>
-          <p:cNvPr id="33" name="Rectangle 32"/>
+          <p:cNvPr id="30" name="Rectangle 29"/>
           <p:cNvSpPr/>
           <p:nvPr/>
         </p:nvSpPr>
         <p:spPr>
           <a:xfrm>
-            <a:off x="1773936" y="2798064"/>
+            <a:off x="1773936" y="2304288"/>
             <a:ext cx="949832" cy="36576"/>
           </a:xfrm>
           <a:prstGeom prst="rect">
@@ -4995,13 +4810,13 @@
       </p:sp>
       <p:sp>
         <p:nvSpPr>
-          <p:cNvPr id="34" name="Chevron 33"/>
+          <p:cNvPr id="31" name="Chevron 30"/>
           <p:cNvSpPr/>
           <p:nvPr/>
         </p:nvSpPr>
         <p:spPr>
           <a:xfrm>
-            <a:off x="2705481" y="3182112"/>
+            <a:off x="2705481" y="2688336"/>
             <a:ext cx="128016" cy="164592"/>
           </a:xfrm>
           <a:prstGeom prst="chevron">
@@ -5039,13 +4854,13 @@
       </p:sp>
       <p:sp>
         <p:nvSpPr>
-          <p:cNvPr id="35" name="Rounded Rectangle 34"/>
+          <p:cNvPr id="32" name="Rounded Rectangle 31"/>
           <p:cNvSpPr/>
           <p:nvPr/>
         </p:nvSpPr>
         <p:spPr>
           <a:xfrm>
-            <a:off x="2806064" y="2798064"/>
+            <a:off x="2806064" y="2304288"/>
             <a:ext cx="949832" cy="932688"/>
           </a:xfrm>
           <a:prstGeom prst="roundRect">
@@ -5181,13 +4996,13 @@
       </p:sp>
       <p:sp>
         <p:nvSpPr>
-          <p:cNvPr id="36" name="Rectangle 35"/>
+          <p:cNvPr id="33" name="Rectangle 32"/>
           <p:cNvSpPr/>
           <p:nvPr/>
         </p:nvSpPr>
         <p:spPr>
           <a:xfrm>
-            <a:off x="2806064" y="2798064"/>
+            <a:off x="2806064" y="2304288"/>
             <a:ext cx="949832" cy="36576"/>
           </a:xfrm>
           <a:prstGeom prst="rect">
@@ -5225,13 +5040,13 @@
       </p:sp>
       <p:sp>
         <p:nvSpPr>
-          <p:cNvPr id="37" name="Chevron 36"/>
+          <p:cNvPr id="34" name="Chevron 33"/>
           <p:cNvSpPr/>
           <p:nvPr/>
         </p:nvSpPr>
         <p:spPr>
           <a:xfrm>
-            <a:off x="3737610" y="3182112"/>
+            <a:off x="3737610" y="2688336"/>
             <a:ext cx="128016" cy="164592"/>
           </a:xfrm>
           <a:prstGeom prst="chevron">
@@ -5269,13 +5084,13 @@
       </p:sp>
       <p:sp>
         <p:nvSpPr>
-          <p:cNvPr id="38" name="Rounded Rectangle 37"/>
+          <p:cNvPr id="35" name="Rounded Rectangle 34"/>
           <p:cNvSpPr/>
           <p:nvPr/>
         </p:nvSpPr>
         <p:spPr>
           <a:xfrm>
-            <a:off x="3838194" y="2798064"/>
+            <a:off x="3838194" y="2304288"/>
             <a:ext cx="949832" cy="932688"/>
           </a:xfrm>
           <a:prstGeom prst="roundRect">
@@ -5411,13 +5226,13 @@
       </p:sp>
       <p:sp>
         <p:nvSpPr>
-          <p:cNvPr id="39" name="Rectangle 38"/>
+          <p:cNvPr id="36" name="Rectangle 35"/>
           <p:cNvSpPr/>
           <p:nvPr/>
         </p:nvSpPr>
         <p:spPr>
           <a:xfrm>
-            <a:off x="3838194" y="2798064"/>
+            <a:off x="3838194" y="2304288"/>
             <a:ext cx="949832" cy="36576"/>
           </a:xfrm>
           <a:prstGeom prst="rect">
@@ -5455,13 +5270,13 @@
       </p:sp>
       <p:sp>
         <p:nvSpPr>
-          <p:cNvPr id="40" name="Chevron 39"/>
+          <p:cNvPr id="37" name="Chevron 36"/>
           <p:cNvSpPr/>
           <p:nvPr/>
         </p:nvSpPr>
         <p:spPr>
           <a:xfrm>
-            <a:off x="4769739" y="3182112"/>
+            <a:off x="4769739" y="2688336"/>
             <a:ext cx="128016" cy="164592"/>
           </a:xfrm>
           <a:prstGeom prst="chevron">
@@ -5499,13 +5314,13 @@
       </p:sp>
       <p:sp>
         <p:nvSpPr>
-          <p:cNvPr id="41" name="Rounded Rectangle 40"/>
+          <p:cNvPr id="38" name="Rounded Rectangle 37"/>
           <p:cNvSpPr/>
           <p:nvPr/>
         </p:nvSpPr>
         <p:spPr>
           <a:xfrm>
-            <a:off x="4870323" y="2798064"/>
+            <a:off x="4870323" y="2304288"/>
             <a:ext cx="949832" cy="932688"/>
           </a:xfrm>
           <a:prstGeom prst="roundRect">
@@ -5641,13 +5456,13 @@
       </p:sp>
       <p:sp>
         <p:nvSpPr>
-          <p:cNvPr id="42" name="Rectangle 41"/>
+          <p:cNvPr id="39" name="Rectangle 38"/>
           <p:cNvSpPr/>
           <p:nvPr/>
         </p:nvSpPr>
         <p:spPr>
           <a:xfrm>
-            <a:off x="4870323" y="2798064"/>
+            <a:off x="4870323" y="2304288"/>
             <a:ext cx="949832" cy="36576"/>
           </a:xfrm>
           <a:prstGeom prst="rect">
@@ -5685,13 +5500,13 @@
       </p:sp>
       <p:sp>
         <p:nvSpPr>
-          <p:cNvPr id="43" name="Chevron 42"/>
+          <p:cNvPr id="40" name="Chevron 39"/>
           <p:cNvSpPr/>
           <p:nvPr/>
         </p:nvSpPr>
         <p:spPr>
           <a:xfrm>
-            <a:off x="5801868" y="3182112"/>
+            <a:off x="5801868" y="2688336"/>
             <a:ext cx="128016" cy="164592"/>
           </a:xfrm>
           <a:prstGeom prst="chevron">
@@ -5729,13 +5544,13 @@
       </p:sp>
       <p:sp>
         <p:nvSpPr>
-          <p:cNvPr id="44" name="Rounded Rectangle 43"/>
+          <p:cNvPr id="41" name="Rounded Rectangle 40"/>
           <p:cNvSpPr/>
           <p:nvPr/>
         </p:nvSpPr>
         <p:spPr>
           <a:xfrm>
-            <a:off x="5902452" y="2798064"/>
+            <a:off x="5902452" y="2304288"/>
             <a:ext cx="949832" cy="932688"/>
           </a:xfrm>
           <a:prstGeom prst="roundRect">
@@ -5871,13 +5686,13 @@
       </p:sp>
       <p:sp>
         <p:nvSpPr>
-          <p:cNvPr id="45" name="Rectangle 44"/>
+          <p:cNvPr id="42" name="Rectangle 41"/>
           <p:cNvSpPr/>
           <p:nvPr/>
         </p:nvSpPr>
         <p:spPr>
           <a:xfrm>
-            <a:off x="5902452" y="2798064"/>
+            <a:off x="5902452" y="2304288"/>
             <a:ext cx="949832" cy="36576"/>
           </a:xfrm>
           <a:prstGeom prst="rect">
@@ -5915,13 +5730,13 @@
       </p:sp>
       <p:sp>
         <p:nvSpPr>
-          <p:cNvPr id="46" name="Chevron 45"/>
+          <p:cNvPr id="43" name="Chevron 42"/>
           <p:cNvSpPr/>
           <p:nvPr/>
         </p:nvSpPr>
         <p:spPr>
           <a:xfrm>
-            <a:off x="6833997" y="3182112"/>
+            <a:off x="6833997" y="2688336"/>
             <a:ext cx="128016" cy="164592"/>
           </a:xfrm>
           <a:prstGeom prst="chevron">
@@ -5959,13 +5774,13 @@
       </p:sp>
       <p:sp>
         <p:nvSpPr>
-          <p:cNvPr id="47" name="Rounded Rectangle 46"/>
+          <p:cNvPr id="44" name="Rounded Rectangle 43"/>
           <p:cNvSpPr/>
           <p:nvPr/>
         </p:nvSpPr>
         <p:spPr>
           <a:xfrm>
-            <a:off x="6934581" y="2798064"/>
+            <a:off x="6934581" y="2304288"/>
             <a:ext cx="949832" cy="932688"/>
           </a:xfrm>
           <a:prstGeom prst="roundRect">
@@ -6101,13 +5916,13 @@
       </p:sp>
       <p:sp>
         <p:nvSpPr>
-          <p:cNvPr id="48" name="Rectangle 47"/>
+          <p:cNvPr id="45" name="Rectangle 44"/>
           <p:cNvSpPr/>
           <p:nvPr/>
         </p:nvSpPr>
         <p:spPr>
           <a:xfrm>
-            <a:off x="6934581" y="2798064"/>
+            <a:off x="6934581" y="2304288"/>
             <a:ext cx="949832" cy="36576"/>
           </a:xfrm>
           <a:prstGeom prst="rect">
@@ -6145,13 +5960,13 @@
       </p:sp>
       <p:sp>
         <p:nvSpPr>
-          <p:cNvPr id="49" name="Chevron 48"/>
+          <p:cNvPr id="46" name="Chevron 45"/>
           <p:cNvSpPr/>
           <p:nvPr/>
         </p:nvSpPr>
         <p:spPr>
           <a:xfrm>
-            <a:off x="7866126" y="3182112"/>
+            <a:off x="7866126" y="2688336"/>
             <a:ext cx="128016" cy="164592"/>
           </a:xfrm>
           <a:prstGeom prst="chevron">
@@ -6189,13 +6004,13 @@
       </p:sp>
       <p:sp>
         <p:nvSpPr>
-          <p:cNvPr id="50" name="Rounded Rectangle 49"/>
+          <p:cNvPr id="47" name="Rounded Rectangle 46"/>
           <p:cNvSpPr/>
           <p:nvPr/>
         </p:nvSpPr>
         <p:spPr>
           <a:xfrm>
-            <a:off x="7966709" y="2798064"/>
+            <a:off x="7966709" y="2304288"/>
             <a:ext cx="949832" cy="932688"/>
           </a:xfrm>
           <a:prstGeom prst="roundRect">
@@ -6331,13 +6146,13 @@
       </p:sp>
       <p:sp>
         <p:nvSpPr>
-          <p:cNvPr id="51" name="Rectangle 50"/>
+          <p:cNvPr id="48" name="Rectangle 47"/>
           <p:cNvSpPr/>
           <p:nvPr/>
         </p:nvSpPr>
         <p:spPr>
           <a:xfrm>
-            <a:off x="7966709" y="2798064"/>
+            <a:off x="7966709" y="2304288"/>
             <a:ext cx="949832" cy="36576"/>
           </a:xfrm>
           <a:prstGeom prst="rect">
@@ -6375,13 +6190,13 @@
       </p:sp>
       <p:sp>
         <p:nvSpPr>
-          <p:cNvPr id="52" name="Chevron 51"/>
+          <p:cNvPr id="49" name="Chevron 48"/>
           <p:cNvSpPr/>
           <p:nvPr/>
         </p:nvSpPr>
         <p:spPr>
           <a:xfrm>
-            <a:off x="8898255" y="3182112"/>
+            <a:off x="8898255" y="2688336"/>
             <a:ext cx="128016" cy="164592"/>
           </a:xfrm>
           <a:prstGeom prst="chevron">
@@ -6419,13 +6234,13 @@
       </p:sp>
       <p:sp>
         <p:nvSpPr>
-          <p:cNvPr id="53" name="Rounded Rectangle 52"/>
+          <p:cNvPr id="50" name="Rounded Rectangle 49"/>
           <p:cNvSpPr/>
           <p:nvPr/>
         </p:nvSpPr>
         <p:spPr>
           <a:xfrm>
-            <a:off x="8998838" y="2798064"/>
+            <a:off x="8998838" y="2304288"/>
             <a:ext cx="949832" cy="932688"/>
           </a:xfrm>
           <a:prstGeom prst="roundRect">
@@ -6561,13 +6376,13 @@
       </p:sp>
       <p:sp>
         <p:nvSpPr>
-          <p:cNvPr id="54" name="Rectangle 53"/>
+          <p:cNvPr id="51" name="Rectangle 50"/>
           <p:cNvSpPr/>
           <p:nvPr/>
         </p:nvSpPr>
         <p:spPr>
           <a:xfrm>
-            <a:off x="8998838" y="2798064"/>
+            <a:off x="8998838" y="2304288"/>
             <a:ext cx="949832" cy="36576"/>
           </a:xfrm>
           <a:prstGeom prst="rect">
@@ -6603,16 +6418,328 @@
           </a:p>
         </p:txBody>
       </p:sp>
-      <p:sp>
-        <p:nvSpPr>
-          <p:cNvPr id="55" name="Rounded Rectangle 54"/>
+      <p:cxnSp>
+        <p:nvCxnSpPr>
+          <p:cNvPr id="52" name="Connector 51"/>
+          <p:cNvCxnSpPr/>
+          <p:nvPr/>
+        </p:nvCxnSpPr>
+        <p:spPr>
+          <a:xfrm>
+            <a:off x="2248852" y="3236976"/>
+            <a:ext cx="0" cy="493776"/>
+          </a:xfrm>
+          <a:prstGeom prst="line">
+            <a:avLst/>
+          </a:prstGeom>
+          <a:ln w="15240">
+            <a:solidFill>
+              <a:srgbClr val="FFB020"/>
+            </a:solidFill>
+            <a:prstDash val="dash"/>
+            <a:headEnd type="triangle" w="med" len="med"/>
+            <a:tailEnd type="triangle" w="med" len="med"/>
+          </a:ln>
+          <a:effectLst/>
+        </p:spPr>
+        <p:style>
+          <a:lnRef idx="2">
+            <a:schemeClr val="accent1"/>
+          </a:lnRef>
+          <a:fillRef idx="0">
+            <a:schemeClr val="accent1"/>
+          </a:fillRef>
+          <a:effectRef idx="1">
+            <a:schemeClr val="accent1"/>
+          </a:effectRef>
+          <a:fontRef idx="minor">
+            <a:schemeClr val="tx1"/>
+          </a:fontRef>
+        </p:style>
+      </p:cxnSp>
+      <p:cxnSp>
+        <p:nvCxnSpPr>
+          <p:cNvPr id="53" name="Connector 52"/>
+          <p:cNvCxnSpPr/>
+          <p:nvPr/>
+        </p:nvCxnSpPr>
+        <p:spPr>
+          <a:xfrm>
+            <a:off x="3280981" y="3236976"/>
+            <a:ext cx="0" cy="493776"/>
+          </a:xfrm>
+          <a:prstGeom prst="line">
+            <a:avLst/>
+          </a:prstGeom>
+          <a:ln w="15240">
+            <a:solidFill>
+              <a:srgbClr val="FFB020"/>
+            </a:solidFill>
+            <a:prstDash val="dash"/>
+            <a:headEnd type="triangle" w="med" len="med"/>
+            <a:tailEnd type="triangle" w="med" len="med"/>
+          </a:ln>
+          <a:effectLst/>
+        </p:spPr>
+        <p:style>
+          <a:lnRef idx="2">
+            <a:schemeClr val="accent1"/>
+          </a:lnRef>
+          <a:fillRef idx="0">
+            <a:schemeClr val="accent1"/>
+          </a:fillRef>
+          <a:effectRef idx="1">
+            <a:schemeClr val="accent1"/>
+          </a:effectRef>
+          <a:fontRef idx="minor">
+            <a:schemeClr val="tx1"/>
+          </a:fontRef>
+        </p:style>
+      </p:cxnSp>
+      <p:cxnSp>
+        <p:nvCxnSpPr>
+          <p:cNvPr id="54" name="Connector 53"/>
+          <p:cNvCxnSpPr/>
+          <p:nvPr/>
+        </p:nvCxnSpPr>
+        <p:spPr>
+          <a:xfrm>
+            <a:off x="4313110" y="3236976"/>
+            <a:ext cx="0" cy="493776"/>
+          </a:xfrm>
+          <a:prstGeom prst="line">
+            <a:avLst/>
+          </a:prstGeom>
+          <a:ln w="15240">
+            <a:solidFill>
+              <a:srgbClr val="FFB020"/>
+            </a:solidFill>
+            <a:prstDash val="dash"/>
+            <a:headEnd type="triangle" w="med" len="med"/>
+            <a:tailEnd type="triangle" w="med" len="med"/>
+          </a:ln>
+          <a:effectLst/>
+        </p:spPr>
+        <p:style>
+          <a:lnRef idx="2">
+            <a:schemeClr val="accent1"/>
+          </a:lnRef>
+          <a:fillRef idx="0">
+            <a:schemeClr val="accent1"/>
+          </a:fillRef>
+          <a:effectRef idx="1">
+            <a:schemeClr val="accent1"/>
+          </a:effectRef>
+          <a:fontRef idx="minor">
+            <a:schemeClr val="tx1"/>
+          </a:fontRef>
+        </p:style>
+      </p:cxnSp>
+      <p:cxnSp>
+        <p:nvCxnSpPr>
+          <p:cNvPr id="55" name="Connector 54"/>
+          <p:cNvCxnSpPr/>
+          <p:nvPr/>
+        </p:nvCxnSpPr>
+        <p:spPr>
+          <a:xfrm>
+            <a:off x="5345239" y="3236976"/>
+            <a:ext cx="0" cy="493776"/>
+          </a:xfrm>
+          <a:prstGeom prst="line">
+            <a:avLst/>
+          </a:prstGeom>
+          <a:ln w="15240">
+            <a:solidFill>
+              <a:srgbClr val="FFB020"/>
+            </a:solidFill>
+            <a:prstDash val="dash"/>
+            <a:headEnd type="triangle" w="med" len="med"/>
+            <a:tailEnd type="triangle" w="med" len="med"/>
+          </a:ln>
+          <a:effectLst/>
+        </p:spPr>
+        <p:style>
+          <a:lnRef idx="2">
+            <a:schemeClr val="accent1"/>
+          </a:lnRef>
+          <a:fillRef idx="0">
+            <a:schemeClr val="accent1"/>
+          </a:fillRef>
+          <a:effectRef idx="1">
+            <a:schemeClr val="accent1"/>
+          </a:effectRef>
+          <a:fontRef idx="minor">
+            <a:schemeClr val="tx1"/>
+          </a:fontRef>
+        </p:style>
+      </p:cxnSp>
+      <p:cxnSp>
+        <p:nvCxnSpPr>
+          <p:cNvPr id="56" name="Connector 55"/>
+          <p:cNvCxnSpPr/>
+          <p:nvPr/>
+        </p:nvCxnSpPr>
+        <p:spPr>
+          <a:xfrm>
+            <a:off x="6377368" y="3236976"/>
+            <a:ext cx="0" cy="493776"/>
+          </a:xfrm>
+          <a:prstGeom prst="line">
+            <a:avLst/>
+          </a:prstGeom>
+          <a:ln w="15240">
+            <a:solidFill>
+              <a:srgbClr val="FFB020"/>
+            </a:solidFill>
+            <a:prstDash val="dash"/>
+            <a:headEnd type="triangle" w="med" len="med"/>
+            <a:tailEnd type="triangle" w="med" len="med"/>
+          </a:ln>
+          <a:effectLst/>
+        </p:spPr>
+        <p:style>
+          <a:lnRef idx="2">
+            <a:schemeClr val="accent1"/>
+          </a:lnRef>
+          <a:fillRef idx="0">
+            <a:schemeClr val="accent1"/>
+          </a:fillRef>
+          <a:effectRef idx="1">
+            <a:schemeClr val="accent1"/>
+          </a:effectRef>
+          <a:fontRef idx="minor">
+            <a:schemeClr val="tx1"/>
+          </a:fontRef>
+        </p:style>
+      </p:cxnSp>
+      <p:cxnSp>
+        <p:nvCxnSpPr>
+          <p:cNvPr id="57" name="Connector 56"/>
+          <p:cNvCxnSpPr/>
+          <p:nvPr/>
+        </p:nvCxnSpPr>
+        <p:spPr>
+          <a:xfrm>
+            <a:off x="7409497" y="3236976"/>
+            <a:ext cx="0" cy="493776"/>
+          </a:xfrm>
+          <a:prstGeom prst="line">
+            <a:avLst/>
+          </a:prstGeom>
+          <a:ln w="15240">
+            <a:solidFill>
+              <a:srgbClr val="FFB020"/>
+            </a:solidFill>
+            <a:prstDash val="dash"/>
+            <a:headEnd type="triangle" w="med" len="med"/>
+            <a:tailEnd type="triangle" w="med" len="med"/>
+          </a:ln>
+          <a:effectLst/>
+        </p:spPr>
+        <p:style>
+          <a:lnRef idx="2">
+            <a:schemeClr val="accent1"/>
+          </a:lnRef>
+          <a:fillRef idx="0">
+            <a:schemeClr val="accent1"/>
+          </a:fillRef>
+          <a:effectRef idx="1">
+            <a:schemeClr val="accent1"/>
+          </a:effectRef>
+          <a:fontRef idx="minor">
+            <a:schemeClr val="tx1"/>
+          </a:fontRef>
+        </p:style>
+      </p:cxnSp>
+      <p:cxnSp>
+        <p:nvCxnSpPr>
+          <p:cNvPr id="58" name="Connector 57"/>
+          <p:cNvCxnSpPr/>
+          <p:nvPr/>
+        </p:nvCxnSpPr>
+        <p:spPr>
+          <a:xfrm>
+            <a:off x="8441626" y="3236976"/>
+            <a:ext cx="0" cy="493776"/>
+          </a:xfrm>
+          <a:prstGeom prst="line">
+            <a:avLst/>
+          </a:prstGeom>
+          <a:ln w="15240">
+            <a:solidFill>
+              <a:srgbClr val="FFB020"/>
+            </a:solidFill>
+            <a:prstDash val="dash"/>
+            <a:headEnd type="triangle" w="med" len="med"/>
+            <a:tailEnd type="triangle" w="med" len="med"/>
+          </a:ln>
+          <a:effectLst/>
+        </p:spPr>
+        <p:style>
+          <a:lnRef idx="2">
+            <a:schemeClr val="accent1"/>
+          </a:lnRef>
+          <a:fillRef idx="0">
+            <a:schemeClr val="accent1"/>
+          </a:fillRef>
+          <a:effectRef idx="1">
+            <a:schemeClr val="accent1"/>
+          </a:effectRef>
+          <a:fontRef idx="minor">
+            <a:schemeClr val="tx1"/>
+          </a:fontRef>
+        </p:style>
+      </p:cxnSp>
+      <p:cxnSp>
+        <p:nvCxnSpPr>
+          <p:cNvPr id="59" name="Connector 58"/>
+          <p:cNvCxnSpPr/>
+          <p:nvPr/>
+        </p:nvCxnSpPr>
+        <p:spPr>
+          <a:xfrm>
+            <a:off x="9473755" y="3236976"/>
+            <a:ext cx="0" cy="493776"/>
+          </a:xfrm>
+          <a:prstGeom prst="line">
+            <a:avLst/>
+          </a:prstGeom>
+          <a:ln w="15240">
+            <a:solidFill>
+              <a:srgbClr val="FFB020"/>
+            </a:solidFill>
+            <a:prstDash val="dash"/>
+            <a:headEnd type="triangle" w="med" len="med"/>
+            <a:tailEnd type="triangle" w="med" len="med"/>
+          </a:ln>
+          <a:effectLst/>
+        </p:spPr>
+        <p:style>
+          <a:lnRef idx="2">
+            <a:schemeClr val="accent1"/>
+          </a:lnRef>
+          <a:fillRef idx="0">
+            <a:schemeClr val="accent1"/>
+          </a:fillRef>
+          <a:effectRef idx="1">
+            <a:schemeClr val="accent1"/>
+          </a:effectRef>
+          <a:fontRef idx="minor">
+            <a:schemeClr val="tx1"/>
+          </a:fontRef>
+        </p:style>
+      </p:cxnSp>
+      <p:sp>
+        <p:nvSpPr>
+          <p:cNvPr id="60" name="Rounded Rectangle 59"/>
           <p:cNvSpPr/>
           <p:nvPr/>
         </p:nvSpPr>
         <p:spPr>
           <a:xfrm>
-            <a:off x="1773936" y="3822191"/>
-            <a:ext cx="4014215" cy="420624"/>
+            <a:off x="1773936" y="3730752"/>
+            <a:ext cx="8174736" cy="475488"/>
           </a:xfrm>
           <a:prstGeom prst="roundRect">
             <a:avLst>
@@ -6622,9 +6749,9 @@
           <a:solidFill>
             <a:srgbClr val="222230"/>
           </a:solidFill>
-          <a:ln w="12700">
+          <a:ln w="16510">
             <a:solidFill>
-              <a:srgbClr val="35C759"/>
+              <a:srgbClr val="FFB020"/>
             </a:solidFill>
           </a:ln>
           <a:effectLst/>
@@ -6644,29 +6771,111 @@
           </a:fontRef>
         </p:style>
         <p:txBody>
-          <a:bodyPr rtlCol="0" anchor="ctr" wrap="square"/>
-          <a:lstStyle/>
-          <a:p>
-            <a:pPr algn="ctr"/>
-          </a:p>
-        </p:txBody>
-      </p:sp>
-      <p:sp>
-        <p:nvSpPr>
-          <p:cNvPr id="56" name="Rectangle 55"/>
+          <a:bodyPr rtlCol="0" anchor="ctr" wrap="square" lIns="27432" rIns="27432" tIns="9144" bIns="9144"/>
+          <a:lstStyle/>
+          <a:p>
+            <a:pPr algn="ctr">
+              <a:lnSpc>
+                <a:spcPct val="100000"/>
+              </a:lnSpc>
+              <a:spcBef>
+                <a:spcPts val="0"/>
+              </a:spcBef>
+              <a:spcAft>
+                <a:spcPts val="0"/>
+              </a:spcAft>
+            </a:pPr>
+            <a:r>
+              <a:rPr sz="919" b="1" i="0">
+                <a:solidFill>
+                  <a:srgbClr val="FFB020"/>
+                </a:solidFill>
+                <a:latin typeface="Segoe UI"/>
+              </a:rPr>
+              <a:t>⚠  CSR DECISION LAYER   </a:t>
+            </a:r>
+            <a:r>
+              <a:rPr sz="760" b="0" i="0">
+                <a:solidFill>
+                  <a:srgbClr val="C2C2D0"/>
+                </a:solidFill>
+                <a:latin typeface="Segoe UI"/>
+              </a:rPr>
+              <a:t>— every agent pauses on exception and hands the decision to the CSR:   </a:t>
+            </a:r>
+            <a:r>
+              <a:rPr sz="800" b="1" i="0">
+                <a:solidFill>
+                  <a:srgbClr val="35C759"/>
+                </a:solidFill>
+                <a:latin typeface="Segoe UI"/>
+              </a:rPr>
+              <a:t>Approve</a:t>
+            </a:r>
+            <a:r>
+              <a:rPr sz="760" b="0" i="0">
+                <a:solidFill>
+                  <a:srgbClr val="C2C2D0"/>
+                </a:solidFill>
+                <a:latin typeface="Segoe UI"/>
+              </a:rPr>
+              <a:t>  ·  </a:t>
+            </a:r>
+            <a:r>
+              <a:rPr sz="800" b="1" i="0">
+                <a:solidFill>
+                  <a:srgbClr val="FF5A5A"/>
+                </a:solidFill>
+                <a:latin typeface="Segoe UI"/>
+              </a:rPr>
+              <a:t>Reject</a:t>
+            </a:r>
+            <a:r>
+              <a:rPr sz="760" b="0" i="0">
+                <a:solidFill>
+                  <a:srgbClr val="C2C2D0"/>
+                </a:solidFill>
+                <a:latin typeface="Segoe UI"/>
+              </a:rPr>
+              <a:t>  ·  </a:t>
+            </a:r>
+            <a:r>
+              <a:rPr sz="800" b="1" i="0">
+                <a:solidFill>
+                  <a:srgbClr val="FFB020"/>
+                </a:solidFill>
+                <a:latin typeface="Segoe UI"/>
+              </a:rPr>
+              <a:t>Escalate</a:t>
+            </a:r>
+            <a:r>
+              <a:rPr sz="760" b="0" i="0">
+                <a:solidFill>
+                  <a:srgbClr val="C2C2D0"/>
+                </a:solidFill>
+                <a:latin typeface="Segoe UI"/>
+              </a:rPr>
+              <a:t>   → the pipeline resumes        (all agents pass ⇒ straight-through, autonomous)</a:t>
+            </a:r>
+          </a:p>
+        </p:txBody>
+      </p:sp>
+      <p:sp>
+        <p:nvSpPr>
+          <p:cNvPr id="61" name="Rectangle 60"/>
           <p:cNvSpPr/>
           <p:nvPr/>
         </p:nvSpPr>
         <p:spPr>
           <a:xfrm>
-            <a:off x="1773936" y="3822191"/>
-            <a:ext cx="64008" cy="420624"/>
+            <a:off x="1773936" y="3730752"/>
+            <a:ext cx="8174736" cy="54864"/>
           </a:xfrm>
           <a:prstGeom prst="rect">
             <a:avLst/>
           </a:prstGeom>
           <a:solidFill>
-            <a:srgbClr val="35C759"/>
+            <a:srgbClr val="FFB020"/>
           </a:solidFill>
           <a:ln>
             <a:noFill/>
@@ -6697,207 +6906,7 @@
       </p:sp>
       <p:sp>
         <p:nvSpPr>
-          <p:cNvPr id="57" name="TextBox 56"/>
-          <p:cNvSpPr txBox="1"/>
-          <p:nvPr/>
-        </p:nvSpPr>
-        <p:spPr>
-          <a:xfrm>
-            <a:off x="1920240" y="3867911"/>
-            <a:ext cx="3739896" cy="329184"/>
-          </a:xfrm>
-          <a:prstGeom prst="rect">
-            <a:avLst/>
-          </a:prstGeom>
-          <a:noFill/>
-        </p:spPr>
-        <p:txBody>
-          <a:bodyPr wrap="square" anchor="t" lIns="0" rIns="0" tIns="0" bIns="0">
-            <a:spAutoFit/>
-          </a:bodyPr>
-          <a:lstStyle/>
-          <a:p>
-            <a:pPr algn="l">
-              <a:lnSpc>
-                <a:spcPct val="95000"/>
-              </a:lnSpc>
-              <a:spcBef>
-                <a:spcPts val="0"/>
-              </a:spcBef>
-              <a:spcAft>
-                <a:spcPts val="0"/>
-              </a:spcAft>
-            </a:pPr>
-            <a:r>
-              <a:rPr sz="830" b="1" i="0">
-                <a:solidFill>
-                  <a:srgbClr val="35C759"/>
-                </a:solidFill>
-                <a:latin typeface="Segoe UI"/>
-              </a:rPr>
-              <a:t>✓ Straight-through</a:t>
-            </a:r>
-            <a:r>
-              <a:rPr sz="740" b="0" i="0">
-                <a:solidFill>
-                  <a:srgbClr val="C2C2D0"/>
-                </a:solidFill>
-                <a:latin typeface="Segoe UI"/>
-              </a:rPr>
-              <a:t>  — all agents pass → autonomous → order creation</a:t>
-            </a:r>
-          </a:p>
-        </p:txBody>
-      </p:sp>
-      <p:sp>
-        <p:nvSpPr>
-          <p:cNvPr id="58" name="Rounded Rectangle 57"/>
-          <p:cNvSpPr/>
-          <p:nvPr/>
-        </p:nvSpPr>
-        <p:spPr>
-          <a:xfrm>
-            <a:off x="5934456" y="3822191"/>
-            <a:ext cx="4014215" cy="420624"/>
-          </a:xfrm>
-          <a:prstGeom prst="roundRect">
-            <a:avLst>
-              <a:gd name="adj" fmla="val 6000"/>
-            </a:avLst>
-          </a:prstGeom>
-          <a:solidFill>
-            <a:srgbClr val="222230"/>
-          </a:solidFill>
-          <a:ln w="12700">
-            <a:solidFill>
-              <a:srgbClr val="FFB020"/>
-            </a:solidFill>
-          </a:ln>
-          <a:effectLst/>
-        </p:spPr>
-        <p:style>
-          <a:lnRef idx="1">
-            <a:schemeClr val="accent1"/>
-          </a:lnRef>
-          <a:fillRef idx="3">
-            <a:schemeClr val="accent1"/>
-          </a:fillRef>
-          <a:effectRef idx="2">
-            <a:schemeClr val="accent1"/>
-          </a:effectRef>
-          <a:fontRef idx="minor">
-            <a:schemeClr val="lt1"/>
-          </a:fontRef>
-        </p:style>
-        <p:txBody>
-          <a:bodyPr rtlCol="0" anchor="ctr" wrap="square"/>
-          <a:lstStyle/>
-          <a:p>
-            <a:pPr algn="ctr"/>
-          </a:p>
-        </p:txBody>
-      </p:sp>
-      <p:sp>
-        <p:nvSpPr>
-          <p:cNvPr id="59" name="Rectangle 58"/>
-          <p:cNvSpPr/>
-          <p:nvPr/>
-        </p:nvSpPr>
-        <p:spPr>
-          <a:xfrm>
-            <a:off x="5934456" y="3822191"/>
-            <a:ext cx="64008" cy="420624"/>
-          </a:xfrm>
-          <a:prstGeom prst="rect">
-            <a:avLst/>
-          </a:prstGeom>
-          <a:solidFill>
-            <a:srgbClr val="FFB020"/>
-          </a:solidFill>
-          <a:ln>
-            <a:noFill/>
-          </a:ln>
-          <a:effectLst/>
-        </p:spPr>
-        <p:style>
-          <a:lnRef idx="1">
-            <a:schemeClr val="accent1"/>
-          </a:lnRef>
-          <a:fillRef idx="3">
-            <a:schemeClr val="accent1"/>
-          </a:fillRef>
-          <a:effectRef idx="2">
-            <a:schemeClr val="accent1"/>
-          </a:effectRef>
-          <a:fontRef idx="minor">
-            <a:schemeClr val="lt1"/>
-          </a:fontRef>
-        </p:style>
-        <p:txBody>
-          <a:bodyPr rtlCol="0" anchor="ctr" wrap="square"/>
-          <a:lstStyle/>
-          <a:p>
-            <a:pPr algn="ctr"/>
-          </a:p>
-        </p:txBody>
-      </p:sp>
-      <p:sp>
-        <p:nvSpPr>
-          <p:cNvPr id="60" name="TextBox 59"/>
-          <p:cNvSpPr txBox="1"/>
-          <p:nvPr/>
-        </p:nvSpPr>
-        <p:spPr>
-          <a:xfrm>
-            <a:off x="6080760" y="3867911"/>
-            <a:ext cx="3739896" cy="329184"/>
-          </a:xfrm>
-          <a:prstGeom prst="rect">
-            <a:avLst/>
-          </a:prstGeom>
-          <a:noFill/>
-        </p:spPr>
-        <p:txBody>
-          <a:bodyPr wrap="square" anchor="t" lIns="0" rIns="0" tIns="0" bIns="0">
-            <a:spAutoFit/>
-          </a:bodyPr>
-          <a:lstStyle/>
-          <a:p>
-            <a:pPr algn="l">
-              <a:lnSpc>
-                <a:spcPct val="95000"/>
-              </a:lnSpc>
-              <a:spcBef>
-                <a:spcPts val="0"/>
-              </a:spcBef>
-              <a:spcAft>
-                <a:spcPts val="0"/>
-              </a:spcAft>
-            </a:pPr>
-            <a:r>
-              <a:rPr sz="830" b="1" i="0">
-                <a:solidFill>
-                  <a:srgbClr val="FFB020"/>
-                </a:solidFill>
-                <a:latin typeface="Segoe UI"/>
-              </a:rPr>
-              <a:t>⚠ Human-in-the-loop</a:t>
-            </a:r>
-            <a:r>
-              <a:rPr sz="740" b="0" i="0">
-                <a:solidFill>
-                  <a:srgbClr val="C2C2D0"/>
-                </a:solidFill>
-                <a:latin typeface="Segoe UI"/>
-              </a:rPr>
-              <a:t>  — an agent raises an exception → CSR decides → resumes</a:t>
-            </a:r>
-          </a:p>
-        </p:txBody>
-      </p:sp>
-      <p:sp>
-        <p:nvSpPr>
-          <p:cNvPr id="61" name="Rounded Rectangle 60"/>
+          <p:cNvPr id="62" name="Rounded Rectangle 61"/>
           <p:cNvSpPr/>
           <p:nvPr/>
         </p:nvSpPr>
@@ -6973,7 +6982,7 @@
       </p:sp>
       <p:sp>
         <p:nvSpPr>
-          <p:cNvPr id="62" name="Rectangle 61"/>
+          <p:cNvPr id="63" name="Rectangle 62"/>
           <p:cNvSpPr/>
           <p:nvPr/>
         </p:nvSpPr>
@@ -7017,7 +7026,7 @@
       </p:sp>
       <p:sp>
         <p:nvSpPr>
-          <p:cNvPr id="63" name="TextBox 62"/>
+          <p:cNvPr id="64" name="TextBox 63"/>
           <p:cNvSpPr txBox="1"/>
           <p:nvPr/>
         </p:nvSpPr>
@@ -7071,7 +7080,7 @@
       </p:sp>
       <p:sp>
         <p:nvSpPr>
-          <p:cNvPr id="64" name="Rounded Rectangle 63"/>
+          <p:cNvPr id="65" name="Rounded Rectangle 64"/>
           <p:cNvSpPr/>
           <p:nvPr/>
         </p:nvSpPr>
@@ -7160,7 +7169,7 @@
       </p:sp>
       <p:sp>
         <p:nvSpPr>
-          <p:cNvPr id="65" name="Chevron 64"/>
+          <p:cNvPr id="66" name="Chevron 65"/>
           <p:cNvSpPr/>
           <p:nvPr/>
         </p:nvSpPr>
@@ -7204,7 +7213,7 @@
       </p:sp>
       <p:sp>
         <p:nvSpPr>
-          <p:cNvPr id="66" name="Rounded Rectangle 65"/>
+          <p:cNvPr id="67" name="Rounded Rectangle 66"/>
           <p:cNvSpPr/>
           <p:nvPr/>
         </p:nvSpPr>
@@ -7293,7 +7302,7 @@
       </p:sp>
       <p:sp>
         <p:nvSpPr>
-          <p:cNvPr id="67" name="Rounded Rectangle 66"/>
+          <p:cNvPr id="68" name="Rounded Rectangle 67"/>
           <p:cNvSpPr/>
           <p:nvPr/>
         </p:nvSpPr>
@@ -7382,7 +7391,7 @@
       </p:sp>
       <p:sp>
         <p:nvSpPr>
-          <p:cNvPr id="68" name="Rounded Rectangle 67"/>
+          <p:cNvPr id="69" name="Rounded Rectangle 68"/>
           <p:cNvSpPr/>
           <p:nvPr/>
         </p:nvSpPr>
@@ -7471,7 +7480,7 @@
       </p:sp>
       <p:sp>
         <p:nvSpPr>
-          <p:cNvPr id="69" name="Rounded Rectangle 68"/>
+          <p:cNvPr id="70" name="Rounded Rectangle 69"/>
           <p:cNvSpPr/>
           <p:nvPr/>
         </p:nvSpPr>
@@ -7560,7 +7569,7 @@
       </p:sp>
       <p:sp>
         <p:nvSpPr>
-          <p:cNvPr id="70" name="Rounded Rectangle 69"/>
+          <p:cNvPr id="71" name="Rounded Rectangle 70"/>
           <p:cNvSpPr/>
           <p:nvPr/>
         </p:nvSpPr>
@@ -7649,7 +7658,7 @@
       </p:sp>
       <p:sp>
         <p:nvSpPr>
-          <p:cNvPr id="71" name="Rounded Rectangle 70"/>
+          <p:cNvPr id="72" name="Rounded Rectangle 71"/>
           <p:cNvSpPr/>
           <p:nvPr/>
         </p:nvSpPr>
@@ -7738,7 +7747,7 @@
       </p:sp>
       <p:sp>
         <p:nvSpPr>
-          <p:cNvPr id="72" name="Rounded Rectangle 71"/>
+          <p:cNvPr id="73" name="Rounded Rectangle 72"/>
           <p:cNvSpPr/>
           <p:nvPr/>
         </p:nvSpPr>
@@ -7786,7 +7795,7 @@
       </p:sp>
       <p:sp>
         <p:nvSpPr>
-          <p:cNvPr id="73" name="TextBox 72"/>
+          <p:cNvPr id="74" name="TextBox 73"/>
           <p:cNvSpPr txBox="1"/>
           <p:nvPr/>
         </p:nvSpPr>
@@ -7840,7 +7849,7 @@
       </p:sp>
       <p:sp>
         <p:nvSpPr>
-          <p:cNvPr id="74" name="Rounded Rectangle 73"/>
+          <p:cNvPr id="75" name="Rounded Rectangle 74"/>
           <p:cNvSpPr/>
           <p:nvPr/>
         </p:nvSpPr>
@@ -7929,7 +7938,7 @@
       </p:sp>
       <p:sp>
         <p:nvSpPr>
-          <p:cNvPr id="75" name="Rounded Rectangle 74"/>
+          <p:cNvPr id="76" name="Rounded Rectangle 75"/>
           <p:cNvSpPr/>
           <p:nvPr/>
         </p:nvSpPr>
@@ -8018,7 +8027,7 @@
       </p:sp>
       <p:sp>
         <p:nvSpPr>
-          <p:cNvPr id="76" name="Rounded Rectangle 75"/>
+          <p:cNvPr id="77" name="Rounded Rectangle 76"/>
           <p:cNvSpPr/>
           <p:nvPr/>
         </p:nvSpPr>
@@ -8085,7 +8094,7 @@
       </p:sp>
       <p:sp>
         <p:nvSpPr>
-          <p:cNvPr id="77" name="Rounded Rectangle 76"/>
+          <p:cNvPr id="78" name="Rounded Rectangle 77"/>
           <p:cNvSpPr/>
           <p:nvPr/>
         </p:nvSpPr>
@@ -8152,7 +8161,7 @@
       </p:sp>
       <p:sp>
         <p:nvSpPr>
-          <p:cNvPr id="78" name="Rounded Rectangle 77"/>
+          <p:cNvPr id="79" name="Rounded Rectangle 78"/>
           <p:cNvSpPr/>
           <p:nvPr/>
         </p:nvSpPr>
@@ -8219,7 +8228,7 @@
       </p:sp>
       <p:sp>
         <p:nvSpPr>
-          <p:cNvPr id="79" name="Rounded Rectangle 78"/>
+          <p:cNvPr id="80" name="Rounded Rectangle 79"/>
           <p:cNvSpPr/>
           <p:nvPr/>
         </p:nvSpPr>
@@ -8286,7 +8295,7 @@
       </p:sp>
       <p:sp>
         <p:nvSpPr>
-          <p:cNvPr id="80" name="Rounded Rectangle 79"/>
+          <p:cNvPr id="81" name="Rounded Rectangle 80"/>
           <p:cNvSpPr/>
           <p:nvPr/>
         </p:nvSpPr>
@@ -8353,7 +8362,7 @@
       </p:sp>
       <p:sp>
         <p:nvSpPr>
-          <p:cNvPr id="81" name="Rounded Rectangle 80"/>
+          <p:cNvPr id="82" name="Rounded Rectangle 81"/>
           <p:cNvSpPr/>
           <p:nvPr/>
         </p:nvSpPr>
@@ -8442,7 +8451,7 @@
       </p:sp>
       <p:sp>
         <p:nvSpPr>
-          <p:cNvPr id="82" name="Rounded Rectangle 81"/>
+          <p:cNvPr id="83" name="Rounded Rectangle 82"/>
           <p:cNvSpPr/>
           <p:nvPr/>
         </p:nvSpPr>
@@ -8531,7 +8540,7 @@
       </p:sp>
       <p:sp>
         <p:nvSpPr>
-          <p:cNvPr id="83" name="Rounded Rectangle 82"/>
+          <p:cNvPr id="84" name="Rounded Rectangle 83"/>
           <p:cNvSpPr/>
           <p:nvPr/>
         </p:nvSpPr>
@@ -8620,7 +8629,7 @@
       </p:sp>
       <p:sp>
         <p:nvSpPr>
-          <p:cNvPr id="84" name="Rounded Rectangle 83"/>
+          <p:cNvPr id="85" name="Rounded Rectangle 84"/>
           <p:cNvSpPr/>
           <p:nvPr/>
         </p:nvSpPr>
@@ -8709,7 +8718,7 @@
       </p:sp>
       <p:sp>
         <p:nvSpPr>
-          <p:cNvPr id="85" name="Down Arrow 84"/>
+          <p:cNvPr id="86" name="Down Arrow 85"/>
           <p:cNvSpPr/>
           <p:nvPr/>
         </p:nvSpPr>
@@ -8753,13 +8762,13 @@
       </p:sp>
       <p:sp>
         <p:nvSpPr>
-          <p:cNvPr id="86" name="Down Arrow 85"/>
+          <p:cNvPr id="87" name="Down Arrow 86"/>
           <p:cNvSpPr/>
           <p:nvPr/>
         </p:nvSpPr>
         <p:spPr>
           <a:xfrm>
-            <a:off x="5715000" y="2103120"/>
+            <a:off x="5715000" y="4297680"/>
             <a:ext cx="292608" cy="109728"/>
           </a:xfrm>
           <a:prstGeom prst="downArrow">
@@ -8797,13 +8806,13 @@
       </p:sp>
       <p:sp>
         <p:nvSpPr>
-          <p:cNvPr id="87" name="Down Arrow 86"/>
+          <p:cNvPr id="88" name="Down Arrow 87"/>
           <p:cNvSpPr/>
           <p:nvPr/>
         </p:nvSpPr>
         <p:spPr>
           <a:xfrm>
-            <a:off x="5715000" y="4279392"/>
+            <a:off x="5715000" y="4700016"/>
             <a:ext cx="292608" cy="109728"/>
           </a:xfrm>
           <a:prstGeom prst="downArrow">
@@ -8839,50 +8848,6 @@
           </a:p>
         </p:txBody>
       </p:sp>
-      <p:sp>
-        <p:nvSpPr>
-          <p:cNvPr id="88" name="Down Arrow 87"/>
-          <p:cNvSpPr/>
-          <p:nvPr/>
-        </p:nvSpPr>
-        <p:spPr>
-          <a:xfrm>
-            <a:off x="5715000" y="4700016"/>
-            <a:ext cx="292608" cy="109728"/>
-          </a:xfrm>
-          <a:prstGeom prst="downArrow">
-            <a:avLst/>
-          </a:prstGeom>
-          <a:solidFill>
-            <a:srgbClr val="FFE600"/>
-          </a:solidFill>
-          <a:ln>
-            <a:noFill/>
-          </a:ln>
-          <a:effectLst/>
-        </p:spPr>
-        <p:style>
-          <a:lnRef idx="1">
-            <a:schemeClr val="accent1"/>
-          </a:lnRef>
-          <a:fillRef idx="3">
-            <a:schemeClr val="accent1"/>
-          </a:fillRef>
-          <a:effectRef idx="2">
-            <a:schemeClr val="accent1"/>
-          </a:effectRef>
-          <a:fontRef idx="minor">
-            <a:schemeClr val="lt1"/>
-          </a:fontRef>
-        </p:style>
-        <p:txBody>
-          <a:bodyPr rtlCol="0" anchor="ctr"/>
-          <a:lstStyle/>
-          <a:p>
-            <a:pPr algn="ctr"/>
-          </a:p>
-        </p:txBody>
-      </p:sp>
       <p:cxnSp>
         <p:nvCxnSpPr>
           <p:cNvPr id="89" name="Connector 88"/>
@@ -8891,8 +8856,8 @@
         </p:nvCxnSpPr>
         <p:spPr>
           <a:xfrm flipV="1">
-            <a:off x="1609344" y="4297679"/>
-            <a:ext cx="0" cy="1316737"/>
+            <a:off x="1609344" y="4315968"/>
+            <a:ext cx="0" cy="1298448"/>
           </a:xfrm>
           <a:prstGeom prst="line">
             <a:avLst/>

</xml_diff>

<commit_message>
docs: replace "state machine" with "pause-and-resume workflow" across architecture decks
</commit_message>
<xml_diff>
--- a/demo/Order-Creation-Orchestration-Architecture.pptx
+++ b/demo/Order-Creation-Orchestration-Architecture.pptx
@@ -4573,7 +4573,7 @@
                 </a:solidFill>
                 <a:latin typeface="Segoe UI"/>
               </a:rPr>
-              <a:t>coordinates a team of specialist AI agents over a shared context · resumable pipeline / state machine · Approvals runs last</a:t>
+              <a:t>coordinates a team of specialist AI agents over a shared context · resumable, pause-and-resume workflow · Approvals runs last</a:t>
             </a:r>
           </a:p>
         </p:txBody>
@@ -9615,7 +9615,7 @@
                 </a:solidFill>
                 <a:latin typeface="Segoe UI"/>
               </a:rPr>
-              <a:t>Resumable</a:t>
+              <a:t>Pause &amp; resume</a:t>
             </a:r>
           </a:p>
           <a:p>
@@ -9637,7 +9637,7 @@
                 </a:solidFill>
                 <a:latin typeface="Segoe UI"/>
               </a:rPr>
-              <a:t>state machine</a:t>
+              <a:t>workflow</a:t>
             </a:r>
           </a:p>
         </p:txBody>

</xml_diff>

<commit_message>
docs: remove platform capabilities rail and widen orchestration architecture slide
</commit_message>
<xml_diff>
--- a/demo/Order-Creation-Orchestration-Architecture.pptx
+++ b/demo/Order-Creation-Orchestration-Architecture.pptx
@@ -4272,7 +4272,7 @@
         <p:spPr>
           <a:xfrm>
             <a:off x="4590288" y="1005840"/>
-            <a:ext cx="5422392" cy="658368"/>
+            <a:ext cx="7251192" cy="658368"/>
           </a:xfrm>
           <a:prstGeom prst="roundRect">
             <a:avLst>
@@ -4320,7 +4320,7 @@
         <p:spPr>
           <a:xfrm>
             <a:off x="4590288" y="1005840"/>
-            <a:ext cx="5422392" cy="45720"/>
+            <a:ext cx="7251192" cy="45720"/>
           </a:xfrm>
           <a:prstGeom prst="rect">
             <a:avLst/>
@@ -4364,7 +4364,7 @@
         <p:spPr>
           <a:xfrm>
             <a:off x="4700016" y="1088136"/>
-            <a:ext cx="5193792" cy="182880"/>
+            <a:ext cx="7022592" cy="182880"/>
           </a:xfrm>
           <a:prstGeom prst="rect">
             <a:avLst/>
@@ -4409,7 +4409,7 @@
         <p:spPr>
           <a:xfrm>
             <a:off x="4700016" y="1298448"/>
-            <a:ext cx="5193792" cy="347472"/>
+            <a:ext cx="7022592" cy="347472"/>
           </a:xfrm>
           <a:prstGeom prst="rect">
             <a:avLst/>
@@ -4463,7 +4463,7 @@
         <p:spPr>
           <a:xfrm>
             <a:off x="1664208" y="1737360"/>
-            <a:ext cx="8394192" cy="2578608"/>
+            <a:ext cx="10222992" cy="2578608"/>
           </a:xfrm>
           <a:prstGeom prst="roundRect">
             <a:avLst>
@@ -4511,7 +4511,7 @@
         <p:spPr>
           <a:xfrm>
             <a:off x="1773936" y="1792224"/>
-            <a:ext cx="8174736" cy="329184"/>
+            <a:ext cx="10003536" cy="329184"/>
           </a:xfrm>
           <a:prstGeom prst="roundRect">
             <a:avLst>
@@ -4586,7 +4586,7 @@
         </p:nvSpPr>
         <p:spPr>
           <a:xfrm>
-            <a:off x="5733288" y="2139696"/>
+            <a:off x="6647688" y="2139696"/>
             <a:ext cx="256032" cy="109728"/>
           </a:xfrm>
           <a:prstGeom prst="downArrow">
@@ -4631,7 +4631,7 @@
         <p:spPr>
           <a:xfrm>
             <a:off x="1773936" y="2304288"/>
-            <a:ext cx="949832" cy="932688"/>
+            <a:ext cx="1178432" cy="932688"/>
           </a:xfrm>
           <a:prstGeom prst="roundRect">
             <a:avLst>
@@ -4773,7 +4773,7 @@
         <p:spPr>
           <a:xfrm>
             <a:off x="1773936" y="2304288"/>
-            <a:ext cx="949832" cy="36576"/>
+            <a:ext cx="1178432" cy="36576"/>
           </a:xfrm>
           <a:prstGeom prst="rect">
             <a:avLst/>
@@ -4816,7 +4816,7 @@
         </p:nvSpPr>
         <p:spPr>
           <a:xfrm>
-            <a:off x="2705481" y="2688336"/>
+            <a:off x="2934081" y="2688336"/>
             <a:ext cx="128016" cy="164592"/>
           </a:xfrm>
           <a:prstGeom prst="chevron">
@@ -4860,8 +4860,8 @@
         </p:nvSpPr>
         <p:spPr>
           <a:xfrm>
-            <a:off x="2806064" y="2304288"/>
-            <a:ext cx="949832" cy="932688"/>
+            <a:off x="3034664" y="2304288"/>
+            <a:ext cx="1178432" cy="932688"/>
           </a:xfrm>
           <a:prstGeom prst="roundRect">
             <a:avLst>
@@ -5002,8 +5002,8 @@
         </p:nvSpPr>
         <p:spPr>
           <a:xfrm>
-            <a:off x="2806064" y="2304288"/>
-            <a:ext cx="949832" cy="36576"/>
+            <a:off x="3034664" y="2304288"/>
+            <a:ext cx="1178432" cy="36576"/>
           </a:xfrm>
           <a:prstGeom prst="rect">
             <a:avLst/>
@@ -5046,7 +5046,7 @@
         </p:nvSpPr>
         <p:spPr>
           <a:xfrm>
-            <a:off x="3737610" y="2688336"/>
+            <a:off x="4194810" y="2688336"/>
             <a:ext cx="128016" cy="164592"/>
           </a:xfrm>
           <a:prstGeom prst="chevron">
@@ -5090,8 +5090,8 @@
         </p:nvSpPr>
         <p:spPr>
           <a:xfrm>
-            <a:off x="3838194" y="2304288"/>
-            <a:ext cx="949832" cy="932688"/>
+            <a:off x="4295394" y="2304288"/>
+            <a:ext cx="1178432" cy="932688"/>
           </a:xfrm>
           <a:prstGeom prst="roundRect">
             <a:avLst>
@@ -5232,8 +5232,8 @@
         </p:nvSpPr>
         <p:spPr>
           <a:xfrm>
-            <a:off x="3838194" y="2304288"/>
-            <a:ext cx="949832" cy="36576"/>
+            <a:off x="4295394" y="2304288"/>
+            <a:ext cx="1178432" cy="36576"/>
           </a:xfrm>
           <a:prstGeom prst="rect">
             <a:avLst/>
@@ -5276,7 +5276,7 @@
         </p:nvSpPr>
         <p:spPr>
           <a:xfrm>
-            <a:off x="4769739" y="2688336"/>
+            <a:off x="5455539" y="2688336"/>
             <a:ext cx="128016" cy="164592"/>
           </a:xfrm>
           <a:prstGeom prst="chevron">
@@ -5320,8 +5320,8 @@
         </p:nvSpPr>
         <p:spPr>
           <a:xfrm>
-            <a:off x="4870323" y="2304288"/>
-            <a:ext cx="949832" cy="932688"/>
+            <a:off x="5556123" y="2304288"/>
+            <a:ext cx="1178432" cy="932688"/>
           </a:xfrm>
           <a:prstGeom prst="roundRect">
             <a:avLst>
@@ -5462,8 +5462,8 @@
         </p:nvSpPr>
         <p:spPr>
           <a:xfrm>
-            <a:off x="4870323" y="2304288"/>
-            <a:ext cx="949832" cy="36576"/>
+            <a:off x="5556123" y="2304288"/>
+            <a:ext cx="1178432" cy="36576"/>
           </a:xfrm>
           <a:prstGeom prst="rect">
             <a:avLst/>
@@ -5506,7 +5506,7 @@
         </p:nvSpPr>
         <p:spPr>
           <a:xfrm>
-            <a:off x="5801868" y="2688336"/>
+            <a:off x="6716268" y="2688336"/>
             <a:ext cx="128016" cy="164592"/>
           </a:xfrm>
           <a:prstGeom prst="chevron">
@@ -5550,8 +5550,8 @@
         </p:nvSpPr>
         <p:spPr>
           <a:xfrm>
-            <a:off x="5902452" y="2304288"/>
-            <a:ext cx="949832" cy="932688"/>
+            <a:off x="6816852" y="2304288"/>
+            <a:ext cx="1178432" cy="932688"/>
           </a:xfrm>
           <a:prstGeom prst="roundRect">
             <a:avLst>
@@ -5692,8 +5692,8 @@
         </p:nvSpPr>
         <p:spPr>
           <a:xfrm>
-            <a:off x="5902452" y="2304288"/>
-            <a:ext cx="949832" cy="36576"/>
+            <a:off x="6816852" y="2304288"/>
+            <a:ext cx="1178432" cy="36576"/>
           </a:xfrm>
           <a:prstGeom prst="rect">
             <a:avLst/>
@@ -5736,7 +5736,7 @@
         </p:nvSpPr>
         <p:spPr>
           <a:xfrm>
-            <a:off x="6833997" y="2688336"/>
+            <a:off x="7976997" y="2688336"/>
             <a:ext cx="128016" cy="164592"/>
           </a:xfrm>
           <a:prstGeom prst="chevron">
@@ -5780,8 +5780,8 @@
         </p:nvSpPr>
         <p:spPr>
           <a:xfrm>
-            <a:off x="6934581" y="2304288"/>
-            <a:ext cx="949832" cy="932688"/>
+            <a:off x="8077581" y="2304288"/>
+            <a:ext cx="1178432" cy="932688"/>
           </a:xfrm>
           <a:prstGeom prst="roundRect">
             <a:avLst>
@@ -5922,8 +5922,8 @@
         </p:nvSpPr>
         <p:spPr>
           <a:xfrm>
-            <a:off x="6934581" y="2304288"/>
-            <a:ext cx="949832" cy="36576"/>
+            <a:off x="8077581" y="2304288"/>
+            <a:ext cx="1178432" cy="36576"/>
           </a:xfrm>
           <a:prstGeom prst="rect">
             <a:avLst/>
@@ -5966,7 +5966,7 @@
         </p:nvSpPr>
         <p:spPr>
           <a:xfrm>
-            <a:off x="7866126" y="2688336"/>
+            <a:off x="9237726" y="2688336"/>
             <a:ext cx="128016" cy="164592"/>
           </a:xfrm>
           <a:prstGeom prst="chevron">
@@ -6010,8 +6010,8 @@
         </p:nvSpPr>
         <p:spPr>
           <a:xfrm>
-            <a:off x="7966709" y="2304288"/>
-            <a:ext cx="949832" cy="932688"/>
+            <a:off x="9338309" y="2304288"/>
+            <a:ext cx="1178432" cy="932688"/>
           </a:xfrm>
           <a:prstGeom prst="roundRect">
             <a:avLst>
@@ -6152,8 +6152,8 @@
         </p:nvSpPr>
         <p:spPr>
           <a:xfrm>
-            <a:off x="7966709" y="2304288"/>
-            <a:ext cx="949832" cy="36576"/>
+            <a:off x="9338309" y="2304288"/>
+            <a:ext cx="1178432" cy="36576"/>
           </a:xfrm>
           <a:prstGeom prst="rect">
             <a:avLst/>
@@ -6196,7 +6196,7 @@
         </p:nvSpPr>
         <p:spPr>
           <a:xfrm>
-            <a:off x="8898255" y="2688336"/>
+            <a:off x="10498455" y="2688336"/>
             <a:ext cx="128016" cy="164592"/>
           </a:xfrm>
           <a:prstGeom prst="chevron">
@@ -6240,8 +6240,8 @@
         </p:nvSpPr>
         <p:spPr>
           <a:xfrm>
-            <a:off x="8998838" y="2304288"/>
-            <a:ext cx="949832" cy="932688"/>
+            <a:off x="10599038" y="2304288"/>
+            <a:ext cx="1178432" cy="932688"/>
           </a:xfrm>
           <a:prstGeom prst="roundRect">
             <a:avLst>
@@ -6382,8 +6382,8 @@
         </p:nvSpPr>
         <p:spPr>
           <a:xfrm>
-            <a:off x="8998838" y="2304288"/>
-            <a:ext cx="949832" cy="36576"/>
+            <a:off x="10599038" y="2304288"/>
+            <a:ext cx="1178432" cy="36576"/>
           </a:xfrm>
           <a:prstGeom prst="rect">
             <a:avLst/>
@@ -6426,7 +6426,7 @@
         </p:nvCxnSpPr>
         <p:spPr>
           <a:xfrm>
-            <a:off x="2248852" y="3236976"/>
+            <a:off x="2363152" y="3236976"/>
             <a:ext cx="0" cy="493776"/>
           </a:xfrm>
           <a:prstGeom prst="line">
@@ -6465,7 +6465,7 @@
         </p:nvCxnSpPr>
         <p:spPr>
           <a:xfrm>
-            <a:off x="3280981" y="3236976"/>
+            <a:off x="3623881" y="3236976"/>
             <a:ext cx="0" cy="493776"/>
           </a:xfrm>
           <a:prstGeom prst="line">
@@ -6504,7 +6504,7 @@
         </p:nvCxnSpPr>
         <p:spPr>
           <a:xfrm>
-            <a:off x="4313110" y="3236976"/>
+            <a:off x="4884610" y="3236976"/>
             <a:ext cx="0" cy="493776"/>
           </a:xfrm>
           <a:prstGeom prst="line">
@@ -6543,7 +6543,7 @@
         </p:nvCxnSpPr>
         <p:spPr>
           <a:xfrm>
-            <a:off x="5345239" y="3236976"/>
+            <a:off x="6145339" y="3236976"/>
             <a:ext cx="0" cy="493776"/>
           </a:xfrm>
           <a:prstGeom prst="line">
@@ -6582,7 +6582,7 @@
         </p:nvCxnSpPr>
         <p:spPr>
           <a:xfrm>
-            <a:off x="6377368" y="3236976"/>
+            <a:off x="7406068" y="3236976"/>
             <a:ext cx="0" cy="493776"/>
           </a:xfrm>
           <a:prstGeom prst="line">
@@ -6621,7 +6621,7 @@
         </p:nvCxnSpPr>
         <p:spPr>
           <a:xfrm>
-            <a:off x="7409497" y="3236976"/>
+            <a:off x="8666797" y="3236976"/>
             <a:ext cx="0" cy="493776"/>
           </a:xfrm>
           <a:prstGeom prst="line">
@@ -6660,7 +6660,7 @@
         </p:nvCxnSpPr>
         <p:spPr>
           <a:xfrm>
-            <a:off x="8441626" y="3236976"/>
+            <a:off x="9927526" y="3236976"/>
             <a:ext cx="0" cy="493776"/>
           </a:xfrm>
           <a:prstGeom prst="line">
@@ -6699,7 +6699,7 @@
         </p:nvCxnSpPr>
         <p:spPr>
           <a:xfrm>
-            <a:off x="9473755" y="3236976"/>
+            <a:off x="11188255" y="3236976"/>
             <a:ext cx="0" cy="493776"/>
           </a:xfrm>
           <a:prstGeom prst="line">
@@ -6739,7 +6739,7 @@
         <p:spPr>
           <a:xfrm>
             <a:off x="1773936" y="3730752"/>
-            <a:ext cx="8174736" cy="475488"/>
+            <a:ext cx="10003536" cy="475488"/>
           </a:xfrm>
           <a:prstGeom prst="roundRect">
             <a:avLst>
@@ -6869,7 +6869,7 @@
         <p:spPr>
           <a:xfrm>
             <a:off x="1773936" y="3730752"/>
-            <a:ext cx="8174736" cy="54864"/>
+            <a:ext cx="10003536" cy="54864"/>
           </a:xfrm>
           <a:prstGeom prst="rect">
             <a:avLst/>
@@ -6913,7 +6913,7 @@
         <p:spPr>
           <a:xfrm>
             <a:off x="1664208" y="4352544"/>
-            <a:ext cx="8394192" cy="365760"/>
+            <a:ext cx="10222992" cy="365760"/>
           </a:xfrm>
           <a:prstGeom prst="roundRect">
             <a:avLst>
@@ -7220,7 +7220,7 @@
         <p:spPr>
           <a:xfrm>
             <a:off x="4315968" y="5010912"/>
-            <a:ext cx="888491" cy="475488"/>
+            <a:ext cx="1193291" cy="475488"/>
           </a:xfrm>
           <a:prstGeom prst="roundRect">
             <a:avLst>
@@ -7308,8 +7308,8 @@
         </p:nvSpPr>
         <p:spPr>
           <a:xfrm>
-            <a:off x="5277612" y="5010912"/>
-            <a:ext cx="888491" cy="475488"/>
+            <a:off x="5582412" y="5010912"/>
+            <a:ext cx="1193291" cy="475488"/>
           </a:xfrm>
           <a:prstGeom prst="roundRect">
             <a:avLst>
@@ -7397,8 +7397,8 @@
         </p:nvSpPr>
         <p:spPr>
           <a:xfrm>
-            <a:off x="6239255" y="5010912"/>
-            <a:ext cx="888491" cy="475488"/>
+            <a:off x="6848855" y="5010912"/>
+            <a:ext cx="1193291" cy="475488"/>
           </a:xfrm>
           <a:prstGeom prst="roundRect">
             <a:avLst>
@@ -7486,8 +7486,8 @@
         </p:nvSpPr>
         <p:spPr>
           <a:xfrm>
-            <a:off x="7200899" y="5010912"/>
-            <a:ext cx="888491" cy="475488"/>
+            <a:off x="8115300" y="5010912"/>
+            <a:ext cx="1193291" cy="475488"/>
           </a:xfrm>
           <a:prstGeom prst="roundRect">
             <a:avLst>
@@ -7575,8 +7575,8 @@
         </p:nvSpPr>
         <p:spPr>
           <a:xfrm>
-            <a:off x="8162543" y="5010912"/>
-            <a:ext cx="888491" cy="475488"/>
+            <a:off x="9381743" y="5010912"/>
+            <a:ext cx="1193291" cy="475488"/>
           </a:xfrm>
           <a:prstGeom prst="roundRect">
             <a:avLst>
@@ -7664,8 +7664,8 @@
         </p:nvSpPr>
         <p:spPr>
           <a:xfrm>
-            <a:off x="9124187" y="5010912"/>
-            <a:ext cx="888491" cy="475488"/>
+            <a:off x="10648188" y="5010912"/>
+            <a:ext cx="1193291" cy="475488"/>
           </a:xfrm>
           <a:prstGeom prst="roundRect">
             <a:avLst>
@@ -7754,7 +7754,7 @@
         <p:spPr>
           <a:xfrm>
             <a:off x="1664208" y="5614416"/>
-            <a:ext cx="8394192" cy="841248"/>
+            <a:ext cx="10222992" cy="841248"/>
           </a:xfrm>
           <a:prstGeom prst="roundRect">
             <a:avLst>
@@ -7802,7 +7802,7 @@
         <p:spPr>
           <a:xfrm>
             <a:off x="1773936" y="5669279"/>
-            <a:ext cx="8174736" cy="182880"/>
+            <a:ext cx="10003536" cy="182880"/>
           </a:xfrm>
           <a:prstGeom prst="rect">
             <a:avLst/>
@@ -7856,7 +7856,7 @@
         <p:spPr>
           <a:xfrm>
             <a:off x="1773936" y="5934455"/>
-            <a:ext cx="693281" cy="438912"/>
+            <a:ext cx="859536" cy="438912"/>
           </a:xfrm>
           <a:prstGeom prst="roundRect">
             <a:avLst>
@@ -7944,8 +7944,8 @@
         </p:nvSpPr>
         <p:spPr>
           <a:xfrm>
-            <a:off x="2522081" y="5934455"/>
-            <a:ext cx="693281" cy="438912"/>
+            <a:off x="2688336" y="5934455"/>
+            <a:ext cx="859536" cy="438912"/>
           </a:xfrm>
           <a:prstGeom prst="roundRect">
             <a:avLst>
@@ -8033,8 +8033,8 @@
         </p:nvSpPr>
         <p:spPr>
           <a:xfrm>
-            <a:off x="3270226" y="5934455"/>
-            <a:ext cx="693281" cy="438912"/>
+            <a:off x="3602736" y="5934455"/>
+            <a:ext cx="859536" cy="438912"/>
           </a:xfrm>
           <a:prstGeom prst="roundRect">
             <a:avLst>
@@ -8100,8 +8100,8 @@
         </p:nvSpPr>
         <p:spPr>
           <a:xfrm>
-            <a:off x="4018372" y="5934455"/>
-            <a:ext cx="693281" cy="438912"/>
+            <a:off x="4517136" y="5934455"/>
+            <a:ext cx="859536" cy="438912"/>
           </a:xfrm>
           <a:prstGeom prst="roundRect">
             <a:avLst>
@@ -8167,8 +8167,8 @@
         </p:nvSpPr>
         <p:spPr>
           <a:xfrm>
-            <a:off x="4766517" y="5934455"/>
-            <a:ext cx="693281" cy="438912"/>
+            <a:off x="5431536" y="5934455"/>
+            <a:ext cx="859536" cy="438912"/>
           </a:xfrm>
           <a:prstGeom prst="roundRect">
             <a:avLst>
@@ -8234,8 +8234,8 @@
         </p:nvSpPr>
         <p:spPr>
           <a:xfrm>
-            <a:off x="5514663" y="5934455"/>
-            <a:ext cx="693281" cy="438912"/>
+            <a:off x="6345936" y="5934455"/>
+            <a:ext cx="859536" cy="438912"/>
           </a:xfrm>
           <a:prstGeom prst="roundRect">
             <a:avLst>
@@ -8301,8 +8301,8 @@
         </p:nvSpPr>
         <p:spPr>
           <a:xfrm>
-            <a:off x="6262808" y="5934455"/>
-            <a:ext cx="693281" cy="438912"/>
+            <a:off x="7260336" y="5934455"/>
+            <a:ext cx="859536" cy="438912"/>
           </a:xfrm>
           <a:prstGeom prst="roundRect">
             <a:avLst>
@@ -8368,8 +8368,8 @@
         </p:nvSpPr>
         <p:spPr>
           <a:xfrm>
-            <a:off x="7010954" y="5934455"/>
-            <a:ext cx="693281" cy="438912"/>
+            <a:off x="8174736" y="5934455"/>
+            <a:ext cx="859536" cy="438912"/>
           </a:xfrm>
           <a:prstGeom prst="roundRect">
             <a:avLst>
@@ -8457,8 +8457,8 @@
         </p:nvSpPr>
         <p:spPr>
           <a:xfrm>
-            <a:off x="7759099" y="5934455"/>
-            <a:ext cx="693281" cy="438912"/>
+            <a:off x="9089136" y="5934455"/>
+            <a:ext cx="859536" cy="438912"/>
           </a:xfrm>
           <a:prstGeom prst="roundRect">
             <a:avLst>
@@ -8546,8 +8546,8 @@
         </p:nvSpPr>
         <p:spPr>
           <a:xfrm>
-            <a:off x="8507245" y="5934455"/>
-            <a:ext cx="693281" cy="438912"/>
+            <a:off x="10003536" y="5934455"/>
+            <a:ext cx="859536" cy="438912"/>
           </a:xfrm>
           <a:prstGeom prst="roundRect">
             <a:avLst>
@@ -8635,8 +8635,8 @@
         </p:nvSpPr>
         <p:spPr>
           <a:xfrm>
-            <a:off x="9255390" y="5934455"/>
-            <a:ext cx="693281" cy="438912"/>
+            <a:off x="10917936" y="5934455"/>
+            <a:ext cx="859536" cy="438912"/>
           </a:xfrm>
           <a:prstGeom prst="roundRect">
             <a:avLst>
@@ -8724,7 +8724,7 @@
         </p:nvSpPr>
         <p:spPr>
           <a:xfrm>
-            <a:off x="5715000" y="1664207"/>
+            <a:off x="6629400" y="1664207"/>
             <a:ext cx="292608" cy="109728"/>
           </a:xfrm>
           <a:prstGeom prst="downArrow">
@@ -8768,7 +8768,7 @@
         </p:nvSpPr>
         <p:spPr>
           <a:xfrm>
-            <a:off x="5715000" y="4297680"/>
+            <a:off x="6629400" y="4297680"/>
             <a:ext cx="292608" cy="109728"/>
           </a:xfrm>
           <a:prstGeom prst="downArrow">
@@ -8812,7 +8812,7 @@
         </p:nvSpPr>
         <p:spPr>
           <a:xfrm>
-            <a:off x="5715000" y="4700016"/>
+            <a:off x="6629400" y="4700016"/>
             <a:ext cx="292608" cy="109728"/>
           </a:xfrm>
           <a:prstGeom prst="downArrow">
@@ -8888,807 +8888,7 @@
       </p:cxnSp>
       <p:sp>
         <p:nvSpPr>
-          <p:cNvPr id="90" name="Rounded Rectangle 89"/>
-          <p:cNvSpPr/>
-          <p:nvPr/>
-        </p:nvSpPr>
-        <p:spPr>
-          <a:xfrm>
-            <a:off x="10168128" y="749808"/>
-            <a:ext cx="1737360" cy="4809744"/>
-          </a:xfrm>
-          <a:prstGeom prst="roundRect">
-            <a:avLst>
-              <a:gd name="adj" fmla="val 6000"/>
-            </a:avLst>
-          </a:prstGeom>
-          <a:solidFill>
-            <a:srgbClr val="222230"/>
-          </a:solidFill>
-          <a:ln>
-            <a:noFill/>
-          </a:ln>
-          <a:effectLst/>
-        </p:spPr>
-        <p:style>
-          <a:lnRef idx="1">
-            <a:schemeClr val="accent1"/>
-          </a:lnRef>
-          <a:fillRef idx="3">
-            <a:schemeClr val="accent1"/>
-          </a:fillRef>
-          <a:effectRef idx="2">
-            <a:schemeClr val="accent1"/>
-          </a:effectRef>
-          <a:fontRef idx="minor">
-            <a:schemeClr val="lt1"/>
-          </a:fontRef>
-        </p:style>
-        <p:txBody>
-          <a:bodyPr rtlCol="0" anchor="ctr" wrap="square"/>
-          <a:lstStyle/>
-          <a:p>
-            <a:pPr algn="ctr"/>
-          </a:p>
-        </p:txBody>
-      </p:sp>
-      <p:sp>
-        <p:nvSpPr>
-          <p:cNvPr id="91" name="Rectangle 90"/>
-          <p:cNvSpPr/>
-          <p:nvPr/>
-        </p:nvSpPr>
-        <p:spPr>
-          <a:xfrm>
-            <a:off x="10168128" y="749808"/>
-            <a:ext cx="1737360" cy="82296"/>
-          </a:xfrm>
-          <a:prstGeom prst="rect">
-            <a:avLst/>
-          </a:prstGeom>
-          <a:solidFill>
-            <a:srgbClr val="FFE600"/>
-          </a:solidFill>
-          <a:ln>
-            <a:noFill/>
-          </a:ln>
-          <a:effectLst/>
-        </p:spPr>
-        <p:style>
-          <a:lnRef idx="1">
-            <a:schemeClr val="accent1"/>
-          </a:lnRef>
-          <a:fillRef idx="3">
-            <a:schemeClr val="accent1"/>
-          </a:fillRef>
-          <a:effectRef idx="2">
-            <a:schemeClr val="accent1"/>
-          </a:effectRef>
-          <a:fontRef idx="minor">
-            <a:schemeClr val="lt1"/>
-          </a:fontRef>
-        </p:style>
-        <p:txBody>
-          <a:bodyPr rtlCol="0" anchor="ctr" wrap="square"/>
-          <a:lstStyle/>
-          <a:p>
-            <a:pPr algn="ctr"/>
-          </a:p>
-        </p:txBody>
-      </p:sp>
-      <p:sp>
-        <p:nvSpPr>
-          <p:cNvPr id="92" name="TextBox 91"/>
-          <p:cNvSpPr txBox="1"/>
-          <p:nvPr/>
-        </p:nvSpPr>
-        <p:spPr>
-          <a:xfrm>
-            <a:off x="10277855" y="859536"/>
-            <a:ext cx="1517904" cy="201168"/>
-          </a:xfrm>
-          <a:prstGeom prst="rect">
-            <a:avLst/>
-          </a:prstGeom>
-          <a:noFill/>
-        </p:spPr>
-        <p:txBody>
-          <a:bodyPr wrap="square" anchor="t" lIns="0" rIns="0" tIns="0" bIns="0">
-            <a:spAutoFit/>
-          </a:bodyPr>
-          <a:lstStyle/>
-          <a:p>
-            <a:pPr algn="l">
-              <a:lnSpc>
-                <a:spcPct val="100000"/>
-              </a:lnSpc>
-              <a:spcBef>
-                <a:spcPts val="0"/>
-              </a:spcBef>
-              <a:spcAft>
-                <a:spcPts val="0"/>
-              </a:spcAft>
-            </a:pPr>
-            <a:r>
-              <a:rPr sz="850" b="1" i="0">
-                <a:solidFill>
-                  <a:srgbClr val="FFE600"/>
-                </a:solidFill>
-                <a:latin typeface="Segoe UI"/>
-              </a:rPr>
-              <a:t>PLATFORM CAPABILITIES</a:t>
-            </a:r>
-          </a:p>
-        </p:txBody>
-      </p:sp>
-      <p:sp>
-        <p:nvSpPr>
-          <p:cNvPr id="93" name="Rounded Rectangle 92"/>
-          <p:cNvSpPr/>
-          <p:nvPr/>
-        </p:nvSpPr>
-        <p:spPr>
-          <a:xfrm>
-            <a:off x="10277855" y="1133856"/>
-            <a:ext cx="1517904" cy="808329"/>
-          </a:xfrm>
-          <a:prstGeom prst="roundRect">
-            <a:avLst>
-              <a:gd name="adj" fmla="val 6000"/>
-            </a:avLst>
-          </a:prstGeom>
-          <a:solidFill>
-            <a:srgbClr val="2E2E40"/>
-          </a:solidFill>
-          <a:ln w="7620">
-            <a:solidFill>
-              <a:srgbClr val="3C3C4E"/>
-            </a:solidFill>
-          </a:ln>
-          <a:effectLst/>
-        </p:spPr>
-        <p:style>
-          <a:lnRef idx="1">
-            <a:schemeClr val="accent1"/>
-          </a:lnRef>
-          <a:fillRef idx="3">
-            <a:schemeClr val="accent1"/>
-          </a:fillRef>
-          <a:effectRef idx="2">
-            <a:schemeClr val="accent1"/>
-          </a:effectRef>
-          <a:fontRef idx="minor">
-            <a:schemeClr val="lt1"/>
-          </a:fontRef>
-        </p:style>
-        <p:txBody>
-          <a:bodyPr rtlCol="0" anchor="ctr" wrap="square" lIns="27432" rIns="27432" tIns="9144" bIns="9144"/>
-          <a:lstStyle/>
-          <a:p>
-            <a:pPr algn="ctr">
-              <a:lnSpc>
-                <a:spcPct val="95000"/>
-              </a:lnSpc>
-              <a:spcBef>
-                <a:spcPts val="0"/>
-              </a:spcBef>
-              <a:spcAft>
-                <a:spcPts val="0"/>
-              </a:spcAft>
-            </a:pPr>
-            <a:r>
-              <a:rPr sz="750" b="1" i="0">
-                <a:solidFill>
-                  <a:srgbClr val="FFFFFF"/>
-                </a:solidFill>
-                <a:latin typeface="Segoe UI"/>
-              </a:rPr>
-              <a:t>Multi-agent</a:t>
-            </a:r>
-          </a:p>
-          <a:p>
-            <a:pPr algn="ctr">
-              <a:lnSpc>
-                <a:spcPct val="95000"/>
-              </a:lnSpc>
-              <a:spcBef>
-                <a:spcPts val="0"/>
-              </a:spcBef>
-              <a:spcAft>
-                <a:spcPts val="0"/>
-              </a:spcAft>
-            </a:pPr>
-            <a:r>
-              <a:rPr sz="750" b="1" i="0">
-                <a:solidFill>
-                  <a:srgbClr val="FFFFFF"/>
-                </a:solidFill>
-                <a:latin typeface="Segoe UI"/>
-              </a:rPr>
-              <a:t>orchestration</a:t>
-            </a:r>
-          </a:p>
-        </p:txBody>
-      </p:sp>
-      <p:sp>
-        <p:nvSpPr>
-          <p:cNvPr id="94" name="Rectangle 93"/>
-          <p:cNvSpPr/>
-          <p:nvPr/>
-        </p:nvSpPr>
-        <p:spPr>
-          <a:xfrm>
-            <a:off x="10277855" y="1133856"/>
-            <a:ext cx="45720" cy="808329"/>
-          </a:xfrm>
-          <a:prstGeom prst="rect">
-            <a:avLst/>
-          </a:prstGeom>
-          <a:solidFill>
-            <a:srgbClr val="FFE600"/>
-          </a:solidFill>
-          <a:ln>
-            <a:noFill/>
-          </a:ln>
-          <a:effectLst/>
-        </p:spPr>
-        <p:style>
-          <a:lnRef idx="1">
-            <a:schemeClr val="accent1"/>
-          </a:lnRef>
-          <a:fillRef idx="3">
-            <a:schemeClr val="accent1"/>
-          </a:fillRef>
-          <a:effectRef idx="2">
-            <a:schemeClr val="accent1"/>
-          </a:effectRef>
-          <a:fontRef idx="minor">
-            <a:schemeClr val="lt1"/>
-          </a:fontRef>
-        </p:style>
-        <p:txBody>
-          <a:bodyPr rtlCol="0" anchor="ctr" wrap="square"/>
-          <a:lstStyle/>
-          <a:p>
-            <a:pPr algn="ctr"/>
-          </a:p>
-        </p:txBody>
-      </p:sp>
-      <p:sp>
-        <p:nvSpPr>
-          <p:cNvPr id="95" name="Rounded Rectangle 94"/>
-          <p:cNvSpPr/>
-          <p:nvPr/>
-        </p:nvSpPr>
-        <p:spPr>
-          <a:xfrm>
-            <a:off x="10277855" y="2033625"/>
-            <a:ext cx="1517904" cy="808329"/>
-          </a:xfrm>
-          <a:prstGeom prst="roundRect">
-            <a:avLst>
-              <a:gd name="adj" fmla="val 6000"/>
-            </a:avLst>
-          </a:prstGeom>
-          <a:solidFill>
-            <a:srgbClr val="2E2E40"/>
-          </a:solidFill>
-          <a:ln w="7620">
-            <a:solidFill>
-              <a:srgbClr val="3C3C4E"/>
-            </a:solidFill>
-          </a:ln>
-          <a:effectLst/>
-        </p:spPr>
-        <p:style>
-          <a:lnRef idx="1">
-            <a:schemeClr val="accent1"/>
-          </a:lnRef>
-          <a:fillRef idx="3">
-            <a:schemeClr val="accent1"/>
-          </a:fillRef>
-          <a:effectRef idx="2">
-            <a:schemeClr val="accent1"/>
-          </a:effectRef>
-          <a:fontRef idx="minor">
-            <a:schemeClr val="lt1"/>
-          </a:fontRef>
-        </p:style>
-        <p:txBody>
-          <a:bodyPr rtlCol="0" anchor="ctr" wrap="square" lIns="27432" rIns="27432" tIns="9144" bIns="9144"/>
-          <a:lstStyle/>
-          <a:p>
-            <a:pPr algn="ctr">
-              <a:lnSpc>
-                <a:spcPct val="95000"/>
-              </a:lnSpc>
-              <a:spcBef>
-                <a:spcPts val="0"/>
-              </a:spcBef>
-              <a:spcAft>
-                <a:spcPts val="0"/>
-              </a:spcAft>
-            </a:pPr>
-            <a:r>
-              <a:rPr sz="750" b="1" i="0">
-                <a:solidFill>
-                  <a:srgbClr val="FFFFFF"/>
-                </a:solidFill>
-                <a:latin typeface="Segoe UI"/>
-              </a:rPr>
-              <a:t>Human-in-the-loop</a:t>
-            </a:r>
-          </a:p>
-          <a:p>
-            <a:pPr algn="ctr">
-              <a:lnSpc>
-                <a:spcPct val="95000"/>
-              </a:lnSpc>
-              <a:spcBef>
-                <a:spcPts val="0"/>
-              </a:spcBef>
-              <a:spcAft>
-                <a:spcPts val="0"/>
-              </a:spcAft>
-            </a:pPr>
-            <a:r>
-              <a:rPr sz="750" b="1" i="0">
-                <a:solidFill>
-                  <a:srgbClr val="FFFFFF"/>
-                </a:solidFill>
-                <a:latin typeface="Segoe UI"/>
-              </a:rPr>
-              <a:t>control</a:t>
-            </a:r>
-          </a:p>
-        </p:txBody>
-      </p:sp>
-      <p:sp>
-        <p:nvSpPr>
-          <p:cNvPr id="96" name="Rectangle 95"/>
-          <p:cNvSpPr/>
-          <p:nvPr/>
-        </p:nvSpPr>
-        <p:spPr>
-          <a:xfrm>
-            <a:off x="10277855" y="2033625"/>
-            <a:ext cx="45720" cy="808329"/>
-          </a:xfrm>
-          <a:prstGeom prst="rect">
-            <a:avLst/>
-          </a:prstGeom>
-          <a:solidFill>
-            <a:srgbClr val="FFB020"/>
-          </a:solidFill>
-          <a:ln>
-            <a:noFill/>
-          </a:ln>
-          <a:effectLst/>
-        </p:spPr>
-        <p:style>
-          <a:lnRef idx="1">
-            <a:schemeClr val="accent1"/>
-          </a:lnRef>
-          <a:fillRef idx="3">
-            <a:schemeClr val="accent1"/>
-          </a:fillRef>
-          <a:effectRef idx="2">
-            <a:schemeClr val="accent1"/>
-          </a:effectRef>
-          <a:fontRef idx="minor">
-            <a:schemeClr val="lt1"/>
-          </a:fontRef>
-        </p:style>
-        <p:txBody>
-          <a:bodyPr rtlCol="0" anchor="ctr" wrap="square"/>
-          <a:lstStyle/>
-          <a:p>
-            <a:pPr algn="ctr"/>
-          </a:p>
-        </p:txBody>
-      </p:sp>
-      <p:sp>
-        <p:nvSpPr>
-          <p:cNvPr id="97" name="Rounded Rectangle 96"/>
-          <p:cNvSpPr/>
-          <p:nvPr/>
-        </p:nvSpPr>
-        <p:spPr>
-          <a:xfrm>
-            <a:off x="10277855" y="2933395"/>
-            <a:ext cx="1517904" cy="808329"/>
-          </a:xfrm>
-          <a:prstGeom prst="roundRect">
-            <a:avLst>
-              <a:gd name="adj" fmla="val 6000"/>
-            </a:avLst>
-          </a:prstGeom>
-          <a:solidFill>
-            <a:srgbClr val="2E2E40"/>
-          </a:solidFill>
-          <a:ln w="7620">
-            <a:solidFill>
-              <a:srgbClr val="3C3C4E"/>
-            </a:solidFill>
-          </a:ln>
-          <a:effectLst/>
-        </p:spPr>
-        <p:style>
-          <a:lnRef idx="1">
-            <a:schemeClr val="accent1"/>
-          </a:lnRef>
-          <a:fillRef idx="3">
-            <a:schemeClr val="accent1"/>
-          </a:fillRef>
-          <a:effectRef idx="2">
-            <a:schemeClr val="accent1"/>
-          </a:effectRef>
-          <a:fontRef idx="minor">
-            <a:schemeClr val="lt1"/>
-          </a:fontRef>
-        </p:style>
-        <p:txBody>
-          <a:bodyPr rtlCol="0" anchor="ctr" wrap="square" lIns="27432" rIns="27432" tIns="9144" bIns="9144"/>
-          <a:lstStyle/>
-          <a:p>
-            <a:pPr algn="ctr">
-              <a:lnSpc>
-                <a:spcPct val="95000"/>
-              </a:lnSpc>
-              <a:spcBef>
-                <a:spcPts val="0"/>
-              </a:spcBef>
-              <a:spcAft>
-                <a:spcPts val="0"/>
-              </a:spcAft>
-            </a:pPr>
-            <a:r>
-              <a:rPr sz="750" b="1" i="0">
-                <a:solidFill>
-                  <a:srgbClr val="FFFFFF"/>
-                </a:solidFill>
-                <a:latin typeface="Segoe UI"/>
-              </a:rPr>
-              <a:t>Exception governance</a:t>
-            </a:r>
-          </a:p>
-          <a:p>
-            <a:pPr algn="ctr">
-              <a:lnSpc>
-                <a:spcPct val="95000"/>
-              </a:lnSpc>
-              <a:spcBef>
-                <a:spcPts val="0"/>
-              </a:spcBef>
-              <a:spcAft>
-                <a:spcPts val="0"/>
-              </a:spcAft>
-            </a:pPr>
-            <a:r>
-              <a:rPr sz="750" b="1" i="0">
-                <a:solidFill>
-                  <a:srgbClr val="FFFFFF"/>
-                </a:solidFill>
-                <a:latin typeface="Segoe UI"/>
-              </a:rPr>
-              <a:t>&amp; SLA routing</a:t>
-            </a:r>
-          </a:p>
-        </p:txBody>
-      </p:sp>
-      <p:sp>
-        <p:nvSpPr>
-          <p:cNvPr id="98" name="Rectangle 97"/>
-          <p:cNvSpPr/>
-          <p:nvPr/>
-        </p:nvSpPr>
-        <p:spPr>
-          <a:xfrm>
-            <a:off x="10277855" y="2933395"/>
-            <a:ext cx="45720" cy="808329"/>
-          </a:xfrm>
-          <a:prstGeom prst="rect">
-            <a:avLst/>
-          </a:prstGeom>
-          <a:solidFill>
-            <a:srgbClr val="FF5A5A"/>
-          </a:solidFill>
-          <a:ln>
-            <a:noFill/>
-          </a:ln>
-          <a:effectLst/>
-        </p:spPr>
-        <p:style>
-          <a:lnRef idx="1">
-            <a:schemeClr val="accent1"/>
-          </a:lnRef>
-          <a:fillRef idx="3">
-            <a:schemeClr val="accent1"/>
-          </a:fillRef>
-          <a:effectRef idx="2">
-            <a:schemeClr val="accent1"/>
-          </a:effectRef>
-          <a:fontRef idx="minor">
-            <a:schemeClr val="lt1"/>
-          </a:fontRef>
-        </p:style>
-        <p:txBody>
-          <a:bodyPr rtlCol="0" anchor="ctr" wrap="square"/>
-          <a:lstStyle/>
-          <a:p>
-            <a:pPr algn="ctr"/>
-          </a:p>
-        </p:txBody>
-      </p:sp>
-      <p:sp>
-        <p:nvSpPr>
-          <p:cNvPr id="99" name="Rounded Rectangle 98"/>
-          <p:cNvSpPr/>
-          <p:nvPr/>
-        </p:nvSpPr>
-        <p:spPr>
-          <a:xfrm>
-            <a:off x="10277855" y="3833164"/>
-            <a:ext cx="1517904" cy="808329"/>
-          </a:xfrm>
-          <a:prstGeom prst="roundRect">
-            <a:avLst>
-              <a:gd name="adj" fmla="val 6000"/>
-            </a:avLst>
-          </a:prstGeom>
-          <a:solidFill>
-            <a:srgbClr val="2E2E40"/>
-          </a:solidFill>
-          <a:ln w="7620">
-            <a:solidFill>
-              <a:srgbClr val="3C3C4E"/>
-            </a:solidFill>
-          </a:ln>
-          <a:effectLst/>
-        </p:spPr>
-        <p:style>
-          <a:lnRef idx="1">
-            <a:schemeClr val="accent1"/>
-          </a:lnRef>
-          <a:fillRef idx="3">
-            <a:schemeClr val="accent1"/>
-          </a:fillRef>
-          <a:effectRef idx="2">
-            <a:schemeClr val="accent1"/>
-          </a:effectRef>
-          <a:fontRef idx="minor">
-            <a:schemeClr val="lt1"/>
-          </a:fontRef>
-        </p:style>
-        <p:txBody>
-          <a:bodyPr rtlCol="0" anchor="ctr" wrap="square" lIns="27432" rIns="27432" tIns="9144" bIns="9144"/>
-          <a:lstStyle/>
-          <a:p>
-            <a:pPr algn="ctr">
-              <a:lnSpc>
-                <a:spcPct val="95000"/>
-              </a:lnSpc>
-              <a:spcBef>
-                <a:spcPts val="0"/>
-              </a:spcBef>
-              <a:spcAft>
-                <a:spcPts val="0"/>
-              </a:spcAft>
-            </a:pPr>
-            <a:r>
-              <a:rPr sz="750" b="1" i="0">
-                <a:solidFill>
-                  <a:srgbClr val="FFFFFF"/>
-                </a:solidFill>
-                <a:latin typeface="Segoe UI"/>
-              </a:rPr>
-              <a:t>Audit &amp;</a:t>
-            </a:r>
-          </a:p>
-          <a:p>
-            <a:pPr algn="ctr">
-              <a:lnSpc>
-                <a:spcPct val="95000"/>
-              </a:lnSpc>
-              <a:spcBef>
-                <a:spcPts val="0"/>
-              </a:spcBef>
-              <a:spcAft>
-                <a:spcPts val="0"/>
-              </a:spcAft>
-            </a:pPr>
-            <a:r>
-              <a:rPr sz="750" b="1" i="0">
-                <a:solidFill>
-                  <a:srgbClr val="FFFFFF"/>
-                </a:solidFill>
-                <a:latin typeface="Segoe UI"/>
-              </a:rPr>
-              <a:t>traceability</a:t>
-            </a:r>
-          </a:p>
-        </p:txBody>
-      </p:sp>
-      <p:sp>
-        <p:nvSpPr>
-          <p:cNvPr id="100" name="Rectangle 99"/>
-          <p:cNvSpPr/>
-          <p:nvPr/>
-        </p:nvSpPr>
-        <p:spPr>
-          <a:xfrm>
-            <a:off x="10277855" y="3833164"/>
-            <a:ext cx="45720" cy="808329"/>
-          </a:xfrm>
-          <a:prstGeom prst="rect">
-            <a:avLst/>
-          </a:prstGeom>
-          <a:solidFill>
-            <a:srgbClr val="4A9EFF"/>
-          </a:solidFill>
-          <a:ln>
-            <a:noFill/>
-          </a:ln>
-          <a:effectLst/>
-        </p:spPr>
-        <p:style>
-          <a:lnRef idx="1">
-            <a:schemeClr val="accent1"/>
-          </a:lnRef>
-          <a:fillRef idx="3">
-            <a:schemeClr val="accent1"/>
-          </a:fillRef>
-          <a:effectRef idx="2">
-            <a:schemeClr val="accent1"/>
-          </a:effectRef>
-          <a:fontRef idx="minor">
-            <a:schemeClr val="lt1"/>
-          </a:fontRef>
-        </p:style>
-        <p:txBody>
-          <a:bodyPr rtlCol="0" anchor="ctr" wrap="square"/>
-          <a:lstStyle/>
-          <a:p>
-            <a:pPr algn="ctr"/>
-          </a:p>
-        </p:txBody>
-      </p:sp>
-      <p:sp>
-        <p:nvSpPr>
-          <p:cNvPr id="101" name="Rounded Rectangle 100"/>
-          <p:cNvSpPr/>
-          <p:nvPr/>
-        </p:nvSpPr>
-        <p:spPr>
-          <a:xfrm>
-            <a:off x="10277855" y="4732934"/>
-            <a:ext cx="1517904" cy="808329"/>
-          </a:xfrm>
-          <a:prstGeom prst="roundRect">
-            <a:avLst>
-              <a:gd name="adj" fmla="val 6000"/>
-            </a:avLst>
-          </a:prstGeom>
-          <a:solidFill>
-            <a:srgbClr val="2E2E40"/>
-          </a:solidFill>
-          <a:ln w="7620">
-            <a:solidFill>
-              <a:srgbClr val="3C3C4E"/>
-            </a:solidFill>
-          </a:ln>
-          <a:effectLst/>
-        </p:spPr>
-        <p:style>
-          <a:lnRef idx="1">
-            <a:schemeClr val="accent1"/>
-          </a:lnRef>
-          <a:fillRef idx="3">
-            <a:schemeClr val="accent1"/>
-          </a:fillRef>
-          <a:effectRef idx="2">
-            <a:schemeClr val="accent1"/>
-          </a:effectRef>
-          <a:fontRef idx="minor">
-            <a:schemeClr val="lt1"/>
-          </a:fontRef>
-        </p:style>
-        <p:txBody>
-          <a:bodyPr rtlCol="0" anchor="ctr" wrap="square" lIns="27432" rIns="27432" tIns="9144" bIns="9144"/>
-          <a:lstStyle/>
-          <a:p>
-            <a:pPr algn="ctr">
-              <a:lnSpc>
-                <a:spcPct val="95000"/>
-              </a:lnSpc>
-              <a:spcBef>
-                <a:spcPts val="0"/>
-              </a:spcBef>
-              <a:spcAft>
-                <a:spcPts val="0"/>
-              </a:spcAft>
-            </a:pPr>
-            <a:r>
-              <a:rPr sz="750" b="1" i="0">
-                <a:solidFill>
-                  <a:srgbClr val="FFFFFF"/>
-                </a:solidFill>
-                <a:latin typeface="Segoe UI"/>
-              </a:rPr>
-              <a:t>Pause &amp; resume</a:t>
-            </a:r>
-          </a:p>
-          <a:p>
-            <a:pPr algn="ctr">
-              <a:lnSpc>
-                <a:spcPct val="95000"/>
-              </a:lnSpc>
-              <a:spcBef>
-                <a:spcPts val="0"/>
-              </a:spcBef>
-              <a:spcAft>
-                <a:spcPts val="0"/>
-              </a:spcAft>
-            </a:pPr>
-            <a:r>
-              <a:rPr sz="750" b="1" i="0">
-                <a:solidFill>
-                  <a:srgbClr val="FFFFFF"/>
-                </a:solidFill>
-                <a:latin typeface="Segoe UI"/>
-              </a:rPr>
-              <a:t>workflow</a:t>
-            </a:r>
-          </a:p>
-        </p:txBody>
-      </p:sp>
-      <p:sp>
-        <p:nvSpPr>
-          <p:cNvPr id="102" name="Rectangle 101"/>
-          <p:cNvSpPr/>
-          <p:nvPr/>
-        </p:nvSpPr>
-        <p:spPr>
-          <a:xfrm>
-            <a:off x="10277855" y="4732934"/>
-            <a:ext cx="45720" cy="808329"/>
-          </a:xfrm>
-          <a:prstGeom prst="rect">
-            <a:avLst/>
-          </a:prstGeom>
-          <a:solidFill>
-            <a:srgbClr val="35C759"/>
-          </a:solidFill>
-          <a:ln>
-            <a:noFill/>
-          </a:ln>
-          <a:effectLst/>
-        </p:spPr>
-        <p:style>
-          <a:lnRef idx="1">
-            <a:schemeClr val="accent1"/>
-          </a:lnRef>
-          <a:fillRef idx="3">
-            <a:schemeClr val="accent1"/>
-          </a:fillRef>
-          <a:effectRef idx="2">
-            <a:schemeClr val="accent1"/>
-          </a:effectRef>
-          <a:fontRef idx="minor">
-            <a:schemeClr val="lt1"/>
-          </a:fontRef>
-        </p:style>
-        <p:txBody>
-          <a:bodyPr rtlCol="0" anchor="ctr" wrap="square"/>
-          <a:lstStyle/>
-          <a:p>
-            <a:pPr algn="ctr"/>
-          </a:p>
-        </p:txBody>
-      </p:sp>
-      <p:sp>
-        <p:nvSpPr>
-          <p:cNvPr id="103" name="TextBox 102"/>
+          <p:cNvPr id="90" name="TextBox 89"/>
           <p:cNvSpPr txBox="1"/>
           <p:nvPr/>
         </p:nvSpPr>

</xml_diff>

<commit_message>
docs: describe PO intake as any channel (Email/Excel/PDF/Scanned PO, etc.)
</commit_message>
<xml_diff>
--- a/demo/Order-Creation-Orchestration-Architecture.pptx
+++ b/demo/Order-Creation-Orchestration-Architecture.pptx
@@ -4125,7 +4125,7 @@
                 </a:solidFill>
                 <a:latin typeface="Segoe UI"/>
               </a:rPr>
-              <a:t>PO INTAKE  —  4 methods</a:t>
+              <a:t>PO INTAKE  —  any channel</a:t>
             </a:r>
           </a:p>
         </p:txBody>
@@ -4170,7 +4170,7 @@
                 </a:solidFill>
                 <a:latin typeface="Segoe UI"/>
               </a:rPr>
-              <a:t>• Email PO      • PDF PO</a:t>
+              <a:t>Received as Email PO,</a:t>
             </a:r>
           </a:p>
           <a:p>
@@ -4192,7 +4192,7 @@
                 </a:solidFill>
                 <a:latin typeface="Segoe UI"/>
               </a:rPr>
-              <a:t>• Excel PO (.xlsx/.xls)</a:t>
+              <a:t>Excel PO, PDF PO,</a:t>
             </a:r>
           </a:p>
           <a:p>
@@ -4214,7 +4214,7 @@
                 </a:solidFill>
                 <a:latin typeface="Segoe UI"/>
               </a:rPr>
-              <a:t>• Scanned PO</a:t>
+              <a:t>Scanned PO, etc.</a:t>
             </a:r>
           </a:p>
         </p:txBody>

</xml_diff>

<commit_message>
docs: shorten PO intake description to "Received as Email PO, Excel PO etc."
</commit_message>
<xml_diff>
--- a/demo/Order-Creation-Orchestration-Architecture.pptx
+++ b/demo/Order-Creation-Orchestration-Architecture.pptx
@@ -4192,29 +4192,7 @@
                 </a:solidFill>
                 <a:latin typeface="Segoe UI"/>
               </a:rPr>
-              <a:t>Excel PO, PDF PO,</a:t>
-            </a:r>
-          </a:p>
-          <a:p>
-            <a:pPr algn="l">
-              <a:lnSpc>
-                <a:spcPct val="104000"/>
-              </a:lnSpc>
-              <a:spcBef>
-                <a:spcPts val="0"/>
-              </a:spcBef>
-              <a:spcAft>
-                <a:spcPts val="0"/>
-              </a:spcAft>
-            </a:pPr>
-            <a:r>
-              <a:rPr sz="660" b="0" i="0">
-                <a:solidFill>
-                  <a:srgbClr val="C2C2D0"/>
-                </a:solidFill>
-                <a:latin typeface="Segoe UI"/>
-              </a:rPr>
-              <a:t>Scanned PO, etc.</a:t>
+              <a:t>Excel PO etc.</a:t>
             </a:r>
           </a:p>
         </p:txBody>

</xml_diff>

<commit_message>
docs: rename Data Foundation tier to Legacy Data System in architecture slide
</commit_message>
<xml_diff>
--- a/demo/Order-Creation-Orchestration-Architecture.pptx
+++ b/demo/Order-Creation-Orchestration-Architecture.pptx
@@ -3859,7 +3859,7 @@
                 </a:solidFill>
                 <a:latin typeface="Segoe UI"/>
               </a:rPr>
-              <a:t>DATA</a:t>
+              <a:t>LEGACY DATA</a:t>
             </a:r>
           </a:p>
           <a:p>
@@ -3881,7 +3881,7 @@
                 </a:solidFill>
                 <a:latin typeface="Segoe UI"/>
               </a:rPr>
-              <a:t>FOUNDATION</a:t>
+              <a:t>SYSTEM</a:t>
             </a:r>
           </a:p>
         </p:txBody>

</xml_diff>

<commit_message>
docs: rename CSR decision layer to Human decision layer in architecture slide
</commit_message>
<xml_diff>
--- a/demo/Order-Creation-Orchestration-Architecture.pptx
+++ b/demo/Order-Creation-Orchestration-Architecture.pptx
@@ -3488,7 +3488,7 @@
                 </a:solidFill>
                 <a:latin typeface="Segoe UI"/>
               </a:rPr>
-              <a:t>&amp; CSR</a:t>
+              <a:t>&amp; HUMAN</a:t>
             </a:r>
           </a:p>
           <a:p>
@@ -6770,7 +6770,7 @@
                 </a:solidFill>
                 <a:latin typeface="Segoe UI"/>
               </a:rPr>
-              <a:t>⚠  CSR DECISION LAYER   </a:t>
+              <a:t>⚠  HUMAN DECISION LAYER   </a:t>
             </a:r>
             <a:r>
               <a:rPr sz="760" b="0" i="0">

</xml_diff>

<commit_message>
docs: remove separate exception governance layer and reflow architecture slide
</commit_message>
<xml_diff>
--- a/demo/Order-Creation-Orchestration-Architecture.pptx
+++ b/demo/Order-Creation-Orchestration-Architecture.pptx
@@ -3567,8 +3567,8 @@
         </p:nvSpPr>
         <p:spPr>
           <a:xfrm>
-            <a:off x="301752" y="4352544"/>
-            <a:ext cx="1225296" cy="365760"/>
+            <a:off x="301752" y="4443984"/>
+            <a:ext cx="1225296" cy="932688"/>
           </a:xfrm>
           <a:prstGeom prst="roundRect">
             <a:avLst>
@@ -3619,7 +3619,29 @@
                 </a:solidFill>
                 <a:latin typeface="Segoe UI"/>
               </a:rPr>
-              <a:t>GOVERNANCE</a:t>
+              <a:t>ORDER CREATION</a:t>
+            </a:r>
+          </a:p>
+          <a:p>
+            <a:pPr algn="ctr">
+              <a:lnSpc>
+                <a:spcPct val="98000"/>
+              </a:lnSpc>
+              <a:spcBef>
+                <a:spcPts val="0"/>
+              </a:spcBef>
+              <a:spcAft>
+                <a:spcPts val="0"/>
+              </a:spcAft>
+            </a:pPr>
+            <a:r>
+              <a:rPr sz="830" b="1" i="0">
+                <a:solidFill>
+                  <a:srgbClr val="FFFFFF"/>
+                </a:solidFill>
+                <a:latin typeface="Segoe UI"/>
+              </a:rPr>
+              <a:t>&amp; DOWNSTREAM</a:t>
             </a:r>
           </a:p>
         </p:txBody>
@@ -3632,14 +3654,14 @@
         </p:nvSpPr>
         <p:spPr>
           <a:xfrm>
-            <a:off x="301752" y="4352544"/>
-            <a:ext cx="54864" cy="365760"/>
+            <a:off x="301752" y="4443984"/>
+            <a:ext cx="54864" cy="932688"/>
           </a:xfrm>
           <a:prstGeom prst="rect">
             <a:avLst/>
           </a:prstGeom>
           <a:solidFill>
-            <a:srgbClr val="FF5A5A"/>
+            <a:srgbClr val="35C759"/>
           </a:solidFill>
           <a:ln>
             <a:noFill/>
@@ -3676,8 +3698,8 @@
         </p:nvSpPr>
         <p:spPr>
           <a:xfrm>
-            <a:off x="301752" y="4773168"/>
-            <a:ext cx="1225296" cy="786384"/>
+            <a:off x="301752" y="5486400"/>
+            <a:ext cx="1225296" cy="969264"/>
           </a:xfrm>
           <a:prstGeom prst="roundRect">
             <a:avLst>
@@ -3728,7 +3750,7 @@
                 </a:solidFill>
                 <a:latin typeface="Segoe UI"/>
               </a:rPr>
-              <a:t>ORDER CREATION</a:t>
+              <a:t>LEGACY DATA</a:t>
             </a:r>
           </a:p>
           <a:p>
@@ -3750,7 +3772,7 @@
                 </a:solidFill>
                 <a:latin typeface="Segoe UI"/>
               </a:rPr>
-              <a:t>&amp; DOWNSTREAM</a:t>
+              <a:t>SYSTEM</a:t>
             </a:r>
           </a:p>
         </p:txBody>
@@ -3763,139 +3785,8 @@
         </p:nvSpPr>
         <p:spPr>
           <a:xfrm>
-            <a:off x="301752" y="4773168"/>
-            <a:ext cx="54864" cy="786384"/>
-          </a:xfrm>
-          <a:prstGeom prst="rect">
-            <a:avLst/>
-          </a:prstGeom>
-          <a:solidFill>
-            <a:srgbClr val="35C759"/>
-          </a:solidFill>
-          <a:ln>
-            <a:noFill/>
-          </a:ln>
-          <a:effectLst/>
-        </p:spPr>
-        <p:style>
-          <a:lnRef idx="1">
-            <a:schemeClr val="accent1"/>
-          </a:lnRef>
-          <a:fillRef idx="3">
-            <a:schemeClr val="accent1"/>
-          </a:fillRef>
-          <a:effectRef idx="2">
-            <a:schemeClr val="accent1"/>
-          </a:effectRef>
-          <a:fontRef idx="minor">
-            <a:schemeClr val="lt1"/>
-          </a:fontRef>
-        </p:style>
-        <p:txBody>
-          <a:bodyPr rtlCol="0" anchor="ctr" wrap="square"/>
-          <a:lstStyle/>
-          <a:p>
-            <a:pPr algn="ctr"/>
-          </a:p>
-        </p:txBody>
-      </p:sp>
-      <p:sp>
-        <p:nvSpPr>
-          <p:cNvPr id="14" name="Rounded Rectangle 13"/>
-          <p:cNvSpPr/>
-          <p:nvPr/>
-        </p:nvSpPr>
-        <p:spPr>
-          <a:xfrm>
-            <a:off x="301752" y="5614416"/>
-            <a:ext cx="1225296" cy="841248"/>
-          </a:xfrm>
-          <a:prstGeom prst="roundRect">
-            <a:avLst>
-              <a:gd name="adj" fmla="val 6000"/>
-            </a:avLst>
-          </a:prstGeom>
-          <a:solidFill>
-            <a:srgbClr val="222230"/>
-          </a:solidFill>
-          <a:ln>
-            <a:noFill/>
-          </a:ln>
-          <a:effectLst/>
-        </p:spPr>
-        <p:style>
-          <a:lnRef idx="1">
-            <a:schemeClr val="accent1"/>
-          </a:lnRef>
-          <a:fillRef idx="3">
-            <a:schemeClr val="accent1"/>
-          </a:fillRef>
-          <a:effectRef idx="2">
-            <a:schemeClr val="accent1"/>
-          </a:effectRef>
-          <a:fontRef idx="minor">
-            <a:schemeClr val="lt1"/>
-          </a:fontRef>
-        </p:style>
-        <p:txBody>
-          <a:bodyPr rtlCol="0" anchor="ctr" wrap="square" lIns="27432" rIns="27432" tIns="9144" bIns="9144"/>
-          <a:lstStyle/>
-          <a:p>
-            <a:pPr algn="ctr">
-              <a:lnSpc>
-                <a:spcPct val="98000"/>
-              </a:lnSpc>
-              <a:spcBef>
-                <a:spcPts val="0"/>
-              </a:spcBef>
-              <a:spcAft>
-                <a:spcPts val="0"/>
-              </a:spcAft>
-            </a:pPr>
-            <a:r>
-              <a:rPr sz="830" b="1" i="0">
-                <a:solidFill>
-                  <a:srgbClr val="FFFFFF"/>
-                </a:solidFill>
-                <a:latin typeface="Segoe UI"/>
-              </a:rPr>
-              <a:t>LEGACY DATA</a:t>
-            </a:r>
-          </a:p>
-          <a:p>
-            <a:pPr algn="ctr">
-              <a:lnSpc>
-                <a:spcPct val="98000"/>
-              </a:lnSpc>
-              <a:spcBef>
-                <a:spcPts val="0"/>
-              </a:spcBef>
-              <a:spcAft>
-                <a:spcPts val="0"/>
-              </a:spcAft>
-            </a:pPr>
-            <a:r>
-              <a:rPr sz="830" b="1" i="0">
-                <a:solidFill>
-                  <a:srgbClr val="FFFFFF"/>
-                </a:solidFill>
-                <a:latin typeface="Segoe UI"/>
-              </a:rPr>
-              <a:t>SYSTEM</a:t>
-            </a:r>
-          </a:p>
-        </p:txBody>
-      </p:sp>
-      <p:sp>
-        <p:nvSpPr>
-          <p:cNvPr id="15" name="Rectangle 14"/>
-          <p:cNvSpPr/>
-          <p:nvPr/>
-        </p:nvSpPr>
-        <p:spPr>
-          <a:xfrm>
-            <a:off x="301752" y="5614416"/>
-            <a:ext cx="54864" cy="841248"/>
+            <a:off x="301752" y="5486400"/>
+            <a:ext cx="54864" cy="969264"/>
           </a:xfrm>
           <a:prstGeom prst="rect">
             <a:avLst/>
@@ -3932,7 +3823,7 @@
       </p:sp>
       <p:sp>
         <p:nvSpPr>
-          <p:cNvPr id="16" name="TextBox 15"/>
+          <p:cNvPr id="14" name="TextBox 13"/>
           <p:cNvSpPr txBox="1"/>
           <p:nvPr/>
         </p:nvSpPr>
@@ -3995,7 +3886,7 @@
       </p:sp>
       <p:sp>
         <p:nvSpPr>
-          <p:cNvPr id="17" name="Rounded Rectangle 16"/>
+          <p:cNvPr id="15" name="Rounded Rectangle 14"/>
           <p:cNvSpPr/>
           <p:nvPr/>
         </p:nvSpPr>
@@ -4043,7 +3934,7 @@
       </p:sp>
       <p:sp>
         <p:nvSpPr>
-          <p:cNvPr id="18" name="Rectangle 17"/>
+          <p:cNvPr id="16" name="Rectangle 15"/>
           <p:cNvSpPr/>
           <p:nvPr/>
         </p:nvSpPr>
@@ -4087,7 +3978,7 @@
       </p:sp>
       <p:sp>
         <p:nvSpPr>
-          <p:cNvPr id="19" name="TextBox 18"/>
+          <p:cNvPr id="17" name="TextBox 16"/>
           <p:cNvSpPr txBox="1"/>
           <p:nvPr/>
         </p:nvSpPr>
@@ -4132,7 +4023,7 @@
       </p:sp>
       <p:sp>
         <p:nvSpPr>
-          <p:cNvPr id="20" name="TextBox 19"/>
+          <p:cNvPr id="18" name="TextBox 17"/>
           <p:cNvSpPr txBox="1"/>
           <p:nvPr/>
         </p:nvSpPr>
@@ -4199,7 +4090,7 @@
       </p:sp>
       <p:sp>
         <p:nvSpPr>
-          <p:cNvPr id="21" name="Chevron 20"/>
+          <p:cNvPr id="19" name="Chevron 18"/>
           <p:cNvSpPr/>
           <p:nvPr/>
         </p:nvSpPr>
@@ -4243,7 +4134,7 @@
       </p:sp>
       <p:sp>
         <p:nvSpPr>
-          <p:cNvPr id="22" name="Rounded Rectangle 21"/>
+          <p:cNvPr id="20" name="Rounded Rectangle 19"/>
           <p:cNvSpPr/>
           <p:nvPr/>
         </p:nvSpPr>
@@ -4291,7 +4182,7 @@
       </p:sp>
       <p:sp>
         <p:nvSpPr>
-          <p:cNvPr id="23" name="Rectangle 22"/>
+          <p:cNvPr id="21" name="Rectangle 20"/>
           <p:cNvSpPr/>
           <p:nvPr/>
         </p:nvSpPr>
@@ -4335,7 +4226,7 @@
       </p:sp>
       <p:sp>
         <p:nvSpPr>
-          <p:cNvPr id="24" name="TextBox 23"/>
+          <p:cNvPr id="22" name="TextBox 21"/>
           <p:cNvSpPr txBox="1"/>
           <p:nvPr/>
         </p:nvSpPr>
@@ -4380,7 +4271,7 @@
       </p:sp>
       <p:sp>
         <p:nvSpPr>
-          <p:cNvPr id="25" name="TextBox 24"/>
+          <p:cNvPr id="23" name="TextBox 22"/>
           <p:cNvSpPr txBox="1"/>
           <p:nvPr/>
         </p:nvSpPr>
@@ -4434,7 +4325,7 @@
       </p:sp>
       <p:sp>
         <p:nvSpPr>
-          <p:cNvPr id="26" name="Rounded Rectangle 25"/>
+          <p:cNvPr id="24" name="Rounded Rectangle 23"/>
           <p:cNvSpPr/>
           <p:nvPr/>
         </p:nvSpPr>
@@ -4482,7 +4373,7 @@
       </p:sp>
       <p:sp>
         <p:nvSpPr>
-          <p:cNvPr id="27" name="Rounded Rectangle 26"/>
+          <p:cNvPr id="25" name="Rounded Rectangle 24"/>
           <p:cNvSpPr/>
           <p:nvPr/>
         </p:nvSpPr>
@@ -4558,7 +4449,7 @@
       </p:sp>
       <p:sp>
         <p:nvSpPr>
-          <p:cNvPr id="28" name="Down Arrow 27"/>
+          <p:cNvPr id="26" name="Down Arrow 25"/>
           <p:cNvSpPr/>
           <p:nvPr/>
         </p:nvSpPr>
@@ -4602,7 +4493,7 @@
       </p:sp>
       <p:sp>
         <p:nvSpPr>
-          <p:cNvPr id="29" name="Rounded Rectangle 28"/>
+          <p:cNvPr id="27" name="Rounded Rectangle 26"/>
           <p:cNvSpPr/>
           <p:nvPr/>
         </p:nvSpPr>
@@ -4744,7 +4635,7 @@
       </p:sp>
       <p:sp>
         <p:nvSpPr>
-          <p:cNvPr id="30" name="Rectangle 29"/>
+          <p:cNvPr id="28" name="Rectangle 27"/>
           <p:cNvSpPr/>
           <p:nvPr/>
         </p:nvSpPr>
@@ -4788,7 +4679,7 @@
       </p:sp>
       <p:sp>
         <p:nvSpPr>
-          <p:cNvPr id="31" name="Chevron 30"/>
+          <p:cNvPr id="29" name="Chevron 28"/>
           <p:cNvSpPr/>
           <p:nvPr/>
         </p:nvSpPr>
@@ -4832,7 +4723,7 @@
       </p:sp>
       <p:sp>
         <p:nvSpPr>
-          <p:cNvPr id="32" name="Rounded Rectangle 31"/>
+          <p:cNvPr id="30" name="Rounded Rectangle 29"/>
           <p:cNvSpPr/>
           <p:nvPr/>
         </p:nvSpPr>
@@ -4974,7 +4865,7 @@
       </p:sp>
       <p:sp>
         <p:nvSpPr>
-          <p:cNvPr id="33" name="Rectangle 32"/>
+          <p:cNvPr id="31" name="Rectangle 30"/>
           <p:cNvSpPr/>
           <p:nvPr/>
         </p:nvSpPr>
@@ -5018,7 +4909,7 @@
       </p:sp>
       <p:sp>
         <p:nvSpPr>
-          <p:cNvPr id="34" name="Chevron 33"/>
+          <p:cNvPr id="32" name="Chevron 31"/>
           <p:cNvSpPr/>
           <p:nvPr/>
         </p:nvSpPr>
@@ -5062,7 +4953,7 @@
       </p:sp>
       <p:sp>
         <p:nvSpPr>
-          <p:cNvPr id="35" name="Rounded Rectangle 34"/>
+          <p:cNvPr id="33" name="Rounded Rectangle 32"/>
           <p:cNvSpPr/>
           <p:nvPr/>
         </p:nvSpPr>
@@ -5204,7 +5095,7 @@
       </p:sp>
       <p:sp>
         <p:nvSpPr>
-          <p:cNvPr id="36" name="Rectangle 35"/>
+          <p:cNvPr id="34" name="Rectangle 33"/>
           <p:cNvSpPr/>
           <p:nvPr/>
         </p:nvSpPr>
@@ -5248,7 +5139,7 @@
       </p:sp>
       <p:sp>
         <p:nvSpPr>
-          <p:cNvPr id="37" name="Chevron 36"/>
+          <p:cNvPr id="35" name="Chevron 34"/>
           <p:cNvSpPr/>
           <p:nvPr/>
         </p:nvSpPr>
@@ -5292,7 +5183,7 @@
       </p:sp>
       <p:sp>
         <p:nvSpPr>
-          <p:cNvPr id="38" name="Rounded Rectangle 37"/>
+          <p:cNvPr id="36" name="Rounded Rectangle 35"/>
           <p:cNvSpPr/>
           <p:nvPr/>
         </p:nvSpPr>
@@ -5434,7 +5325,7 @@
       </p:sp>
       <p:sp>
         <p:nvSpPr>
-          <p:cNvPr id="39" name="Rectangle 38"/>
+          <p:cNvPr id="37" name="Rectangle 36"/>
           <p:cNvSpPr/>
           <p:nvPr/>
         </p:nvSpPr>
@@ -5478,7 +5369,7 @@
       </p:sp>
       <p:sp>
         <p:nvSpPr>
-          <p:cNvPr id="40" name="Chevron 39"/>
+          <p:cNvPr id="38" name="Chevron 37"/>
           <p:cNvSpPr/>
           <p:nvPr/>
         </p:nvSpPr>
@@ -5522,7 +5413,7 @@
       </p:sp>
       <p:sp>
         <p:nvSpPr>
-          <p:cNvPr id="41" name="Rounded Rectangle 40"/>
+          <p:cNvPr id="39" name="Rounded Rectangle 38"/>
           <p:cNvSpPr/>
           <p:nvPr/>
         </p:nvSpPr>
@@ -5664,7 +5555,7 @@
       </p:sp>
       <p:sp>
         <p:nvSpPr>
-          <p:cNvPr id="42" name="Rectangle 41"/>
+          <p:cNvPr id="40" name="Rectangle 39"/>
           <p:cNvSpPr/>
           <p:nvPr/>
         </p:nvSpPr>
@@ -5708,7 +5599,7 @@
       </p:sp>
       <p:sp>
         <p:nvSpPr>
-          <p:cNvPr id="43" name="Chevron 42"/>
+          <p:cNvPr id="41" name="Chevron 40"/>
           <p:cNvSpPr/>
           <p:nvPr/>
         </p:nvSpPr>
@@ -5752,7 +5643,7 @@
       </p:sp>
       <p:sp>
         <p:nvSpPr>
-          <p:cNvPr id="44" name="Rounded Rectangle 43"/>
+          <p:cNvPr id="42" name="Rounded Rectangle 41"/>
           <p:cNvSpPr/>
           <p:nvPr/>
         </p:nvSpPr>
@@ -5894,7 +5785,7 @@
       </p:sp>
       <p:sp>
         <p:nvSpPr>
-          <p:cNvPr id="45" name="Rectangle 44"/>
+          <p:cNvPr id="43" name="Rectangle 42"/>
           <p:cNvSpPr/>
           <p:nvPr/>
         </p:nvSpPr>
@@ -5938,7 +5829,7 @@
       </p:sp>
       <p:sp>
         <p:nvSpPr>
-          <p:cNvPr id="46" name="Chevron 45"/>
+          <p:cNvPr id="44" name="Chevron 43"/>
           <p:cNvSpPr/>
           <p:nvPr/>
         </p:nvSpPr>
@@ -5982,7 +5873,7 @@
       </p:sp>
       <p:sp>
         <p:nvSpPr>
-          <p:cNvPr id="47" name="Rounded Rectangle 46"/>
+          <p:cNvPr id="45" name="Rounded Rectangle 44"/>
           <p:cNvSpPr/>
           <p:nvPr/>
         </p:nvSpPr>
@@ -6124,7 +6015,7 @@
       </p:sp>
       <p:sp>
         <p:nvSpPr>
-          <p:cNvPr id="48" name="Rectangle 47"/>
+          <p:cNvPr id="46" name="Rectangle 45"/>
           <p:cNvSpPr/>
           <p:nvPr/>
         </p:nvSpPr>
@@ -6168,7 +6059,7 @@
       </p:sp>
       <p:sp>
         <p:nvSpPr>
-          <p:cNvPr id="49" name="Chevron 48"/>
+          <p:cNvPr id="47" name="Chevron 46"/>
           <p:cNvSpPr/>
           <p:nvPr/>
         </p:nvSpPr>
@@ -6212,7 +6103,7 @@
       </p:sp>
       <p:sp>
         <p:nvSpPr>
-          <p:cNvPr id="50" name="Rounded Rectangle 49"/>
+          <p:cNvPr id="48" name="Rounded Rectangle 47"/>
           <p:cNvSpPr/>
           <p:nvPr/>
         </p:nvSpPr>
@@ -6354,7 +6245,7 @@
       </p:sp>
       <p:sp>
         <p:nvSpPr>
-          <p:cNvPr id="51" name="Rectangle 50"/>
+          <p:cNvPr id="49" name="Rectangle 48"/>
           <p:cNvSpPr/>
           <p:nvPr/>
         </p:nvSpPr>
@@ -6398,7 +6289,7 @@
       </p:sp>
       <p:cxnSp>
         <p:nvCxnSpPr>
-          <p:cNvPr id="52" name="Connector 51"/>
+          <p:cNvPr id="50" name="Connector 49"/>
           <p:cNvCxnSpPr/>
           <p:nvPr/>
         </p:nvCxnSpPr>
@@ -6437,7 +6328,7 @@
       </p:cxnSp>
       <p:cxnSp>
         <p:nvCxnSpPr>
-          <p:cNvPr id="53" name="Connector 52"/>
+          <p:cNvPr id="51" name="Connector 50"/>
           <p:cNvCxnSpPr/>
           <p:nvPr/>
         </p:nvCxnSpPr>
@@ -6476,7 +6367,7 @@
       </p:cxnSp>
       <p:cxnSp>
         <p:nvCxnSpPr>
-          <p:cNvPr id="54" name="Connector 53"/>
+          <p:cNvPr id="52" name="Connector 51"/>
           <p:cNvCxnSpPr/>
           <p:nvPr/>
         </p:nvCxnSpPr>
@@ -6515,7 +6406,7 @@
       </p:cxnSp>
       <p:cxnSp>
         <p:nvCxnSpPr>
-          <p:cNvPr id="55" name="Connector 54"/>
+          <p:cNvPr id="53" name="Connector 52"/>
           <p:cNvCxnSpPr/>
           <p:nvPr/>
         </p:nvCxnSpPr>
@@ -6554,7 +6445,7 @@
       </p:cxnSp>
       <p:cxnSp>
         <p:nvCxnSpPr>
-          <p:cNvPr id="56" name="Connector 55"/>
+          <p:cNvPr id="54" name="Connector 53"/>
           <p:cNvCxnSpPr/>
           <p:nvPr/>
         </p:nvCxnSpPr>
@@ -6593,7 +6484,7 @@
       </p:cxnSp>
       <p:cxnSp>
         <p:nvCxnSpPr>
-          <p:cNvPr id="57" name="Connector 56"/>
+          <p:cNvPr id="55" name="Connector 54"/>
           <p:cNvCxnSpPr/>
           <p:nvPr/>
         </p:nvCxnSpPr>
@@ -6632,7 +6523,7 @@
       </p:cxnSp>
       <p:cxnSp>
         <p:nvCxnSpPr>
-          <p:cNvPr id="58" name="Connector 57"/>
+          <p:cNvPr id="56" name="Connector 55"/>
           <p:cNvCxnSpPr/>
           <p:nvPr/>
         </p:nvCxnSpPr>
@@ -6671,7 +6562,7 @@
       </p:cxnSp>
       <p:cxnSp>
         <p:nvCxnSpPr>
-          <p:cNvPr id="59" name="Connector 58"/>
+          <p:cNvPr id="57" name="Connector 56"/>
           <p:cNvCxnSpPr/>
           <p:nvPr/>
         </p:nvCxnSpPr>
@@ -6710,7 +6601,7 @@
       </p:cxnSp>
       <p:sp>
         <p:nvSpPr>
-          <p:cNvPr id="60" name="Rounded Rectangle 59"/>
+          <p:cNvPr id="58" name="Rounded Rectangle 57"/>
           <p:cNvSpPr/>
           <p:nvPr/>
         </p:nvSpPr>
@@ -6840,7 +6731,7 @@
       </p:sp>
       <p:sp>
         <p:nvSpPr>
-          <p:cNvPr id="61" name="Rectangle 60"/>
+          <p:cNvPr id="59" name="Rectangle 58"/>
           <p:cNvSpPr/>
           <p:nvPr/>
         </p:nvSpPr>
@@ -6884,46 +6775,24 @@
       </p:sp>
       <p:sp>
         <p:nvSpPr>
-          <p:cNvPr id="62" name="Rounded Rectangle 61"/>
-          <p:cNvSpPr/>
+          <p:cNvPr id="60" name="TextBox 59"/>
+          <p:cNvSpPr txBox="1"/>
           <p:nvPr/>
         </p:nvSpPr>
         <p:spPr>
           <a:xfrm>
-            <a:off x="1664208" y="4352544"/>
-            <a:ext cx="10222992" cy="365760"/>
-          </a:xfrm>
-          <a:prstGeom prst="roundRect">
-            <a:avLst>
-              <a:gd name="adj" fmla="val 6000"/>
-            </a:avLst>
+            <a:off x="1682496" y="4480560"/>
+            <a:ext cx="8229600" cy="182880"/>
+          </a:xfrm>
+          <a:prstGeom prst="rect">
+            <a:avLst/>
           </a:prstGeom>
-          <a:solidFill>
-            <a:srgbClr val="222230"/>
-          </a:solidFill>
-          <a:ln w="12700">
-            <a:solidFill>
-              <a:srgbClr val="FF5A5A"/>
-            </a:solidFill>
-          </a:ln>
-          <a:effectLst/>
-        </p:spPr>
-        <p:style>
-          <a:lnRef idx="1">
-            <a:schemeClr val="accent1"/>
-          </a:lnRef>
-          <a:fillRef idx="3">
-            <a:schemeClr val="accent1"/>
-          </a:fillRef>
-          <a:effectRef idx="2">
-            <a:schemeClr val="accent1"/>
-          </a:effectRef>
-          <a:fontRef idx="minor">
-            <a:schemeClr val="lt1"/>
-          </a:fontRef>
-        </p:style>
-        <p:txBody>
-          <a:bodyPr rtlCol="0" anchor="ctr" wrap="square" lIns="27432" rIns="27432" tIns="9144" bIns="9144"/>
+          <a:noFill/>
+        </p:spPr>
+        <p:txBody>
+          <a:bodyPr wrap="square" anchor="t" lIns="0" rIns="0" tIns="0" bIns="0">
+            <a:spAutoFit/>
+          </a:bodyPr>
           <a:lstStyle/>
           <a:p>
             <a:pPr algn="l">
@@ -6938,134 +6807,36 @@
               </a:spcAft>
             </a:pPr>
             <a:r>
-              <a:rPr sz="850" b="1" i="0">
-                <a:solidFill>
-                  <a:srgbClr val="FF5A5A"/>
-                </a:solidFill>
-                <a:latin typeface="Segoe UI"/>
-              </a:rPr>
-              <a:t>🤖  EXCEPTION GOVERNANCE AGENT   </a:t>
-            </a:r>
-            <a:r>
-              <a:rPr sz="760" b="0" i="0">
-                <a:solidFill>
-                  <a:srgbClr val="C2C2D0"/>
-                </a:solidFill>
-                <a:latin typeface="Segoe UI"/>
-              </a:rPr>
-              <a:t>routes every exception to its owner with severity + SLA (governance master · severity matrix · role routing)</a:t>
-            </a:r>
-          </a:p>
-        </p:txBody>
-      </p:sp>
-      <p:sp>
-        <p:nvSpPr>
-          <p:cNvPr id="63" name="Rectangle 62"/>
+              <a:rPr sz="800" b="1" i="0">
+                <a:solidFill>
+                  <a:srgbClr val="FFE600"/>
+                </a:solidFill>
+                <a:latin typeface="Segoe UI"/>
+              </a:rPr>
+              <a:t>ORDER CREATION &amp; DOWNSTREAM — the </a:t>
+            </a:r>
+            <a:r>
+              <a:rPr sz="800" b="1" i="0">
+                <a:solidFill>
+                  <a:srgbClr val="FFFFFF"/>
+                </a:solidFill>
+                <a:latin typeface="Segoe UI"/>
+              </a:rPr>
+              <a:t>🤖 Order Execution Agent</a:t>
+            </a:r>
+          </a:p>
+        </p:txBody>
+      </p:sp>
+      <p:sp>
+        <p:nvSpPr>
+          <p:cNvPr id="61" name="Rounded Rectangle 60"/>
           <p:cNvSpPr/>
           <p:nvPr/>
         </p:nvSpPr>
         <p:spPr>
           <a:xfrm>
-            <a:off x="1664208" y="4352544"/>
-            <a:ext cx="64008" cy="365760"/>
-          </a:xfrm>
-          <a:prstGeom prst="rect">
-            <a:avLst/>
-          </a:prstGeom>
-          <a:solidFill>
-            <a:srgbClr val="FF5A5A"/>
-          </a:solidFill>
-          <a:ln>
-            <a:noFill/>
-          </a:ln>
-          <a:effectLst/>
-        </p:spPr>
-        <p:style>
-          <a:lnRef idx="1">
-            <a:schemeClr val="accent1"/>
-          </a:lnRef>
-          <a:fillRef idx="3">
-            <a:schemeClr val="accent1"/>
-          </a:fillRef>
-          <a:effectRef idx="2">
-            <a:schemeClr val="accent1"/>
-          </a:effectRef>
-          <a:fontRef idx="minor">
-            <a:schemeClr val="lt1"/>
-          </a:fontRef>
-        </p:style>
-        <p:txBody>
-          <a:bodyPr rtlCol="0" anchor="ctr" wrap="square"/>
-          <a:lstStyle/>
-          <a:p>
-            <a:pPr algn="ctr"/>
-          </a:p>
-        </p:txBody>
-      </p:sp>
-      <p:sp>
-        <p:nvSpPr>
-          <p:cNvPr id="64" name="TextBox 63"/>
-          <p:cNvSpPr txBox="1"/>
-          <p:nvPr/>
-        </p:nvSpPr>
-        <p:spPr>
-          <a:xfrm>
-            <a:off x="1682496" y="4791455"/>
-            <a:ext cx="8229600" cy="182880"/>
-          </a:xfrm>
-          <a:prstGeom prst="rect">
-            <a:avLst/>
-          </a:prstGeom>
-          <a:noFill/>
-        </p:spPr>
-        <p:txBody>
-          <a:bodyPr wrap="square" anchor="t" lIns="0" rIns="0" tIns="0" bIns="0">
-            <a:spAutoFit/>
-          </a:bodyPr>
-          <a:lstStyle/>
-          <a:p>
-            <a:pPr algn="l">
-              <a:lnSpc>
-                <a:spcPct val="100000"/>
-              </a:lnSpc>
-              <a:spcBef>
-                <a:spcPts val="0"/>
-              </a:spcBef>
-              <a:spcAft>
-                <a:spcPts val="0"/>
-              </a:spcAft>
-            </a:pPr>
-            <a:r>
-              <a:rPr sz="800" b="1" i="0">
-                <a:solidFill>
-                  <a:srgbClr val="FFE600"/>
-                </a:solidFill>
-                <a:latin typeface="Segoe UI"/>
-              </a:rPr>
-              <a:t>ORDER CREATION &amp; DOWNSTREAM — the </a:t>
-            </a:r>
-            <a:r>
-              <a:rPr sz="800" b="1" i="0">
-                <a:solidFill>
-                  <a:srgbClr val="FFFFFF"/>
-                </a:solidFill>
-                <a:latin typeface="Segoe UI"/>
-              </a:rPr>
-              <a:t>🤖 Order Execution Agent</a:t>
-            </a:r>
-          </a:p>
-        </p:txBody>
-      </p:sp>
-      <p:sp>
-        <p:nvSpPr>
-          <p:cNvPr id="65" name="Rounded Rectangle 64"/>
-          <p:cNvSpPr/>
-          <p:nvPr/>
-        </p:nvSpPr>
-        <p:spPr>
-          <a:xfrm>
-            <a:off x="1709928" y="5010912"/>
-            <a:ext cx="2148840" cy="475488"/>
+            <a:off x="1709928" y="4736592"/>
+            <a:ext cx="2148840" cy="548640"/>
           </a:xfrm>
           <a:prstGeom prst="roundRect">
             <a:avLst>
@@ -7147,13 +6918,13 @@
       </p:sp>
       <p:sp>
         <p:nvSpPr>
-          <p:cNvPr id="66" name="Chevron 65"/>
+          <p:cNvPr id="62" name="Chevron 61"/>
           <p:cNvSpPr/>
           <p:nvPr/>
         </p:nvSpPr>
         <p:spPr>
           <a:xfrm>
-            <a:off x="3895344" y="5157216"/>
+            <a:off x="3895344" y="4919472"/>
             <a:ext cx="274320" cy="182880"/>
           </a:xfrm>
           <a:prstGeom prst="chevron">
@@ -7191,14 +6962,14 @@
       </p:sp>
       <p:sp>
         <p:nvSpPr>
-          <p:cNvPr id="67" name="Rounded Rectangle 66"/>
+          <p:cNvPr id="63" name="Rounded Rectangle 62"/>
           <p:cNvSpPr/>
           <p:nvPr/>
         </p:nvSpPr>
         <p:spPr>
           <a:xfrm>
-            <a:off x="4315968" y="5010912"/>
-            <a:ext cx="1193291" cy="475488"/>
+            <a:off x="4315968" y="4736592"/>
+            <a:ext cx="1193291" cy="548640"/>
           </a:xfrm>
           <a:prstGeom prst="roundRect">
             <a:avLst>
@@ -7280,14 +7051,14 @@
       </p:sp>
       <p:sp>
         <p:nvSpPr>
-          <p:cNvPr id="68" name="Rounded Rectangle 67"/>
+          <p:cNvPr id="64" name="Rounded Rectangle 63"/>
           <p:cNvSpPr/>
           <p:nvPr/>
         </p:nvSpPr>
         <p:spPr>
           <a:xfrm>
-            <a:off x="5582412" y="5010912"/>
-            <a:ext cx="1193291" cy="475488"/>
+            <a:off x="5582412" y="4736592"/>
+            <a:ext cx="1193291" cy="548640"/>
           </a:xfrm>
           <a:prstGeom prst="roundRect">
             <a:avLst>
@@ -7369,14 +7140,14 @@
       </p:sp>
       <p:sp>
         <p:nvSpPr>
-          <p:cNvPr id="69" name="Rounded Rectangle 68"/>
+          <p:cNvPr id="65" name="Rounded Rectangle 64"/>
           <p:cNvSpPr/>
           <p:nvPr/>
         </p:nvSpPr>
         <p:spPr>
           <a:xfrm>
-            <a:off x="6848855" y="5010912"/>
-            <a:ext cx="1193291" cy="475488"/>
+            <a:off x="6848855" y="4736592"/>
+            <a:ext cx="1193291" cy="548640"/>
           </a:xfrm>
           <a:prstGeom prst="roundRect">
             <a:avLst>
@@ -7458,14 +7229,14 @@
       </p:sp>
       <p:sp>
         <p:nvSpPr>
-          <p:cNvPr id="70" name="Rounded Rectangle 69"/>
+          <p:cNvPr id="66" name="Rounded Rectangle 65"/>
           <p:cNvSpPr/>
           <p:nvPr/>
         </p:nvSpPr>
         <p:spPr>
           <a:xfrm>
-            <a:off x="8115300" y="5010912"/>
-            <a:ext cx="1193291" cy="475488"/>
+            <a:off x="8115300" y="4736592"/>
+            <a:ext cx="1193291" cy="548640"/>
           </a:xfrm>
           <a:prstGeom prst="roundRect">
             <a:avLst>
@@ -7547,14 +7318,14 @@
       </p:sp>
       <p:sp>
         <p:nvSpPr>
-          <p:cNvPr id="71" name="Rounded Rectangle 70"/>
+          <p:cNvPr id="67" name="Rounded Rectangle 66"/>
           <p:cNvSpPr/>
           <p:nvPr/>
         </p:nvSpPr>
         <p:spPr>
           <a:xfrm>
-            <a:off x="9381743" y="5010912"/>
-            <a:ext cx="1193291" cy="475488"/>
+            <a:off x="9381743" y="4736592"/>
+            <a:ext cx="1193291" cy="548640"/>
           </a:xfrm>
           <a:prstGeom prst="roundRect">
             <a:avLst>
@@ -7636,14 +7407,14 @@
       </p:sp>
       <p:sp>
         <p:nvSpPr>
-          <p:cNvPr id="72" name="Rounded Rectangle 71"/>
+          <p:cNvPr id="68" name="Rounded Rectangle 67"/>
           <p:cNvSpPr/>
           <p:nvPr/>
         </p:nvSpPr>
         <p:spPr>
           <a:xfrm>
-            <a:off x="10648188" y="5010912"/>
-            <a:ext cx="1193291" cy="475488"/>
+            <a:off x="10648188" y="4736592"/>
+            <a:ext cx="1193291" cy="548640"/>
           </a:xfrm>
           <a:prstGeom prst="roundRect">
             <a:avLst>
@@ -7725,14 +7496,14 @@
       </p:sp>
       <p:sp>
         <p:nvSpPr>
-          <p:cNvPr id="73" name="Rounded Rectangle 72"/>
+          <p:cNvPr id="69" name="Rounded Rectangle 68"/>
           <p:cNvSpPr/>
           <p:nvPr/>
         </p:nvSpPr>
         <p:spPr>
           <a:xfrm>
-            <a:off x="1664208" y="5614416"/>
-            <a:ext cx="10222992" cy="841248"/>
+            <a:off x="1664208" y="5486400"/>
+            <a:ext cx="10222992" cy="969264"/>
           </a:xfrm>
           <a:prstGeom prst="roundRect">
             <a:avLst>
@@ -7773,13 +7544,13 @@
       </p:sp>
       <p:sp>
         <p:nvSpPr>
-          <p:cNvPr id="74" name="TextBox 73"/>
+          <p:cNvPr id="70" name="TextBox 69"/>
           <p:cNvSpPr txBox="1"/>
           <p:nvPr/>
         </p:nvSpPr>
         <p:spPr>
           <a:xfrm>
-            <a:off x="1773936" y="5669279"/>
+            <a:off x="1773936" y="5559552"/>
             <a:ext cx="10003536" cy="182880"/>
           </a:xfrm>
           <a:prstGeom prst="rect">
@@ -7827,14 +7598,14 @@
       </p:sp>
       <p:sp>
         <p:nvSpPr>
-          <p:cNvPr id="75" name="Rounded Rectangle 74"/>
+          <p:cNvPr id="71" name="Rounded Rectangle 70"/>
           <p:cNvSpPr/>
           <p:nvPr/>
         </p:nvSpPr>
         <p:spPr>
           <a:xfrm>
-            <a:off x="1773936" y="5934455"/>
-            <a:ext cx="859536" cy="438912"/>
+            <a:off x="1773936" y="5870448"/>
+            <a:ext cx="859536" cy="512064"/>
           </a:xfrm>
           <a:prstGeom prst="roundRect">
             <a:avLst>
@@ -7916,14 +7687,14 @@
       </p:sp>
       <p:sp>
         <p:nvSpPr>
-          <p:cNvPr id="76" name="Rounded Rectangle 75"/>
+          <p:cNvPr id="72" name="Rounded Rectangle 71"/>
           <p:cNvSpPr/>
           <p:nvPr/>
         </p:nvSpPr>
         <p:spPr>
           <a:xfrm>
-            <a:off x="2688336" y="5934455"/>
-            <a:ext cx="859536" cy="438912"/>
+            <a:off x="2688336" y="5870448"/>
+            <a:ext cx="859536" cy="512064"/>
           </a:xfrm>
           <a:prstGeom prst="roundRect">
             <a:avLst>
@@ -8005,14 +7776,14 @@
       </p:sp>
       <p:sp>
         <p:nvSpPr>
-          <p:cNvPr id="77" name="Rounded Rectangle 76"/>
+          <p:cNvPr id="73" name="Rounded Rectangle 72"/>
           <p:cNvSpPr/>
           <p:nvPr/>
         </p:nvSpPr>
         <p:spPr>
           <a:xfrm>
-            <a:off x="3602736" y="5934455"/>
-            <a:ext cx="859536" cy="438912"/>
+            <a:off x="3602736" y="5870448"/>
+            <a:ext cx="859536" cy="512064"/>
           </a:xfrm>
           <a:prstGeom prst="roundRect">
             <a:avLst>
@@ -8072,14 +7843,14 @@
       </p:sp>
       <p:sp>
         <p:nvSpPr>
-          <p:cNvPr id="78" name="Rounded Rectangle 77"/>
+          <p:cNvPr id="74" name="Rounded Rectangle 73"/>
           <p:cNvSpPr/>
           <p:nvPr/>
         </p:nvSpPr>
         <p:spPr>
           <a:xfrm>
-            <a:off x="4517136" y="5934455"/>
-            <a:ext cx="859536" cy="438912"/>
+            <a:off x="4517136" y="5870448"/>
+            <a:ext cx="859536" cy="512064"/>
           </a:xfrm>
           <a:prstGeom prst="roundRect">
             <a:avLst>
@@ -8139,14 +7910,14 @@
       </p:sp>
       <p:sp>
         <p:nvSpPr>
-          <p:cNvPr id="79" name="Rounded Rectangle 78"/>
+          <p:cNvPr id="75" name="Rounded Rectangle 74"/>
           <p:cNvSpPr/>
           <p:nvPr/>
         </p:nvSpPr>
         <p:spPr>
           <a:xfrm>
-            <a:off x="5431536" y="5934455"/>
-            <a:ext cx="859536" cy="438912"/>
+            <a:off x="5431536" y="5870448"/>
+            <a:ext cx="859536" cy="512064"/>
           </a:xfrm>
           <a:prstGeom prst="roundRect">
             <a:avLst>
@@ -8206,14 +7977,14 @@
       </p:sp>
       <p:sp>
         <p:nvSpPr>
-          <p:cNvPr id="80" name="Rounded Rectangle 79"/>
+          <p:cNvPr id="76" name="Rounded Rectangle 75"/>
           <p:cNvSpPr/>
           <p:nvPr/>
         </p:nvSpPr>
         <p:spPr>
           <a:xfrm>
-            <a:off x="6345936" y="5934455"/>
-            <a:ext cx="859536" cy="438912"/>
+            <a:off x="6345936" y="5870448"/>
+            <a:ext cx="859536" cy="512064"/>
           </a:xfrm>
           <a:prstGeom prst="roundRect">
             <a:avLst>
@@ -8273,14 +8044,14 @@
       </p:sp>
       <p:sp>
         <p:nvSpPr>
-          <p:cNvPr id="81" name="Rounded Rectangle 80"/>
+          <p:cNvPr id="77" name="Rounded Rectangle 76"/>
           <p:cNvSpPr/>
           <p:nvPr/>
         </p:nvSpPr>
         <p:spPr>
           <a:xfrm>
-            <a:off x="7260336" y="5934455"/>
-            <a:ext cx="859536" cy="438912"/>
+            <a:off x="7260336" y="5870448"/>
+            <a:ext cx="859536" cy="512064"/>
           </a:xfrm>
           <a:prstGeom prst="roundRect">
             <a:avLst>
@@ -8340,14 +8111,14 @@
       </p:sp>
       <p:sp>
         <p:nvSpPr>
-          <p:cNvPr id="82" name="Rounded Rectangle 81"/>
+          <p:cNvPr id="78" name="Rounded Rectangle 77"/>
           <p:cNvSpPr/>
           <p:nvPr/>
         </p:nvSpPr>
         <p:spPr>
           <a:xfrm>
-            <a:off x="8174736" y="5934455"/>
-            <a:ext cx="859536" cy="438912"/>
+            <a:off x="8174736" y="5870448"/>
+            <a:ext cx="859536" cy="512064"/>
           </a:xfrm>
           <a:prstGeom prst="roundRect">
             <a:avLst>
@@ -8429,14 +8200,14 @@
       </p:sp>
       <p:sp>
         <p:nvSpPr>
-          <p:cNvPr id="83" name="Rounded Rectangle 82"/>
+          <p:cNvPr id="79" name="Rounded Rectangle 78"/>
           <p:cNvSpPr/>
           <p:nvPr/>
         </p:nvSpPr>
         <p:spPr>
           <a:xfrm>
-            <a:off x="9089136" y="5934455"/>
-            <a:ext cx="859536" cy="438912"/>
+            <a:off x="9089136" y="5870448"/>
+            <a:ext cx="859536" cy="512064"/>
           </a:xfrm>
           <a:prstGeom prst="roundRect">
             <a:avLst>
@@ -8518,14 +8289,14 @@
       </p:sp>
       <p:sp>
         <p:nvSpPr>
-          <p:cNvPr id="84" name="Rounded Rectangle 83"/>
+          <p:cNvPr id="80" name="Rounded Rectangle 79"/>
           <p:cNvSpPr/>
           <p:nvPr/>
         </p:nvSpPr>
         <p:spPr>
           <a:xfrm>
-            <a:off x="10003536" y="5934455"/>
-            <a:ext cx="859536" cy="438912"/>
+            <a:off x="10003536" y="5870448"/>
+            <a:ext cx="859536" cy="512064"/>
           </a:xfrm>
           <a:prstGeom prst="roundRect">
             <a:avLst>
@@ -8607,14 +8378,14 @@
       </p:sp>
       <p:sp>
         <p:nvSpPr>
-          <p:cNvPr id="85" name="Rounded Rectangle 84"/>
+          <p:cNvPr id="81" name="Rounded Rectangle 80"/>
           <p:cNvSpPr/>
           <p:nvPr/>
         </p:nvSpPr>
         <p:spPr>
           <a:xfrm>
-            <a:off x="10917936" y="5934455"/>
-            <a:ext cx="859536" cy="438912"/>
+            <a:off x="10917936" y="5870448"/>
+            <a:ext cx="859536" cy="512064"/>
           </a:xfrm>
           <a:prstGeom prst="roundRect">
             <a:avLst>
@@ -8696,7 +8467,7 @@
       </p:sp>
       <p:sp>
         <p:nvSpPr>
-          <p:cNvPr id="86" name="Down Arrow 85"/>
+          <p:cNvPr id="82" name="Down Arrow 81"/>
           <p:cNvSpPr/>
           <p:nvPr/>
         </p:nvSpPr>
@@ -8740,7 +8511,7 @@
       </p:sp>
       <p:sp>
         <p:nvSpPr>
-          <p:cNvPr id="87" name="Down Arrow 86"/>
+          <p:cNvPr id="83" name="Down Arrow 82"/>
           <p:cNvSpPr/>
           <p:nvPr/>
         </p:nvSpPr>
@@ -8782,60 +8553,16 @@
           </a:p>
         </p:txBody>
       </p:sp>
-      <p:sp>
-        <p:nvSpPr>
-          <p:cNvPr id="88" name="Down Arrow 87"/>
-          <p:cNvSpPr/>
-          <p:nvPr/>
-        </p:nvSpPr>
-        <p:spPr>
-          <a:xfrm>
-            <a:off x="6629400" y="4700016"/>
-            <a:ext cx="292608" cy="109728"/>
-          </a:xfrm>
-          <a:prstGeom prst="downArrow">
-            <a:avLst/>
-          </a:prstGeom>
-          <a:solidFill>
-            <a:srgbClr val="FFE600"/>
-          </a:solidFill>
-          <a:ln>
-            <a:noFill/>
-          </a:ln>
-          <a:effectLst/>
-        </p:spPr>
-        <p:style>
-          <a:lnRef idx="1">
-            <a:schemeClr val="accent1"/>
-          </a:lnRef>
-          <a:fillRef idx="3">
-            <a:schemeClr val="accent1"/>
-          </a:fillRef>
-          <a:effectRef idx="2">
-            <a:schemeClr val="accent1"/>
-          </a:effectRef>
-          <a:fontRef idx="minor">
-            <a:schemeClr val="lt1"/>
-          </a:fontRef>
-        </p:style>
-        <p:txBody>
-          <a:bodyPr rtlCol="0" anchor="ctr"/>
-          <a:lstStyle/>
-          <a:p>
-            <a:pPr algn="ctr"/>
-          </a:p>
-        </p:txBody>
-      </p:sp>
       <p:cxnSp>
         <p:nvCxnSpPr>
-          <p:cNvPr id="89" name="Connector 88"/>
+          <p:cNvPr id="84" name="Connector 83"/>
           <p:cNvCxnSpPr/>
           <p:nvPr/>
         </p:nvCxnSpPr>
         <p:spPr>
           <a:xfrm flipV="1">
             <a:off x="1609344" y="4315968"/>
-            <a:ext cx="0" cy="1298448"/>
+            <a:ext cx="0" cy="1170432"/>
           </a:xfrm>
           <a:prstGeom prst="line">
             <a:avLst/>
@@ -8866,7 +8593,7 @@
       </p:cxnSp>
       <p:sp>
         <p:nvSpPr>
-          <p:cNvPr id="90" name="TextBox 89"/>
+          <p:cNvPr id="85" name="TextBox 84"/>
           <p:cNvSpPr txBox="1"/>
           <p:nvPr/>
         </p:nvSpPr>

</xml_diff>

<commit_message>
docs: drop orphaned governance matrix data tile after removing governance layer
</commit_message>
<xml_diff>
--- a/demo/Order-Creation-Orchestration-Architecture.pptx
+++ b/demo/Order-Creation-Orchestration-Architecture.pptx
@@ -7605,7 +7605,7 @@
         <p:spPr>
           <a:xfrm>
             <a:off x="1773936" y="5870448"/>
-            <a:ext cx="859536" cy="512064"/>
+            <a:ext cx="950975" cy="512064"/>
           </a:xfrm>
           <a:prstGeom prst="roundRect">
             <a:avLst>
@@ -7693,8 +7693,8 @@
         </p:nvSpPr>
         <p:spPr>
           <a:xfrm>
-            <a:off x="2688336" y="5870448"/>
-            <a:ext cx="859536" cy="512064"/>
+            <a:off x="2779776" y="5870448"/>
+            <a:ext cx="950975" cy="512064"/>
           </a:xfrm>
           <a:prstGeom prst="roundRect">
             <a:avLst>
@@ -7782,8 +7782,8 @@
         </p:nvSpPr>
         <p:spPr>
           <a:xfrm>
-            <a:off x="3602736" y="5870448"/>
-            <a:ext cx="859536" cy="512064"/>
+            <a:off x="3785615" y="5870448"/>
+            <a:ext cx="950975" cy="512064"/>
           </a:xfrm>
           <a:prstGeom prst="roundRect">
             <a:avLst>
@@ -7849,8 +7849,8 @@
         </p:nvSpPr>
         <p:spPr>
           <a:xfrm>
-            <a:off x="4517136" y="5870448"/>
-            <a:ext cx="859536" cy="512064"/>
+            <a:off x="4791456" y="5870448"/>
+            <a:ext cx="950975" cy="512064"/>
           </a:xfrm>
           <a:prstGeom prst="roundRect">
             <a:avLst>
@@ -7916,8 +7916,8 @@
         </p:nvSpPr>
         <p:spPr>
           <a:xfrm>
-            <a:off x="5431536" y="5870448"/>
-            <a:ext cx="859536" cy="512064"/>
+            <a:off x="5797296" y="5870448"/>
+            <a:ext cx="950975" cy="512064"/>
           </a:xfrm>
           <a:prstGeom prst="roundRect">
             <a:avLst>
@@ -7983,8 +7983,8 @@
         </p:nvSpPr>
         <p:spPr>
           <a:xfrm>
-            <a:off x="6345936" y="5870448"/>
-            <a:ext cx="859536" cy="512064"/>
+            <a:off x="6803136" y="5870448"/>
+            <a:ext cx="950975" cy="512064"/>
           </a:xfrm>
           <a:prstGeom prst="roundRect">
             <a:avLst>
@@ -8050,8 +8050,8 @@
         </p:nvSpPr>
         <p:spPr>
           <a:xfrm>
-            <a:off x="7260336" y="5870448"/>
-            <a:ext cx="859536" cy="512064"/>
+            <a:off x="7808975" y="5870448"/>
+            <a:ext cx="950975" cy="512064"/>
           </a:xfrm>
           <a:prstGeom prst="roundRect">
             <a:avLst>
@@ -8117,8 +8117,8 @@
         </p:nvSpPr>
         <p:spPr>
           <a:xfrm>
-            <a:off x="8174736" y="5870448"/>
-            <a:ext cx="859536" cy="512064"/>
+            <a:off x="8814815" y="5870448"/>
+            <a:ext cx="950975" cy="512064"/>
           </a:xfrm>
           <a:prstGeom prst="roundRect">
             <a:avLst>
@@ -8206,8 +8206,8 @@
         </p:nvSpPr>
         <p:spPr>
           <a:xfrm>
-            <a:off x="9089136" y="5870448"/>
-            <a:ext cx="859536" cy="512064"/>
+            <a:off x="9820655" y="5870448"/>
+            <a:ext cx="950975" cy="512064"/>
           </a:xfrm>
           <a:prstGeom prst="roundRect">
             <a:avLst>
@@ -8295,8 +8295,8 @@
         </p:nvSpPr>
         <p:spPr>
           <a:xfrm>
-            <a:off x="10003536" y="5870448"/>
-            <a:ext cx="859536" cy="512064"/>
+            <a:off x="10826495" y="5870448"/>
+            <a:ext cx="950975" cy="512064"/>
           </a:xfrm>
           <a:prstGeom prst="roundRect">
             <a:avLst>
@@ -8378,96 +8378,7 @@
       </p:sp>
       <p:sp>
         <p:nvSpPr>
-          <p:cNvPr id="81" name="Rounded Rectangle 80"/>
-          <p:cNvSpPr/>
-          <p:nvPr/>
-        </p:nvSpPr>
-        <p:spPr>
-          <a:xfrm>
-            <a:off x="10917936" y="5870448"/>
-            <a:ext cx="859536" cy="512064"/>
-          </a:xfrm>
-          <a:prstGeom prst="roundRect">
-            <a:avLst>
-              <a:gd name="adj" fmla="val 6000"/>
-            </a:avLst>
-          </a:prstGeom>
-          <a:solidFill>
-            <a:srgbClr val="222230"/>
-          </a:solidFill>
-          <a:ln w="7620">
-            <a:solidFill>
-              <a:srgbClr val="3C3C4E"/>
-            </a:solidFill>
-          </a:ln>
-          <a:effectLst/>
-        </p:spPr>
-        <p:style>
-          <a:lnRef idx="1">
-            <a:schemeClr val="accent1"/>
-          </a:lnRef>
-          <a:fillRef idx="3">
-            <a:schemeClr val="accent1"/>
-          </a:fillRef>
-          <a:effectRef idx="2">
-            <a:schemeClr val="accent1"/>
-          </a:effectRef>
-          <a:fontRef idx="minor">
-            <a:schemeClr val="lt1"/>
-          </a:fontRef>
-        </p:style>
-        <p:txBody>
-          <a:bodyPr rtlCol="0" anchor="ctr" wrap="square" lIns="27432" rIns="27432" tIns="9144" bIns="9144"/>
-          <a:lstStyle/>
-          <a:p>
-            <a:pPr algn="ctr">
-              <a:lnSpc>
-                <a:spcPct val="95000"/>
-              </a:lnSpc>
-              <a:spcBef>
-                <a:spcPts val="0"/>
-              </a:spcBef>
-              <a:spcAft>
-                <a:spcPts val="0"/>
-              </a:spcAft>
-            </a:pPr>
-            <a:r>
-              <a:rPr sz="630" b="1" i="0">
-                <a:solidFill>
-                  <a:srgbClr val="C2C2D0"/>
-                </a:solidFill>
-                <a:latin typeface="Segoe UI"/>
-              </a:rPr>
-              <a:t>Governance</a:t>
-            </a:r>
-          </a:p>
-          <a:p>
-            <a:pPr algn="ctr">
-              <a:lnSpc>
-                <a:spcPct val="95000"/>
-              </a:lnSpc>
-              <a:spcBef>
-                <a:spcPts val="0"/>
-              </a:spcBef>
-              <a:spcAft>
-                <a:spcPts val="0"/>
-              </a:spcAft>
-            </a:pPr>
-            <a:r>
-              <a:rPr sz="630" b="1" i="0">
-                <a:solidFill>
-                  <a:srgbClr val="C2C2D0"/>
-                </a:solidFill>
-                <a:latin typeface="Segoe UI"/>
-              </a:rPr>
-              <a:t>matrix</a:t>
-            </a:r>
-          </a:p>
-        </p:txBody>
-      </p:sp>
-      <p:sp>
-        <p:nvSpPr>
-          <p:cNvPr id="82" name="Down Arrow 81"/>
+          <p:cNvPr id="81" name="Down Arrow 80"/>
           <p:cNvSpPr/>
           <p:nvPr/>
         </p:nvSpPr>
@@ -8511,7 +8422,7 @@
       </p:sp>
       <p:sp>
         <p:nvSpPr>
-          <p:cNvPr id="83" name="Down Arrow 82"/>
+          <p:cNvPr id="82" name="Down Arrow 81"/>
           <p:cNvSpPr/>
           <p:nvPr/>
         </p:nvSpPr>
@@ -8555,7 +8466,7 @@
       </p:sp>
       <p:cxnSp>
         <p:nvCxnSpPr>
-          <p:cNvPr id="84" name="Connector 83"/>
+          <p:cNvPr id="83" name="Connector 82"/>
           <p:cNvCxnSpPr/>
           <p:nvPr/>
         </p:nvCxnSpPr>
@@ -8593,7 +8504,7 @@
       </p:cxnSp>
       <p:sp>
         <p:nvSpPr>
-          <p:cNvPr id="85" name="TextBox 84"/>
+          <p:cNvPr id="84" name="TextBox 83"/>
           <p:cNvSpPr txBox="1"/>
           <p:nvPr/>
         </p:nvSpPr>

</xml_diff>

<commit_message>
docs: shorten human decision layer caption (drop Approve/Reject/Escalate list)
</commit_message>
<xml_diff>
--- a/demo/Order-Creation-Orchestration-Architecture.pptx
+++ b/demo/Order-Creation-Orchestration-Architecture.pptx
@@ -6670,61 +6670,7 @@
                 </a:solidFill>
                 <a:latin typeface="Segoe UI"/>
               </a:rPr>
-              <a:t>— every agent pauses on exception and hands the decision to the CSR:   </a:t>
-            </a:r>
-            <a:r>
-              <a:rPr sz="800" b="1" i="0">
-                <a:solidFill>
-                  <a:srgbClr val="35C759"/>
-                </a:solidFill>
-                <a:latin typeface="Segoe UI"/>
-              </a:rPr>
-              <a:t>Approve</a:t>
-            </a:r>
-            <a:r>
-              <a:rPr sz="760" b="0" i="0">
-                <a:solidFill>
-                  <a:srgbClr val="C2C2D0"/>
-                </a:solidFill>
-                <a:latin typeface="Segoe UI"/>
-              </a:rPr>
-              <a:t>  ·  </a:t>
-            </a:r>
-            <a:r>
-              <a:rPr sz="800" b="1" i="0">
-                <a:solidFill>
-                  <a:srgbClr val="FF5A5A"/>
-                </a:solidFill>
-                <a:latin typeface="Segoe UI"/>
-              </a:rPr>
-              <a:t>Reject</a:t>
-            </a:r>
-            <a:r>
-              <a:rPr sz="760" b="0" i="0">
-                <a:solidFill>
-                  <a:srgbClr val="C2C2D0"/>
-                </a:solidFill>
-                <a:latin typeface="Segoe UI"/>
-              </a:rPr>
-              <a:t>  ·  </a:t>
-            </a:r>
-            <a:r>
-              <a:rPr sz="800" b="1" i="0">
-                <a:solidFill>
-                  <a:srgbClr val="FFB020"/>
-                </a:solidFill>
-                <a:latin typeface="Segoe UI"/>
-              </a:rPr>
-              <a:t>Escalate</a:t>
-            </a:r>
-            <a:r>
-              <a:rPr sz="760" b="0" i="0">
-                <a:solidFill>
-                  <a:srgbClr val="C2C2D0"/>
-                </a:solidFill>
-                <a:latin typeface="Segoe UI"/>
-              </a:rPr>
-              <a:t>   → the pipeline resumes        (all agents pass ⇒ straight-through, autonomous)</a:t>
+              <a:t>— every agent pauses on exception for a human decision, then the pipeline resumes   (all agents pass ⇒ straight-through, autonomous)</a:t>
             </a:r>
           </a:p>
         </p:txBody>

</xml_diff>

<commit_message>
docs: use generic data categories in legacy data system panel (no entity names)
</commit_message>
<xml_diff>
--- a/demo/Order-Creation-Orchestration-Architecture.pptx
+++ b/demo/Order-Creation-Orchestration-Architecture.pptx
@@ -7310,7 +7310,7 @@
                 </a:solidFill>
                 <a:latin typeface="Segoe UI"/>
               </a:rPr>
-              <a:t>governed master data · read by the agents</a:t>
+              <a:t>governed data · read by the agents</a:t>
             </a:r>
           </a:p>
         </p:txBody>
@@ -7324,7 +7324,7 @@
         <p:spPr>
           <a:xfrm>
             <a:off x="10186415" y="1408176"/>
-            <a:ext cx="1627632" cy="423367"/>
+            <a:ext cx="1627632" cy="736092"/>
           </a:xfrm>
           <a:prstGeom prst="roundRect">
             <a:avLst>
@@ -7377,7 +7377,7 @@
                 </a:solidFill>
                 <a:latin typeface="Segoe UI"/>
               </a:rPr>
-              <a:t>Product catalog · subs · UOM</a:t>
+              <a:t>Master data</a:t>
             </a:r>
           </a:p>
         </p:txBody>
@@ -7391,7 +7391,7 @@
         <p:spPr>
           <a:xfrm>
             <a:off x="10186415" y="1408176"/>
-            <a:ext cx="45720" cy="423367"/>
+            <a:ext cx="45720" cy="736092"/>
           </a:xfrm>
           <a:prstGeom prst="rect">
             <a:avLst/>
@@ -7434,8 +7434,8 @@
         </p:nvSpPr>
         <p:spPr>
           <a:xfrm>
-            <a:off x="10186415" y="1877263"/>
-            <a:ext cx="1627632" cy="423367"/>
+            <a:off x="10186415" y="2189988"/>
+            <a:ext cx="1627632" cy="736092"/>
           </a:xfrm>
           <a:prstGeom prst="roundRect">
             <a:avLst>
@@ -7488,7 +7488,7 @@
                 </a:solidFill>
                 <a:latin typeface="Segoe UI"/>
               </a:rPr>
-              <a:t>Customer &amp; Ship-to</a:t>
+              <a:t>Reference &amp; catalog data</a:t>
             </a:r>
           </a:p>
         </p:txBody>
@@ -7501,8 +7501,8 @@
         </p:nvSpPr>
         <p:spPr>
           <a:xfrm>
-            <a:off x="10186415" y="1877263"/>
-            <a:ext cx="45720" cy="423367"/>
+            <a:off x="10186415" y="2189988"/>
+            <a:ext cx="45720" cy="736092"/>
           </a:xfrm>
           <a:prstGeom prst="rect">
             <a:avLst/>
@@ -7545,8 +7545,8 @@
         </p:nvSpPr>
         <p:spPr>
           <a:xfrm>
-            <a:off x="10186415" y="2346350"/>
-            <a:ext cx="1627632" cy="423367"/>
+            <a:off x="10186415" y="2971800"/>
+            <a:ext cx="1627632" cy="736092"/>
           </a:xfrm>
           <a:prstGeom prst="roundRect">
             <a:avLst>
@@ -7599,7 +7599,7 @@
                 </a:solidFill>
                 <a:latin typeface="Segoe UI"/>
               </a:rPr>
-              <a:t>Buyer</a:t>
+              <a:t>Business rules &amp; policies</a:t>
             </a:r>
           </a:p>
         </p:txBody>
@@ -7612,8 +7612,8 @@
         </p:nvSpPr>
         <p:spPr>
           <a:xfrm>
-            <a:off x="10186415" y="2346350"/>
-            <a:ext cx="45720" cy="423367"/>
+            <a:off x="10186415" y="2971800"/>
+            <a:ext cx="45720" cy="736092"/>
           </a:xfrm>
           <a:prstGeom prst="rect">
             <a:avLst/>
@@ -7656,8 +7656,8 @@
         </p:nvSpPr>
         <p:spPr>
           <a:xfrm>
-            <a:off x="10186415" y="2815437"/>
-            <a:ext cx="1627632" cy="423367"/>
+            <a:off x="10186415" y="3753612"/>
+            <a:ext cx="1627632" cy="736092"/>
           </a:xfrm>
           <a:prstGeom prst="roundRect">
             <a:avLst>
@@ -7710,7 +7710,7 @@
                 </a:solidFill>
                 <a:latin typeface="Segoe UI"/>
               </a:rPr>
-              <a:t>Pricing</a:t>
+              <a:t>Limits &amp; thresholds</a:t>
             </a:r>
           </a:p>
         </p:txBody>
@@ -7723,8 +7723,8 @@
         </p:nvSpPr>
         <p:spPr>
           <a:xfrm>
-            <a:off x="10186415" y="2815437"/>
-            <a:ext cx="45720" cy="423367"/>
+            <a:off x="10186415" y="3753612"/>
+            <a:ext cx="45720" cy="736092"/>
           </a:xfrm>
           <a:prstGeom prst="rect">
             <a:avLst/>
@@ -7767,8 +7767,8 @@
         </p:nvSpPr>
         <p:spPr>
           <a:xfrm>
-            <a:off x="10186415" y="3284524"/>
-            <a:ext cx="1627632" cy="423367"/>
+            <a:off x="10186415" y="4535424"/>
+            <a:ext cx="1627632" cy="736092"/>
           </a:xfrm>
           <a:prstGeom prst="roundRect">
             <a:avLst>
@@ -7821,7 +7821,7 @@
                 </a:solidFill>
                 <a:latin typeface="Segoe UI"/>
               </a:rPr>
-              <a:t>Credit</a:t>
+              <a:t>Contracts &amp; pricing data</a:t>
             </a:r>
           </a:p>
         </p:txBody>
@@ -7834,8 +7834,8 @@
         </p:nvSpPr>
         <p:spPr>
           <a:xfrm>
-            <a:off x="10186415" y="3284524"/>
-            <a:ext cx="45720" cy="423367"/>
+            <a:off x="10186415" y="4535424"/>
+            <a:ext cx="45720" cy="736092"/>
           </a:xfrm>
           <a:prstGeom prst="rect">
             <a:avLst/>
@@ -7878,8 +7878,8 @@
         </p:nvSpPr>
         <p:spPr>
           <a:xfrm>
-            <a:off x="10186415" y="3753612"/>
-            <a:ext cx="1627632" cy="423367"/>
+            <a:off x="10186415" y="5317236"/>
+            <a:ext cx="1627632" cy="736092"/>
           </a:xfrm>
           <a:prstGeom prst="roundRect">
             <a:avLst>
@@ -7932,7 +7932,7 @@
                 </a:solidFill>
                 <a:latin typeface="Segoe UI"/>
               </a:rPr>
-              <a:t>Inventory</a:t>
+              <a:t>Integration endpoints</a:t>
             </a:r>
           </a:p>
         </p:txBody>
@@ -7945,8 +7945,8 @@
         </p:nvSpPr>
         <p:spPr>
           <a:xfrm>
-            <a:off x="10186415" y="3753612"/>
-            <a:ext cx="45720" cy="423367"/>
+            <a:off x="10186415" y="5317236"/>
+            <a:ext cx="45720" cy="736092"/>
           </a:xfrm>
           <a:prstGeom prst="rect">
             <a:avLst/>
@@ -7983,27 +7983,23 @@
       </p:sp>
       <p:sp>
         <p:nvSpPr>
-          <p:cNvPr id="83" name="Rounded Rectangle 82"/>
+          <p:cNvPr id="83" name="Down Arrow 82"/>
           <p:cNvSpPr/>
           <p:nvPr/>
         </p:nvSpPr>
         <p:spPr>
           <a:xfrm>
-            <a:off x="10186415" y="4222699"/>
-            <a:ext cx="1627632" cy="423367"/>
-          </a:xfrm>
-          <a:prstGeom prst="roundRect">
-            <a:avLst>
-              <a:gd name="adj" fmla="val 6000"/>
-            </a:avLst>
-          </a:prstGeom>
-          <a:solidFill>
-            <a:srgbClr val="222230"/>
-          </a:solidFill>
-          <a:ln w="7620">
-            <a:solidFill>
-              <a:srgbClr val="3C3C4E"/>
-            </a:solidFill>
+            <a:off x="5605271" y="1627631"/>
+            <a:ext cx="292608" cy="109728"/>
+          </a:xfrm>
+          <a:prstGeom prst="downArrow">
+            <a:avLst/>
+          </a:prstGeom>
+          <a:solidFill>
+            <a:srgbClr val="FFE600"/>
+          </a:solidFill>
+          <a:ln>
+            <a:noFill/>
           </a:ln>
           <a:effectLst/>
         </p:spPr>
@@ -8022,48 +8018,29 @@
           </a:fontRef>
         </p:style>
         <p:txBody>
-          <a:bodyPr rtlCol="0" anchor="ctr" wrap="square" lIns="27432" rIns="27432" tIns="9144" bIns="9144"/>
-          <a:lstStyle/>
-          <a:p>
-            <a:pPr algn="l">
-              <a:lnSpc>
-                <a:spcPct val="95000"/>
-              </a:lnSpc>
-              <a:spcBef>
-                <a:spcPts val="0"/>
-              </a:spcBef>
-              <a:spcAft>
-                <a:spcPts val="0"/>
-              </a:spcAft>
-            </a:pPr>
-            <a:r>
-              <a:rPr sz="690" b="0" i="0">
-                <a:solidFill>
-                  <a:srgbClr val="FFFFFF"/>
-                </a:solidFill>
-                <a:latin typeface="Segoe UI"/>
-              </a:rPr>
-              <a:t>Logistics</a:t>
-            </a:r>
-          </a:p>
-        </p:txBody>
-      </p:sp>
-      <p:sp>
-        <p:nvSpPr>
-          <p:cNvPr id="84" name="Rectangle 83"/>
+          <a:bodyPr rtlCol="0" anchor="ctr"/>
+          <a:lstStyle/>
+          <a:p>
+            <a:pPr algn="ctr"/>
+          </a:p>
+        </p:txBody>
+      </p:sp>
+      <p:sp>
+        <p:nvSpPr>
+          <p:cNvPr id="84" name="Down Arrow 83"/>
           <p:cNvSpPr/>
           <p:nvPr/>
         </p:nvSpPr>
         <p:spPr>
           <a:xfrm>
-            <a:off x="10186415" y="4222699"/>
-            <a:ext cx="45720" cy="423367"/>
-          </a:xfrm>
-          <a:prstGeom prst="rect">
+            <a:off x="5605271" y="5010912"/>
+            <a:ext cx="292608" cy="109728"/>
+          </a:xfrm>
+          <a:prstGeom prst="downArrow">
             <a:avLst/>
           </a:prstGeom>
           <a:solidFill>
-            <a:srgbClr val="A97BFF"/>
+            <a:srgbClr val="FFE600"/>
           </a:solidFill>
           <a:ln>
             <a:noFill/>
@@ -8085,427 +8062,6 @@
           </a:fontRef>
         </p:style>
         <p:txBody>
-          <a:bodyPr rtlCol="0" anchor="ctr" wrap="square"/>
-          <a:lstStyle/>
-          <a:p>
-            <a:pPr algn="ctr"/>
-          </a:p>
-        </p:txBody>
-      </p:sp>
-      <p:sp>
-        <p:nvSpPr>
-          <p:cNvPr id="85" name="Rounded Rectangle 84"/>
-          <p:cNvSpPr/>
-          <p:nvPr/>
-        </p:nvSpPr>
-        <p:spPr>
-          <a:xfrm>
-            <a:off x="10186415" y="4691786"/>
-            <a:ext cx="1627632" cy="423367"/>
-          </a:xfrm>
-          <a:prstGeom prst="roundRect">
-            <a:avLst>
-              <a:gd name="adj" fmla="val 6000"/>
-            </a:avLst>
-          </a:prstGeom>
-          <a:solidFill>
-            <a:srgbClr val="222230"/>
-          </a:solidFill>
-          <a:ln w="7620">
-            <a:solidFill>
-              <a:srgbClr val="3C3C4E"/>
-            </a:solidFill>
-          </a:ln>
-          <a:effectLst/>
-        </p:spPr>
-        <p:style>
-          <a:lnRef idx="1">
-            <a:schemeClr val="accent1"/>
-          </a:lnRef>
-          <a:fillRef idx="3">
-            <a:schemeClr val="accent1"/>
-          </a:fillRef>
-          <a:effectRef idx="2">
-            <a:schemeClr val="accent1"/>
-          </a:effectRef>
-          <a:fontRef idx="minor">
-            <a:schemeClr val="lt1"/>
-          </a:fontRef>
-        </p:style>
-        <p:txBody>
-          <a:bodyPr rtlCol="0" anchor="ctr" wrap="square" lIns="27432" rIns="27432" tIns="9144" bIns="9144"/>
-          <a:lstStyle/>
-          <a:p>
-            <a:pPr algn="l">
-              <a:lnSpc>
-                <a:spcPct val="95000"/>
-              </a:lnSpc>
-              <a:spcBef>
-                <a:spcPts val="0"/>
-              </a:spcBef>
-              <a:spcAft>
-                <a:spcPts val="0"/>
-              </a:spcAft>
-            </a:pPr>
-            <a:r>
-              <a:rPr sz="690" b="0" i="0">
-                <a:solidFill>
-                  <a:srgbClr val="FFFFFF"/>
-                </a:solidFill>
-                <a:latin typeface="Segoe UI"/>
-              </a:rPr>
-              <a:t>Budget &amp; Approval</a:t>
-            </a:r>
-          </a:p>
-        </p:txBody>
-      </p:sp>
-      <p:sp>
-        <p:nvSpPr>
-          <p:cNvPr id="86" name="Rectangle 85"/>
-          <p:cNvSpPr/>
-          <p:nvPr/>
-        </p:nvSpPr>
-        <p:spPr>
-          <a:xfrm>
-            <a:off x="10186415" y="4691786"/>
-            <a:ext cx="45720" cy="423367"/>
-          </a:xfrm>
-          <a:prstGeom prst="rect">
-            <a:avLst/>
-          </a:prstGeom>
-          <a:solidFill>
-            <a:srgbClr val="A97BFF"/>
-          </a:solidFill>
-          <a:ln>
-            <a:noFill/>
-          </a:ln>
-          <a:effectLst/>
-        </p:spPr>
-        <p:style>
-          <a:lnRef idx="1">
-            <a:schemeClr val="accent1"/>
-          </a:lnRef>
-          <a:fillRef idx="3">
-            <a:schemeClr val="accent1"/>
-          </a:fillRef>
-          <a:effectRef idx="2">
-            <a:schemeClr val="accent1"/>
-          </a:effectRef>
-          <a:fontRef idx="minor">
-            <a:schemeClr val="lt1"/>
-          </a:fontRef>
-        </p:style>
-        <p:txBody>
-          <a:bodyPr rtlCol="0" anchor="ctr" wrap="square"/>
-          <a:lstStyle/>
-          <a:p>
-            <a:pPr algn="ctr"/>
-          </a:p>
-        </p:txBody>
-      </p:sp>
-      <p:sp>
-        <p:nvSpPr>
-          <p:cNvPr id="87" name="Rounded Rectangle 86"/>
-          <p:cNvSpPr/>
-          <p:nvPr/>
-        </p:nvSpPr>
-        <p:spPr>
-          <a:xfrm>
-            <a:off x="10186415" y="5160873"/>
-            <a:ext cx="1627632" cy="423367"/>
-          </a:xfrm>
-          <a:prstGeom prst="roundRect">
-            <a:avLst>
-              <a:gd name="adj" fmla="val 6000"/>
-            </a:avLst>
-          </a:prstGeom>
-          <a:solidFill>
-            <a:srgbClr val="222230"/>
-          </a:solidFill>
-          <a:ln w="7620">
-            <a:solidFill>
-              <a:srgbClr val="3C3C4E"/>
-            </a:solidFill>
-          </a:ln>
-          <a:effectLst/>
-        </p:spPr>
-        <p:style>
-          <a:lnRef idx="1">
-            <a:schemeClr val="accent1"/>
-          </a:lnRef>
-          <a:fillRef idx="3">
-            <a:schemeClr val="accent1"/>
-          </a:fillRef>
-          <a:effectRef idx="2">
-            <a:schemeClr val="accent1"/>
-          </a:effectRef>
-          <a:fontRef idx="minor">
-            <a:schemeClr val="lt1"/>
-          </a:fontRef>
-        </p:style>
-        <p:txBody>
-          <a:bodyPr rtlCol="0" anchor="ctr" wrap="square" lIns="27432" rIns="27432" tIns="9144" bIns="9144"/>
-          <a:lstStyle/>
-          <a:p>
-            <a:pPr algn="l">
-              <a:lnSpc>
-                <a:spcPct val="95000"/>
-              </a:lnSpc>
-              <a:spcBef>
-                <a:spcPts val="0"/>
-              </a:spcBef>
-              <a:spcAft>
-                <a:spcPts val="0"/>
-              </a:spcAft>
-            </a:pPr>
-            <a:r>
-              <a:rPr sz="690" b="0" i="0">
-                <a:solidFill>
-                  <a:srgbClr val="FFFFFF"/>
-                </a:solidFill>
-                <a:latin typeface="Segoe UI"/>
-              </a:rPr>
-              <a:t>Compliance &amp; SDS</a:t>
-            </a:r>
-          </a:p>
-        </p:txBody>
-      </p:sp>
-      <p:sp>
-        <p:nvSpPr>
-          <p:cNvPr id="88" name="Rectangle 87"/>
-          <p:cNvSpPr/>
-          <p:nvPr/>
-        </p:nvSpPr>
-        <p:spPr>
-          <a:xfrm>
-            <a:off x="10186415" y="5160873"/>
-            <a:ext cx="45720" cy="423367"/>
-          </a:xfrm>
-          <a:prstGeom prst="rect">
-            <a:avLst/>
-          </a:prstGeom>
-          <a:solidFill>
-            <a:srgbClr val="A97BFF"/>
-          </a:solidFill>
-          <a:ln>
-            <a:noFill/>
-          </a:ln>
-          <a:effectLst/>
-        </p:spPr>
-        <p:style>
-          <a:lnRef idx="1">
-            <a:schemeClr val="accent1"/>
-          </a:lnRef>
-          <a:fillRef idx="3">
-            <a:schemeClr val="accent1"/>
-          </a:fillRef>
-          <a:effectRef idx="2">
-            <a:schemeClr val="accent1"/>
-          </a:effectRef>
-          <a:fontRef idx="minor">
-            <a:schemeClr val="lt1"/>
-          </a:fontRef>
-        </p:style>
-        <p:txBody>
-          <a:bodyPr rtlCol="0" anchor="ctr" wrap="square"/>
-          <a:lstStyle/>
-          <a:p>
-            <a:pPr algn="ctr"/>
-          </a:p>
-        </p:txBody>
-      </p:sp>
-      <p:sp>
-        <p:nvSpPr>
-          <p:cNvPr id="89" name="Rounded Rectangle 88"/>
-          <p:cNvSpPr/>
-          <p:nvPr/>
-        </p:nvSpPr>
-        <p:spPr>
-          <a:xfrm>
-            <a:off x="10186415" y="5629960"/>
-            <a:ext cx="1627632" cy="423367"/>
-          </a:xfrm>
-          <a:prstGeom prst="roundRect">
-            <a:avLst>
-              <a:gd name="adj" fmla="val 6000"/>
-            </a:avLst>
-          </a:prstGeom>
-          <a:solidFill>
-            <a:srgbClr val="222230"/>
-          </a:solidFill>
-          <a:ln w="7620">
-            <a:solidFill>
-              <a:srgbClr val="3C3C4E"/>
-            </a:solidFill>
-          </a:ln>
-          <a:effectLst/>
-        </p:spPr>
-        <p:style>
-          <a:lnRef idx="1">
-            <a:schemeClr val="accent1"/>
-          </a:lnRef>
-          <a:fillRef idx="3">
-            <a:schemeClr val="accent1"/>
-          </a:fillRef>
-          <a:effectRef idx="2">
-            <a:schemeClr val="accent1"/>
-          </a:effectRef>
-          <a:fontRef idx="minor">
-            <a:schemeClr val="lt1"/>
-          </a:fontRef>
-        </p:style>
-        <p:txBody>
-          <a:bodyPr rtlCol="0" anchor="ctr" wrap="square" lIns="27432" rIns="27432" tIns="9144" bIns="9144"/>
-          <a:lstStyle/>
-          <a:p>
-            <a:pPr algn="l">
-              <a:lnSpc>
-                <a:spcPct val="95000"/>
-              </a:lnSpc>
-              <a:spcBef>
-                <a:spcPts val="0"/>
-              </a:spcBef>
-              <a:spcAft>
-                <a:spcPts val="0"/>
-              </a:spcAft>
-            </a:pPr>
-            <a:r>
-              <a:rPr sz="690" b="0" i="0">
-                <a:solidFill>
-                  <a:srgbClr val="FFFFFF"/>
-                </a:solidFill>
-                <a:latin typeface="Segoe UI"/>
-              </a:rPr>
-              <a:t>Execution endpoints</a:t>
-            </a:r>
-          </a:p>
-        </p:txBody>
-      </p:sp>
-      <p:sp>
-        <p:nvSpPr>
-          <p:cNvPr id="90" name="Rectangle 89"/>
-          <p:cNvSpPr/>
-          <p:nvPr/>
-        </p:nvSpPr>
-        <p:spPr>
-          <a:xfrm>
-            <a:off x="10186415" y="5629960"/>
-            <a:ext cx="45720" cy="423367"/>
-          </a:xfrm>
-          <a:prstGeom prst="rect">
-            <a:avLst/>
-          </a:prstGeom>
-          <a:solidFill>
-            <a:srgbClr val="A97BFF"/>
-          </a:solidFill>
-          <a:ln>
-            <a:noFill/>
-          </a:ln>
-          <a:effectLst/>
-        </p:spPr>
-        <p:style>
-          <a:lnRef idx="1">
-            <a:schemeClr val="accent1"/>
-          </a:lnRef>
-          <a:fillRef idx="3">
-            <a:schemeClr val="accent1"/>
-          </a:fillRef>
-          <a:effectRef idx="2">
-            <a:schemeClr val="accent1"/>
-          </a:effectRef>
-          <a:fontRef idx="minor">
-            <a:schemeClr val="lt1"/>
-          </a:fontRef>
-        </p:style>
-        <p:txBody>
-          <a:bodyPr rtlCol="0" anchor="ctr" wrap="square"/>
-          <a:lstStyle/>
-          <a:p>
-            <a:pPr algn="ctr"/>
-          </a:p>
-        </p:txBody>
-      </p:sp>
-      <p:sp>
-        <p:nvSpPr>
-          <p:cNvPr id="91" name="Down Arrow 90"/>
-          <p:cNvSpPr/>
-          <p:nvPr/>
-        </p:nvSpPr>
-        <p:spPr>
-          <a:xfrm>
-            <a:off x="5605271" y="1627631"/>
-            <a:ext cx="292608" cy="109728"/>
-          </a:xfrm>
-          <a:prstGeom prst="downArrow">
-            <a:avLst/>
-          </a:prstGeom>
-          <a:solidFill>
-            <a:srgbClr val="FFE600"/>
-          </a:solidFill>
-          <a:ln>
-            <a:noFill/>
-          </a:ln>
-          <a:effectLst/>
-        </p:spPr>
-        <p:style>
-          <a:lnRef idx="1">
-            <a:schemeClr val="accent1"/>
-          </a:lnRef>
-          <a:fillRef idx="3">
-            <a:schemeClr val="accent1"/>
-          </a:fillRef>
-          <a:effectRef idx="2">
-            <a:schemeClr val="accent1"/>
-          </a:effectRef>
-          <a:fontRef idx="minor">
-            <a:schemeClr val="lt1"/>
-          </a:fontRef>
-        </p:style>
-        <p:txBody>
-          <a:bodyPr rtlCol="0" anchor="ctr"/>
-          <a:lstStyle/>
-          <a:p>
-            <a:pPr algn="ctr"/>
-          </a:p>
-        </p:txBody>
-      </p:sp>
-      <p:sp>
-        <p:nvSpPr>
-          <p:cNvPr id="92" name="Down Arrow 91"/>
-          <p:cNvSpPr/>
-          <p:nvPr/>
-        </p:nvSpPr>
-        <p:spPr>
-          <a:xfrm>
-            <a:off x="5605271" y="5010912"/>
-            <a:ext cx="292608" cy="109728"/>
-          </a:xfrm>
-          <a:prstGeom prst="downArrow">
-            <a:avLst/>
-          </a:prstGeom>
-          <a:solidFill>
-            <a:srgbClr val="FFE600"/>
-          </a:solidFill>
-          <a:ln>
-            <a:noFill/>
-          </a:ln>
-          <a:effectLst/>
-        </p:spPr>
-        <p:style>
-          <a:lnRef idx="1">
-            <a:schemeClr val="accent1"/>
-          </a:lnRef>
-          <a:fillRef idx="3">
-            <a:schemeClr val="accent1"/>
-          </a:fillRef>
-          <a:effectRef idx="2">
-            <a:schemeClr val="accent1"/>
-          </a:effectRef>
-          <a:fontRef idx="minor">
-            <a:schemeClr val="lt1"/>
-          </a:fontRef>
-        </p:style>
-        <p:txBody>
           <a:bodyPr rtlCol="0" anchor="ctr"/>
           <a:lstStyle/>
           <a:p>
@@ -8515,7 +8071,7 @@
       </p:sp>
       <p:cxnSp>
         <p:nvCxnSpPr>
-          <p:cNvPr id="93" name="Connector 92"/>
+          <p:cNvPr id="85" name="Connector 84"/>
           <p:cNvCxnSpPr/>
           <p:nvPr/>
         </p:nvCxnSpPr>
@@ -8553,7 +8109,7 @@
       </p:cxnSp>
       <p:cxnSp>
         <p:nvCxnSpPr>
-          <p:cNvPr id="94" name="Connector 93"/>
+          <p:cNvPr id="86" name="Connector 85"/>
           <p:cNvCxnSpPr/>
           <p:nvPr/>
         </p:nvCxnSpPr>
@@ -8591,7 +8147,7 @@
       </p:cxnSp>
       <p:sp>
         <p:nvSpPr>
-          <p:cNvPr id="95" name="TextBox 94"/>
+          <p:cNvPr id="87" name="TextBox 86"/>
           <p:cNvSpPr txBox="1"/>
           <p:nvPr/>
         </p:nvSpPr>

</xml_diff>

<commit_message>
docs: make Intake Agent part of the orchestration (first agent) in architecture slide
</commit_message>
<xml_diff>
--- a/demo/Order-Creation-Orchestration-Architecture.pptx
+++ b/demo/Order-Creation-Orchestration-Architecture.pptx
@@ -3284,7 +3284,7 @@
         <p:spPr>
           <a:xfrm>
             <a:off x="301752" y="749808"/>
-            <a:ext cx="1170432" cy="896112"/>
+            <a:ext cx="1170432" cy="731520"/>
           </a:xfrm>
           <a:prstGeom prst="roundRect">
             <a:avLst>
@@ -3335,7 +3335,7 @@
                 </a:solidFill>
                 <a:latin typeface="Segoe UI"/>
               </a:rPr>
-              <a:t>INTAKE</a:t>
+              <a:t>PO</a:t>
             </a:r>
           </a:p>
           <a:p>
@@ -3357,7 +3357,7 @@
                 </a:solidFill>
                 <a:latin typeface="Segoe UI"/>
               </a:rPr>
-              <a:t>&amp; RESOLUTION</a:t>
+              <a:t>INTAKE</a:t>
             </a:r>
           </a:p>
         </p:txBody>
@@ -3371,7 +3371,7 @@
         <p:spPr>
           <a:xfrm>
             <a:off x="301752" y="749808"/>
-            <a:ext cx="54864" cy="896112"/>
+            <a:ext cx="54864" cy="731520"/>
           </a:xfrm>
           <a:prstGeom prst="rect">
             <a:avLst/>
@@ -3414,8 +3414,8 @@
         </p:nvSpPr>
         <p:spPr>
           <a:xfrm>
-            <a:off x="301752" y="1719072"/>
-            <a:ext cx="1170432" cy="3310128"/>
+            <a:off x="301752" y="1572768"/>
+            <a:ext cx="1170432" cy="3200400"/>
           </a:xfrm>
           <a:prstGeom prst="roundRect">
             <a:avLst>
@@ -3523,8 +3523,8 @@
         </p:nvSpPr>
         <p:spPr>
           <a:xfrm>
-            <a:off x="301752" y="1719072"/>
-            <a:ext cx="54864" cy="3310128"/>
+            <a:off x="301752" y="1572768"/>
+            <a:ext cx="54864" cy="3200400"/>
           </a:xfrm>
           <a:prstGeom prst="rect">
             <a:avLst/>
@@ -3567,7 +3567,7 @@
         </p:nvSpPr>
         <p:spPr>
           <a:xfrm>
-            <a:off x="301752" y="5102352"/>
+            <a:off x="301752" y="4882896"/>
             <a:ext cx="1170432" cy="1024128"/>
           </a:xfrm>
           <a:prstGeom prst="roundRect">
@@ -3654,7 +3654,7 @@
         </p:nvSpPr>
         <p:spPr>
           <a:xfrm>
-            <a:off x="301752" y="5102352"/>
+            <a:off x="301752" y="4882896"/>
             <a:ext cx="54864" cy="1024128"/>
           </a:xfrm>
           <a:prstGeom prst="rect">
@@ -3699,7 +3699,7 @@
         <p:spPr>
           <a:xfrm>
             <a:off x="1591056" y="768096"/>
-            <a:ext cx="8229600" cy="182880"/>
+            <a:ext cx="8266175" cy="182880"/>
           </a:xfrm>
           <a:prstGeom prst="rect">
             <a:avLst/>
@@ -3730,7 +3730,7 @@
                 </a:solidFill>
                 <a:latin typeface="Segoe UI"/>
               </a:rPr>
-              <a:t>INTAKE — the </a:t>
+              <a:t>PO INTAKE — received via any channel; the </a:t>
             </a:r>
             <a:r>
               <a:rPr sz="800" b="1" i="0">
@@ -3748,7 +3748,7 @@
                 </a:solidFill>
                 <a:latin typeface="Segoe UI"/>
               </a:rPr>
-              <a:t> reads every PO and extracts the order fields</a:t>
+              <a:t> is the first agent in the orchestration below</a:t>
             </a:r>
           </a:p>
         </p:txBody>
@@ -3762,7 +3762,7 @@
         <p:spPr>
           <a:xfrm>
             <a:off x="1618488" y="987552"/>
-            <a:ext cx="2468880" cy="585216"/>
+            <a:ext cx="2651760" cy="438912"/>
           </a:xfrm>
           <a:prstGeom prst="roundRect">
             <a:avLst>
@@ -3810,7 +3810,7 @@
         <p:spPr>
           <a:xfrm>
             <a:off x="1618488" y="987552"/>
-            <a:ext cx="2468880" cy="45720"/>
+            <a:ext cx="2651760" cy="45720"/>
           </a:xfrm>
           <a:prstGeom prst="rect">
             <a:avLst/>
@@ -3854,7 +3854,7 @@
         <p:spPr>
           <a:xfrm>
             <a:off x="1709928" y="1069848"/>
-            <a:ext cx="2286000" cy="182880"/>
+            <a:ext cx="2468879" cy="182880"/>
           </a:xfrm>
           <a:prstGeom prst="rect">
             <a:avLst/>
@@ -3899,7 +3899,7 @@
         <p:spPr>
           <a:xfrm>
             <a:off x="1709928" y="1271016"/>
-            <a:ext cx="2286000" cy="265176"/>
+            <a:ext cx="2468879" cy="118872"/>
           </a:xfrm>
           <a:prstGeom prst="rect">
             <a:avLst/>
@@ -3930,87 +3930,21 @@
                 </a:solidFill>
                 <a:latin typeface="Segoe UI"/>
               </a:rPr>
-              <a:t>Received as Email PO,</a:t>
-            </a:r>
-          </a:p>
-          <a:p>
-            <a:pPr algn="l">
-              <a:lnSpc>
-                <a:spcPct val="104000"/>
-              </a:lnSpc>
-              <a:spcBef>
-                <a:spcPts val="0"/>
-              </a:spcBef>
-              <a:spcAft>
-                <a:spcPts val="0"/>
-              </a:spcAft>
-            </a:pPr>
-            <a:r>
-              <a:rPr sz="660" b="0" i="0">
-                <a:solidFill>
-                  <a:srgbClr val="C2C2D0"/>
-                </a:solidFill>
-                <a:latin typeface="Segoe UI"/>
-              </a:rPr>
-              <a:t>Excel PO etc.</a:t>
-            </a:r>
-          </a:p>
-        </p:txBody>
-      </p:sp>
-      <p:sp>
-        <p:nvSpPr>
-          <p:cNvPr id="17" name="Chevron 16"/>
+              <a:t>Received as Email PO, Excel PO etc.</a:t>
+            </a:r>
+          </a:p>
+        </p:txBody>
+      </p:sp>
+      <p:sp>
+        <p:nvSpPr>
+          <p:cNvPr id="17" name="Rounded Rectangle 16"/>
           <p:cNvSpPr/>
           <p:nvPr/>
         </p:nvSpPr>
         <p:spPr>
           <a:xfrm>
-            <a:off x="4133087" y="1207007"/>
-            <a:ext cx="292608" cy="182880"/>
-          </a:xfrm>
-          <a:prstGeom prst="chevron">
-            <a:avLst/>
-          </a:prstGeom>
-          <a:solidFill>
-            <a:srgbClr val="4A9EFF"/>
-          </a:solidFill>
-          <a:ln>
-            <a:noFill/>
-          </a:ln>
-          <a:effectLst/>
-        </p:spPr>
-        <p:style>
-          <a:lnRef idx="1">
-            <a:schemeClr val="accent1"/>
-          </a:lnRef>
-          <a:fillRef idx="3">
-            <a:schemeClr val="accent1"/>
-          </a:fillRef>
-          <a:effectRef idx="2">
-            <a:schemeClr val="accent1"/>
-          </a:effectRef>
-          <a:fontRef idx="minor">
-            <a:schemeClr val="lt1"/>
-          </a:fontRef>
-        </p:style>
-        <p:txBody>
-          <a:bodyPr rtlCol="0" anchor="ctr"/>
-          <a:lstStyle/>
-          <a:p>
-            <a:pPr algn="ctr"/>
-          </a:p>
-        </p:txBody>
-      </p:sp>
-      <p:sp>
-        <p:nvSpPr>
-          <p:cNvPr id="18" name="Rounded Rectangle 17"/>
-          <p:cNvSpPr/>
-          <p:nvPr/>
-        </p:nvSpPr>
-        <p:spPr>
-          <a:xfrm>
-            <a:off x="4498848" y="987552"/>
-            <a:ext cx="5385815" cy="585216"/>
+            <a:off x="4636008" y="987552"/>
+            <a:ext cx="5248655" cy="438912"/>
           </a:xfrm>
           <a:prstGeom prst="roundRect">
             <a:avLst>
@@ -4051,14 +3985,14 @@
       </p:sp>
       <p:sp>
         <p:nvSpPr>
-          <p:cNvPr id="19" name="Rectangle 18"/>
+          <p:cNvPr id="18" name="Rectangle 17"/>
           <p:cNvSpPr/>
           <p:nvPr/>
         </p:nvSpPr>
         <p:spPr>
           <a:xfrm>
-            <a:off x="4498848" y="987552"/>
-            <a:ext cx="5385815" cy="45720"/>
+            <a:off x="4636008" y="987552"/>
+            <a:ext cx="5248655" cy="45720"/>
           </a:xfrm>
           <a:prstGeom prst="rect">
             <a:avLst/>
@@ -4095,59 +4029,14 @@
       </p:sp>
       <p:sp>
         <p:nvSpPr>
-          <p:cNvPr id="20" name="TextBox 19"/>
+          <p:cNvPr id="19" name="TextBox 18"/>
           <p:cNvSpPr txBox="1"/>
           <p:nvPr/>
         </p:nvSpPr>
         <p:spPr>
           <a:xfrm>
-            <a:off x="4608576" y="1060704"/>
-            <a:ext cx="5157215" cy="182880"/>
-          </a:xfrm>
-          <a:prstGeom prst="rect">
-            <a:avLst/>
-          </a:prstGeom>
-          <a:noFill/>
-        </p:spPr>
-        <p:txBody>
-          <a:bodyPr wrap="square" anchor="t" lIns="0" rIns="0" tIns="0" bIns="0">
-            <a:spAutoFit/>
-          </a:bodyPr>
-          <a:lstStyle/>
-          <a:p>
-            <a:pPr algn="l">
-              <a:lnSpc>
-                <a:spcPct val="100000"/>
-              </a:lnSpc>
-              <a:spcBef>
-                <a:spcPts val="0"/>
-              </a:spcBef>
-              <a:spcAft>
-                <a:spcPts val="0"/>
-              </a:spcAft>
-            </a:pPr>
-            <a:r>
-              <a:rPr sz="819" b="1" i="0">
-                <a:solidFill>
-                  <a:srgbClr val="4A9EFF"/>
-                </a:solidFill>
-                <a:latin typeface="Segoe UI"/>
-              </a:rPr>
-              <a:t>🤖  Intake Agent</a:t>
-            </a:r>
-          </a:p>
-        </p:txBody>
-      </p:sp>
-      <p:sp>
-        <p:nvSpPr>
-          <p:cNvPr id="21" name="TextBox 20"/>
-          <p:cNvSpPr txBox="1"/>
-          <p:nvPr/>
-        </p:nvSpPr>
-        <p:spPr>
-          <a:xfrm>
-            <a:off x="4608576" y="1252728"/>
-            <a:ext cx="5157215" cy="310896"/>
+            <a:off x="4745736" y="1078992"/>
+            <a:ext cx="5065775" cy="329184"/>
           </a:xfrm>
           <a:prstGeom prst="rect">
             <a:avLst/>
@@ -4172,36 +4061,45 @@
               </a:spcAft>
             </a:pPr>
             <a:r>
-              <a:rPr sz="670" b="0" i="0">
+              <a:rPr sz="700" b="0" i="0">
                 <a:solidFill>
                   <a:srgbClr val="C2C2D0"/>
                 </a:solidFill>
                 <a:latin typeface="Segoe UI"/>
               </a:rPr>
-              <a:t>extracts order fields (rule-based · confidence-scored): </a:t>
-            </a:r>
-            <a:r>
-              <a:rPr sz="670" b="0" i="0">
-                <a:solidFill>
-                  <a:srgbClr val="FFFFFF"/>
+              <a:t>The </a:t>
+            </a:r>
+            <a:r>
+              <a:rPr sz="700" b="1" i="0">
+                <a:solidFill>
+                  <a:srgbClr val="4A9EFF"/>
                 </a:solidFill>
                 <a:latin typeface="Segoe UI"/>
               </a:rPr>
-              <a:t>SKU · qty · UOM · ship-to ZIP · delivery date · PO number · customer / buyer</a:t>
-            </a:r>
-          </a:p>
-        </p:txBody>
-      </p:sp>
-      <p:sp>
-        <p:nvSpPr>
-          <p:cNvPr id="22" name="Rounded Rectangle 21"/>
+              <a:t>🤖 Intake Agent</a:t>
+            </a:r>
+            <a:r>
+              <a:rPr sz="700" b="0" i="0">
+                <a:solidFill>
+                  <a:srgbClr val="FFFFFF"/>
+                </a:solidFill>
+                <a:latin typeface="Segoe UI"/>
+              </a:rPr>
+              <a:t> reads every PO and extracts: SKU · qty · UOM · ship-to ZIP · delivery date · PO number · customer / buyer</a:t>
+            </a:r>
+          </a:p>
+        </p:txBody>
+      </p:sp>
+      <p:sp>
+        <p:nvSpPr>
+          <p:cNvPr id="20" name="Rounded Rectangle 19"/>
           <p:cNvSpPr/>
           <p:nvPr/>
         </p:nvSpPr>
         <p:spPr>
           <a:xfrm>
-            <a:off x="1572768" y="1719072"/>
-            <a:ext cx="8357615" cy="3310128"/>
+            <a:off x="1572768" y="1572768"/>
+            <a:ext cx="8357615" cy="3200400"/>
           </a:xfrm>
           <a:prstGeom prst="roundRect">
             <a:avLst>
@@ -4242,13 +4140,13 @@
       </p:sp>
       <p:sp>
         <p:nvSpPr>
-          <p:cNvPr id="23" name="Rounded Rectangle 22"/>
+          <p:cNvPr id="21" name="Rounded Rectangle 20"/>
           <p:cNvSpPr/>
           <p:nvPr/>
         </p:nvSpPr>
         <p:spPr>
           <a:xfrm>
-            <a:off x="1700784" y="1828800"/>
+            <a:off x="1700784" y="1682495"/>
             <a:ext cx="8101583" cy="365760"/>
           </a:xfrm>
           <a:prstGeom prst="roundRect">
@@ -4318,13 +4216,13 @@
       </p:sp>
       <p:sp>
         <p:nvSpPr>
-          <p:cNvPr id="24" name="Down Arrow 23"/>
+          <p:cNvPr id="22" name="Down Arrow 21"/>
           <p:cNvSpPr/>
           <p:nvPr/>
         </p:nvSpPr>
         <p:spPr>
           <a:xfrm>
-            <a:off x="5623559" y="2231136"/>
+            <a:off x="5623559" y="2084832"/>
             <a:ext cx="256032" cy="109728"/>
           </a:xfrm>
           <a:prstGeom prst="downArrow">
@@ -4362,14 +4260,14 @@
       </p:sp>
       <p:sp>
         <p:nvSpPr>
-          <p:cNvPr id="25" name="Rounded Rectangle 24"/>
+          <p:cNvPr id="23" name="Rounded Rectangle 22"/>
           <p:cNvSpPr/>
           <p:nvPr/>
         </p:nvSpPr>
         <p:spPr>
           <a:xfrm>
-            <a:off x="1700784" y="2414015"/>
-            <a:ext cx="932688" cy="1060704"/>
+            <a:off x="1700784" y="2249424"/>
+            <a:ext cx="835151" cy="1060704"/>
           </a:xfrm>
           <a:prstGeom prst="roundRect">
             <a:avLst>
@@ -4406,7 +4304,7 @@
           <a:p>
             <a:pPr algn="ctr">
               <a:lnSpc>
-                <a:spcPct val="118000"/>
+                <a:spcPct val="116000"/>
               </a:lnSpc>
               <a:spcBef>
                 <a:spcPts val="0"/>
@@ -4416,7 +4314,7 @@
               </a:spcAft>
             </a:pPr>
             <a:r>
-              <a:rPr sz="900" b="1" i="0">
+              <a:rPr sz="830" b="1" i="0">
                 <a:solidFill>
                   <a:srgbClr val="FFE600"/>
                 </a:solidFill>
@@ -4425,19 +4323,19 @@
               <a:t>🤖 </a:t>
             </a:r>
             <a:r>
-              <a:rPr sz="740" b="1" i="0">
+              <a:rPr sz="680" b="1" i="0">
                 <a:solidFill>
                   <a:srgbClr val="FFFFFF"/>
                 </a:solidFill>
                 <a:latin typeface="Segoe UI"/>
               </a:rPr>
-              <a:t>Customer</a:t>
+              <a:t>Intake</a:t>
             </a:r>
           </a:p>
           <a:p>
             <a:pPr algn="ctr">
               <a:lnSpc>
-                <a:spcPct val="118000"/>
+                <a:spcPct val="116000"/>
               </a:lnSpc>
               <a:spcBef>
                 <a:spcPts val="0"/>
@@ -4447,19 +4345,19 @@
               </a:spcAft>
             </a:pPr>
             <a:r>
-              <a:rPr sz="740" b="1" i="0">
+              <a:rPr sz="680" b="1" i="0">
                 <a:solidFill>
                   <a:srgbClr val="FFFFFF"/>
                 </a:solidFill>
                 <a:latin typeface="Segoe UI"/>
               </a:rPr>
-              <a:t>Validation Agent</a:t>
+              <a:t>Agent</a:t>
             </a:r>
           </a:p>
           <a:p>
             <a:pPr algn="ctr">
               <a:lnSpc>
-                <a:spcPct val="118000"/>
+                <a:spcPct val="116000"/>
               </a:lnSpc>
               <a:spcBef>
                 <a:spcPts val="0"/>
@@ -4469,27 +4367,27 @@
               </a:spcAft>
             </a:pPr>
             <a:r>
-              <a:rPr sz="600" b="0" i="0">
+              <a:rPr sz="560" b="0" i="0">
                 <a:solidFill>
                   <a:srgbClr val="C2C2D0"/>
                 </a:solidFill>
                 <a:latin typeface="Segoe UI"/>
               </a:rPr>
-              <a:t>account · buyer auth · ship-to</a:t>
-            </a:r>
-          </a:p>
-        </p:txBody>
-      </p:sp>
-      <p:sp>
-        <p:nvSpPr>
-          <p:cNvPr id="26" name="Rectangle 25"/>
+              <a:t>reads PO · extracts fields</a:t>
+            </a:r>
+          </a:p>
+        </p:txBody>
+      </p:sp>
+      <p:sp>
+        <p:nvSpPr>
+          <p:cNvPr id="24" name="Rectangle 23"/>
           <p:cNvSpPr/>
           <p:nvPr/>
         </p:nvSpPr>
         <p:spPr>
           <a:xfrm>
-            <a:off x="1700784" y="2414015"/>
-            <a:ext cx="932688" cy="45720"/>
+            <a:off x="1700784" y="2249424"/>
+            <a:ext cx="835151" cy="45720"/>
           </a:xfrm>
           <a:prstGeom prst="rect">
             <a:avLst/>
@@ -4526,14 +4424,14 @@
       </p:sp>
       <p:sp>
         <p:nvSpPr>
-          <p:cNvPr id="27" name="Chevron 26"/>
+          <p:cNvPr id="25" name="Chevron 24"/>
           <p:cNvSpPr/>
           <p:nvPr/>
         </p:nvSpPr>
         <p:spPr>
           <a:xfrm>
-            <a:off x="2615184" y="2862072"/>
-            <a:ext cx="146304" cy="164592"/>
+            <a:off x="2517647" y="2697480"/>
+            <a:ext cx="128016" cy="164592"/>
           </a:xfrm>
           <a:prstGeom prst="chevron">
             <a:avLst/>
@@ -4570,14 +4468,14 @@
       </p:sp>
       <p:sp>
         <p:nvSpPr>
-          <p:cNvPr id="28" name="Rounded Rectangle 27"/>
+          <p:cNvPr id="26" name="Rounded Rectangle 25"/>
           <p:cNvSpPr/>
           <p:nvPr/>
         </p:nvSpPr>
         <p:spPr>
           <a:xfrm>
-            <a:off x="2724912" y="2414015"/>
-            <a:ext cx="932688" cy="1060704"/>
+            <a:off x="2609087" y="2249424"/>
+            <a:ext cx="835151" cy="1060704"/>
           </a:xfrm>
           <a:prstGeom prst="roundRect">
             <a:avLst>
@@ -4614,7 +4512,7 @@
           <a:p>
             <a:pPr algn="ctr">
               <a:lnSpc>
-                <a:spcPct val="118000"/>
+                <a:spcPct val="116000"/>
               </a:lnSpc>
               <a:spcBef>
                 <a:spcPts val="0"/>
@@ -4624,7 +4522,7 @@
               </a:spcAft>
             </a:pPr>
             <a:r>
-              <a:rPr sz="900" b="1" i="0">
+              <a:rPr sz="830" b="1" i="0">
                 <a:solidFill>
                   <a:srgbClr val="FFE600"/>
                 </a:solidFill>
@@ -4633,19 +4531,19 @@
               <a:t>🤖 </a:t>
             </a:r>
             <a:r>
-              <a:rPr sz="740" b="1" i="0">
+              <a:rPr sz="680" b="1" i="0">
                 <a:solidFill>
                   <a:srgbClr val="FFFFFF"/>
                 </a:solidFill>
                 <a:latin typeface="Segoe UI"/>
               </a:rPr>
-              <a:t>Product</a:t>
+              <a:t>Customer</a:t>
             </a:r>
           </a:p>
           <a:p>
             <a:pPr algn="ctr">
               <a:lnSpc>
-                <a:spcPct val="118000"/>
+                <a:spcPct val="116000"/>
               </a:lnSpc>
               <a:spcBef>
                 <a:spcPts val="0"/>
@@ -4655,19 +4553,19 @@
               </a:spcAft>
             </a:pPr>
             <a:r>
-              <a:rPr sz="740" b="1" i="0">
+              <a:rPr sz="680" b="1" i="0">
                 <a:solidFill>
                   <a:srgbClr val="FFFFFF"/>
                 </a:solidFill>
                 <a:latin typeface="Segoe UI"/>
               </a:rPr>
-              <a:t>Matching Agent</a:t>
+              <a:t>Validation Agent</a:t>
             </a:r>
           </a:p>
           <a:p>
             <a:pPr algn="ctr">
               <a:lnSpc>
-                <a:spcPct val="118000"/>
+                <a:spcPct val="116000"/>
               </a:lnSpc>
               <a:spcBef>
                 <a:spcPts val="0"/>
@@ -4677,27 +4575,27 @@
               </a:spcAft>
             </a:pPr>
             <a:r>
-              <a:rPr sz="600" b="0" i="0">
+              <a:rPr sz="560" b="0" i="0">
                 <a:solidFill>
                   <a:srgbClr val="C2C2D0"/>
                 </a:solidFill>
                 <a:latin typeface="Segoe UI"/>
               </a:rPr>
-              <a:t>catalog · compliance &amp; SDS</a:t>
-            </a:r>
-          </a:p>
-        </p:txBody>
-      </p:sp>
-      <p:sp>
-        <p:nvSpPr>
-          <p:cNvPr id="29" name="Rectangle 28"/>
+              <a:t>account · buyer auth · ship-to</a:t>
+            </a:r>
+          </a:p>
+        </p:txBody>
+      </p:sp>
+      <p:sp>
+        <p:nvSpPr>
+          <p:cNvPr id="27" name="Rectangle 26"/>
           <p:cNvSpPr/>
           <p:nvPr/>
         </p:nvSpPr>
         <p:spPr>
           <a:xfrm>
-            <a:off x="2724912" y="2414015"/>
-            <a:ext cx="932688" cy="45720"/>
+            <a:off x="2609087" y="2249424"/>
+            <a:ext cx="835151" cy="45720"/>
           </a:xfrm>
           <a:prstGeom prst="rect">
             <a:avLst/>
@@ -4734,14 +4632,14 @@
       </p:sp>
       <p:sp>
         <p:nvSpPr>
-          <p:cNvPr id="30" name="Chevron 29"/>
+          <p:cNvPr id="28" name="Chevron 27"/>
           <p:cNvSpPr/>
           <p:nvPr/>
         </p:nvSpPr>
         <p:spPr>
           <a:xfrm>
-            <a:off x="3639312" y="2862072"/>
-            <a:ext cx="146304" cy="164592"/>
+            <a:off x="3425951" y="2697480"/>
+            <a:ext cx="128016" cy="164592"/>
           </a:xfrm>
           <a:prstGeom prst="chevron">
             <a:avLst/>
@@ -4778,14 +4676,14 @@
       </p:sp>
       <p:sp>
         <p:nvSpPr>
-          <p:cNvPr id="31" name="Rounded Rectangle 30"/>
+          <p:cNvPr id="29" name="Rounded Rectangle 28"/>
           <p:cNvSpPr/>
           <p:nvPr/>
         </p:nvSpPr>
         <p:spPr>
           <a:xfrm>
-            <a:off x="3749039" y="2414015"/>
-            <a:ext cx="932688" cy="1060704"/>
+            <a:off x="3517391" y="2249424"/>
+            <a:ext cx="835151" cy="1060704"/>
           </a:xfrm>
           <a:prstGeom prst="roundRect">
             <a:avLst>
@@ -4822,7 +4720,7 @@
           <a:p>
             <a:pPr algn="ctr">
               <a:lnSpc>
-                <a:spcPct val="118000"/>
+                <a:spcPct val="116000"/>
               </a:lnSpc>
               <a:spcBef>
                 <a:spcPts val="0"/>
@@ -4832,7 +4730,7 @@
               </a:spcAft>
             </a:pPr>
             <a:r>
-              <a:rPr sz="900" b="1" i="0">
+              <a:rPr sz="830" b="1" i="0">
                 <a:solidFill>
                   <a:srgbClr val="FFE600"/>
                 </a:solidFill>
@@ -4841,19 +4739,19 @@
               <a:t>🤖 </a:t>
             </a:r>
             <a:r>
-              <a:rPr sz="740" b="1" i="0">
+              <a:rPr sz="680" b="1" i="0">
                 <a:solidFill>
                   <a:srgbClr val="FFFFFF"/>
                 </a:solidFill>
                 <a:latin typeface="Segoe UI"/>
               </a:rPr>
-              <a:t>Pricing &amp;</a:t>
+              <a:t>Product</a:t>
             </a:r>
           </a:p>
           <a:p>
             <a:pPr algn="ctr">
               <a:lnSpc>
-                <a:spcPct val="118000"/>
+                <a:spcPct val="116000"/>
               </a:lnSpc>
               <a:spcBef>
                 <a:spcPts val="0"/>
@@ -4863,19 +4761,19 @@
               </a:spcAft>
             </a:pPr>
             <a:r>
-              <a:rPr sz="740" b="1" i="0">
+              <a:rPr sz="680" b="1" i="0">
                 <a:solidFill>
                   <a:srgbClr val="FFFFFF"/>
                 </a:solidFill>
                 <a:latin typeface="Segoe UI"/>
               </a:rPr>
-              <a:t>Promo Agent</a:t>
+              <a:t>Matching Agent</a:t>
             </a:r>
           </a:p>
           <a:p>
             <a:pPr algn="ctr">
               <a:lnSpc>
-                <a:spcPct val="118000"/>
+                <a:spcPct val="116000"/>
               </a:lnSpc>
               <a:spcBef>
                 <a:spcPts val="0"/>
@@ -4885,27 +4783,27 @@
               </a:spcAft>
             </a:pPr>
             <a:r>
-              <a:rPr sz="600" b="0" i="0">
+              <a:rPr sz="560" b="0" i="0">
                 <a:solidFill>
                   <a:srgbClr val="C2C2D0"/>
                 </a:solidFill>
                 <a:latin typeface="Segoe UI"/>
               </a:rPr>
-              <a:t>contract · promo · margin</a:t>
-            </a:r>
-          </a:p>
-        </p:txBody>
-      </p:sp>
-      <p:sp>
-        <p:nvSpPr>
-          <p:cNvPr id="32" name="Rectangle 31"/>
+              <a:t>catalog · compliance</a:t>
+            </a:r>
+          </a:p>
+        </p:txBody>
+      </p:sp>
+      <p:sp>
+        <p:nvSpPr>
+          <p:cNvPr id="30" name="Rectangle 29"/>
           <p:cNvSpPr/>
           <p:nvPr/>
         </p:nvSpPr>
         <p:spPr>
           <a:xfrm>
-            <a:off x="3749039" y="2414015"/>
-            <a:ext cx="932688" cy="45720"/>
+            <a:off x="3517391" y="2249424"/>
+            <a:ext cx="835151" cy="45720"/>
           </a:xfrm>
           <a:prstGeom prst="rect">
             <a:avLst/>
@@ -4942,14 +4840,14 @@
       </p:sp>
       <p:sp>
         <p:nvSpPr>
-          <p:cNvPr id="33" name="Chevron 32"/>
+          <p:cNvPr id="31" name="Chevron 30"/>
           <p:cNvSpPr/>
           <p:nvPr/>
         </p:nvSpPr>
         <p:spPr>
           <a:xfrm>
-            <a:off x="4663440" y="2862072"/>
-            <a:ext cx="146304" cy="164592"/>
+            <a:off x="4334256" y="2697480"/>
+            <a:ext cx="128016" cy="164592"/>
           </a:xfrm>
           <a:prstGeom prst="chevron">
             <a:avLst/>
@@ -4986,14 +4884,14 @@
       </p:sp>
       <p:sp>
         <p:nvSpPr>
-          <p:cNvPr id="34" name="Rounded Rectangle 33"/>
+          <p:cNvPr id="32" name="Rounded Rectangle 31"/>
           <p:cNvSpPr/>
           <p:nvPr/>
         </p:nvSpPr>
         <p:spPr>
           <a:xfrm>
-            <a:off x="4773168" y="2414015"/>
-            <a:ext cx="932688" cy="1060704"/>
+            <a:off x="4425696" y="2249424"/>
+            <a:ext cx="835151" cy="1060704"/>
           </a:xfrm>
           <a:prstGeom prst="roundRect">
             <a:avLst>
@@ -5030,7 +4928,7 @@
           <a:p>
             <a:pPr algn="ctr">
               <a:lnSpc>
-                <a:spcPct val="118000"/>
+                <a:spcPct val="116000"/>
               </a:lnSpc>
               <a:spcBef>
                 <a:spcPts val="0"/>
@@ -5040,7 +4938,7 @@
               </a:spcAft>
             </a:pPr>
             <a:r>
-              <a:rPr sz="900" b="1" i="0">
+              <a:rPr sz="830" b="1" i="0">
                 <a:solidFill>
                   <a:srgbClr val="FFE600"/>
                 </a:solidFill>
@@ -5049,19 +4947,19 @@
               <a:t>🤖 </a:t>
             </a:r>
             <a:r>
-              <a:rPr sz="740" b="1" i="0">
+              <a:rPr sz="680" b="1" i="0">
                 <a:solidFill>
                   <a:srgbClr val="FFFFFF"/>
                 </a:solidFill>
                 <a:latin typeface="Segoe UI"/>
               </a:rPr>
-              <a:t>Credit</a:t>
+              <a:t>Pricing &amp;</a:t>
             </a:r>
           </a:p>
           <a:p>
             <a:pPr algn="ctr">
               <a:lnSpc>
-                <a:spcPct val="118000"/>
+                <a:spcPct val="116000"/>
               </a:lnSpc>
               <a:spcBef>
                 <a:spcPts val="0"/>
@@ -5071,19 +4969,19 @@
               </a:spcAft>
             </a:pPr>
             <a:r>
-              <a:rPr sz="740" b="1" i="0">
+              <a:rPr sz="680" b="1" i="0">
                 <a:solidFill>
                   <a:srgbClr val="FFFFFF"/>
                 </a:solidFill>
                 <a:latin typeface="Segoe UI"/>
               </a:rPr>
-              <a:t>Agent</a:t>
+              <a:t>Promo Agent</a:t>
             </a:r>
           </a:p>
           <a:p>
             <a:pPr algn="ctr">
               <a:lnSpc>
-                <a:spcPct val="118000"/>
+                <a:spcPct val="116000"/>
               </a:lnSpc>
               <a:spcBef>
                 <a:spcPts val="0"/>
@@ -5093,27 +4991,27 @@
               </a:spcAft>
             </a:pPr>
             <a:r>
-              <a:rPr sz="600" b="0" i="0">
+              <a:rPr sz="560" b="0" i="0">
                 <a:solidFill>
                   <a:srgbClr val="C2C2D0"/>
                 </a:solidFill>
                 <a:latin typeface="Segoe UI"/>
               </a:rPr>
-              <a:t>limit · terms · risk</a:t>
-            </a:r>
-          </a:p>
-        </p:txBody>
-      </p:sp>
-      <p:sp>
-        <p:nvSpPr>
-          <p:cNvPr id="35" name="Rectangle 34"/>
+              <a:t>contract · promo · margin</a:t>
+            </a:r>
+          </a:p>
+        </p:txBody>
+      </p:sp>
+      <p:sp>
+        <p:nvSpPr>
+          <p:cNvPr id="33" name="Rectangle 32"/>
           <p:cNvSpPr/>
           <p:nvPr/>
         </p:nvSpPr>
         <p:spPr>
           <a:xfrm>
-            <a:off x="4773168" y="2414015"/>
-            <a:ext cx="932688" cy="45720"/>
+            <a:off x="4425696" y="2249424"/>
+            <a:ext cx="835151" cy="45720"/>
           </a:xfrm>
           <a:prstGeom prst="rect">
             <a:avLst/>
@@ -5150,14 +5048,14 @@
       </p:sp>
       <p:sp>
         <p:nvSpPr>
-          <p:cNvPr id="36" name="Chevron 35"/>
+          <p:cNvPr id="34" name="Chevron 33"/>
           <p:cNvSpPr/>
           <p:nvPr/>
         </p:nvSpPr>
         <p:spPr>
           <a:xfrm>
-            <a:off x="5687568" y="2862072"/>
-            <a:ext cx="146304" cy="164592"/>
+            <a:off x="5242560" y="2697480"/>
+            <a:ext cx="128016" cy="164592"/>
           </a:xfrm>
           <a:prstGeom prst="chevron">
             <a:avLst/>
@@ -5194,14 +5092,14 @@
       </p:sp>
       <p:sp>
         <p:nvSpPr>
-          <p:cNvPr id="37" name="Rounded Rectangle 36"/>
+          <p:cNvPr id="35" name="Rounded Rectangle 34"/>
           <p:cNvSpPr/>
           <p:nvPr/>
         </p:nvSpPr>
         <p:spPr>
           <a:xfrm>
-            <a:off x="5797296" y="2414015"/>
-            <a:ext cx="932688" cy="1060704"/>
+            <a:off x="5333999" y="2249424"/>
+            <a:ext cx="835151" cy="1060704"/>
           </a:xfrm>
           <a:prstGeom prst="roundRect">
             <a:avLst>
@@ -5238,7 +5136,7 @@
           <a:p>
             <a:pPr algn="ctr">
               <a:lnSpc>
-                <a:spcPct val="118000"/>
+                <a:spcPct val="116000"/>
               </a:lnSpc>
               <a:spcBef>
                 <a:spcPts val="0"/>
@@ -5248,7 +5146,7 @@
               </a:spcAft>
             </a:pPr>
             <a:r>
-              <a:rPr sz="900" b="1" i="0">
+              <a:rPr sz="830" b="1" i="0">
                 <a:solidFill>
                   <a:srgbClr val="FFE600"/>
                 </a:solidFill>
@@ -5257,19 +5155,19 @@
               <a:t>🤖 </a:t>
             </a:r>
             <a:r>
-              <a:rPr sz="740" b="1" i="0">
+              <a:rPr sz="680" b="1" i="0">
                 <a:solidFill>
                   <a:srgbClr val="FFFFFF"/>
                 </a:solidFill>
                 <a:latin typeface="Segoe UI"/>
               </a:rPr>
-              <a:t>Inventory</a:t>
+              <a:t>Credit</a:t>
             </a:r>
           </a:p>
           <a:p>
             <a:pPr algn="ctr">
               <a:lnSpc>
-                <a:spcPct val="118000"/>
+                <a:spcPct val="116000"/>
               </a:lnSpc>
               <a:spcBef>
                 <a:spcPts val="0"/>
@@ -5279,7 +5177,7 @@
               </a:spcAft>
             </a:pPr>
             <a:r>
-              <a:rPr sz="740" b="1" i="0">
+              <a:rPr sz="680" b="1" i="0">
                 <a:solidFill>
                   <a:srgbClr val="FFFFFF"/>
                 </a:solidFill>
@@ -5291,7 +5189,7 @@
           <a:p>
             <a:pPr algn="ctr">
               <a:lnSpc>
-                <a:spcPct val="118000"/>
+                <a:spcPct val="116000"/>
               </a:lnSpc>
               <a:spcBef>
                 <a:spcPts val="0"/>
@@ -5301,27 +5199,27 @@
               </a:spcAft>
             </a:pPr>
             <a:r>
-              <a:rPr sz="600" b="0" i="0">
+              <a:rPr sz="560" b="0" i="0">
                 <a:solidFill>
                   <a:srgbClr val="C2C2D0"/>
                 </a:solidFill>
                 <a:latin typeface="Segoe UI"/>
               </a:rPr>
-              <a:t>DC stock · ATP · alloc</a:t>
-            </a:r>
-          </a:p>
-        </p:txBody>
-      </p:sp>
-      <p:sp>
-        <p:nvSpPr>
-          <p:cNvPr id="38" name="Rectangle 37"/>
+              <a:t>limit · terms · risk</a:t>
+            </a:r>
+          </a:p>
+        </p:txBody>
+      </p:sp>
+      <p:sp>
+        <p:nvSpPr>
+          <p:cNvPr id="36" name="Rectangle 35"/>
           <p:cNvSpPr/>
           <p:nvPr/>
         </p:nvSpPr>
         <p:spPr>
           <a:xfrm>
-            <a:off x="5797296" y="2414015"/>
-            <a:ext cx="932688" cy="45720"/>
+            <a:off x="5333999" y="2249424"/>
+            <a:ext cx="835151" cy="45720"/>
           </a:xfrm>
           <a:prstGeom prst="rect">
             <a:avLst/>
@@ -5358,14 +5256,14 @@
       </p:sp>
       <p:sp>
         <p:nvSpPr>
-          <p:cNvPr id="39" name="Chevron 38"/>
+          <p:cNvPr id="37" name="Chevron 36"/>
           <p:cNvSpPr/>
           <p:nvPr/>
         </p:nvSpPr>
         <p:spPr>
           <a:xfrm>
-            <a:off x="6711696" y="2862072"/>
-            <a:ext cx="146304" cy="164592"/>
+            <a:off x="6150863" y="2697480"/>
+            <a:ext cx="128016" cy="164592"/>
           </a:xfrm>
           <a:prstGeom prst="chevron">
             <a:avLst/>
@@ -5402,14 +5300,14 @@
       </p:sp>
       <p:sp>
         <p:nvSpPr>
-          <p:cNvPr id="40" name="Rounded Rectangle 39"/>
+          <p:cNvPr id="38" name="Rounded Rectangle 37"/>
           <p:cNvSpPr/>
           <p:nvPr/>
         </p:nvSpPr>
         <p:spPr>
           <a:xfrm>
-            <a:off x="6821424" y="2414015"/>
-            <a:ext cx="932688" cy="1060704"/>
+            <a:off x="6242304" y="2249424"/>
+            <a:ext cx="835151" cy="1060704"/>
           </a:xfrm>
           <a:prstGeom prst="roundRect">
             <a:avLst>
@@ -5446,7 +5344,7 @@
           <a:p>
             <a:pPr algn="ctr">
               <a:lnSpc>
-                <a:spcPct val="118000"/>
+                <a:spcPct val="116000"/>
               </a:lnSpc>
               <a:spcBef>
                 <a:spcPts val="0"/>
@@ -5456,7 +5354,7 @@
               </a:spcAft>
             </a:pPr>
             <a:r>
-              <a:rPr sz="900" b="1" i="0">
+              <a:rPr sz="830" b="1" i="0">
                 <a:solidFill>
                   <a:srgbClr val="FFE600"/>
                 </a:solidFill>
@@ -5465,19 +5363,19 @@
               <a:t>🤖 </a:t>
             </a:r>
             <a:r>
-              <a:rPr sz="740" b="1" i="0">
+              <a:rPr sz="680" b="1" i="0">
                 <a:solidFill>
                   <a:srgbClr val="FFFFFF"/>
                 </a:solidFill>
                 <a:latin typeface="Segoe UI"/>
               </a:rPr>
-              <a:t>Shipments</a:t>
+              <a:t>Inventory</a:t>
             </a:r>
           </a:p>
           <a:p>
             <a:pPr algn="ctr">
               <a:lnSpc>
-                <a:spcPct val="118000"/>
+                <a:spcPct val="116000"/>
               </a:lnSpc>
               <a:spcBef>
                 <a:spcPts val="0"/>
@@ -5487,7 +5385,7 @@
               </a:spcAft>
             </a:pPr>
             <a:r>
-              <a:rPr sz="740" b="1" i="0">
+              <a:rPr sz="680" b="1" i="0">
                 <a:solidFill>
                   <a:srgbClr val="FFFFFF"/>
                 </a:solidFill>
@@ -5499,7 +5397,7 @@
           <a:p>
             <a:pPr algn="ctr">
               <a:lnSpc>
-                <a:spcPct val="118000"/>
+                <a:spcPct val="116000"/>
               </a:lnSpc>
               <a:spcBef>
                 <a:spcPts val="0"/>
@@ -5509,27 +5407,27 @@
               </a:spcAft>
             </a:pPr>
             <a:r>
-              <a:rPr sz="600" b="0" i="0">
+              <a:rPr sz="560" b="0" i="0">
                 <a:solidFill>
                   <a:srgbClr val="C2C2D0"/>
                 </a:solidFill>
                 <a:latin typeface="Segoe UI"/>
               </a:rPr>
-              <a:t>carrier · service · SLA</a:t>
-            </a:r>
-          </a:p>
-        </p:txBody>
-      </p:sp>
-      <p:sp>
-        <p:nvSpPr>
-          <p:cNvPr id="41" name="Rectangle 40"/>
+              <a:t>DC stock · ATP · alloc</a:t>
+            </a:r>
+          </a:p>
+        </p:txBody>
+      </p:sp>
+      <p:sp>
+        <p:nvSpPr>
+          <p:cNvPr id="39" name="Rectangle 38"/>
           <p:cNvSpPr/>
           <p:nvPr/>
         </p:nvSpPr>
         <p:spPr>
           <a:xfrm>
-            <a:off x="6821424" y="2414015"/>
-            <a:ext cx="932688" cy="45720"/>
+            <a:off x="6242304" y="2249424"/>
+            <a:ext cx="835151" cy="45720"/>
           </a:xfrm>
           <a:prstGeom prst="rect">
             <a:avLst/>
@@ -5566,14 +5464,14 @@
       </p:sp>
       <p:sp>
         <p:nvSpPr>
-          <p:cNvPr id="42" name="Chevron 41"/>
+          <p:cNvPr id="40" name="Chevron 39"/>
           <p:cNvSpPr/>
           <p:nvPr/>
         </p:nvSpPr>
         <p:spPr>
           <a:xfrm>
-            <a:off x="7735824" y="2862072"/>
-            <a:ext cx="146304" cy="164592"/>
+            <a:off x="7059168" y="2697480"/>
+            <a:ext cx="128016" cy="164592"/>
           </a:xfrm>
           <a:prstGeom prst="chevron">
             <a:avLst/>
@@ -5610,14 +5508,14 @@
       </p:sp>
       <p:sp>
         <p:nvSpPr>
-          <p:cNvPr id="43" name="Rounded Rectangle 42"/>
+          <p:cNvPr id="41" name="Rounded Rectangle 40"/>
           <p:cNvSpPr/>
           <p:nvPr/>
         </p:nvSpPr>
         <p:spPr>
           <a:xfrm>
-            <a:off x="7845552" y="2414015"/>
-            <a:ext cx="932688" cy="1060704"/>
+            <a:off x="7150607" y="2249424"/>
+            <a:ext cx="835151" cy="1060704"/>
           </a:xfrm>
           <a:prstGeom prst="roundRect">
             <a:avLst>
@@ -5654,7 +5552,7 @@
           <a:p>
             <a:pPr algn="ctr">
               <a:lnSpc>
-                <a:spcPct val="118000"/>
+                <a:spcPct val="116000"/>
               </a:lnSpc>
               <a:spcBef>
                 <a:spcPts val="0"/>
@@ -5664,7 +5562,7 @@
               </a:spcAft>
             </a:pPr>
             <a:r>
-              <a:rPr sz="900" b="1" i="0">
+              <a:rPr sz="830" b="1" i="0">
                 <a:solidFill>
                   <a:srgbClr val="FFE600"/>
                 </a:solidFill>
@@ -5673,19 +5571,19 @@
               <a:t>🤖 </a:t>
             </a:r>
             <a:r>
-              <a:rPr sz="740" b="1" i="0">
+              <a:rPr sz="680" b="1" i="0">
                 <a:solidFill>
                   <a:srgbClr val="FFFFFF"/>
                 </a:solidFill>
                 <a:latin typeface="Segoe UI"/>
               </a:rPr>
-              <a:t>Optimization</a:t>
+              <a:t>Shipments</a:t>
             </a:r>
           </a:p>
           <a:p>
             <a:pPr algn="ctr">
               <a:lnSpc>
-                <a:spcPct val="118000"/>
+                <a:spcPct val="116000"/>
               </a:lnSpc>
               <a:spcBef>
                 <a:spcPts val="0"/>
@@ -5695,7 +5593,7 @@
               </a:spcAft>
             </a:pPr>
             <a:r>
-              <a:rPr sz="740" b="1" i="0">
+              <a:rPr sz="680" b="1" i="0">
                 <a:solidFill>
                   <a:srgbClr val="FFFFFF"/>
                 </a:solidFill>
@@ -5707,7 +5605,7 @@
           <a:p>
             <a:pPr algn="ctr">
               <a:lnSpc>
-                <a:spcPct val="118000"/>
+                <a:spcPct val="116000"/>
               </a:lnSpc>
               <a:spcBef>
                 <a:spcPts val="0"/>
@@ -5717,27 +5615,27 @@
               </a:spcAft>
             </a:pPr>
             <a:r>
-              <a:rPr sz="600" b="0" i="0">
+              <a:rPr sz="560" b="0" i="0">
                 <a:solidFill>
                   <a:srgbClr val="C2C2D0"/>
                 </a:solidFill>
                 <a:latin typeface="Segoe UI"/>
               </a:rPr>
-              <a:t>plan A/B/C · freight</a:t>
-            </a:r>
-          </a:p>
-        </p:txBody>
-      </p:sp>
-      <p:sp>
-        <p:nvSpPr>
-          <p:cNvPr id="44" name="Rectangle 43"/>
+              <a:t>carrier · service · SLA</a:t>
+            </a:r>
+          </a:p>
+        </p:txBody>
+      </p:sp>
+      <p:sp>
+        <p:nvSpPr>
+          <p:cNvPr id="42" name="Rectangle 41"/>
           <p:cNvSpPr/>
           <p:nvPr/>
         </p:nvSpPr>
         <p:spPr>
           <a:xfrm>
-            <a:off x="7845552" y="2414015"/>
-            <a:ext cx="932688" cy="45720"/>
+            <a:off x="7150607" y="2249424"/>
+            <a:ext cx="835151" cy="45720"/>
           </a:xfrm>
           <a:prstGeom prst="rect">
             <a:avLst/>
@@ -5774,14 +5672,14 @@
       </p:sp>
       <p:sp>
         <p:nvSpPr>
-          <p:cNvPr id="45" name="Chevron 44"/>
+          <p:cNvPr id="43" name="Chevron 42"/>
           <p:cNvSpPr/>
           <p:nvPr/>
         </p:nvSpPr>
         <p:spPr>
           <a:xfrm>
-            <a:off x="8759952" y="2862072"/>
-            <a:ext cx="146304" cy="164592"/>
+            <a:off x="7967472" y="2697480"/>
+            <a:ext cx="128016" cy="164592"/>
           </a:xfrm>
           <a:prstGeom prst="chevron">
             <a:avLst/>
@@ -5818,14 +5716,14 @@
       </p:sp>
       <p:sp>
         <p:nvSpPr>
-          <p:cNvPr id="46" name="Rounded Rectangle 45"/>
+          <p:cNvPr id="44" name="Rounded Rectangle 43"/>
           <p:cNvSpPr/>
           <p:nvPr/>
         </p:nvSpPr>
         <p:spPr>
           <a:xfrm>
-            <a:off x="8869680" y="2414015"/>
-            <a:ext cx="932688" cy="1060704"/>
+            <a:off x="8058911" y="2249424"/>
+            <a:ext cx="835151" cy="1060704"/>
           </a:xfrm>
           <a:prstGeom prst="roundRect">
             <a:avLst>
@@ -5862,7 +5760,7 @@
           <a:p>
             <a:pPr algn="ctr">
               <a:lnSpc>
-                <a:spcPct val="118000"/>
+                <a:spcPct val="116000"/>
               </a:lnSpc>
               <a:spcBef>
                 <a:spcPts val="0"/>
@@ -5872,7 +5770,7 @@
               </a:spcAft>
             </a:pPr>
             <a:r>
-              <a:rPr sz="900" b="1" i="0">
+              <a:rPr sz="830" b="1" i="0">
                 <a:solidFill>
                   <a:srgbClr val="FFE600"/>
                 </a:solidFill>
@@ -5881,19 +5779,19 @@
               <a:t>🤖 </a:t>
             </a:r>
             <a:r>
-              <a:rPr sz="740" b="1" i="0">
+              <a:rPr sz="680" b="1" i="0">
                 <a:solidFill>
                   <a:srgbClr val="FFFFFF"/>
                 </a:solidFill>
                 <a:latin typeface="Segoe UI"/>
               </a:rPr>
-              <a:t>Approvals</a:t>
+              <a:t>Optimization</a:t>
             </a:r>
           </a:p>
           <a:p>
             <a:pPr algn="ctr">
               <a:lnSpc>
-                <a:spcPct val="118000"/>
+                <a:spcPct val="116000"/>
               </a:lnSpc>
               <a:spcBef>
                 <a:spcPts val="0"/>
@@ -5903,7 +5801,7 @@
               </a:spcAft>
             </a:pPr>
             <a:r>
-              <a:rPr sz="740" b="1" i="0">
+              <a:rPr sz="680" b="1" i="0">
                 <a:solidFill>
                   <a:srgbClr val="FFFFFF"/>
                 </a:solidFill>
@@ -5915,7 +5813,7 @@
           <a:p>
             <a:pPr algn="ctr">
               <a:lnSpc>
-                <a:spcPct val="118000"/>
+                <a:spcPct val="116000"/>
               </a:lnSpc>
               <a:spcBef>
                 <a:spcPts val="0"/>
@@ -5925,27 +5823,27 @@
               </a:spcAft>
             </a:pPr>
             <a:r>
-              <a:rPr sz="600" b="0" i="0">
+              <a:rPr sz="560" b="0" i="0">
                 <a:solidFill>
                   <a:srgbClr val="C2C2D0"/>
                 </a:solidFill>
                 <a:latin typeface="Segoe UI"/>
               </a:rPr>
-              <a:t>budget · matrix (last)</a:t>
-            </a:r>
-          </a:p>
-        </p:txBody>
-      </p:sp>
-      <p:sp>
-        <p:nvSpPr>
-          <p:cNvPr id="47" name="Rectangle 46"/>
+              <a:t>plan A/B/C · freight</a:t>
+            </a:r>
+          </a:p>
+        </p:txBody>
+      </p:sp>
+      <p:sp>
+        <p:nvSpPr>
+          <p:cNvPr id="45" name="Rectangle 44"/>
           <p:cNvSpPr/>
           <p:nvPr/>
         </p:nvSpPr>
         <p:spPr>
           <a:xfrm>
-            <a:off x="8869680" y="2414015"/>
-            <a:ext cx="932688" cy="45720"/>
+            <a:off x="8058911" y="2249424"/>
+            <a:ext cx="835151" cy="45720"/>
           </a:xfrm>
           <a:prstGeom prst="rect">
             <a:avLst/>
@@ -5980,45 +5878,214 @@
           </a:p>
         </p:txBody>
       </p:sp>
-      <p:cxnSp>
-        <p:nvCxnSpPr>
-          <p:cNvPr id="48" name="Connector 47"/>
-          <p:cNvCxnSpPr/>
-          <p:nvPr/>
-        </p:nvCxnSpPr>
-        <p:spPr>
-          <a:xfrm>
-            <a:off x="2167128" y="3474720"/>
-            <a:ext cx="0" cy="694944"/>
-          </a:xfrm>
-          <a:prstGeom prst="line">
+      <p:sp>
+        <p:nvSpPr>
+          <p:cNvPr id="46" name="Chevron 45"/>
+          <p:cNvSpPr/>
+          <p:nvPr/>
+        </p:nvSpPr>
+        <p:spPr>
+          <a:xfrm>
+            <a:off x="8875776" y="2697480"/>
+            <a:ext cx="128016" cy="164592"/>
+          </a:xfrm>
+          <a:prstGeom prst="chevron">
             <a:avLst/>
           </a:prstGeom>
-          <a:ln w="15240">
-            <a:solidFill>
-              <a:srgbClr val="FFB020"/>
-            </a:solidFill>
-            <a:prstDash val="dash"/>
-            <a:headEnd type="triangle" w="med" len="med"/>
-            <a:tailEnd type="triangle" w="med" len="med"/>
+          <a:solidFill>
+            <a:srgbClr val="FFE600"/>
+          </a:solidFill>
+          <a:ln>
+            <a:noFill/>
           </a:ln>
           <a:effectLst/>
         </p:spPr>
         <p:style>
-          <a:lnRef idx="2">
+          <a:lnRef idx="1">
             <a:schemeClr val="accent1"/>
           </a:lnRef>
-          <a:fillRef idx="0">
+          <a:fillRef idx="3">
             <a:schemeClr val="accent1"/>
           </a:fillRef>
-          <a:effectRef idx="1">
+          <a:effectRef idx="2">
             <a:schemeClr val="accent1"/>
           </a:effectRef>
           <a:fontRef idx="minor">
-            <a:schemeClr val="tx1"/>
+            <a:schemeClr val="lt1"/>
           </a:fontRef>
         </p:style>
-      </p:cxnSp>
+        <p:txBody>
+          <a:bodyPr rtlCol="0" anchor="ctr"/>
+          <a:lstStyle/>
+          <a:p>
+            <a:pPr algn="ctr"/>
+          </a:p>
+        </p:txBody>
+      </p:sp>
+      <p:sp>
+        <p:nvSpPr>
+          <p:cNvPr id="47" name="Rounded Rectangle 46"/>
+          <p:cNvSpPr/>
+          <p:nvPr/>
+        </p:nvSpPr>
+        <p:spPr>
+          <a:xfrm>
+            <a:off x="8967215" y="2249424"/>
+            <a:ext cx="835151" cy="1060704"/>
+          </a:xfrm>
+          <a:prstGeom prst="roundRect">
+            <a:avLst>
+              <a:gd name="adj" fmla="val 6000"/>
+            </a:avLst>
+          </a:prstGeom>
+          <a:solidFill>
+            <a:srgbClr val="222230"/>
+          </a:solidFill>
+          <a:ln w="10160">
+            <a:solidFill>
+              <a:srgbClr val="FFE600"/>
+            </a:solidFill>
+          </a:ln>
+          <a:effectLst/>
+        </p:spPr>
+        <p:style>
+          <a:lnRef idx="1">
+            <a:schemeClr val="accent1"/>
+          </a:lnRef>
+          <a:fillRef idx="3">
+            <a:schemeClr val="accent1"/>
+          </a:fillRef>
+          <a:effectRef idx="2">
+            <a:schemeClr val="accent1"/>
+          </a:effectRef>
+          <a:fontRef idx="minor">
+            <a:schemeClr val="lt1"/>
+          </a:fontRef>
+        </p:style>
+        <p:txBody>
+          <a:bodyPr rtlCol="0" anchor="ctr" wrap="square" lIns="27432" rIns="27432" tIns="9144" bIns="9144"/>
+          <a:lstStyle/>
+          <a:p>
+            <a:pPr algn="ctr">
+              <a:lnSpc>
+                <a:spcPct val="116000"/>
+              </a:lnSpc>
+              <a:spcBef>
+                <a:spcPts val="0"/>
+              </a:spcBef>
+              <a:spcAft>
+                <a:spcPts val="0"/>
+              </a:spcAft>
+            </a:pPr>
+            <a:r>
+              <a:rPr sz="830" b="1" i="0">
+                <a:solidFill>
+                  <a:srgbClr val="FFE600"/>
+                </a:solidFill>
+                <a:latin typeface="Segoe UI"/>
+              </a:rPr>
+              <a:t>🤖 </a:t>
+            </a:r>
+            <a:r>
+              <a:rPr sz="680" b="1" i="0">
+                <a:solidFill>
+                  <a:srgbClr val="FFFFFF"/>
+                </a:solidFill>
+                <a:latin typeface="Segoe UI"/>
+              </a:rPr>
+              <a:t>Approvals</a:t>
+            </a:r>
+          </a:p>
+          <a:p>
+            <a:pPr algn="ctr">
+              <a:lnSpc>
+                <a:spcPct val="116000"/>
+              </a:lnSpc>
+              <a:spcBef>
+                <a:spcPts val="0"/>
+              </a:spcBef>
+              <a:spcAft>
+                <a:spcPts val="0"/>
+              </a:spcAft>
+            </a:pPr>
+            <a:r>
+              <a:rPr sz="680" b="1" i="0">
+                <a:solidFill>
+                  <a:srgbClr val="FFFFFF"/>
+                </a:solidFill>
+                <a:latin typeface="Segoe UI"/>
+              </a:rPr>
+              <a:t>Agent</a:t>
+            </a:r>
+          </a:p>
+          <a:p>
+            <a:pPr algn="ctr">
+              <a:lnSpc>
+                <a:spcPct val="116000"/>
+              </a:lnSpc>
+              <a:spcBef>
+                <a:spcPts val="0"/>
+              </a:spcBef>
+              <a:spcAft>
+                <a:spcPts val="0"/>
+              </a:spcAft>
+            </a:pPr>
+            <a:r>
+              <a:rPr sz="560" b="0" i="0">
+                <a:solidFill>
+                  <a:srgbClr val="C2C2D0"/>
+                </a:solidFill>
+                <a:latin typeface="Segoe UI"/>
+              </a:rPr>
+              <a:t>budget · matrix (last)</a:t>
+            </a:r>
+          </a:p>
+        </p:txBody>
+      </p:sp>
+      <p:sp>
+        <p:nvSpPr>
+          <p:cNvPr id="48" name="Rectangle 47"/>
+          <p:cNvSpPr/>
+          <p:nvPr/>
+        </p:nvSpPr>
+        <p:spPr>
+          <a:xfrm>
+            <a:off x="8967215" y="2249424"/>
+            <a:ext cx="835151" cy="45720"/>
+          </a:xfrm>
+          <a:prstGeom prst="rect">
+            <a:avLst/>
+          </a:prstGeom>
+          <a:solidFill>
+            <a:srgbClr val="FFE600"/>
+          </a:solidFill>
+          <a:ln>
+            <a:noFill/>
+          </a:ln>
+          <a:effectLst/>
+        </p:spPr>
+        <p:style>
+          <a:lnRef idx="1">
+            <a:schemeClr val="accent1"/>
+          </a:lnRef>
+          <a:fillRef idx="3">
+            <a:schemeClr val="accent1"/>
+          </a:fillRef>
+          <a:effectRef idx="2">
+            <a:schemeClr val="accent1"/>
+          </a:effectRef>
+          <a:fontRef idx="minor">
+            <a:schemeClr val="lt1"/>
+          </a:fontRef>
+        </p:style>
+        <p:txBody>
+          <a:bodyPr rtlCol="0" anchor="ctr" wrap="square"/>
+          <a:lstStyle/>
+          <a:p>
+            <a:pPr algn="ctr"/>
+          </a:p>
+        </p:txBody>
+      </p:sp>
       <p:cxnSp>
         <p:nvCxnSpPr>
           <p:cNvPr id="49" name="Connector 48"/>
@@ -6027,8 +6094,8 @@
         </p:nvCxnSpPr>
         <p:spPr>
           <a:xfrm>
-            <a:off x="3191256" y="3474720"/>
-            <a:ext cx="0" cy="694944"/>
+            <a:off x="2118360" y="3310128"/>
+            <a:ext cx="0" cy="594359"/>
           </a:xfrm>
           <a:prstGeom prst="line">
             <a:avLst/>
@@ -6066,8 +6133,8 @@
         </p:nvCxnSpPr>
         <p:spPr>
           <a:xfrm>
-            <a:off x="4215383" y="3474720"/>
-            <a:ext cx="0" cy="694944"/>
+            <a:off x="3026663" y="3310128"/>
+            <a:ext cx="0" cy="594359"/>
           </a:xfrm>
           <a:prstGeom prst="line">
             <a:avLst/>
@@ -6105,8 +6172,8 @@
         </p:nvCxnSpPr>
         <p:spPr>
           <a:xfrm>
-            <a:off x="5239512" y="3474720"/>
-            <a:ext cx="0" cy="694944"/>
+            <a:off x="3934967" y="3310128"/>
+            <a:ext cx="0" cy="594359"/>
           </a:xfrm>
           <a:prstGeom prst="line">
             <a:avLst/>
@@ -6144,8 +6211,8 @@
         </p:nvCxnSpPr>
         <p:spPr>
           <a:xfrm>
-            <a:off x="6263640" y="3474720"/>
-            <a:ext cx="0" cy="694944"/>
+            <a:off x="4843272" y="3310128"/>
+            <a:ext cx="0" cy="594359"/>
           </a:xfrm>
           <a:prstGeom prst="line">
             <a:avLst/>
@@ -6183,8 +6250,8 @@
         </p:nvCxnSpPr>
         <p:spPr>
           <a:xfrm>
-            <a:off x="7287768" y="3474720"/>
-            <a:ext cx="0" cy="694944"/>
+            <a:off x="5751575" y="3310128"/>
+            <a:ext cx="0" cy="594359"/>
           </a:xfrm>
           <a:prstGeom prst="line">
             <a:avLst/>
@@ -6222,8 +6289,8 @@
         </p:nvCxnSpPr>
         <p:spPr>
           <a:xfrm>
-            <a:off x="8311896" y="3474720"/>
-            <a:ext cx="0" cy="694944"/>
+            <a:off x="6659880" y="3310128"/>
+            <a:ext cx="0" cy="594359"/>
           </a:xfrm>
           <a:prstGeom prst="line">
             <a:avLst/>
@@ -6261,8 +6328,8 @@
         </p:nvCxnSpPr>
         <p:spPr>
           <a:xfrm>
-            <a:off x="9336024" y="3474720"/>
-            <a:ext cx="0" cy="694944"/>
+            <a:off x="7568183" y="3310128"/>
+            <a:ext cx="0" cy="594359"/>
           </a:xfrm>
           <a:prstGeom prst="line">
             <a:avLst/>
@@ -6292,15 +6359,93 @@
           </a:fontRef>
         </p:style>
       </p:cxnSp>
-      <p:sp>
-        <p:nvSpPr>
-          <p:cNvPr id="56" name="Rounded Rectangle 55"/>
+      <p:cxnSp>
+        <p:nvCxnSpPr>
+          <p:cNvPr id="56" name="Connector 55"/>
+          <p:cNvCxnSpPr/>
+          <p:nvPr/>
+        </p:nvCxnSpPr>
+        <p:spPr>
+          <a:xfrm>
+            <a:off x="8476488" y="3310128"/>
+            <a:ext cx="0" cy="594359"/>
+          </a:xfrm>
+          <a:prstGeom prst="line">
+            <a:avLst/>
+          </a:prstGeom>
+          <a:ln w="15240">
+            <a:solidFill>
+              <a:srgbClr val="FFB020"/>
+            </a:solidFill>
+            <a:prstDash val="dash"/>
+            <a:headEnd type="triangle" w="med" len="med"/>
+            <a:tailEnd type="triangle" w="med" len="med"/>
+          </a:ln>
+          <a:effectLst/>
+        </p:spPr>
+        <p:style>
+          <a:lnRef idx="2">
+            <a:schemeClr val="accent1"/>
+          </a:lnRef>
+          <a:fillRef idx="0">
+            <a:schemeClr val="accent1"/>
+          </a:fillRef>
+          <a:effectRef idx="1">
+            <a:schemeClr val="accent1"/>
+          </a:effectRef>
+          <a:fontRef idx="minor">
+            <a:schemeClr val="tx1"/>
+          </a:fontRef>
+        </p:style>
+      </p:cxnSp>
+      <p:cxnSp>
+        <p:nvCxnSpPr>
+          <p:cNvPr id="57" name="Connector 56"/>
+          <p:cNvCxnSpPr/>
+          <p:nvPr/>
+        </p:nvCxnSpPr>
+        <p:spPr>
+          <a:xfrm>
+            <a:off x="9384791" y="3310128"/>
+            <a:ext cx="0" cy="594359"/>
+          </a:xfrm>
+          <a:prstGeom prst="line">
+            <a:avLst/>
+          </a:prstGeom>
+          <a:ln w="15240">
+            <a:solidFill>
+              <a:srgbClr val="FFB020"/>
+            </a:solidFill>
+            <a:prstDash val="dash"/>
+            <a:headEnd type="triangle" w="med" len="med"/>
+            <a:tailEnd type="triangle" w="med" len="med"/>
+          </a:ln>
+          <a:effectLst/>
+        </p:spPr>
+        <p:style>
+          <a:lnRef idx="2">
+            <a:schemeClr val="accent1"/>
+          </a:lnRef>
+          <a:fillRef idx="0">
+            <a:schemeClr val="accent1"/>
+          </a:fillRef>
+          <a:effectRef idx="1">
+            <a:schemeClr val="accent1"/>
+          </a:effectRef>
+          <a:fontRef idx="minor">
+            <a:schemeClr val="tx1"/>
+          </a:fontRef>
+        </p:style>
+      </p:cxnSp>
+      <p:sp>
+        <p:nvSpPr>
+          <p:cNvPr id="58" name="Rounded Rectangle 57"/>
           <p:cNvSpPr/>
           <p:nvPr/>
         </p:nvSpPr>
         <p:spPr>
           <a:xfrm>
-            <a:off x="1700784" y="4169664"/>
+            <a:off x="1700784" y="3904487"/>
             <a:ext cx="8101583" cy="566928"/>
           </a:xfrm>
           <a:prstGeom prst="roundRect">
@@ -6370,13 +6515,13 @@
       </p:sp>
       <p:sp>
         <p:nvSpPr>
-          <p:cNvPr id="57" name="Rectangle 56"/>
+          <p:cNvPr id="59" name="Rectangle 58"/>
           <p:cNvSpPr/>
           <p:nvPr/>
         </p:nvSpPr>
         <p:spPr>
           <a:xfrm>
-            <a:off x="1700784" y="4169664"/>
+            <a:off x="1700784" y="3904487"/>
             <a:ext cx="8101583" cy="54864"/>
           </a:xfrm>
           <a:prstGeom prst="rect">
@@ -6414,13 +6559,13 @@
       </p:sp>
       <p:sp>
         <p:nvSpPr>
-          <p:cNvPr id="58" name="TextBox 57"/>
+          <p:cNvPr id="60" name="TextBox 59"/>
           <p:cNvSpPr txBox="1"/>
           <p:nvPr/>
         </p:nvSpPr>
         <p:spPr>
           <a:xfrm>
-            <a:off x="1591056" y="5138928"/>
+            <a:off x="1591056" y="4919472"/>
             <a:ext cx="8229600" cy="182880"/>
           </a:xfrm>
           <a:prstGeom prst="rect">
@@ -6468,13 +6613,13 @@
       </p:sp>
       <p:sp>
         <p:nvSpPr>
-          <p:cNvPr id="59" name="Rounded Rectangle 58"/>
+          <p:cNvPr id="61" name="Rounded Rectangle 60"/>
           <p:cNvSpPr/>
           <p:nvPr/>
         </p:nvSpPr>
         <p:spPr>
           <a:xfrm>
-            <a:off x="1618488" y="5413248"/>
+            <a:off x="1618488" y="5193792"/>
             <a:ext cx="2148840" cy="585216"/>
           </a:xfrm>
           <a:prstGeom prst="roundRect">
@@ -6557,13 +6702,13 @@
       </p:sp>
       <p:sp>
         <p:nvSpPr>
-          <p:cNvPr id="60" name="Chevron 59"/>
+          <p:cNvPr id="62" name="Chevron 61"/>
           <p:cNvSpPr/>
           <p:nvPr/>
         </p:nvSpPr>
         <p:spPr>
           <a:xfrm>
-            <a:off x="3803904" y="5614416"/>
+            <a:off x="3803904" y="5394960"/>
             <a:ext cx="274320" cy="182880"/>
           </a:xfrm>
           <a:prstGeom prst="chevron">
@@ -6601,13 +6746,13 @@
       </p:sp>
       <p:sp>
         <p:nvSpPr>
-          <p:cNvPr id="61" name="Rounded Rectangle 60"/>
+          <p:cNvPr id="63" name="Rounded Rectangle 62"/>
           <p:cNvSpPr/>
           <p:nvPr/>
         </p:nvSpPr>
         <p:spPr>
           <a:xfrm>
-            <a:off x="4224528" y="5413248"/>
+            <a:off x="4224528" y="5193792"/>
             <a:ext cx="867155" cy="585216"/>
           </a:xfrm>
           <a:prstGeom prst="roundRect">
@@ -6690,13 +6835,13 @@
       </p:sp>
       <p:sp>
         <p:nvSpPr>
-          <p:cNvPr id="62" name="Rounded Rectangle 61"/>
+          <p:cNvPr id="64" name="Rounded Rectangle 63"/>
           <p:cNvSpPr/>
           <p:nvPr/>
         </p:nvSpPr>
         <p:spPr>
           <a:xfrm>
-            <a:off x="5183124" y="5413248"/>
+            <a:off x="5183124" y="5193792"/>
             <a:ext cx="867155" cy="585216"/>
           </a:xfrm>
           <a:prstGeom prst="roundRect">
@@ -6779,13 +6924,13 @@
       </p:sp>
       <p:sp>
         <p:nvSpPr>
-          <p:cNvPr id="63" name="Rounded Rectangle 62"/>
+          <p:cNvPr id="65" name="Rounded Rectangle 64"/>
           <p:cNvSpPr/>
           <p:nvPr/>
         </p:nvSpPr>
         <p:spPr>
           <a:xfrm>
-            <a:off x="6141720" y="5413248"/>
+            <a:off x="6141720" y="5193792"/>
             <a:ext cx="867155" cy="585216"/>
           </a:xfrm>
           <a:prstGeom prst="roundRect">
@@ -6868,13 +7013,13 @@
       </p:sp>
       <p:sp>
         <p:nvSpPr>
-          <p:cNvPr id="64" name="Rounded Rectangle 63"/>
+          <p:cNvPr id="66" name="Rounded Rectangle 65"/>
           <p:cNvSpPr/>
           <p:nvPr/>
         </p:nvSpPr>
         <p:spPr>
           <a:xfrm>
-            <a:off x="7100316" y="5413248"/>
+            <a:off x="7100316" y="5193792"/>
             <a:ext cx="867155" cy="585216"/>
           </a:xfrm>
           <a:prstGeom prst="roundRect">
@@ -6957,13 +7102,13 @@
       </p:sp>
       <p:sp>
         <p:nvSpPr>
-          <p:cNvPr id="65" name="Rounded Rectangle 64"/>
+          <p:cNvPr id="67" name="Rounded Rectangle 66"/>
           <p:cNvSpPr/>
           <p:nvPr/>
         </p:nvSpPr>
         <p:spPr>
           <a:xfrm>
-            <a:off x="8058911" y="5413248"/>
+            <a:off x="8058911" y="5193792"/>
             <a:ext cx="867155" cy="585216"/>
           </a:xfrm>
           <a:prstGeom prst="roundRect">
@@ -7046,13 +7191,13 @@
       </p:sp>
       <p:sp>
         <p:nvSpPr>
-          <p:cNvPr id="66" name="Rounded Rectangle 65"/>
+          <p:cNvPr id="68" name="Rounded Rectangle 67"/>
           <p:cNvSpPr/>
           <p:nvPr/>
         </p:nvSpPr>
         <p:spPr>
           <a:xfrm>
-            <a:off x="9017507" y="5413248"/>
+            <a:off x="9017507" y="5193792"/>
             <a:ext cx="867155" cy="585216"/>
           </a:xfrm>
           <a:prstGeom prst="roundRect">
@@ -7135,14 +7280,14 @@
       </p:sp>
       <p:sp>
         <p:nvSpPr>
-          <p:cNvPr id="67" name="Rounded Rectangle 66"/>
+          <p:cNvPr id="69" name="Rounded Rectangle 68"/>
           <p:cNvSpPr/>
           <p:nvPr/>
         </p:nvSpPr>
         <p:spPr>
           <a:xfrm>
             <a:off x="10076688" y="749808"/>
-            <a:ext cx="1847088" cy="5376672"/>
+            <a:ext cx="1847088" cy="5157216"/>
           </a:xfrm>
           <a:prstGeom prst="roundRect">
             <a:avLst>
@@ -7183,7 +7328,7 @@
       </p:sp>
       <p:sp>
         <p:nvSpPr>
-          <p:cNvPr id="68" name="Rectangle 67"/>
+          <p:cNvPr id="70" name="Rectangle 69"/>
           <p:cNvSpPr/>
           <p:nvPr/>
         </p:nvSpPr>
@@ -7227,7 +7372,7 @@
       </p:sp>
       <p:sp>
         <p:nvSpPr>
-          <p:cNvPr id="69" name="TextBox 68"/>
+          <p:cNvPr id="71" name="TextBox 70"/>
           <p:cNvSpPr txBox="1"/>
           <p:nvPr/>
         </p:nvSpPr>
@@ -7272,7 +7417,7 @@
       </p:sp>
       <p:sp>
         <p:nvSpPr>
-          <p:cNvPr id="70" name="TextBox 69"/>
+          <p:cNvPr id="72" name="TextBox 71"/>
           <p:cNvSpPr txBox="1"/>
           <p:nvPr/>
         </p:nvSpPr>
@@ -7317,14 +7462,14 @@
       </p:sp>
       <p:sp>
         <p:nvSpPr>
-          <p:cNvPr id="71" name="Rounded Rectangle 70"/>
+          <p:cNvPr id="73" name="Rounded Rectangle 72"/>
           <p:cNvSpPr/>
           <p:nvPr/>
         </p:nvSpPr>
         <p:spPr>
           <a:xfrm>
             <a:off x="10186415" y="1408176"/>
-            <a:ext cx="1627632" cy="736092"/>
+            <a:ext cx="1627632" cy="699516"/>
           </a:xfrm>
           <a:prstGeom prst="roundRect">
             <a:avLst>
@@ -7384,14 +7529,14 @@
       </p:sp>
       <p:sp>
         <p:nvSpPr>
-          <p:cNvPr id="72" name="Rectangle 71"/>
+          <p:cNvPr id="74" name="Rectangle 73"/>
           <p:cNvSpPr/>
           <p:nvPr/>
         </p:nvSpPr>
         <p:spPr>
           <a:xfrm>
             <a:off x="10186415" y="1408176"/>
-            <a:ext cx="45720" cy="736092"/>
+            <a:ext cx="45720" cy="699516"/>
           </a:xfrm>
           <a:prstGeom prst="rect">
             <a:avLst/>
@@ -7428,14 +7573,14 @@
       </p:sp>
       <p:sp>
         <p:nvSpPr>
-          <p:cNvPr id="73" name="Rounded Rectangle 72"/>
+          <p:cNvPr id="75" name="Rounded Rectangle 74"/>
           <p:cNvSpPr/>
           <p:nvPr/>
         </p:nvSpPr>
         <p:spPr>
           <a:xfrm>
-            <a:off x="10186415" y="2189988"/>
-            <a:ext cx="1627632" cy="736092"/>
+            <a:off x="10186415" y="2153412"/>
+            <a:ext cx="1627632" cy="699516"/>
           </a:xfrm>
           <a:prstGeom prst="roundRect">
             <a:avLst>
@@ -7495,14 +7640,14 @@
       </p:sp>
       <p:sp>
         <p:nvSpPr>
-          <p:cNvPr id="74" name="Rectangle 73"/>
+          <p:cNvPr id="76" name="Rectangle 75"/>
           <p:cNvSpPr/>
           <p:nvPr/>
         </p:nvSpPr>
         <p:spPr>
           <a:xfrm>
-            <a:off x="10186415" y="2189988"/>
-            <a:ext cx="45720" cy="736092"/>
+            <a:off x="10186415" y="2153412"/>
+            <a:ext cx="45720" cy="699516"/>
           </a:xfrm>
           <a:prstGeom prst="rect">
             <a:avLst/>
@@ -7539,14 +7684,14 @@
       </p:sp>
       <p:sp>
         <p:nvSpPr>
-          <p:cNvPr id="75" name="Rounded Rectangle 74"/>
+          <p:cNvPr id="77" name="Rounded Rectangle 76"/>
           <p:cNvSpPr/>
           <p:nvPr/>
         </p:nvSpPr>
         <p:spPr>
           <a:xfrm>
-            <a:off x="10186415" y="2971800"/>
-            <a:ext cx="1627632" cy="736092"/>
+            <a:off x="10186415" y="2898648"/>
+            <a:ext cx="1627632" cy="699516"/>
           </a:xfrm>
           <a:prstGeom prst="roundRect">
             <a:avLst>
@@ -7606,14 +7751,14 @@
       </p:sp>
       <p:sp>
         <p:nvSpPr>
-          <p:cNvPr id="76" name="Rectangle 75"/>
+          <p:cNvPr id="78" name="Rectangle 77"/>
           <p:cNvSpPr/>
           <p:nvPr/>
         </p:nvSpPr>
         <p:spPr>
           <a:xfrm>
-            <a:off x="10186415" y="2971800"/>
-            <a:ext cx="45720" cy="736092"/>
+            <a:off x="10186415" y="2898648"/>
+            <a:ext cx="45720" cy="699516"/>
           </a:xfrm>
           <a:prstGeom prst="rect">
             <a:avLst/>
@@ -7650,14 +7795,14 @@
       </p:sp>
       <p:sp>
         <p:nvSpPr>
-          <p:cNvPr id="77" name="Rounded Rectangle 76"/>
+          <p:cNvPr id="79" name="Rounded Rectangle 78"/>
           <p:cNvSpPr/>
           <p:nvPr/>
         </p:nvSpPr>
         <p:spPr>
           <a:xfrm>
-            <a:off x="10186415" y="3753612"/>
-            <a:ext cx="1627632" cy="736092"/>
+            <a:off x="10186415" y="3643884"/>
+            <a:ext cx="1627632" cy="699516"/>
           </a:xfrm>
           <a:prstGeom prst="roundRect">
             <a:avLst>
@@ -7717,14 +7862,14 @@
       </p:sp>
       <p:sp>
         <p:nvSpPr>
-          <p:cNvPr id="78" name="Rectangle 77"/>
+          <p:cNvPr id="80" name="Rectangle 79"/>
           <p:cNvSpPr/>
           <p:nvPr/>
         </p:nvSpPr>
         <p:spPr>
           <a:xfrm>
-            <a:off x="10186415" y="3753612"/>
-            <a:ext cx="45720" cy="736092"/>
+            <a:off x="10186415" y="3643884"/>
+            <a:ext cx="45720" cy="699516"/>
           </a:xfrm>
           <a:prstGeom prst="rect">
             <a:avLst/>
@@ -7761,14 +7906,14 @@
       </p:sp>
       <p:sp>
         <p:nvSpPr>
-          <p:cNvPr id="79" name="Rounded Rectangle 78"/>
+          <p:cNvPr id="81" name="Rounded Rectangle 80"/>
           <p:cNvSpPr/>
           <p:nvPr/>
         </p:nvSpPr>
         <p:spPr>
           <a:xfrm>
-            <a:off x="10186415" y="4535424"/>
-            <a:ext cx="1627632" cy="736092"/>
+            <a:off x="10186415" y="4389120"/>
+            <a:ext cx="1627632" cy="699516"/>
           </a:xfrm>
           <a:prstGeom prst="roundRect">
             <a:avLst>
@@ -7828,14 +7973,14 @@
       </p:sp>
       <p:sp>
         <p:nvSpPr>
-          <p:cNvPr id="80" name="Rectangle 79"/>
+          <p:cNvPr id="82" name="Rectangle 81"/>
           <p:cNvSpPr/>
           <p:nvPr/>
         </p:nvSpPr>
         <p:spPr>
           <a:xfrm>
-            <a:off x="10186415" y="4535424"/>
-            <a:ext cx="45720" cy="736092"/>
+            <a:off x="10186415" y="4389120"/>
+            <a:ext cx="45720" cy="699516"/>
           </a:xfrm>
           <a:prstGeom prst="rect">
             <a:avLst/>
@@ -7872,14 +8017,14 @@
       </p:sp>
       <p:sp>
         <p:nvSpPr>
-          <p:cNvPr id="81" name="Rounded Rectangle 80"/>
+          <p:cNvPr id="83" name="Rounded Rectangle 82"/>
           <p:cNvSpPr/>
           <p:nvPr/>
         </p:nvSpPr>
         <p:spPr>
           <a:xfrm>
-            <a:off x="10186415" y="5317236"/>
-            <a:ext cx="1627632" cy="736092"/>
+            <a:off x="10186415" y="5134356"/>
+            <a:ext cx="1627632" cy="699516"/>
           </a:xfrm>
           <a:prstGeom prst="roundRect">
             <a:avLst>
@@ -7939,14 +8084,14 @@
       </p:sp>
       <p:sp>
         <p:nvSpPr>
-          <p:cNvPr id="82" name="Rectangle 81"/>
+          <p:cNvPr id="84" name="Rectangle 83"/>
           <p:cNvSpPr/>
           <p:nvPr/>
         </p:nvSpPr>
         <p:spPr>
           <a:xfrm>
-            <a:off x="10186415" y="5317236"/>
-            <a:ext cx="45720" cy="736092"/>
+            <a:off x="10186415" y="5134356"/>
+            <a:ext cx="45720" cy="699516"/>
           </a:xfrm>
           <a:prstGeom prst="rect">
             <a:avLst/>
@@ -7983,13 +8128,13 @@
       </p:sp>
       <p:sp>
         <p:nvSpPr>
-          <p:cNvPr id="83" name="Down Arrow 82"/>
+          <p:cNvPr id="85" name="Down Arrow 84"/>
           <p:cNvSpPr/>
           <p:nvPr/>
         </p:nvSpPr>
         <p:spPr>
           <a:xfrm>
-            <a:off x="5605271" y="1627631"/>
+            <a:off x="5605271" y="1463040"/>
             <a:ext cx="292608" cy="109728"/>
           </a:xfrm>
           <a:prstGeom prst="downArrow">
@@ -8027,13 +8172,13 @@
       </p:sp>
       <p:sp>
         <p:nvSpPr>
-          <p:cNvPr id="84" name="Down Arrow 83"/>
+          <p:cNvPr id="86" name="Down Arrow 85"/>
           <p:cNvSpPr/>
           <p:nvPr/>
         </p:nvSpPr>
         <p:spPr>
           <a:xfrm>
-            <a:off x="5605271" y="5010912"/>
+            <a:off x="5605271" y="4754880"/>
             <a:ext cx="292608" cy="109728"/>
           </a:xfrm>
           <a:prstGeom prst="downArrow">
@@ -8071,13 +8216,13 @@
       </p:sp>
       <p:cxnSp>
         <p:nvCxnSpPr>
-          <p:cNvPr id="85" name="Connector 84"/>
+          <p:cNvPr id="87" name="Connector 86"/>
           <p:cNvCxnSpPr/>
           <p:nvPr/>
         </p:nvCxnSpPr>
         <p:spPr>
           <a:xfrm flipH="1">
-            <a:off x="9930384" y="3374136"/>
+            <a:off x="9930384" y="3172968"/>
             <a:ext cx="146304" cy="0"/>
           </a:xfrm>
           <a:prstGeom prst="line">
@@ -8109,13 +8254,13 @@
       </p:cxnSp>
       <p:cxnSp>
         <p:nvCxnSpPr>
-          <p:cNvPr id="86" name="Connector 85"/>
+          <p:cNvPr id="88" name="Connector 87"/>
           <p:cNvCxnSpPr/>
           <p:nvPr/>
         </p:nvCxnSpPr>
         <p:spPr>
           <a:xfrm flipH="1">
-            <a:off x="9930384" y="5614416"/>
+            <a:off x="9930384" y="5394960"/>
             <a:ext cx="146304" cy="0"/>
           </a:xfrm>
           <a:prstGeom prst="line">
@@ -8147,13 +8292,13 @@
       </p:cxnSp>
       <p:sp>
         <p:nvSpPr>
-          <p:cNvPr id="87" name="TextBox 86"/>
+          <p:cNvPr id="89" name="TextBox 88"/>
           <p:cNvSpPr txBox="1"/>
           <p:nvPr/>
         </p:nvSpPr>
         <p:spPr>
           <a:xfrm>
-            <a:off x="320040" y="6309360"/>
+            <a:off x="320040" y="6089904"/>
             <a:ext cx="11521440" cy="219456"/>
           </a:xfrm>
           <a:prstGeom prst="rect">

</xml_diff>

<commit_message>
docs: remove legacy data system panel and use full-width layout in architecture slide
</commit_message>
<xml_diff>
--- a/demo/Order-Creation-Orchestration-Architecture.pptx
+++ b/demo/Order-Creation-Orchestration-Architecture.pptx
@@ -3699,7 +3699,7 @@
         <p:spPr>
           <a:xfrm>
             <a:off x="1591056" y="768096"/>
-            <a:ext cx="8266175" cy="182880"/>
+            <a:ext cx="10222992" cy="182880"/>
           </a:xfrm>
           <a:prstGeom prst="rect">
             <a:avLst/>
@@ -3944,7 +3944,7 @@
         <p:spPr>
           <a:xfrm>
             <a:off x="4636008" y="987552"/>
-            <a:ext cx="5248655" cy="438912"/>
+            <a:ext cx="7205471" cy="438912"/>
           </a:xfrm>
           <a:prstGeom prst="roundRect">
             <a:avLst>
@@ -3992,7 +3992,7 @@
         <p:spPr>
           <a:xfrm>
             <a:off x="4636008" y="987552"/>
-            <a:ext cx="5248655" cy="45720"/>
+            <a:ext cx="7205471" cy="45720"/>
           </a:xfrm>
           <a:prstGeom prst="rect">
             <a:avLst/>
@@ -4036,7 +4036,7 @@
         <p:spPr>
           <a:xfrm>
             <a:off x="4745736" y="1078992"/>
-            <a:ext cx="5065775" cy="329184"/>
+            <a:ext cx="7022592" cy="329184"/>
           </a:xfrm>
           <a:prstGeom prst="rect">
             <a:avLst/>
@@ -4099,7 +4099,7 @@
         <p:spPr>
           <a:xfrm>
             <a:off x="1572768" y="1572768"/>
-            <a:ext cx="8357615" cy="3200400"/>
+            <a:ext cx="10314432" cy="3200400"/>
           </a:xfrm>
           <a:prstGeom prst="roundRect">
             <a:avLst>
@@ -4147,7 +4147,7 @@
         <p:spPr>
           <a:xfrm>
             <a:off x="1700784" y="1682495"/>
-            <a:ext cx="8101583" cy="365760"/>
+            <a:ext cx="10058400" cy="365760"/>
           </a:xfrm>
           <a:prstGeom prst="roundRect">
             <a:avLst>
@@ -4222,7 +4222,7 @@
         </p:nvSpPr>
         <p:spPr>
           <a:xfrm>
-            <a:off x="5623559" y="2084832"/>
+            <a:off x="6601968" y="2084832"/>
             <a:ext cx="256032" cy="109728"/>
           </a:xfrm>
           <a:prstGeom prst="downArrow">
@@ -4267,7 +4267,7 @@
         <p:spPr>
           <a:xfrm>
             <a:off x="1700784" y="2249424"/>
-            <a:ext cx="835151" cy="1060704"/>
+            <a:ext cx="1052575" cy="1060704"/>
           </a:xfrm>
           <a:prstGeom prst="roundRect">
             <a:avLst>
@@ -4387,7 +4387,7 @@
         <p:spPr>
           <a:xfrm>
             <a:off x="1700784" y="2249424"/>
-            <a:ext cx="835151" cy="45720"/>
+            <a:ext cx="1052575" cy="45720"/>
           </a:xfrm>
           <a:prstGeom prst="rect">
             <a:avLst/>
@@ -4430,7 +4430,7 @@
         </p:nvSpPr>
         <p:spPr>
           <a:xfrm>
-            <a:off x="2517647" y="2697480"/>
+            <a:off x="2735072" y="2697480"/>
             <a:ext cx="128016" cy="164592"/>
           </a:xfrm>
           <a:prstGeom prst="chevron">
@@ -4474,8 +4474,8 @@
         </p:nvSpPr>
         <p:spPr>
           <a:xfrm>
-            <a:off x="2609087" y="2249424"/>
-            <a:ext cx="835151" cy="1060704"/>
+            <a:off x="2826512" y="2249424"/>
+            <a:ext cx="1052575" cy="1060704"/>
           </a:xfrm>
           <a:prstGeom prst="roundRect">
             <a:avLst>
@@ -4594,8 +4594,8 @@
         </p:nvSpPr>
         <p:spPr>
           <a:xfrm>
-            <a:off x="2609087" y="2249424"/>
-            <a:ext cx="835151" cy="45720"/>
+            <a:off x="2826512" y="2249424"/>
+            <a:ext cx="1052575" cy="45720"/>
           </a:xfrm>
           <a:prstGeom prst="rect">
             <a:avLst/>
@@ -4638,7 +4638,7 @@
         </p:nvSpPr>
         <p:spPr>
           <a:xfrm>
-            <a:off x="3425951" y="2697480"/>
+            <a:off x="3860800" y="2697480"/>
             <a:ext cx="128016" cy="164592"/>
           </a:xfrm>
           <a:prstGeom prst="chevron">
@@ -4682,8 +4682,8 @@
         </p:nvSpPr>
         <p:spPr>
           <a:xfrm>
-            <a:off x="3517391" y="2249424"/>
-            <a:ext cx="835151" cy="1060704"/>
+            <a:off x="3952239" y="2249424"/>
+            <a:ext cx="1052575" cy="1060704"/>
           </a:xfrm>
           <a:prstGeom prst="roundRect">
             <a:avLst>
@@ -4802,8 +4802,8 @@
         </p:nvSpPr>
         <p:spPr>
           <a:xfrm>
-            <a:off x="3517391" y="2249424"/>
-            <a:ext cx="835151" cy="45720"/>
+            <a:off x="3952239" y="2249424"/>
+            <a:ext cx="1052575" cy="45720"/>
           </a:xfrm>
           <a:prstGeom prst="rect">
             <a:avLst/>
@@ -4846,7 +4846,7 @@
         </p:nvSpPr>
         <p:spPr>
           <a:xfrm>
-            <a:off x="4334256" y="2697480"/>
+            <a:off x="4986528" y="2697480"/>
             <a:ext cx="128016" cy="164592"/>
           </a:xfrm>
           <a:prstGeom prst="chevron">
@@ -4890,8 +4890,8 @@
         </p:nvSpPr>
         <p:spPr>
           <a:xfrm>
-            <a:off x="4425696" y="2249424"/>
-            <a:ext cx="835151" cy="1060704"/>
+            <a:off x="5077967" y="2249424"/>
+            <a:ext cx="1052575" cy="1060704"/>
           </a:xfrm>
           <a:prstGeom prst="roundRect">
             <a:avLst>
@@ -5010,8 +5010,8 @@
         </p:nvSpPr>
         <p:spPr>
           <a:xfrm>
-            <a:off x="4425696" y="2249424"/>
-            <a:ext cx="835151" cy="45720"/>
+            <a:off x="5077967" y="2249424"/>
+            <a:ext cx="1052575" cy="45720"/>
           </a:xfrm>
           <a:prstGeom prst="rect">
             <a:avLst/>
@@ -5054,7 +5054,7 @@
         </p:nvSpPr>
         <p:spPr>
           <a:xfrm>
-            <a:off x="5242560" y="2697480"/>
+            <a:off x="6112256" y="2697480"/>
             <a:ext cx="128016" cy="164592"/>
           </a:xfrm>
           <a:prstGeom prst="chevron">
@@ -5098,8 +5098,8 @@
         </p:nvSpPr>
         <p:spPr>
           <a:xfrm>
-            <a:off x="5333999" y="2249424"/>
-            <a:ext cx="835151" cy="1060704"/>
+            <a:off x="6203696" y="2249424"/>
+            <a:ext cx="1052575" cy="1060704"/>
           </a:xfrm>
           <a:prstGeom prst="roundRect">
             <a:avLst>
@@ -5218,8 +5218,8 @@
         </p:nvSpPr>
         <p:spPr>
           <a:xfrm>
-            <a:off x="5333999" y="2249424"/>
-            <a:ext cx="835151" cy="45720"/>
+            <a:off x="6203696" y="2249424"/>
+            <a:ext cx="1052575" cy="45720"/>
           </a:xfrm>
           <a:prstGeom prst="rect">
             <a:avLst/>
@@ -5262,7 +5262,7 @@
         </p:nvSpPr>
         <p:spPr>
           <a:xfrm>
-            <a:off x="6150863" y="2697480"/>
+            <a:off x="7237984" y="2697480"/>
             <a:ext cx="128016" cy="164592"/>
           </a:xfrm>
           <a:prstGeom prst="chevron">
@@ -5306,8 +5306,8 @@
         </p:nvSpPr>
         <p:spPr>
           <a:xfrm>
-            <a:off x="6242304" y="2249424"/>
-            <a:ext cx="835151" cy="1060704"/>
+            <a:off x="7329423" y="2249424"/>
+            <a:ext cx="1052575" cy="1060704"/>
           </a:xfrm>
           <a:prstGeom prst="roundRect">
             <a:avLst>
@@ -5426,8 +5426,8 @@
         </p:nvSpPr>
         <p:spPr>
           <a:xfrm>
-            <a:off x="6242304" y="2249424"/>
-            <a:ext cx="835151" cy="45720"/>
+            <a:off x="7329423" y="2249424"/>
+            <a:ext cx="1052575" cy="45720"/>
           </a:xfrm>
           <a:prstGeom prst="rect">
             <a:avLst/>
@@ -5470,7 +5470,7 @@
         </p:nvSpPr>
         <p:spPr>
           <a:xfrm>
-            <a:off x="7059168" y="2697480"/>
+            <a:off x="8363712" y="2697480"/>
             <a:ext cx="128016" cy="164592"/>
           </a:xfrm>
           <a:prstGeom prst="chevron">
@@ -5514,8 +5514,8 @@
         </p:nvSpPr>
         <p:spPr>
           <a:xfrm>
-            <a:off x="7150607" y="2249424"/>
-            <a:ext cx="835151" cy="1060704"/>
+            <a:off x="8455152" y="2249424"/>
+            <a:ext cx="1052575" cy="1060704"/>
           </a:xfrm>
           <a:prstGeom prst="roundRect">
             <a:avLst>
@@ -5634,8 +5634,8 @@
         </p:nvSpPr>
         <p:spPr>
           <a:xfrm>
-            <a:off x="7150607" y="2249424"/>
-            <a:ext cx="835151" cy="45720"/>
+            <a:off x="8455152" y="2249424"/>
+            <a:ext cx="1052575" cy="45720"/>
           </a:xfrm>
           <a:prstGeom prst="rect">
             <a:avLst/>
@@ -5678,7 +5678,7 @@
         </p:nvSpPr>
         <p:spPr>
           <a:xfrm>
-            <a:off x="7967472" y="2697480"/>
+            <a:off x="9489440" y="2697480"/>
             <a:ext cx="128016" cy="164592"/>
           </a:xfrm>
           <a:prstGeom prst="chevron">
@@ -5722,8 +5722,8 @@
         </p:nvSpPr>
         <p:spPr>
           <a:xfrm>
-            <a:off x="8058911" y="2249424"/>
-            <a:ext cx="835151" cy="1060704"/>
+            <a:off x="9580879" y="2249424"/>
+            <a:ext cx="1052575" cy="1060704"/>
           </a:xfrm>
           <a:prstGeom prst="roundRect">
             <a:avLst>
@@ -5842,8 +5842,8 @@
         </p:nvSpPr>
         <p:spPr>
           <a:xfrm>
-            <a:off x="8058911" y="2249424"/>
-            <a:ext cx="835151" cy="45720"/>
+            <a:off x="9580879" y="2249424"/>
+            <a:ext cx="1052575" cy="45720"/>
           </a:xfrm>
           <a:prstGeom prst="rect">
             <a:avLst/>
@@ -5886,7 +5886,7 @@
         </p:nvSpPr>
         <p:spPr>
           <a:xfrm>
-            <a:off x="8875776" y="2697480"/>
+            <a:off x="10615168" y="2697480"/>
             <a:ext cx="128016" cy="164592"/>
           </a:xfrm>
           <a:prstGeom prst="chevron">
@@ -5930,8 +5930,8 @@
         </p:nvSpPr>
         <p:spPr>
           <a:xfrm>
-            <a:off x="8967215" y="2249424"/>
-            <a:ext cx="835151" cy="1060704"/>
+            <a:off x="10706607" y="2249424"/>
+            <a:ext cx="1052575" cy="1060704"/>
           </a:xfrm>
           <a:prstGeom prst="roundRect">
             <a:avLst>
@@ -6050,8 +6050,8 @@
         </p:nvSpPr>
         <p:spPr>
           <a:xfrm>
-            <a:off x="8967215" y="2249424"/>
-            <a:ext cx="835151" cy="45720"/>
+            <a:off x="10706607" y="2249424"/>
+            <a:ext cx="1052575" cy="45720"/>
           </a:xfrm>
           <a:prstGeom prst="rect">
             <a:avLst/>
@@ -6094,7 +6094,7 @@
         </p:nvCxnSpPr>
         <p:spPr>
           <a:xfrm>
-            <a:off x="2118360" y="3310128"/>
+            <a:off x="2227071" y="3310128"/>
             <a:ext cx="0" cy="594359"/>
           </a:xfrm>
           <a:prstGeom prst="line">
@@ -6133,7 +6133,7 @@
         </p:nvCxnSpPr>
         <p:spPr>
           <a:xfrm>
-            <a:off x="3026663" y="3310128"/>
+            <a:off x="3352800" y="3310128"/>
             <a:ext cx="0" cy="594359"/>
           </a:xfrm>
           <a:prstGeom prst="line">
@@ -6172,7 +6172,7 @@
         </p:nvCxnSpPr>
         <p:spPr>
           <a:xfrm>
-            <a:off x="3934967" y="3310128"/>
+            <a:off x="4478528" y="3310128"/>
             <a:ext cx="0" cy="594359"/>
           </a:xfrm>
           <a:prstGeom prst="line">
@@ -6211,7 +6211,7 @@
         </p:nvCxnSpPr>
         <p:spPr>
           <a:xfrm>
-            <a:off x="4843272" y="3310128"/>
+            <a:off x="5604256" y="3310128"/>
             <a:ext cx="0" cy="594359"/>
           </a:xfrm>
           <a:prstGeom prst="line">
@@ -6250,7 +6250,7 @@
         </p:nvCxnSpPr>
         <p:spPr>
           <a:xfrm>
-            <a:off x="5751575" y="3310128"/>
+            <a:off x="6729984" y="3310128"/>
             <a:ext cx="0" cy="594359"/>
           </a:xfrm>
           <a:prstGeom prst="line">
@@ -6289,7 +6289,7 @@
         </p:nvCxnSpPr>
         <p:spPr>
           <a:xfrm>
-            <a:off x="6659880" y="3310128"/>
+            <a:off x="7855711" y="3310128"/>
             <a:ext cx="0" cy="594359"/>
           </a:xfrm>
           <a:prstGeom prst="line">
@@ -6328,7 +6328,7 @@
         </p:nvCxnSpPr>
         <p:spPr>
           <a:xfrm>
-            <a:off x="7568183" y="3310128"/>
+            <a:off x="8981439" y="3310128"/>
             <a:ext cx="0" cy="594359"/>
           </a:xfrm>
           <a:prstGeom prst="line">
@@ -6367,7 +6367,7 @@
         </p:nvCxnSpPr>
         <p:spPr>
           <a:xfrm>
-            <a:off x="8476488" y="3310128"/>
+            <a:off x="10107167" y="3310128"/>
             <a:ext cx="0" cy="594359"/>
           </a:xfrm>
           <a:prstGeom prst="line">
@@ -6406,7 +6406,7 @@
         </p:nvCxnSpPr>
         <p:spPr>
           <a:xfrm>
-            <a:off x="9384791" y="3310128"/>
+            <a:off x="11232895" y="3310128"/>
             <a:ext cx="0" cy="594359"/>
           </a:xfrm>
           <a:prstGeom prst="line">
@@ -6446,7 +6446,7 @@
         <p:spPr>
           <a:xfrm>
             <a:off x="1700784" y="3904487"/>
-            <a:ext cx="8101583" cy="566928"/>
+            <a:ext cx="10058400" cy="566928"/>
           </a:xfrm>
           <a:prstGeom prst="roundRect">
             <a:avLst>
@@ -6522,7 +6522,7 @@
         <p:spPr>
           <a:xfrm>
             <a:off x="1700784" y="3904487"/>
-            <a:ext cx="8101583" cy="54864"/>
+            <a:ext cx="10058400" cy="54864"/>
           </a:xfrm>
           <a:prstGeom prst="rect">
             <a:avLst/>
@@ -6753,7 +6753,7 @@
         <p:spPr>
           <a:xfrm>
             <a:off x="4224528" y="5193792"/>
-            <a:ext cx="867155" cy="585216"/>
+            <a:ext cx="1193291" cy="585216"/>
           </a:xfrm>
           <a:prstGeom prst="roundRect">
             <a:avLst>
@@ -6841,8 +6841,8 @@
         </p:nvSpPr>
         <p:spPr>
           <a:xfrm>
-            <a:off x="5183124" y="5193792"/>
-            <a:ext cx="867155" cy="585216"/>
+            <a:off x="5509260" y="5193792"/>
+            <a:ext cx="1193291" cy="585216"/>
           </a:xfrm>
           <a:prstGeom prst="roundRect">
             <a:avLst>
@@ -6930,8 +6930,8 @@
         </p:nvSpPr>
         <p:spPr>
           <a:xfrm>
-            <a:off x="6141720" y="5193792"/>
-            <a:ext cx="867155" cy="585216"/>
+            <a:off x="6793992" y="5193792"/>
+            <a:ext cx="1193291" cy="585216"/>
           </a:xfrm>
           <a:prstGeom prst="roundRect">
             <a:avLst>
@@ -7019,8 +7019,8 @@
         </p:nvSpPr>
         <p:spPr>
           <a:xfrm>
-            <a:off x="7100316" y="5193792"/>
-            <a:ext cx="867155" cy="585216"/>
+            <a:off x="8078724" y="5193792"/>
+            <a:ext cx="1193291" cy="585216"/>
           </a:xfrm>
           <a:prstGeom prst="roundRect">
             <a:avLst>
@@ -7108,8 +7108,8 @@
         </p:nvSpPr>
         <p:spPr>
           <a:xfrm>
-            <a:off x="8058911" y="5193792"/>
-            <a:ext cx="867155" cy="585216"/>
+            <a:off x="9363455" y="5193792"/>
+            <a:ext cx="1193291" cy="585216"/>
           </a:xfrm>
           <a:prstGeom prst="roundRect">
             <a:avLst>
@@ -7197,8 +7197,8 @@
         </p:nvSpPr>
         <p:spPr>
           <a:xfrm>
-            <a:off x="9017507" y="5193792"/>
-            <a:ext cx="867155" cy="585216"/>
+            <a:off x="10648188" y="5193792"/>
+            <a:ext cx="1193291" cy="585216"/>
           </a:xfrm>
           <a:prstGeom prst="roundRect">
             <a:avLst>
@@ -7280,861 +7280,13 @@
       </p:sp>
       <p:sp>
         <p:nvSpPr>
-          <p:cNvPr id="69" name="Rounded Rectangle 68"/>
+          <p:cNvPr id="69" name="Down Arrow 68"/>
           <p:cNvSpPr/>
           <p:nvPr/>
         </p:nvSpPr>
         <p:spPr>
           <a:xfrm>
-            <a:off x="10076688" y="749808"/>
-            <a:ext cx="1847088" cy="5157216"/>
-          </a:xfrm>
-          <a:prstGeom prst="roundRect">
-            <a:avLst>
-              <a:gd name="adj" fmla="val 6000"/>
-            </a:avLst>
-          </a:prstGeom>
-          <a:solidFill>
-            <a:srgbClr val="0E0E16"/>
-          </a:solidFill>
-          <a:ln w="12700">
-            <a:solidFill>
-              <a:srgbClr val="A97BFF"/>
-            </a:solidFill>
-          </a:ln>
-          <a:effectLst/>
-        </p:spPr>
-        <p:style>
-          <a:lnRef idx="1">
-            <a:schemeClr val="accent1"/>
-          </a:lnRef>
-          <a:fillRef idx="3">
-            <a:schemeClr val="accent1"/>
-          </a:fillRef>
-          <a:effectRef idx="2">
-            <a:schemeClr val="accent1"/>
-          </a:effectRef>
-          <a:fontRef idx="minor">
-            <a:schemeClr val="lt1"/>
-          </a:fontRef>
-        </p:style>
-        <p:txBody>
-          <a:bodyPr rtlCol="0" anchor="ctr" wrap="square"/>
-          <a:lstStyle/>
-          <a:p>
-            <a:pPr algn="ctr"/>
-          </a:p>
-        </p:txBody>
-      </p:sp>
-      <p:sp>
-        <p:nvSpPr>
-          <p:cNvPr id="70" name="Rectangle 69"/>
-          <p:cNvSpPr/>
-          <p:nvPr/>
-        </p:nvSpPr>
-        <p:spPr>
-          <a:xfrm>
-            <a:off x="10076688" y="749808"/>
-            <a:ext cx="1847088" cy="82296"/>
-          </a:xfrm>
-          <a:prstGeom prst="rect">
-            <a:avLst/>
-          </a:prstGeom>
-          <a:solidFill>
-            <a:srgbClr val="A97BFF"/>
-          </a:solidFill>
-          <a:ln>
-            <a:noFill/>
-          </a:ln>
-          <a:effectLst/>
-        </p:spPr>
-        <p:style>
-          <a:lnRef idx="1">
-            <a:schemeClr val="accent1"/>
-          </a:lnRef>
-          <a:fillRef idx="3">
-            <a:schemeClr val="accent1"/>
-          </a:fillRef>
-          <a:effectRef idx="2">
-            <a:schemeClr val="accent1"/>
-          </a:effectRef>
-          <a:fontRef idx="minor">
-            <a:schemeClr val="lt1"/>
-          </a:fontRef>
-        </p:style>
-        <p:txBody>
-          <a:bodyPr rtlCol="0" anchor="ctr" wrap="square"/>
-          <a:lstStyle/>
-          <a:p>
-            <a:pPr algn="ctr"/>
-          </a:p>
-        </p:txBody>
-      </p:sp>
-      <p:sp>
-        <p:nvSpPr>
-          <p:cNvPr id="71" name="TextBox 70"/>
-          <p:cNvSpPr txBox="1"/>
-          <p:nvPr/>
-        </p:nvSpPr>
-        <p:spPr>
-          <a:xfrm>
-            <a:off x="10186415" y="886968"/>
-            <a:ext cx="1627632" cy="201168"/>
-          </a:xfrm>
-          <a:prstGeom prst="rect">
-            <a:avLst/>
-          </a:prstGeom>
-          <a:noFill/>
-        </p:spPr>
-        <p:txBody>
-          <a:bodyPr wrap="square" anchor="t" lIns="0" rIns="0" tIns="0" bIns="0">
-            <a:spAutoFit/>
-          </a:bodyPr>
-          <a:lstStyle/>
-          <a:p>
-            <a:pPr algn="l">
-              <a:lnSpc>
-                <a:spcPct val="100000"/>
-              </a:lnSpc>
-              <a:spcBef>
-                <a:spcPts val="0"/>
-              </a:spcBef>
-              <a:spcAft>
-                <a:spcPts val="0"/>
-              </a:spcAft>
-            </a:pPr>
-            <a:r>
-              <a:rPr sz="919" b="1" i="0">
-                <a:solidFill>
-                  <a:srgbClr val="A97BFF"/>
-                </a:solidFill>
-                <a:latin typeface="Segoe UI"/>
-              </a:rPr>
-              <a:t>LEGACY DATA SYSTEM</a:t>
-            </a:r>
-          </a:p>
-        </p:txBody>
-      </p:sp>
-      <p:sp>
-        <p:nvSpPr>
-          <p:cNvPr id="72" name="TextBox 71"/>
-          <p:cNvSpPr txBox="1"/>
-          <p:nvPr/>
-        </p:nvSpPr>
-        <p:spPr>
-          <a:xfrm>
-            <a:off x="10186415" y="1088136"/>
-            <a:ext cx="1627632" cy="256032"/>
-          </a:xfrm>
-          <a:prstGeom prst="rect">
-            <a:avLst/>
-          </a:prstGeom>
-          <a:noFill/>
-        </p:spPr>
-        <p:txBody>
-          <a:bodyPr wrap="square" anchor="t" lIns="0" rIns="0" tIns="0" bIns="0">
-            <a:spAutoFit/>
-          </a:bodyPr>
-          <a:lstStyle/>
-          <a:p>
-            <a:pPr algn="l">
-              <a:lnSpc>
-                <a:spcPct val="100000"/>
-              </a:lnSpc>
-              <a:spcBef>
-                <a:spcPts val="0"/>
-              </a:spcBef>
-              <a:spcAft>
-                <a:spcPts val="0"/>
-              </a:spcAft>
-            </a:pPr>
-            <a:r>
-              <a:rPr sz="680" b="0" i="1">
-                <a:solidFill>
-                  <a:srgbClr val="C2C2D0"/>
-                </a:solidFill>
-                <a:latin typeface="Segoe UI"/>
-              </a:rPr>
-              <a:t>governed data · read by the agents</a:t>
-            </a:r>
-          </a:p>
-        </p:txBody>
-      </p:sp>
-      <p:sp>
-        <p:nvSpPr>
-          <p:cNvPr id="73" name="Rounded Rectangle 72"/>
-          <p:cNvSpPr/>
-          <p:nvPr/>
-        </p:nvSpPr>
-        <p:spPr>
-          <a:xfrm>
-            <a:off x="10186415" y="1408176"/>
-            <a:ext cx="1627632" cy="699516"/>
-          </a:xfrm>
-          <a:prstGeom prst="roundRect">
-            <a:avLst>
-              <a:gd name="adj" fmla="val 6000"/>
-            </a:avLst>
-          </a:prstGeom>
-          <a:solidFill>
-            <a:srgbClr val="222230"/>
-          </a:solidFill>
-          <a:ln w="7620">
-            <a:solidFill>
-              <a:srgbClr val="3C3C4E"/>
-            </a:solidFill>
-          </a:ln>
-          <a:effectLst/>
-        </p:spPr>
-        <p:style>
-          <a:lnRef idx="1">
-            <a:schemeClr val="accent1"/>
-          </a:lnRef>
-          <a:fillRef idx="3">
-            <a:schemeClr val="accent1"/>
-          </a:fillRef>
-          <a:effectRef idx="2">
-            <a:schemeClr val="accent1"/>
-          </a:effectRef>
-          <a:fontRef idx="minor">
-            <a:schemeClr val="lt1"/>
-          </a:fontRef>
-        </p:style>
-        <p:txBody>
-          <a:bodyPr rtlCol="0" anchor="ctr" wrap="square" lIns="27432" rIns="27432" tIns="9144" bIns="9144"/>
-          <a:lstStyle/>
-          <a:p>
-            <a:pPr algn="l">
-              <a:lnSpc>
-                <a:spcPct val="95000"/>
-              </a:lnSpc>
-              <a:spcBef>
-                <a:spcPts val="0"/>
-              </a:spcBef>
-              <a:spcAft>
-                <a:spcPts val="0"/>
-              </a:spcAft>
-            </a:pPr>
-            <a:r>
-              <a:rPr sz="690" b="0" i="0">
-                <a:solidFill>
-                  <a:srgbClr val="FFFFFF"/>
-                </a:solidFill>
-                <a:latin typeface="Segoe UI"/>
-              </a:rPr>
-              <a:t>Master data</a:t>
-            </a:r>
-          </a:p>
-        </p:txBody>
-      </p:sp>
-      <p:sp>
-        <p:nvSpPr>
-          <p:cNvPr id="74" name="Rectangle 73"/>
-          <p:cNvSpPr/>
-          <p:nvPr/>
-        </p:nvSpPr>
-        <p:spPr>
-          <a:xfrm>
-            <a:off x="10186415" y="1408176"/>
-            <a:ext cx="45720" cy="699516"/>
-          </a:xfrm>
-          <a:prstGeom prst="rect">
-            <a:avLst/>
-          </a:prstGeom>
-          <a:solidFill>
-            <a:srgbClr val="A97BFF"/>
-          </a:solidFill>
-          <a:ln>
-            <a:noFill/>
-          </a:ln>
-          <a:effectLst/>
-        </p:spPr>
-        <p:style>
-          <a:lnRef idx="1">
-            <a:schemeClr val="accent1"/>
-          </a:lnRef>
-          <a:fillRef idx="3">
-            <a:schemeClr val="accent1"/>
-          </a:fillRef>
-          <a:effectRef idx="2">
-            <a:schemeClr val="accent1"/>
-          </a:effectRef>
-          <a:fontRef idx="minor">
-            <a:schemeClr val="lt1"/>
-          </a:fontRef>
-        </p:style>
-        <p:txBody>
-          <a:bodyPr rtlCol="0" anchor="ctr" wrap="square"/>
-          <a:lstStyle/>
-          <a:p>
-            <a:pPr algn="ctr"/>
-          </a:p>
-        </p:txBody>
-      </p:sp>
-      <p:sp>
-        <p:nvSpPr>
-          <p:cNvPr id="75" name="Rounded Rectangle 74"/>
-          <p:cNvSpPr/>
-          <p:nvPr/>
-        </p:nvSpPr>
-        <p:spPr>
-          <a:xfrm>
-            <a:off x="10186415" y="2153412"/>
-            <a:ext cx="1627632" cy="699516"/>
-          </a:xfrm>
-          <a:prstGeom prst="roundRect">
-            <a:avLst>
-              <a:gd name="adj" fmla="val 6000"/>
-            </a:avLst>
-          </a:prstGeom>
-          <a:solidFill>
-            <a:srgbClr val="222230"/>
-          </a:solidFill>
-          <a:ln w="7620">
-            <a:solidFill>
-              <a:srgbClr val="3C3C4E"/>
-            </a:solidFill>
-          </a:ln>
-          <a:effectLst/>
-        </p:spPr>
-        <p:style>
-          <a:lnRef idx="1">
-            <a:schemeClr val="accent1"/>
-          </a:lnRef>
-          <a:fillRef idx="3">
-            <a:schemeClr val="accent1"/>
-          </a:fillRef>
-          <a:effectRef idx="2">
-            <a:schemeClr val="accent1"/>
-          </a:effectRef>
-          <a:fontRef idx="minor">
-            <a:schemeClr val="lt1"/>
-          </a:fontRef>
-        </p:style>
-        <p:txBody>
-          <a:bodyPr rtlCol="0" anchor="ctr" wrap="square" lIns="27432" rIns="27432" tIns="9144" bIns="9144"/>
-          <a:lstStyle/>
-          <a:p>
-            <a:pPr algn="l">
-              <a:lnSpc>
-                <a:spcPct val="95000"/>
-              </a:lnSpc>
-              <a:spcBef>
-                <a:spcPts val="0"/>
-              </a:spcBef>
-              <a:spcAft>
-                <a:spcPts val="0"/>
-              </a:spcAft>
-            </a:pPr>
-            <a:r>
-              <a:rPr sz="690" b="0" i="0">
-                <a:solidFill>
-                  <a:srgbClr val="FFFFFF"/>
-                </a:solidFill>
-                <a:latin typeface="Segoe UI"/>
-              </a:rPr>
-              <a:t>Reference &amp; catalog data</a:t>
-            </a:r>
-          </a:p>
-        </p:txBody>
-      </p:sp>
-      <p:sp>
-        <p:nvSpPr>
-          <p:cNvPr id="76" name="Rectangle 75"/>
-          <p:cNvSpPr/>
-          <p:nvPr/>
-        </p:nvSpPr>
-        <p:spPr>
-          <a:xfrm>
-            <a:off x="10186415" y="2153412"/>
-            <a:ext cx="45720" cy="699516"/>
-          </a:xfrm>
-          <a:prstGeom prst="rect">
-            <a:avLst/>
-          </a:prstGeom>
-          <a:solidFill>
-            <a:srgbClr val="A97BFF"/>
-          </a:solidFill>
-          <a:ln>
-            <a:noFill/>
-          </a:ln>
-          <a:effectLst/>
-        </p:spPr>
-        <p:style>
-          <a:lnRef idx="1">
-            <a:schemeClr val="accent1"/>
-          </a:lnRef>
-          <a:fillRef idx="3">
-            <a:schemeClr val="accent1"/>
-          </a:fillRef>
-          <a:effectRef idx="2">
-            <a:schemeClr val="accent1"/>
-          </a:effectRef>
-          <a:fontRef idx="minor">
-            <a:schemeClr val="lt1"/>
-          </a:fontRef>
-        </p:style>
-        <p:txBody>
-          <a:bodyPr rtlCol="0" anchor="ctr" wrap="square"/>
-          <a:lstStyle/>
-          <a:p>
-            <a:pPr algn="ctr"/>
-          </a:p>
-        </p:txBody>
-      </p:sp>
-      <p:sp>
-        <p:nvSpPr>
-          <p:cNvPr id="77" name="Rounded Rectangle 76"/>
-          <p:cNvSpPr/>
-          <p:nvPr/>
-        </p:nvSpPr>
-        <p:spPr>
-          <a:xfrm>
-            <a:off x="10186415" y="2898648"/>
-            <a:ext cx="1627632" cy="699516"/>
-          </a:xfrm>
-          <a:prstGeom prst="roundRect">
-            <a:avLst>
-              <a:gd name="adj" fmla="val 6000"/>
-            </a:avLst>
-          </a:prstGeom>
-          <a:solidFill>
-            <a:srgbClr val="222230"/>
-          </a:solidFill>
-          <a:ln w="7620">
-            <a:solidFill>
-              <a:srgbClr val="3C3C4E"/>
-            </a:solidFill>
-          </a:ln>
-          <a:effectLst/>
-        </p:spPr>
-        <p:style>
-          <a:lnRef idx="1">
-            <a:schemeClr val="accent1"/>
-          </a:lnRef>
-          <a:fillRef idx="3">
-            <a:schemeClr val="accent1"/>
-          </a:fillRef>
-          <a:effectRef idx="2">
-            <a:schemeClr val="accent1"/>
-          </a:effectRef>
-          <a:fontRef idx="minor">
-            <a:schemeClr val="lt1"/>
-          </a:fontRef>
-        </p:style>
-        <p:txBody>
-          <a:bodyPr rtlCol="0" anchor="ctr" wrap="square" lIns="27432" rIns="27432" tIns="9144" bIns="9144"/>
-          <a:lstStyle/>
-          <a:p>
-            <a:pPr algn="l">
-              <a:lnSpc>
-                <a:spcPct val="95000"/>
-              </a:lnSpc>
-              <a:spcBef>
-                <a:spcPts val="0"/>
-              </a:spcBef>
-              <a:spcAft>
-                <a:spcPts val="0"/>
-              </a:spcAft>
-            </a:pPr>
-            <a:r>
-              <a:rPr sz="690" b="0" i="0">
-                <a:solidFill>
-                  <a:srgbClr val="FFFFFF"/>
-                </a:solidFill>
-                <a:latin typeface="Segoe UI"/>
-              </a:rPr>
-              <a:t>Business rules &amp; policies</a:t>
-            </a:r>
-          </a:p>
-        </p:txBody>
-      </p:sp>
-      <p:sp>
-        <p:nvSpPr>
-          <p:cNvPr id="78" name="Rectangle 77"/>
-          <p:cNvSpPr/>
-          <p:nvPr/>
-        </p:nvSpPr>
-        <p:spPr>
-          <a:xfrm>
-            <a:off x="10186415" y="2898648"/>
-            <a:ext cx="45720" cy="699516"/>
-          </a:xfrm>
-          <a:prstGeom prst="rect">
-            <a:avLst/>
-          </a:prstGeom>
-          <a:solidFill>
-            <a:srgbClr val="A97BFF"/>
-          </a:solidFill>
-          <a:ln>
-            <a:noFill/>
-          </a:ln>
-          <a:effectLst/>
-        </p:spPr>
-        <p:style>
-          <a:lnRef idx="1">
-            <a:schemeClr val="accent1"/>
-          </a:lnRef>
-          <a:fillRef idx="3">
-            <a:schemeClr val="accent1"/>
-          </a:fillRef>
-          <a:effectRef idx="2">
-            <a:schemeClr val="accent1"/>
-          </a:effectRef>
-          <a:fontRef idx="minor">
-            <a:schemeClr val="lt1"/>
-          </a:fontRef>
-        </p:style>
-        <p:txBody>
-          <a:bodyPr rtlCol="0" anchor="ctr" wrap="square"/>
-          <a:lstStyle/>
-          <a:p>
-            <a:pPr algn="ctr"/>
-          </a:p>
-        </p:txBody>
-      </p:sp>
-      <p:sp>
-        <p:nvSpPr>
-          <p:cNvPr id="79" name="Rounded Rectangle 78"/>
-          <p:cNvSpPr/>
-          <p:nvPr/>
-        </p:nvSpPr>
-        <p:spPr>
-          <a:xfrm>
-            <a:off x="10186415" y="3643884"/>
-            <a:ext cx="1627632" cy="699516"/>
-          </a:xfrm>
-          <a:prstGeom prst="roundRect">
-            <a:avLst>
-              <a:gd name="adj" fmla="val 6000"/>
-            </a:avLst>
-          </a:prstGeom>
-          <a:solidFill>
-            <a:srgbClr val="222230"/>
-          </a:solidFill>
-          <a:ln w="7620">
-            <a:solidFill>
-              <a:srgbClr val="3C3C4E"/>
-            </a:solidFill>
-          </a:ln>
-          <a:effectLst/>
-        </p:spPr>
-        <p:style>
-          <a:lnRef idx="1">
-            <a:schemeClr val="accent1"/>
-          </a:lnRef>
-          <a:fillRef idx="3">
-            <a:schemeClr val="accent1"/>
-          </a:fillRef>
-          <a:effectRef idx="2">
-            <a:schemeClr val="accent1"/>
-          </a:effectRef>
-          <a:fontRef idx="minor">
-            <a:schemeClr val="lt1"/>
-          </a:fontRef>
-        </p:style>
-        <p:txBody>
-          <a:bodyPr rtlCol="0" anchor="ctr" wrap="square" lIns="27432" rIns="27432" tIns="9144" bIns="9144"/>
-          <a:lstStyle/>
-          <a:p>
-            <a:pPr algn="l">
-              <a:lnSpc>
-                <a:spcPct val="95000"/>
-              </a:lnSpc>
-              <a:spcBef>
-                <a:spcPts val="0"/>
-              </a:spcBef>
-              <a:spcAft>
-                <a:spcPts val="0"/>
-              </a:spcAft>
-            </a:pPr>
-            <a:r>
-              <a:rPr sz="690" b="0" i="0">
-                <a:solidFill>
-                  <a:srgbClr val="FFFFFF"/>
-                </a:solidFill>
-                <a:latin typeface="Segoe UI"/>
-              </a:rPr>
-              <a:t>Limits &amp; thresholds</a:t>
-            </a:r>
-          </a:p>
-        </p:txBody>
-      </p:sp>
-      <p:sp>
-        <p:nvSpPr>
-          <p:cNvPr id="80" name="Rectangle 79"/>
-          <p:cNvSpPr/>
-          <p:nvPr/>
-        </p:nvSpPr>
-        <p:spPr>
-          <a:xfrm>
-            <a:off x="10186415" y="3643884"/>
-            <a:ext cx="45720" cy="699516"/>
-          </a:xfrm>
-          <a:prstGeom prst="rect">
-            <a:avLst/>
-          </a:prstGeom>
-          <a:solidFill>
-            <a:srgbClr val="A97BFF"/>
-          </a:solidFill>
-          <a:ln>
-            <a:noFill/>
-          </a:ln>
-          <a:effectLst/>
-        </p:spPr>
-        <p:style>
-          <a:lnRef idx="1">
-            <a:schemeClr val="accent1"/>
-          </a:lnRef>
-          <a:fillRef idx="3">
-            <a:schemeClr val="accent1"/>
-          </a:fillRef>
-          <a:effectRef idx="2">
-            <a:schemeClr val="accent1"/>
-          </a:effectRef>
-          <a:fontRef idx="minor">
-            <a:schemeClr val="lt1"/>
-          </a:fontRef>
-        </p:style>
-        <p:txBody>
-          <a:bodyPr rtlCol="0" anchor="ctr" wrap="square"/>
-          <a:lstStyle/>
-          <a:p>
-            <a:pPr algn="ctr"/>
-          </a:p>
-        </p:txBody>
-      </p:sp>
-      <p:sp>
-        <p:nvSpPr>
-          <p:cNvPr id="81" name="Rounded Rectangle 80"/>
-          <p:cNvSpPr/>
-          <p:nvPr/>
-        </p:nvSpPr>
-        <p:spPr>
-          <a:xfrm>
-            <a:off x="10186415" y="4389120"/>
-            <a:ext cx="1627632" cy="699516"/>
-          </a:xfrm>
-          <a:prstGeom prst="roundRect">
-            <a:avLst>
-              <a:gd name="adj" fmla="val 6000"/>
-            </a:avLst>
-          </a:prstGeom>
-          <a:solidFill>
-            <a:srgbClr val="222230"/>
-          </a:solidFill>
-          <a:ln w="7620">
-            <a:solidFill>
-              <a:srgbClr val="3C3C4E"/>
-            </a:solidFill>
-          </a:ln>
-          <a:effectLst/>
-        </p:spPr>
-        <p:style>
-          <a:lnRef idx="1">
-            <a:schemeClr val="accent1"/>
-          </a:lnRef>
-          <a:fillRef idx="3">
-            <a:schemeClr val="accent1"/>
-          </a:fillRef>
-          <a:effectRef idx="2">
-            <a:schemeClr val="accent1"/>
-          </a:effectRef>
-          <a:fontRef idx="minor">
-            <a:schemeClr val="lt1"/>
-          </a:fontRef>
-        </p:style>
-        <p:txBody>
-          <a:bodyPr rtlCol="0" anchor="ctr" wrap="square" lIns="27432" rIns="27432" tIns="9144" bIns="9144"/>
-          <a:lstStyle/>
-          <a:p>
-            <a:pPr algn="l">
-              <a:lnSpc>
-                <a:spcPct val="95000"/>
-              </a:lnSpc>
-              <a:spcBef>
-                <a:spcPts val="0"/>
-              </a:spcBef>
-              <a:spcAft>
-                <a:spcPts val="0"/>
-              </a:spcAft>
-            </a:pPr>
-            <a:r>
-              <a:rPr sz="690" b="0" i="0">
-                <a:solidFill>
-                  <a:srgbClr val="FFFFFF"/>
-                </a:solidFill>
-                <a:latin typeface="Segoe UI"/>
-              </a:rPr>
-              <a:t>Contracts &amp; pricing data</a:t>
-            </a:r>
-          </a:p>
-        </p:txBody>
-      </p:sp>
-      <p:sp>
-        <p:nvSpPr>
-          <p:cNvPr id="82" name="Rectangle 81"/>
-          <p:cNvSpPr/>
-          <p:nvPr/>
-        </p:nvSpPr>
-        <p:spPr>
-          <a:xfrm>
-            <a:off x="10186415" y="4389120"/>
-            <a:ext cx="45720" cy="699516"/>
-          </a:xfrm>
-          <a:prstGeom prst="rect">
-            <a:avLst/>
-          </a:prstGeom>
-          <a:solidFill>
-            <a:srgbClr val="A97BFF"/>
-          </a:solidFill>
-          <a:ln>
-            <a:noFill/>
-          </a:ln>
-          <a:effectLst/>
-        </p:spPr>
-        <p:style>
-          <a:lnRef idx="1">
-            <a:schemeClr val="accent1"/>
-          </a:lnRef>
-          <a:fillRef idx="3">
-            <a:schemeClr val="accent1"/>
-          </a:fillRef>
-          <a:effectRef idx="2">
-            <a:schemeClr val="accent1"/>
-          </a:effectRef>
-          <a:fontRef idx="minor">
-            <a:schemeClr val="lt1"/>
-          </a:fontRef>
-        </p:style>
-        <p:txBody>
-          <a:bodyPr rtlCol="0" anchor="ctr" wrap="square"/>
-          <a:lstStyle/>
-          <a:p>
-            <a:pPr algn="ctr"/>
-          </a:p>
-        </p:txBody>
-      </p:sp>
-      <p:sp>
-        <p:nvSpPr>
-          <p:cNvPr id="83" name="Rounded Rectangle 82"/>
-          <p:cNvSpPr/>
-          <p:nvPr/>
-        </p:nvSpPr>
-        <p:spPr>
-          <a:xfrm>
-            <a:off x="10186415" y="5134356"/>
-            <a:ext cx="1627632" cy="699516"/>
-          </a:xfrm>
-          <a:prstGeom prst="roundRect">
-            <a:avLst>
-              <a:gd name="adj" fmla="val 6000"/>
-            </a:avLst>
-          </a:prstGeom>
-          <a:solidFill>
-            <a:srgbClr val="222230"/>
-          </a:solidFill>
-          <a:ln w="7620">
-            <a:solidFill>
-              <a:srgbClr val="3C3C4E"/>
-            </a:solidFill>
-          </a:ln>
-          <a:effectLst/>
-        </p:spPr>
-        <p:style>
-          <a:lnRef idx="1">
-            <a:schemeClr val="accent1"/>
-          </a:lnRef>
-          <a:fillRef idx="3">
-            <a:schemeClr val="accent1"/>
-          </a:fillRef>
-          <a:effectRef idx="2">
-            <a:schemeClr val="accent1"/>
-          </a:effectRef>
-          <a:fontRef idx="minor">
-            <a:schemeClr val="lt1"/>
-          </a:fontRef>
-        </p:style>
-        <p:txBody>
-          <a:bodyPr rtlCol="0" anchor="ctr" wrap="square" lIns="27432" rIns="27432" tIns="9144" bIns="9144"/>
-          <a:lstStyle/>
-          <a:p>
-            <a:pPr algn="l">
-              <a:lnSpc>
-                <a:spcPct val="95000"/>
-              </a:lnSpc>
-              <a:spcBef>
-                <a:spcPts val="0"/>
-              </a:spcBef>
-              <a:spcAft>
-                <a:spcPts val="0"/>
-              </a:spcAft>
-            </a:pPr>
-            <a:r>
-              <a:rPr sz="690" b="0" i="0">
-                <a:solidFill>
-                  <a:srgbClr val="FFFFFF"/>
-                </a:solidFill>
-                <a:latin typeface="Segoe UI"/>
-              </a:rPr>
-              <a:t>Integration endpoints</a:t>
-            </a:r>
-          </a:p>
-        </p:txBody>
-      </p:sp>
-      <p:sp>
-        <p:nvSpPr>
-          <p:cNvPr id="84" name="Rectangle 83"/>
-          <p:cNvSpPr/>
-          <p:nvPr/>
-        </p:nvSpPr>
-        <p:spPr>
-          <a:xfrm>
-            <a:off x="10186415" y="5134356"/>
-            <a:ext cx="45720" cy="699516"/>
-          </a:xfrm>
-          <a:prstGeom prst="rect">
-            <a:avLst/>
-          </a:prstGeom>
-          <a:solidFill>
-            <a:srgbClr val="A97BFF"/>
-          </a:solidFill>
-          <a:ln>
-            <a:noFill/>
-          </a:ln>
-          <a:effectLst/>
-        </p:spPr>
-        <p:style>
-          <a:lnRef idx="1">
-            <a:schemeClr val="accent1"/>
-          </a:lnRef>
-          <a:fillRef idx="3">
-            <a:schemeClr val="accent1"/>
-          </a:fillRef>
-          <a:effectRef idx="2">
-            <a:schemeClr val="accent1"/>
-          </a:effectRef>
-          <a:fontRef idx="minor">
-            <a:schemeClr val="lt1"/>
-          </a:fontRef>
-        </p:style>
-        <p:txBody>
-          <a:bodyPr rtlCol="0" anchor="ctr" wrap="square"/>
-          <a:lstStyle/>
-          <a:p>
-            <a:pPr algn="ctr"/>
-          </a:p>
-        </p:txBody>
-      </p:sp>
-      <p:sp>
-        <p:nvSpPr>
-          <p:cNvPr id="85" name="Down Arrow 84"/>
-          <p:cNvSpPr/>
-          <p:nvPr/>
-        </p:nvSpPr>
-        <p:spPr>
-          <a:xfrm>
-            <a:off x="5605271" y="1463040"/>
+            <a:off x="6583679" y="1463040"/>
             <a:ext cx="292608" cy="109728"/>
           </a:xfrm>
           <a:prstGeom prst="downArrow">
@@ -8172,13 +7324,13 @@
       </p:sp>
       <p:sp>
         <p:nvSpPr>
-          <p:cNvPr id="86" name="Down Arrow 85"/>
+          <p:cNvPr id="70" name="Down Arrow 69"/>
           <p:cNvSpPr/>
           <p:nvPr/>
         </p:nvSpPr>
         <p:spPr>
           <a:xfrm>
-            <a:off x="5605271" y="4754880"/>
+            <a:off x="6583679" y="4754880"/>
             <a:ext cx="292608" cy="109728"/>
           </a:xfrm>
           <a:prstGeom prst="downArrow">
@@ -8214,85 +7366,9 @@
           </a:p>
         </p:txBody>
       </p:sp>
-      <p:cxnSp>
-        <p:nvCxnSpPr>
-          <p:cNvPr id="87" name="Connector 86"/>
-          <p:cNvCxnSpPr/>
-          <p:nvPr/>
-        </p:nvCxnSpPr>
-        <p:spPr>
-          <a:xfrm flipH="1">
-            <a:off x="9930384" y="3172968"/>
-            <a:ext cx="146304" cy="0"/>
-          </a:xfrm>
-          <a:prstGeom prst="line">
-            <a:avLst/>
-          </a:prstGeom>
-          <a:ln w="13970">
-            <a:solidFill>
-              <a:srgbClr val="A97BFF"/>
-            </a:solidFill>
-            <a:prstDash val="dash"/>
-            <a:tailEnd type="triangle" w="med" len="med"/>
-          </a:ln>
-          <a:effectLst/>
-        </p:spPr>
-        <p:style>
-          <a:lnRef idx="2">
-            <a:schemeClr val="accent1"/>
-          </a:lnRef>
-          <a:fillRef idx="0">
-            <a:schemeClr val="accent1"/>
-          </a:fillRef>
-          <a:effectRef idx="1">
-            <a:schemeClr val="accent1"/>
-          </a:effectRef>
-          <a:fontRef idx="minor">
-            <a:schemeClr val="tx1"/>
-          </a:fontRef>
-        </p:style>
-      </p:cxnSp>
-      <p:cxnSp>
-        <p:nvCxnSpPr>
-          <p:cNvPr id="88" name="Connector 87"/>
-          <p:cNvCxnSpPr/>
-          <p:nvPr/>
-        </p:nvCxnSpPr>
-        <p:spPr>
-          <a:xfrm flipH="1">
-            <a:off x="9930384" y="5394960"/>
-            <a:ext cx="146304" cy="0"/>
-          </a:xfrm>
-          <a:prstGeom prst="line">
-            <a:avLst/>
-          </a:prstGeom>
-          <a:ln w="13970">
-            <a:solidFill>
-              <a:srgbClr val="A97BFF"/>
-            </a:solidFill>
-            <a:prstDash val="dash"/>
-            <a:tailEnd type="triangle" w="med" len="med"/>
-          </a:ln>
-          <a:effectLst/>
-        </p:spPr>
-        <p:style>
-          <a:lnRef idx="2">
-            <a:schemeClr val="accent1"/>
-          </a:lnRef>
-          <a:fillRef idx="0">
-            <a:schemeClr val="accent1"/>
-          </a:fillRef>
-          <a:effectRef idx="1">
-            <a:schemeClr val="accent1"/>
-          </a:effectRef>
-          <a:fontRef idx="minor">
-            <a:schemeClr val="tx1"/>
-          </a:fontRef>
-        </p:style>
-      </p:cxnSp>
-      <p:sp>
-        <p:nvSpPr>
-          <p:cNvPr id="89" name="TextBox 88"/>
+      <p:sp>
+        <p:nvSpPr>
+          <p:cNvPr id="71" name="TextBox 70"/>
           <p:cNvSpPr txBox="1"/>
           <p:nvPr/>
         </p:nvSpPr>
@@ -8348,16 +7424,7 @@
                 </a:solidFill>
                 <a:latin typeface="Segoe UI"/>
               </a:rPr>
-              <a:t>amber = human-in-the-loop decision    ·    </a:t>
-            </a:r>
-            <a:r>
-              <a:rPr sz="800" b="0" i="1">
-                <a:solidFill>
-                  <a:srgbClr val="A97BFF"/>
-                </a:solidFill>
-                <a:latin typeface="Segoe UI"/>
-              </a:rPr>
-              <a:t>dashed purple = master-data reads</a:t>
+              <a:t>amber = human-in-the-loop decision</a:t>
             </a:r>
           </a:p>
         </p:txBody>

</xml_diff>

<commit_message>
docs: drop duplicate intake-agent extraction text from PO intake input band
</commit_message>
<xml_diff>
--- a/demo/Order-Creation-Orchestration-Architecture.pptx
+++ b/demo/Order-Creation-Orchestration-Architecture.pptx
@@ -3762,7 +3762,7 @@
         <p:spPr>
           <a:xfrm>
             <a:off x="1618488" y="987552"/>
-            <a:ext cx="2651760" cy="438912"/>
+            <a:ext cx="10222992" cy="438912"/>
           </a:xfrm>
           <a:prstGeom prst="roundRect">
             <a:avLst>
@@ -3810,7 +3810,7 @@
         <p:spPr>
           <a:xfrm>
             <a:off x="1618488" y="987552"/>
-            <a:ext cx="2651760" cy="45720"/>
+            <a:ext cx="10222992" cy="45720"/>
           </a:xfrm>
           <a:prstGeom prst="rect">
             <a:avLst/>
@@ -3854,7 +3854,7 @@
         <p:spPr>
           <a:xfrm>
             <a:off x="1709928" y="1069848"/>
-            <a:ext cx="2468879" cy="182880"/>
+            <a:ext cx="10040112" cy="182880"/>
           </a:xfrm>
           <a:prstGeom prst="rect">
             <a:avLst/>
@@ -3899,7 +3899,7 @@
         <p:spPr>
           <a:xfrm>
             <a:off x="1709928" y="1271016"/>
-            <a:ext cx="2468879" cy="118872"/>
+            <a:ext cx="10040112" cy="118872"/>
           </a:xfrm>
           <a:prstGeom prst="rect">
             <a:avLst/>
@@ -3930,7 +3930,7 @@
                 </a:solidFill>
                 <a:latin typeface="Segoe UI"/>
               </a:rPr>
-              <a:t>Received as Email PO, Excel PO etc.</a:t>
+              <a:t>Received as Email PO, Excel PO etc.  →  handed to the orchestration below</a:t>
             </a:r>
           </a:p>
         </p:txBody>
@@ -3938,161 +3938,6 @@
       <p:sp>
         <p:nvSpPr>
           <p:cNvPr id="17" name="Rounded Rectangle 16"/>
-          <p:cNvSpPr/>
-          <p:nvPr/>
-        </p:nvSpPr>
-        <p:spPr>
-          <a:xfrm>
-            <a:off x="4636008" y="987552"/>
-            <a:ext cx="7205471" cy="438912"/>
-          </a:xfrm>
-          <a:prstGeom prst="roundRect">
-            <a:avLst>
-              <a:gd name="adj" fmla="val 6000"/>
-            </a:avLst>
-          </a:prstGeom>
-          <a:solidFill>
-            <a:srgbClr val="222230"/>
-          </a:solidFill>
-          <a:ln w="11430">
-            <a:solidFill>
-              <a:srgbClr val="4A9EFF"/>
-            </a:solidFill>
-          </a:ln>
-          <a:effectLst/>
-        </p:spPr>
-        <p:style>
-          <a:lnRef idx="1">
-            <a:schemeClr val="accent1"/>
-          </a:lnRef>
-          <a:fillRef idx="3">
-            <a:schemeClr val="accent1"/>
-          </a:fillRef>
-          <a:effectRef idx="2">
-            <a:schemeClr val="accent1"/>
-          </a:effectRef>
-          <a:fontRef idx="minor">
-            <a:schemeClr val="lt1"/>
-          </a:fontRef>
-        </p:style>
-        <p:txBody>
-          <a:bodyPr rtlCol="0" anchor="ctr" wrap="square"/>
-          <a:lstStyle/>
-          <a:p>
-            <a:pPr algn="ctr"/>
-          </a:p>
-        </p:txBody>
-      </p:sp>
-      <p:sp>
-        <p:nvSpPr>
-          <p:cNvPr id="18" name="Rectangle 17"/>
-          <p:cNvSpPr/>
-          <p:nvPr/>
-        </p:nvSpPr>
-        <p:spPr>
-          <a:xfrm>
-            <a:off x="4636008" y="987552"/>
-            <a:ext cx="7205471" cy="45720"/>
-          </a:xfrm>
-          <a:prstGeom prst="rect">
-            <a:avLst/>
-          </a:prstGeom>
-          <a:solidFill>
-            <a:srgbClr val="4A9EFF"/>
-          </a:solidFill>
-          <a:ln>
-            <a:noFill/>
-          </a:ln>
-          <a:effectLst/>
-        </p:spPr>
-        <p:style>
-          <a:lnRef idx="1">
-            <a:schemeClr val="accent1"/>
-          </a:lnRef>
-          <a:fillRef idx="3">
-            <a:schemeClr val="accent1"/>
-          </a:fillRef>
-          <a:effectRef idx="2">
-            <a:schemeClr val="accent1"/>
-          </a:effectRef>
-          <a:fontRef idx="minor">
-            <a:schemeClr val="lt1"/>
-          </a:fontRef>
-        </p:style>
-        <p:txBody>
-          <a:bodyPr rtlCol="0" anchor="ctr" wrap="square"/>
-          <a:lstStyle/>
-          <a:p>
-            <a:pPr algn="ctr"/>
-          </a:p>
-        </p:txBody>
-      </p:sp>
-      <p:sp>
-        <p:nvSpPr>
-          <p:cNvPr id="19" name="TextBox 18"/>
-          <p:cNvSpPr txBox="1"/>
-          <p:nvPr/>
-        </p:nvSpPr>
-        <p:spPr>
-          <a:xfrm>
-            <a:off x="4745736" y="1078992"/>
-            <a:ext cx="7022592" cy="329184"/>
-          </a:xfrm>
-          <a:prstGeom prst="rect">
-            <a:avLst/>
-          </a:prstGeom>
-          <a:noFill/>
-        </p:spPr>
-        <p:txBody>
-          <a:bodyPr wrap="square" anchor="t" lIns="0" rIns="0" tIns="0" bIns="0">
-            <a:spAutoFit/>
-          </a:bodyPr>
-          <a:lstStyle/>
-          <a:p>
-            <a:pPr algn="l">
-              <a:lnSpc>
-                <a:spcPct val="102000"/>
-              </a:lnSpc>
-              <a:spcBef>
-                <a:spcPts val="0"/>
-              </a:spcBef>
-              <a:spcAft>
-                <a:spcPts val="0"/>
-              </a:spcAft>
-            </a:pPr>
-            <a:r>
-              <a:rPr sz="700" b="0" i="0">
-                <a:solidFill>
-                  <a:srgbClr val="C2C2D0"/>
-                </a:solidFill>
-                <a:latin typeface="Segoe UI"/>
-              </a:rPr>
-              <a:t>The </a:t>
-            </a:r>
-            <a:r>
-              <a:rPr sz="700" b="1" i="0">
-                <a:solidFill>
-                  <a:srgbClr val="4A9EFF"/>
-                </a:solidFill>
-                <a:latin typeface="Segoe UI"/>
-              </a:rPr>
-              <a:t>🤖 Intake Agent</a:t>
-            </a:r>
-            <a:r>
-              <a:rPr sz="700" b="0" i="0">
-                <a:solidFill>
-                  <a:srgbClr val="FFFFFF"/>
-                </a:solidFill>
-                <a:latin typeface="Segoe UI"/>
-              </a:rPr>
-              <a:t> reads every PO and extracts: SKU · qty · UOM · ship-to ZIP · delivery date · PO number · customer / buyer</a:t>
-            </a:r>
-          </a:p>
-        </p:txBody>
-      </p:sp>
-      <p:sp>
-        <p:nvSpPr>
-          <p:cNvPr id="20" name="Rounded Rectangle 19"/>
           <p:cNvSpPr/>
           <p:nvPr/>
         </p:nvSpPr>
@@ -4140,7 +3985,7 @@
       </p:sp>
       <p:sp>
         <p:nvSpPr>
-          <p:cNvPr id="21" name="Rounded Rectangle 20"/>
+          <p:cNvPr id="18" name="Rounded Rectangle 17"/>
           <p:cNvSpPr/>
           <p:nvPr/>
         </p:nvSpPr>
@@ -4216,7 +4061,7 @@
       </p:sp>
       <p:sp>
         <p:nvSpPr>
-          <p:cNvPr id="22" name="Down Arrow 21"/>
+          <p:cNvPr id="19" name="Down Arrow 18"/>
           <p:cNvSpPr/>
           <p:nvPr/>
         </p:nvSpPr>
@@ -4260,7 +4105,7 @@
       </p:sp>
       <p:sp>
         <p:nvSpPr>
-          <p:cNvPr id="23" name="Rounded Rectangle 22"/>
+          <p:cNvPr id="20" name="Rounded Rectangle 19"/>
           <p:cNvSpPr/>
           <p:nvPr/>
         </p:nvSpPr>
@@ -4380,7 +4225,7 @@
       </p:sp>
       <p:sp>
         <p:nvSpPr>
-          <p:cNvPr id="24" name="Rectangle 23"/>
+          <p:cNvPr id="21" name="Rectangle 20"/>
           <p:cNvSpPr/>
           <p:nvPr/>
         </p:nvSpPr>
@@ -4424,7 +4269,7 @@
       </p:sp>
       <p:sp>
         <p:nvSpPr>
-          <p:cNvPr id="25" name="Chevron 24"/>
+          <p:cNvPr id="22" name="Chevron 21"/>
           <p:cNvSpPr/>
           <p:nvPr/>
         </p:nvSpPr>
@@ -4468,7 +4313,7 @@
       </p:sp>
       <p:sp>
         <p:nvSpPr>
-          <p:cNvPr id="26" name="Rounded Rectangle 25"/>
+          <p:cNvPr id="23" name="Rounded Rectangle 22"/>
           <p:cNvSpPr/>
           <p:nvPr/>
         </p:nvSpPr>
@@ -4588,7 +4433,7 @@
       </p:sp>
       <p:sp>
         <p:nvSpPr>
-          <p:cNvPr id="27" name="Rectangle 26"/>
+          <p:cNvPr id="24" name="Rectangle 23"/>
           <p:cNvSpPr/>
           <p:nvPr/>
         </p:nvSpPr>
@@ -4632,7 +4477,7 @@
       </p:sp>
       <p:sp>
         <p:nvSpPr>
-          <p:cNvPr id="28" name="Chevron 27"/>
+          <p:cNvPr id="25" name="Chevron 24"/>
           <p:cNvSpPr/>
           <p:nvPr/>
         </p:nvSpPr>
@@ -4676,7 +4521,7 @@
       </p:sp>
       <p:sp>
         <p:nvSpPr>
-          <p:cNvPr id="29" name="Rounded Rectangle 28"/>
+          <p:cNvPr id="26" name="Rounded Rectangle 25"/>
           <p:cNvSpPr/>
           <p:nvPr/>
         </p:nvSpPr>
@@ -4796,7 +4641,7 @@
       </p:sp>
       <p:sp>
         <p:nvSpPr>
-          <p:cNvPr id="30" name="Rectangle 29"/>
+          <p:cNvPr id="27" name="Rectangle 26"/>
           <p:cNvSpPr/>
           <p:nvPr/>
         </p:nvSpPr>
@@ -4840,7 +4685,7 @@
       </p:sp>
       <p:sp>
         <p:nvSpPr>
-          <p:cNvPr id="31" name="Chevron 30"/>
+          <p:cNvPr id="28" name="Chevron 27"/>
           <p:cNvSpPr/>
           <p:nvPr/>
         </p:nvSpPr>
@@ -4884,7 +4729,7 @@
       </p:sp>
       <p:sp>
         <p:nvSpPr>
-          <p:cNvPr id="32" name="Rounded Rectangle 31"/>
+          <p:cNvPr id="29" name="Rounded Rectangle 28"/>
           <p:cNvSpPr/>
           <p:nvPr/>
         </p:nvSpPr>
@@ -5004,7 +4849,7 @@
       </p:sp>
       <p:sp>
         <p:nvSpPr>
-          <p:cNvPr id="33" name="Rectangle 32"/>
+          <p:cNvPr id="30" name="Rectangle 29"/>
           <p:cNvSpPr/>
           <p:nvPr/>
         </p:nvSpPr>
@@ -5048,7 +4893,7 @@
       </p:sp>
       <p:sp>
         <p:nvSpPr>
-          <p:cNvPr id="34" name="Chevron 33"/>
+          <p:cNvPr id="31" name="Chevron 30"/>
           <p:cNvSpPr/>
           <p:nvPr/>
         </p:nvSpPr>
@@ -5092,7 +4937,7 @@
       </p:sp>
       <p:sp>
         <p:nvSpPr>
-          <p:cNvPr id="35" name="Rounded Rectangle 34"/>
+          <p:cNvPr id="32" name="Rounded Rectangle 31"/>
           <p:cNvSpPr/>
           <p:nvPr/>
         </p:nvSpPr>
@@ -5212,7 +5057,7 @@
       </p:sp>
       <p:sp>
         <p:nvSpPr>
-          <p:cNvPr id="36" name="Rectangle 35"/>
+          <p:cNvPr id="33" name="Rectangle 32"/>
           <p:cNvSpPr/>
           <p:nvPr/>
         </p:nvSpPr>
@@ -5256,7 +5101,7 @@
       </p:sp>
       <p:sp>
         <p:nvSpPr>
-          <p:cNvPr id="37" name="Chevron 36"/>
+          <p:cNvPr id="34" name="Chevron 33"/>
           <p:cNvSpPr/>
           <p:nvPr/>
         </p:nvSpPr>
@@ -5300,7 +5145,7 @@
       </p:sp>
       <p:sp>
         <p:nvSpPr>
-          <p:cNvPr id="38" name="Rounded Rectangle 37"/>
+          <p:cNvPr id="35" name="Rounded Rectangle 34"/>
           <p:cNvSpPr/>
           <p:nvPr/>
         </p:nvSpPr>
@@ -5420,7 +5265,7 @@
       </p:sp>
       <p:sp>
         <p:nvSpPr>
-          <p:cNvPr id="39" name="Rectangle 38"/>
+          <p:cNvPr id="36" name="Rectangle 35"/>
           <p:cNvSpPr/>
           <p:nvPr/>
         </p:nvSpPr>
@@ -5464,7 +5309,7 @@
       </p:sp>
       <p:sp>
         <p:nvSpPr>
-          <p:cNvPr id="40" name="Chevron 39"/>
+          <p:cNvPr id="37" name="Chevron 36"/>
           <p:cNvSpPr/>
           <p:nvPr/>
         </p:nvSpPr>
@@ -5508,7 +5353,7 @@
       </p:sp>
       <p:sp>
         <p:nvSpPr>
-          <p:cNvPr id="41" name="Rounded Rectangle 40"/>
+          <p:cNvPr id="38" name="Rounded Rectangle 37"/>
           <p:cNvSpPr/>
           <p:nvPr/>
         </p:nvSpPr>
@@ -5628,7 +5473,7 @@
       </p:sp>
       <p:sp>
         <p:nvSpPr>
-          <p:cNvPr id="42" name="Rectangle 41"/>
+          <p:cNvPr id="39" name="Rectangle 38"/>
           <p:cNvSpPr/>
           <p:nvPr/>
         </p:nvSpPr>
@@ -5672,7 +5517,7 @@
       </p:sp>
       <p:sp>
         <p:nvSpPr>
-          <p:cNvPr id="43" name="Chevron 42"/>
+          <p:cNvPr id="40" name="Chevron 39"/>
           <p:cNvSpPr/>
           <p:nvPr/>
         </p:nvSpPr>
@@ -5716,7 +5561,7 @@
       </p:sp>
       <p:sp>
         <p:nvSpPr>
-          <p:cNvPr id="44" name="Rounded Rectangle 43"/>
+          <p:cNvPr id="41" name="Rounded Rectangle 40"/>
           <p:cNvSpPr/>
           <p:nvPr/>
         </p:nvSpPr>
@@ -5836,7 +5681,7 @@
       </p:sp>
       <p:sp>
         <p:nvSpPr>
-          <p:cNvPr id="45" name="Rectangle 44"/>
+          <p:cNvPr id="42" name="Rectangle 41"/>
           <p:cNvSpPr/>
           <p:nvPr/>
         </p:nvSpPr>
@@ -5880,7 +5725,7 @@
       </p:sp>
       <p:sp>
         <p:nvSpPr>
-          <p:cNvPr id="46" name="Chevron 45"/>
+          <p:cNvPr id="43" name="Chevron 42"/>
           <p:cNvSpPr/>
           <p:nvPr/>
         </p:nvSpPr>
@@ -5924,7 +5769,7 @@
       </p:sp>
       <p:sp>
         <p:nvSpPr>
-          <p:cNvPr id="47" name="Rounded Rectangle 46"/>
+          <p:cNvPr id="44" name="Rounded Rectangle 43"/>
           <p:cNvSpPr/>
           <p:nvPr/>
         </p:nvSpPr>
@@ -6044,7 +5889,7 @@
       </p:sp>
       <p:sp>
         <p:nvSpPr>
-          <p:cNvPr id="48" name="Rectangle 47"/>
+          <p:cNvPr id="45" name="Rectangle 44"/>
           <p:cNvSpPr/>
           <p:nvPr/>
         </p:nvSpPr>
@@ -6088,7 +5933,7 @@
       </p:sp>
       <p:cxnSp>
         <p:nvCxnSpPr>
-          <p:cNvPr id="49" name="Connector 48"/>
+          <p:cNvPr id="46" name="Connector 45"/>
           <p:cNvCxnSpPr/>
           <p:nvPr/>
         </p:nvCxnSpPr>
@@ -6127,7 +5972,7 @@
       </p:cxnSp>
       <p:cxnSp>
         <p:nvCxnSpPr>
-          <p:cNvPr id="50" name="Connector 49"/>
+          <p:cNvPr id="47" name="Connector 46"/>
           <p:cNvCxnSpPr/>
           <p:nvPr/>
         </p:nvCxnSpPr>
@@ -6166,7 +6011,7 @@
       </p:cxnSp>
       <p:cxnSp>
         <p:nvCxnSpPr>
-          <p:cNvPr id="51" name="Connector 50"/>
+          <p:cNvPr id="48" name="Connector 47"/>
           <p:cNvCxnSpPr/>
           <p:nvPr/>
         </p:nvCxnSpPr>
@@ -6205,7 +6050,7 @@
       </p:cxnSp>
       <p:cxnSp>
         <p:nvCxnSpPr>
-          <p:cNvPr id="52" name="Connector 51"/>
+          <p:cNvPr id="49" name="Connector 48"/>
           <p:cNvCxnSpPr/>
           <p:nvPr/>
         </p:nvCxnSpPr>
@@ -6244,7 +6089,7 @@
       </p:cxnSp>
       <p:cxnSp>
         <p:nvCxnSpPr>
-          <p:cNvPr id="53" name="Connector 52"/>
+          <p:cNvPr id="50" name="Connector 49"/>
           <p:cNvCxnSpPr/>
           <p:nvPr/>
         </p:nvCxnSpPr>
@@ -6283,7 +6128,7 @@
       </p:cxnSp>
       <p:cxnSp>
         <p:nvCxnSpPr>
-          <p:cNvPr id="54" name="Connector 53"/>
+          <p:cNvPr id="51" name="Connector 50"/>
           <p:cNvCxnSpPr/>
           <p:nvPr/>
         </p:nvCxnSpPr>
@@ -6322,7 +6167,7 @@
       </p:cxnSp>
       <p:cxnSp>
         <p:nvCxnSpPr>
-          <p:cNvPr id="55" name="Connector 54"/>
+          <p:cNvPr id="52" name="Connector 51"/>
           <p:cNvCxnSpPr/>
           <p:nvPr/>
         </p:nvCxnSpPr>
@@ -6361,7 +6206,7 @@
       </p:cxnSp>
       <p:cxnSp>
         <p:nvCxnSpPr>
-          <p:cNvPr id="56" name="Connector 55"/>
+          <p:cNvPr id="53" name="Connector 52"/>
           <p:cNvCxnSpPr/>
           <p:nvPr/>
         </p:nvCxnSpPr>
@@ -6400,7 +6245,7 @@
       </p:cxnSp>
       <p:cxnSp>
         <p:nvCxnSpPr>
-          <p:cNvPr id="57" name="Connector 56"/>
+          <p:cNvPr id="54" name="Connector 53"/>
           <p:cNvCxnSpPr/>
           <p:nvPr/>
         </p:nvCxnSpPr>
@@ -6439,7 +6284,7 @@
       </p:cxnSp>
       <p:sp>
         <p:nvSpPr>
-          <p:cNvPr id="58" name="Rounded Rectangle 57"/>
+          <p:cNvPr id="55" name="Rounded Rectangle 54"/>
           <p:cNvSpPr/>
           <p:nvPr/>
         </p:nvSpPr>
@@ -6515,7 +6360,7 @@
       </p:sp>
       <p:sp>
         <p:nvSpPr>
-          <p:cNvPr id="59" name="Rectangle 58"/>
+          <p:cNvPr id="56" name="Rectangle 55"/>
           <p:cNvSpPr/>
           <p:nvPr/>
         </p:nvSpPr>
@@ -6559,7 +6404,7 @@
       </p:sp>
       <p:sp>
         <p:nvSpPr>
-          <p:cNvPr id="60" name="TextBox 59"/>
+          <p:cNvPr id="57" name="TextBox 56"/>
           <p:cNvSpPr txBox="1"/>
           <p:nvPr/>
         </p:nvSpPr>
@@ -6613,7 +6458,7 @@
       </p:sp>
       <p:sp>
         <p:nvSpPr>
-          <p:cNvPr id="61" name="Rounded Rectangle 60"/>
+          <p:cNvPr id="58" name="Rounded Rectangle 57"/>
           <p:cNvSpPr/>
           <p:nvPr/>
         </p:nvSpPr>
@@ -6702,7 +6547,7 @@
       </p:sp>
       <p:sp>
         <p:nvSpPr>
-          <p:cNvPr id="62" name="Chevron 61"/>
+          <p:cNvPr id="59" name="Chevron 58"/>
           <p:cNvSpPr/>
           <p:nvPr/>
         </p:nvSpPr>
@@ -6746,7 +6591,7 @@
       </p:sp>
       <p:sp>
         <p:nvSpPr>
-          <p:cNvPr id="63" name="Rounded Rectangle 62"/>
+          <p:cNvPr id="60" name="Rounded Rectangle 59"/>
           <p:cNvSpPr/>
           <p:nvPr/>
         </p:nvSpPr>
@@ -6835,7 +6680,7 @@
       </p:sp>
       <p:sp>
         <p:nvSpPr>
-          <p:cNvPr id="64" name="Rounded Rectangle 63"/>
+          <p:cNvPr id="61" name="Rounded Rectangle 60"/>
           <p:cNvSpPr/>
           <p:nvPr/>
         </p:nvSpPr>
@@ -6924,7 +6769,7 @@
       </p:sp>
       <p:sp>
         <p:nvSpPr>
-          <p:cNvPr id="65" name="Rounded Rectangle 64"/>
+          <p:cNvPr id="62" name="Rounded Rectangle 61"/>
           <p:cNvSpPr/>
           <p:nvPr/>
         </p:nvSpPr>
@@ -7013,7 +6858,7 @@
       </p:sp>
       <p:sp>
         <p:nvSpPr>
-          <p:cNvPr id="66" name="Rounded Rectangle 65"/>
+          <p:cNvPr id="63" name="Rounded Rectangle 62"/>
           <p:cNvSpPr/>
           <p:nvPr/>
         </p:nvSpPr>
@@ -7102,7 +6947,7 @@
       </p:sp>
       <p:sp>
         <p:nvSpPr>
-          <p:cNvPr id="67" name="Rounded Rectangle 66"/>
+          <p:cNvPr id="64" name="Rounded Rectangle 63"/>
           <p:cNvSpPr/>
           <p:nvPr/>
         </p:nvSpPr>
@@ -7191,7 +7036,7 @@
       </p:sp>
       <p:sp>
         <p:nvSpPr>
-          <p:cNvPr id="68" name="Rounded Rectangle 67"/>
+          <p:cNvPr id="65" name="Rounded Rectangle 64"/>
           <p:cNvSpPr/>
           <p:nvPr/>
         </p:nvSpPr>
@@ -7280,7 +7125,7 @@
       </p:sp>
       <p:sp>
         <p:nvSpPr>
-          <p:cNvPr id="69" name="Down Arrow 68"/>
+          <p:cNvPr id="66" name="Down Arrow 65"/>
           <p:cNvSpPr/>
           <p:nvPr/>
         </p:nvSpPr>
@@ -7324,7 +7169,7 @@
       </p:sp>
       <p:sp>
         <p:nvSpPr>
-          <p:cNvPr id="70" name="Down Arrow 69"/>
+          <p:cNvPr id="67" name="Down Arrow 66"/>
           <p:cNvSpPr/>
           <p:nvPr/>
         </p:nvSpPr>
@@ -7368,7 +7213,7 @@
       </p:sp>
       <p:sp>
         <p:nvSpPr>
-          <p:cNvPr id="71" name="TextBox 70"/>
+          <p:cNvPr id="68" name="TextBox 67"/>
           <p:cNvSpPr txBox="1"/>
           <p:nvPr/>
         </p:nvSpPr>

</xml_diff>

<commit_message>
docs: center-align PO intake box title and text in architecture slide
</commit_message>
<xml_diff>
--- a/demo/Order-Creation-Orchestration-Architecture.pptx
+++ b/demo/Order-Creation-Orchestration-Architecture.pptx
@@ -3867,7 +3867,7 @@
           </a:bodyPr>
           <a:lstStyle/>
           <a:p>
-            <a:pPr algn="l">
+            <a:pPr algn="ctr">
               <a:lnSpc>
                 <a:spcPct val="100000"/>
               </a:lnSpc>
@@ -3912,7 +3912,7 @@
           </a:bodyPr>
           <a:lstStyle/>
           <a:p>
-            <a:pPr algn="l">
+            <a:pPr algn="ctr">
               <a:lnSpc>
                 <a:spcPct val="104000"/>
               </a:lnSpc>

</xml_diff>

<commit_message>
docs: shorten orchestrator caption, remove box, center-align in architecture slide
</commit_message>
<xml_diff>
--- a/demo/Order-Creation-Orchestration-Architecture.pptx
+++ b/demo/Order-Creation-Orchestration-Architecture.pptx
@@ -3985,49 +3985,27 @@
       </p:sp>
       <p:sp>
         <p:nvSpPr>
-          <p:cNvPr id="18" name="Rounded Rectangle 17"/>
-          <p:cNvSpPr/>
+          <p:cNvPr id="18" name="TextBox 17"/>
+          <p:cNvSpPr txBox="1"/>
           <p:nvPr/>
         </p:nvSpPr>
         <p:spPr>
           <a:xfrm>
-            <a:off x="1700784" y="1682495"/>
-            <a:ext cx="10058400" cy="365760"/>
-          </a:xfrm>
-          <a:prstGeom prst="roundRect">
-            <a:avLst>
-              <a:gd name="adj" fmla="val 6000"/>
-            </a:avLst>
+            <a:off x="1700784" y="1737360"/>
+            <a:ext cx="10058400" cy="237744"/>
+          </a:xfrm>
+          <a:prstGeom prst="rect">
+            <a:avLst/>
           </a:prstGeom>
-          <a:solidFill>
-            <a:srgbClr val="2E2E40"/>
-          </a:solidFill>
-          <a:ln w="12700">
-            <a:solidFill>
-              <a:srgbClr val="FFE600"/>
-            </a:solidFill>
-          </a:ln>
-          <a:effectLst/>
-        </p:spPr>
-        <p:style>
-          <a:lnRef idx="1">
-            <a:schemeClr val="accent1"/>
-          </a:lnRef>
-          <a:fillRef idx="3">
-            <a:schemeClr val="accent1"/>
-          </a:fillRef>
-          <a:effectRef idx="2">
-            <a:schemeClr val="accent1"/>
-          </a:effectRef>
-          <a:fontRef idx="minor">
-            <a:schemeClr val="lt1"/>
-          </a:fontRef>
-        </p:style>
-        <p:txBody>
-          <a:bodyPr rtlCol="0" anchor="ctr" wrap="square" lIns="27432" rIns="27432" tIns="9144" bIns="9144"/>
-          <a:lstStyle/>
-          <a:p>
-            <a:pPr algn="l">
+          <a:noFill/>
+        </p:spPr>
+        <p:txBody>
+          <a:bodyPr wrap="square" anchor="t" lIns="0" rIns="0" tIns="0" bIns="0">
+            <a:spAutoFit/>
+          </a:bodyPr>
+          <a:lstStyle/>
+          <a:p>
+            <a:pPr algn="ctr">
               <a:lnSpc>
                 <a:spcPct val="100000"/>
               </a:lnSpc>
@@ -4039,7 +4017,7 @@
               </a:spcAft>
             </a:pPr>
             <a:r>
-              <a:rPr sz="940" b="1" i="0">
+              <a:rPr sz="960" b="1" i="0">
                 <a:solidFill>
                   <a:srgbClr val="FFE600"/>
                 </a:solidFill>
@@ -4048,13 +4026,13 @@
               <a:t>🤖  ORCHESTRATOR  </a:t>
             </a:r>
             <a:r>
-              <a:rPr sz="740" b="0" i="0">
+              <a:rPr sz="800" b="0" i="0">
                 <a:solidFill>
                   <a:srgbClr val="C2C2D0"/>
                 </a:solidFill>
                 <a:latin typeface="Segoe UI"/>
               </a:rPr>
-              <a:t>coordinates a team of specialist AI agents over a shared context · resumable, pause-and-resume workflow · Approvals runs last</a:t>
+              <a:t>— coordinates the specialist AI agents over a shared context</a:t>
             </a:r>
           </a:p>
         </p:txBody>

</xml_diff>

<commit_message>
docs: remove intake header line and left PO Intake tier label in architecture slide
</commit_message>
<xml_diff>
--- a/demo/Order-Creation-Orchestration-Architecture.pptx
+++ b/demo/Order-Creation-Orchestration-Architecture.pptx
@@ -3283,8 +3283,8 @@
         </p:nvSpPr>
         <p:spPr>
           <a:xfrm>
-            <a:off x="301752" y="749808"/>
-            <a:ext cx="1170432" cy="731520"/>
+            <a:off x="301752" y="1572768"/>
+            <a:ext cx="1170432" cy="3200400"/>
           </a:xfrm>
           <a:prstGeom prst="roundRect">
             <a:avLst>
@@ -3335,7 +3335,7 @@
                 </a:solidFill>
                 <a:latin typeface="Segoe UI"/>
               </a:rPr>
-              <a:t>PO</a:t>
+              <a:t>ORCHESTRATION</a:t>
             </a:r>
           </a:p>
           <a:p>
@@ -3357,7 +3357,29 @@
                 </a:solidFill>
                 <a:latin typeface="Segoe UI"/>
               </a:rPr>
-              <a:t>INTAKE</a:t>
+              <a:t>&amp; HUMAN</a:t>
+            </a:r>
+          </a:p>
+          <a:p>
+            <a:pPr algn="ctr">
+              <a:lnSpc>
+                <a:spcPct val="98000"/>
+              </a:lnSpc>
+              <a:spcBef>
+                <a:spcPts val="0"/>
+              </a:spcBef>
+              <a:spcAft>
+                <a:spcPts val="0"/>
+              </a:spcAft>
+            </a:pPr>
+            <a:r>
+              <a:rPr sz="830" b="1" i="0">
+                <a:solidFill>
+                  <a:srgbClr val="FFFFFF"/>
+                </a:solidFill>
+                <a:latin typeface="Segoe UI"/>
+              </a:rPr>
+              <a:t>DECISIONS</a:t>
             </a:r>
           </a:p>
         </p:txBody>
@@ -3370,14 +3392,14 @@
         </p:nvSpPr>
         <p:spPr>
           <a:xfrm>
-            <a:off x="301752" y="749808"/>
-            <a:ext cx="54864" cy="731520"/>
+            <a:off x="301752" y="1572768"/>
+            <a:ext cx="54864" cy="3200400"/>
           </a:xfrm>
           <a:prstGeom prst="rect">
             <a:avLst/>
           </a:prstGeom>
           <a:solidFill>
-            <a:srgbClr val="4A9EFF"/>
+            <a:srgbClr val="FFE600"/>
           </a:solidFill>
           <a:ln>
             <a:noFill/>
@@ -3414,8 +3436,8 @@
         </p:nvSpPr>
         <p:spPr>
           <a:xfrm>
-            <a:off x="301752" y="1572768"/>
-            <a:ext cx="1170432" cy="3200400"/>
+            <a:off x="301752" y="4882896"/>
+            <a:ext cx="1170432" cy="1024128"/>
           </a:xfrm>
           <a:prstGeom prst="roundRect">
             <a:avLst>
@@ -3466,7 +3488,7 @@
                 </a:solidFill>
                 <a:latin typeface="Segoe UI"/>
               </a:rPr>
-              <a:t>ORCHESTRATION</a:t>
+              <a:t>ORDER CREATION</a:t>
             </a:r>
           </a:p>
           <a:p>
@@ -3488,29 +3510,7 @@
                 </a:solidFill>
                 <a:latin typeface="Segoe UI"/>
               </a:rPr>
-              <a:t>&amp; HUMAN</a:t>
-            </a:r>
-          </a:p>
-          <a:p>
-            <a:pPr algn="ctr">
-              <a:lnSpc>
-                <a:spcPct val="98000"/>
-              </a:lnSpc>
-              <a:spcBef>
-                <a:spcPts val="0"/>
-              </a:spcBef>
-              <a:spcAft>
-                <a:spcPts val="0"/>
-              </a:spcAft>
-            </a:pPr>
-            <a:r>
-              <a:rPr sz="830" b="1" i="0">
-                <a:solidFill>
-                  <a:srgbClr val="FFFFFF"/>
-                </a:solidFill>
-                <a:latin typeface="Segoe UI"/>
-              </a:rPr>
-              <a:t>DECISIONS</a:t>
+              <a:t>&amp; DOWNSTREAM</a:t>
             </a:r>
           </a:p>
         </p:txBody>
@@ -3518,137 +3518,6 @@
       <p:sp>
         <p:nvSpPr>
           <p:cNvPr id="9" name="Rectangle 8"/>
-          <p:cNvSpPr/>
-          <p:nvPr/>
-        </p:nvSpPr>
-        <p:spPr>
-          <a:xfrm>
-            <a:off x="301752" y="1572768"/>
-            <a:ext cx="54864" cy="3200400"/>
-          </a:xfrm>
-          <a:prstGeom prst="rect">
-            <a:avLst/>
-          </a:prstGeom>
-          <a:solidFill>
-            <a:srgbClr val="FFE600"/>
-          </a:solidFill>
-          <a:ln>
-            <a:noFill/>
-          </a:ln>
-          <a:effectLst/>
-        </p:spPr>
-        <p:style>
-          <a:lnRef idx="1">
-            <a:schemeClr val="accent1"/>
-          </a:lnRef>
-          <a:fillRef idx="3">
-            <a:schemeClr val="accent1"/>
-          </a:fillRef>
-          <a:effectRef idx="2">
-            <a:schemeClr val="accent1"/>
-          </a:effectRef>
-          <a:fontRef idx="minor">
-            <a:schemeClr val="lt1"/>
-          </a:fontRef>
-        </p:style>
-        <p:txBody>
-          <a:bodyPr rtlCol="0" anchor="ctr" wrap="square"/>
-          <a:lstStyle/>
-          <a:p>
-            <a:pPr algn="ctr"/>
-          </a:p>
-        </p:txBody>
-      </p:sp>
-      <p:sp>
-        <p:nvSpPr>
-          <p:cNvPr id="10" name="Rounded Rectangle 9"/>
-          <p:cNvSpPr/>
-          <p:nvPr/>
-        </p:nvSpPr>
-        <p:spPr>
-          <a:xfrm>
-            <a:off x="301752" y="4882896"/>
-            <a:ext cx="1170432" cy="1024128"/>
-          </a:xfrm>
-          <a:prstGeom prst="roundRect">
-            <a:avLst>
-              <a:gd name="adj" fmla="val 6000"/>
-            </a:avLst>
-          </a:prstGeom>
-          <a:solidFill>
-            <a:srgbClr val="222230"/>
-          </a:solidFill>
-          <a:ln>
-            <a:noFill/>
-          </a:ln>
-          <a:effectLst/>
-        </p:spPr>
-        <p:style>
-          <a:lnRef idx="1">
-            <a:schemeClr val="accent1"/>
-          </a:lnRef>
-          <a:fillRef idx="3">
-            <a:schemeClr val="accent1"/>
-          </a:fillRef>
-          <a:effectRef idx="2">
-            <a:schemeClr val="accent1"/>
-          </a:effectRef>
-          <a:fontRef idx="minor">
-            <a:schemeClr val="lt1"/>
-          </a:fontRef>
-        </p:style>
-        <p:txBody>
-          <a:bodyPr rtlCol="0" anchor="ctr" wrap="square" lIns="27432" rIns="27432" tIns="9144" bIns="9144"/>
-          <a:lstStyle/>
-          <a:p>
-            <a:pPr algn="ctr">
-              <a:lnSpc>
-                <a:spcPct val="98000"/>
-              </a:lnSpc>
-              <a:spcBef>
-                <a:spcPts val="0"/>
-              </a:spcBef>
-              <a:spcAft>
-                <a:spcPts val="0"/>
-              </a:spcAft>
-            </a:pPr>
-            <a:r>
-              <a:rPr sz="830" b="1" i="0">
-                <a:solidFill>
-                  <a:srgbClr val="FFFFFF"/>
-                </a:solidFill>
-                <a:latin typeface="Segoe UI"/>
-              </a:rPr>
-              <a:t>ORDER CREATION</a:t>
-            </a:r>
-          </a:p>
-          <a:p>
-            <a:pPr algn="ctr">
-              <a:lnSpc>
-                <a:spcPct val="98000"/>
-              </a:lnSpc>
-              <a:spcBef>
-                <a:spcPts val="0"/>
-              </a:spcBef>
-              <a:spcAft>
-                <a:spcPts val="0"/>
-              </a:spcAft>
-            </a:pPr>
-            <a:r>
-              <a:rPr sz="830" b="1" i="0">
-                <a:solidFill>
-                  <a:srgbClr val="FFFFFF"/>
-                </a:solidFill>
-                <a:latin typeface="Segoe UI"/>
-              </a:rPr>
-              <a:t>&amp; DOWNSTREAM</a:t>
-            </a:r>
-          </a:p>
-        </p:txBody>
-      </p:sp>
-      <p:sp>
-        <p:nvSpPr>
-          <p:cNvPr id="11" name="Rectangle 10"/>
           <p:cNvSpPr/>
           <p:nvPr/>
         </p:nvSpPr>
@@ -3692,77 +3561,14 @@
       </p:sp>
       <p:sp>
         <p:nvSpPr>
-          <p:cNvPr id="12" name="TextBox 11"/>
-          <p:cNvSpPr txBox="1"/>
-          <p:nvPr/>
-        </p:nvSpPr>
-        <p:spPr>
-          <a:xfrm>
-            <a:off x="1591056" y="768096"/>
-            <a:ext cx="10222992" cy="182880"/>
-          </a:xfrm>
-          <a:prstGeom prst="rect">
-            <a:avLst/>
-          </a:prstGeom>
-          <a:noFill/>
-        </p:spPr>
-        <p:txBody>
-          <a:bodyPr wrap="square" anchor="t" lIns="0" rIns="0" tIns="0" bIns="0">
-            <a:spAutoFit/>
-          </a:bodyPr>
-          <a:lstStyle/>
-          <a:p>
-            <a:pPr algn="l">
-              <a:lnSpc>
-                <a:spcPct val="100000"/>
-              </a:lnSpc>
-              <a:spcBef>
-                <a:spcPts val="0"/>
-              </a:spcBef>
-              <a:spcAft>
-                <a:spcPts val="0"/>
-              </a:spcAft>
-            </a:pPr>
-            <a:r>
-              <a:rPr sz="800" b="1" i="0">
-                <a:solidFill>
-                  <a:srgbClr val="FFE600"/>
-                </a:solidFill>
-                <a:latin typeface="Segoe UI"/>
-              </a:rPr>
-              <a:t>PO INTAKE — received via any channel; the </a:t>
-            </a:r>
-            <a:r>
-              <a:rPr sz="800" b="1" i="0">
-                <a:solidFill>
-                  <a:srgbClr val="FFFFFF"/>
-                </a:solidFill>
-                <a:latin typeface="Segoe UI"/>
-              </a:rPr>
-              <a:t>🤖 Intake Agent</a:t>
-            </a:r>
-            <a:r>
-              <a:rPr sz="800" b="1" i="0">
-                <a:solidFill>
-                  <a:srgbClr val="FFE600"/>
-                </a:solidFill>
-                <a:latin typeface="Segoe UI"/>
-              </a:rPr>
-              <a:t> is the first agent in the orchestration below</a:t>
-            </a:r>
-          </a:p>
-        </p:txBody>
-      </p:sp>
-      <p:sp>
-        <p:nvSpPr>
-          <p:cNvPr id="13" name="Rounded Rectangle 12"/>
+          <p:cNvPr id="10" name="Rounded Rectangle 9"/>
           <p:cNvSpPr/>
           <p:nvPr/>
         </p:nvSpPr>
         <p:spPr>
           <a:xfrm>
-            <a:off x="1618488" y="987552"/>
-            <a:ext cx="10222992" cy="438912"/>
+            <a:off x="1618488" y="896112"/>
+            <a:ext cx="10222992" cy="475488"/>
           </a:xfrm>
           <a:prstGeom prst="roundRect">
             <a:avLst>
@@ -3803,13 +3609,13 @@
       </p:sp>
       <p:sp>
         <p:nvSpPr>
-          <p:cNvPr id="14" name="Rectangle 13"/>
+          <p:cNvPr id="11" name="Rectangle 10"/>
           <p:cNvSpPr/>
           <p:nvPr/>
         </p:nvSpPr>
         <p:spPr>
           <a:xfrm>
-            <a:off x="1618488" y="987552"/>
+            <a:off x="1618488" y="896112"/>
             <a:ext cx="10222992" cy="45720"/>
           </a:xfrm>
           <a:prstGeom prst="rect">
@@ -3847,13 +3653,13 @@
       </p:sp>
       <p:sp>
         <p:nvSpPr>
-          <p:cNvPr id="15" name="TextBox 14"/>
+          <p:cNvPr id="12" name="TextBox 11"/>
           <p:cNvSpPr txBox="1"/>
           <p:nvPr/>
         </p:nvSpPr>
         <p:spPr>
           <a:xfrm>
-            <a:off x="1709928" y="1069848"/>
+            <a:off x="1709928" y="978408"/>
             <a:ext cx="10040112" cy="182880"/>
           </a:xfrm>
           <a:prstGeom prst="rect">
@@ -3892,14 +3698,14 @@
       </p:sp>
       <p:sp>
         <p:nvSpPr>
-          <p:cNvPr id="16" name="TextBox 15"/>
+          <p:cNvPr id="13" name="TextBox 12"/>
           <p:cNvSpPr txBox="1"/>
           <p:nvPr/>
         </p:nvSpPr>
         <p:spPr>
           <a:xfrm>
-            <a:off x="1709928" y="1271016"/>
-            <a:ext cx="10040112" cy="118872"/>
+            <a:off x="1709928" y="1179576"/>
+            <a:ext cx="10040112" cy="155448"/>
           </a:xfrm>
           <a:prstGeom prst="rect">
             <a:avLst/>
@@ -3937,7 +3743,7 @@
       </p:sp>
       <p:sp>
         <p:nvSpPr>
-          <p:cNvPr id="17" name="Rounded Rectangle 16"/>
+          <p:cNvPr id="14" name="Rounded Rectangle 13"/>
           <p:cNvSpPr/>
           <p:nvPr/>
         </p:nvSpPr>
@@ -3985,7 +3791,7 @@
       </p:sp>
       <p:sp>
         <p:nvSpPr>
-          <p:cNvPr id="18" name="TextBox 17"/>
+          <p:cNvPr id="15" name="TextBox 14"/>
           <p:cNvSpPr txBox="1"/>
           <p:nvPr/>
         </p:nvSpPr>
@@ -4039,7 +3845,7 @@
       </p:sp>
       <p:sp>
         <p:nvSpPr>
-          <p:cNvPr id="19" name="Down Arrow 18"/>
+          <p:cNvPr id="16" name="Down Arrow 15"/>
           <p:cNvSpPr/>
           <p:nvPr/>
         </p:nvSpPr>
@@ -4083,7 +3889,7 @@
       </p:sp>
       <p:sp>
         <p:nvSpPr>
-          <p:cNvPr id="20" name="Rounded Rectangle 19"/>
+          <p:cNvPr id="17" name="Rounded Rectangle 16"/>
           <p:cNvSpPr/>
           <p:nvPr/>
         </p:nvSpPr>
@@ -4203,7 +4009,7 @@
       </p:sp>
       <p:sp>
         <p:nvSpPr>
-          <p:cNvPr id="21" name="Rectangle 20"/>
+          <p:cNvPr id="18" name="Rectangle 17"/>
           <p:cNvSpPr/>
           <p:nvPr/>
         </p:nvSpPr>
@@ -4247,7 +4053,7 @@
       </p:sp>
       <p:sp>
         <p:nvSpPr>
-          <p:cNvPr id="22" name="Chevron 21"/>
+          <p:cNvPr id="19" name="Chevron 18"/>
           <p:cNvSpPr/>
           <p:nvPr/>
         </p:nvSpPr>
@@ -4291,7 +4097,7 @@
       </p:sp>
       <p:sp>
         <p:nvSpPr>
-          <p:cNvPr id="23" name="Rounded Rectangle 22"/>
+          <p:cNvPr id="20" name="Rounded Rectangle 19"/>
           <p:cNvSpPr/>
           <p:nvPr/>
         </p:nvSpPr>
@@ -4411,7 +4217,7 @@
       </p:sp>
       <p:sp>
         <p:nvSpPr>
-          <p:cNvPr id="24" name="Rectangle 23"/>
+          <p:cNvPr id="21" name="Rectangle 20"/>
           <p:cNvSpPr/>
           <p:nvPr/>
         </p:nvSpPr>
@@ -4455,7 +4261,7 @@
       </p:sp>
       <p:sp>
         <p:nvSpPr>
-          <p:cNvPr id="25" name="Chevron 24"/>
+          <p:cNvPr id="22" name="Chevron 21"/>
           <p:cNvSpPr/>
           <p:nvPr/>
         </p:nvSpPr>
@@ -4499,7 +4305,7 @@
       </p:sp>
       <p:sp>
         <p:nvSpPr>
-          <p:cNvPr id="26" name="Rounded Rectangle 25"/>
+          <p:cNvPr id="23" name="Rounded Rectangle 22"/>
           <p:cNvSpPr/>
           <p:nvPr/>
         </p:nvSpPr>
@@ -4619,7 +4425,7 @@
       </p:sp>
       <p:sp>
         <p:nvSpPr>
-          <p:cNvPr id="27" name="Rectangle 26"/>
+          <p:cNvPr id="24" name="Rectangle 23"/>
           <p:cNvSpPr/>
           <p:nvPr/>
         </p:nvSpPr>
@@ -4663,7 +4469,7 @@
       </p:sp>
       <p:sp>
         <p:nvSpPr>
-          <p:cNvPr id="28" name="Chevron 27"/>
+          <p:cNvPr id="25" name="Chevron 24"/>
           <p:cNvSpPr/>
           <p:nvPr/>
         </p:nvSpPr>
@@ -4707,7 +4513,7 @@
       </p:sp>
       <p:sp>
         <p:nvSpPr>
-          <p:cNvPr id="29" name="Rounded Rectangle 28"/>
+          <p:cNvPr id="26" name="Rounded Rectangle 25"/>
           <p:cNvSpPr/>
           <p:nvPr/>
         </p:nvSpPr>
@@ -4827,7 +4633,7 @@
       </p:sp>
       <p:sp>
         <p:nvSpPr>
-          <p:cNvPr id="30" name="Rectangle 29"/>
+          <p:cNvPr id="27" name="Rectangle 26"/>
           <p:cNvSpPr/>
           <p:nvPr/>
         </p:nvSpPr>
@@ -4871,7 +4677,7 @@
       </p:sp>
       <p:sp>
         <p:nvSpPr>
-          <p:cNvPr id="31" name="Chevron 30"/>
+          <p:cNvPr id="28" name="Chevron 27"/>
           <p:cNvSpPr/>
           <p:nvPr/>
         </p:nvSpPr>
@@ -4915,7 +4721,7 @@
       </p:sp>
       <p:sp>
         <p:nvSpPr>
-          <p:cNvPr id="32" name="Rounded Rectangle 31"/>
+          <p:cNvPr id="29" name="Rounded Rectangle 28"/>
           <p:cNvSpPr/>
           <p:nvPr/>
         </p:nvSpPr>
@@ -5035,7 +4841,7 @@
       </p:sp>
       <p:sp>
         <p:nvSpPr>
-          <p:cNvPr id="33" name="Rectangle 32"/>
+          <p:cNvPr id="30" name="Rectangle 29"/>
           <p:cNvSpPr/>
           <p:nvPr/>
         </p:nvSpPr>
@@ -5079,7 +4885,7 @@
       </p:sp>
       <p:sp>
         <p:nvSpPr>
-          <p:cNvPr id="34" name="Chevron 33"/>
+          <p:cNvPr id="31" name="Chevron 30"/>
           <p:cNvSpPr/>
           <p:nvPr/>
         </p:nvSpPr>
@@ -5123,7 +4929,7 @@
       </p:sp>
       <p:sp>
         <p:nvSpPr>
-          <p:cNvPr id="35" name="Rounded Rectangle 34"/>
+          <p:cNvPr id="32" name="Rounded Rectangle 31"/>
           <p:cNvSpPr/>
           <p:nvPr/>
         </p:nvSpPr>
@@ -5243,7 +5049,7 @@
       </p:sp>
       <p:sp>
         <p:nvSpPr>
-          <p:cNvPr id="36" name="Rectangle 35"/>
+          <p:cNvPr id="33" name="Rectangle 32"/>
           <p:cNvSpPr/>
           <p:nvPr/>
         </p:nvSpPr>
@@ -5287,7 +5093,7 @@
       </p:sp>
       <p:sp>
         <p:nvSpPr>
-          <p:cNvPr id="37" name="Chevron 36"/>
+          <p:cNvPr id="34" name="Chevron 33"/>
           <p:cNvSpPr/>
           <p:nvPr/>
         </p:nvSpPr>
@@ -5331,7 +5137,7 @@
       </p:sp>
       <p:sp>
         <p:nvSpPr>
-          <p:cNvPr id="38" name="Rounded Rectangle 37"/>
+          <p:cNvPr id="35" name="Rounded Rectangle 34"/>
           <p:cNvSpPr/>
           <p:nvPr/>
         </p:nvSpPr>
@@ -5451,7 +5257,7 @@
       </p:sp>
       <p:sp>
         <p:nvSpPr>
-          <p:cNvPr id="39" name="Rectangle 38"/>
+          <p:cNvPr id="36" name="Rectangle 35"/>
           <p:cNvSpPr/>
           <p:nvPr/>
         </p:nvSpPr>
@@ -5495,7 +5301,7 @@
       </p:sp>
       <p:sp>
         <p:nvSpPr>
-          <p:cNvPr id="40" name="Chevron 39"/>
+          <p:cNvPr id="37" name="Chevron 36"/>
           <p:cNvSpPr/>
           <p:nvPr/>
         </p:nvSpPr>
@@ -5539,7 +5345,7 @@
       </p:sp>
       <p:sp>
         <p:nvSpPr>
-          <p:cNvPr id="41" name="Rounded Rectangle 40"/>
+          <p:cNvPr id="38" name="Rounded Rectangle 37"/>
           <p:cNvSpPr/>
           <p:nvPr/>
         </p:nvSpPr>
@@ -5659,7 +5465,7 @@
       </p:sp>
       <p:sp>
         <p:nvSpPr>
-          <p:cNvPr id="42" name="Rectangle 41"/>
+          <p:cNvPr id="39" name="Rectangle 38"/>
           <p:cNvSpPr/>
           <p:nvPr/>
         </p:nvSpPr>
@@ -5703,7 +5509,7 @@
       </p:sp>
       <p:sp>
         <p:nvSpPr>
-          <p:cNvPr id="43" name="Chevron 42"/>
+          <p:cNvPr id="40" name="Chevron 39"/>
           <p:cNvSpPr/>
           <p:nvPr/>
         </p:nvSpPr>
@@ -5747,7 +5553,7 @@
       </p:sp>
       <p:sp>
         <p:nvSpPr>
-          <p:cNvPr id="44" name="Rounded Rectangle 43"/>
+          <p:cNvPr id="41" name="Rounded Rectangle 40"/>
           <p:cNvSpPr/>
           <p:nvPr/>
         </p:nvSpPr>
@@ -5867,7 +5673,7 @@
       </p:sp>
       <p:sp>
         <p:nvSpPr>
-          <p:cNvPr id="45" name="Rectangle 44"/>
+          <p:cNvPr id="42" name="Rectangle 41"/>
           <p:cNvSpPr/>
           <p:nvPr/>
         </p:nvSpPr>
@@ -5911,7 +5717,7 @@
       </p:sp>
       <p:cxnSp>
         <p:nvCxnSpPr>
-          <p:cNvPr id="46" name="Connector 45"/>
+          <p:cNvPr id="43" name="Connector 42"/>
           <p:cNvCxnSpPr/>
           <p:nvPr/>
         </p:nvCxnSpPr>
@@ -5950,7 +5756,7 @@
       </p:cxnSp>
       <p:cxnSp>
         <p:nvCxnSpPr>
-          <p:cNvPr id="47" name="Connector 46"/>
+          <p:cNvPr id="44" name="Connector 43"/>
           <p:cNvCxnSpPr/>
           <p:nvPr/>
         </p:nvCxnSpPr>
@@ -5989,7 +5795,7 @@
       </p:cxnSp>
       <p:cxnSp>
         <p:nvCxnSpPr>
-          <p:cNvPr id="48" name="Connector 47"/>
+          <p:cNvPr id="45" name="Connector 44"/>
           <p:cNvCxnSpPr/>
           <p:nvPr/>
         </p:nvCxnSpPr>
@@ -6028,7 +5834,7 @@
       </p:cxnSp>
       <p:cxnSp>
         <p:nvCxnSpPr>
-          <p:cNvPr id="49" name="Connector 48"/>
+          <p:cNvPr id="46" name="Connector 45"/>
           <p:cNvCxnSpPr/>
           <p:nvPr/>
         </p:nvCxnSpPr>
@@ -6067,7 +5873,7 @@
       </p:cxnSp>
       <p:cxnSp>
         <p:nvCxnSpPr>
-          <p:cNvPr id="50" name="Connector 49"/>
+          <p:cNvPr id="47" name="Connector 46"/>
           <p:cNvCxnSpPr/>
           <p:nvPr/>
         </p:nvCxnSpPr>
@@ -6106,7 +5912,7 @@
       </p:cxnSp>
       <p:cxnSp>
         <p:nvCxnSpPr>
-          <p:cNvPr id="51" name="Connector 50"/>
+          <p:cNvPr id="48" name="Connector 47"/>
           <p:cNvCxnSpPr/>
           <p:nvPr/>
         </p:nvCxnSpPr>
@@ -6145,7 +5951,7 @@
       </p:cxnSp>
       <p:cxnSp>
         <p:nvCxnSpPr>
-          <p:cNvPr id="52" name="Connector 51"/>
+          <p:cNvPr id="49" name="Connector 48"/>
           <p:cNvCxnSpPr/>
           <p:nvPr/>
         </p:nvCxnSpPr>
@@ -6184,7 +5990,7 @@
       </p:cxnSp>
       <p:cxnSp>
         <p:nvCxnSpPr>
-          <p:cNvPr id="53" name="Connector 52"/>
+          <p:cNvPr id="50" name="Connector 49"/>
           <p:cNvCxnSpPr/>
           <p:nvPr/>
         </p:nvCxnSpPr>
@@ -6223,7 +6029,7 @@
       </p:cxnSp>
       <p:cxnSp>
         <p:nvCxnSpPr>
-          <p:cNvPr id="54" name="Connector 53"/>
+          <p:cNvPr id="51" name="Connector 50"/>
           <p:cNvCxnSpPr/>
           <p:nvPr/>
         </p:nvCxnSpPr>
@@ -6262,7 +6068,7 @@
       </p:cxnSp>
       <p:sp>
         <p:nvSpPr>
-          <p:cNvPr id="55" name="Rounded Rectangle 54"/>
+          <p:cNvPr id="52" name="Rounded Rectangle 51"/>
           <p:cNvSpPr/>
           <p:nvPr/>
         </p:nvSpPr>
@@ -6338,7 +6144,7 @@
       </p:sp>
       <p:sp>
         <p:nvSpPr>
-          <p:cNvPr id="56" name="Rectangle 55"/>
+          <p:cNvPr id="53" name="Rectangle 52"/>
           <p:cNvSpPr/>
           <p:nvPr/>
         </p:nvSpPr>
@@ -6382,7 +6188,7 @@
       </p:sp>
       <p:sp>
         <p:nvSpPr>
-          <p:cNvPr id="57" name="TextBox 56"/>
+          <p:cNvPr id="54" name="TextBox 53"/>
           <p:cNvSpPr txBox="1"/>
           <p:nvPr/>
         </p:nvSpPr>
@@ -6436,7 +6242,7 @@
       </p:sp>
       <p:sp>
         <p:nvSpPr>
-          <p:cNvPr id="58" name="Rounded Rectangle 57"/>
+          <p:cNvPr id="55" name="Rounded Rectangle 54"/>
           <p:cNvSpPr/>
           <p:nvPr/>
         </p:nvSpPr>
@@ -6525,7 +6331,7 @@
       </p:sp>
       <p:sp>
         <p:nvSpPr>
-          <p:cNvPr id="59" name="Chevron 58"/>
+          <p:cNvPr id="56" name="Chevron 55"/>
           <p:cNvSpPr/>
           <p:nvPr/>
         </p:nvSpPr>
@@ -6569,7 +6375,7 @@
       </p:sp>
       <p:sp>
         <p:nvSpPr>
-          <p:cNvPr id="60" name="Rounded Rectangle 59"/>
+          <p:cNvPr id="57" name="Rounded Rectangle 56"/>
           <p:cNvSpPr/>
           <p:nvPr/>
         </p:nvSpPr>
@@ -6658,7 +6464,7 @@
       </p:sp>
       <p:sp>
         <p:nvSpPr>
-          <p:cNvPr id="61" name="Rounded Rectangle 60"/>
+          <p:cNvPr id="58" name="Rounded Rectangle 57"/>
           <p:cNvSpPr/>
           <p:nvPr/>
         </p:nvSpPr>
@@ -6747,7 +6553,7 @@
       </p:sp>
       <p:sp>
         <p:nvSpPr>
-          <p:cNvPr id="62" name="Rounded Rectangle 61"/>
+          <p:cNvPr id="59" name="Rounded Rectangle 58"/>
           <p:cNvSpPr/>
           <p:nvPr/>
         </p:nvSpPr>
@@ -6836,7 +6642,7 @@
       </p:sp>
       <p:sp>
         <p:nvSpPr>
-          <p:cNvPr id="63" name="Rounded Rectangle 62"/>
+          <p:cNvPr id="60" name="Rounded Rectangle 59"/>
           <p:cNvSpPr/>
           <p:nvPr/>
         </p:nvSpPr>
@@ -6925,7 +6731,7 @@
       </p:sp>
       <p:sp>
         <p:nvSpPr>
-          <p:cNvPr id="64" name="Rounded Rectangle 63"/>
+          <p:cNvPr id="61" name="Rounded Rectangle 60"/>
           <p:cNvSpPr/>
           <p:nvPr/>
         </p:nvSpPr>
@@ -7014,7 +6820,7 @@
       </p:sp>
       <p:sp>
         <p:nvSpPr>
-          <p:cNvPr id="65" name="Rounded Rectangle 64"/>
+          <p:cNvPr id="62" name="Rounded Rectangle 61"/>
           <p:cNvSpPr/>
           <p:nvPr/>
         </p:nvSpPr>
@@ -7103,7 +6909,7 @@
       </p:sp>
       <p:sp>
         <p:nvSpPr>
-          <p:cNvPr id="66" name="Down Arrow 65"/>
+          <p:cNvPr id="63" name="Down Arrow 62"/>
           <p:cNvSpPr/>
           <p:nvPr/>
         </p:nvSpPr>
@@ -7147,7 +6953,7 @@
       </p:sp>
       <p:sp>
         <p:nvSpPr>
-          <p:cNvPr id="67" name="Down Arrow 66"/>
+          <p:cNvPr id="64" name="Down Arrow 63"/>
           <p:cNvSpPr/>
           <p:nvPr/>
         </p:nvSpPr>
@@ -7191,7 +6997,7 @@
       </p:sp>
       <p:sp>
         <p:nvSpPr>
-          <p:cNvPr id="68" name="TextBox 67"/>
+          <p:cNvPr id="65" name="TextBox 64"/>
           <p:cNvSpPr txBox="1"/>
           <p:nvPr/>
         </p:nvSpPr>

</xml_diff>

<commit_message>
docs: remove Audit & documents downstream box in architecture slide
</commit_message>
<xml_diff>
--- a/demo/Order-Creation-Orchestration-Architecture.pptx
+++ b/demo/Order-Creation-Orchestration-Architecture.pptx
@@ -6382,7 +6382,7 @@
         <p:spPr>
           <a:xfrm>
             <a:off x="4224528" y="5193792"/>
-            <a:ext cx="1193291" cy="585216"/>
+            <a:ext cx="1450238" cy="585216"/>
           </a:xfrm>
           <a:prstGeom prst="roundRect">
             <a:avLst>
@@ -6470,8 +6470,8 @@
         </p:nvSpPr>
         <p:spPr>
           <a:xfrm>
-            <a:off x="5509260" y="5193792"/>
-            <a:ext cx="1193291" cy="585216"/>
+            <a:off x="5766206" y="5193792"/>
+            <a:ext cx="1450238" cy="585216"/>
           </a:xfrm>
           <a:prstGeom prst="roundRect">
             <a:avLst>
@@ -6559,8 +6559,8 @@
         </p:nvSpPr>
         <p:spPr>
           <a:xfrm>
-            <a:off x="6793992" y="5193792"/>
-            <a:ext cx="1193291" cy="585216"/>
+            <a:off x="7307884" y="5193792"/>
+            <a:ext cx="1450238" cy="585216"/>
           </a:xfrm>
           <a:prstGeom prst="roundRect">
             <a:avLst>
@@ -6648,8 +6648,8 @@
         </p:nvSpPr>
         <p:spPr>
           <a:xfrm>
-            <a:off x="8078724" y="5193792"/>
-            <a:ext cx="1193291" cy="585216"/>
+            <a:off x="8849563" y="5193792"/>
+            <a:ext cx="1450238" cy="585216"/>
           </a:xfrm>
           <a:prstGeom prst="roundRect">
             <a:avLst>
@@ -6737,8 +6737,8 @@
         </p:nvSpPr>
         <p:spPr>
           <a:xfrm>
-            <a:off x="9363455" y="5193792"/>
-            <a:ext cx="1193291" cy="585216"/>
+            <a:off x="10391241" y="5193792"/>
+            <a:ext cx="1450238" cy="585216"/>
           </a:xfrm>
           <a:prstGeom prst="roundRect">
             <a:avLst>
@@ -6820,96 +6820,7 @@
       </p:sp>
       <p:sp>
         <p:nvSpPr>
-          <p:cNvPr id="62" name="Rounded Rectangle 61"/>
-          <p:cNvSpPr/>
-          <p:nvPr/>
-        </p:nvSpPr>
-        <p:spPr>
-          <a:xfrm>
-            <a:off x="10648188" y="5193792"/>
-            <a:ext cx="1193291" cy="585216"/>
-          </a:xfrm>
-          <a:prstGeom prst="roundRect">
-            <a:avLst>
-              <a:gd name="adj" fmla="val 6000"/>
-            </a:avLst>
-          </a:prstGeom>
-          <a:solidFill>
-            <a:srgbClr val="2E2E40"/>
-          </a:solidFill>
-          <a:ln w="8890">
-            <a:solidFill>
-              <a:srgbClr val="3C3C4E"/>
-            </a:solidFill>
-          </a:ln>
-          <a:effectLst/>
-        </p:spPr>
-        <p:style>
-          <a:lnRef idx="1">
-            <a:schemeClr val="accent1"/>
-          </a:lnRef>
-          <a:fillRef idx="3">
-            <a:schemeClr val="accent1"/>
-          </a:fillRef>
-          <a:effectRef idx="2">
-            <a:schemeClr val="accent1"/>
-          </a:effectRef>
-          <a:fontRef idx="minor">
-            <a:schemeClr val="lt1"/>
-          </a:fontRef>
-        </p:style>
-        <p:txBody>
-          <a:bodyPr rtlCol="0" anchor="ctr" wrap="square" lIns="27432" rIns="27432" tIns="9144" bIns="9144"/>
-          <a:lstStyle/>
-          <a:p>
-            <a:pPr algn="ctr">
-              <a:lnSpc>
-                <a:spcPct val="95000"/>
-              </a:lnSpc>
-              <a:spcBef>
-                <a:spcPts val="0"/>
-              </a:spcBef>
-              <a:spcAft>
-                <a:spcPts val="0"/>
-              </a:spcAft>
-            </a:pPr>
-            <a:r>
-              <a:rPr sz="680" b="1" i="0">
-                <a:solidFill>
-                  <a:srgbClr val="FFFFFF"/>
-                </a:solidFill>
-                <a:latin typeface="Segoe UI"/>
-              </a:rPr>
-              <a:t>Audit</a:t>
-            </a:r>
-          </a:p>
-          <a:p>
-            <a:pPr algn="ctr">
-              <a:lnSpc>
-                <a:spcPct val="95000"/>
-              </a:lnSpc>
-              <a:spcBef>
-                <a:spcPts val="0"/>
-              </a:spcBef>
-              <a:spcAft>
-                <a:spcPts val="0"/>
-              </a:spcAft>
-            </a:pPr>
-            <a:r>
-              <a:rPr sz="680" b="1" i="0">
-                <a:solidFill>
-                  <a:srgbClr val="FFFFFF"/>
-                </a:solidFill>
-                <a:latin typeface="Segoe UI"/>
-              </a:rPr>
-              <a:t>&amp; documents</a:t>
-            </a:r>
-          </a:p>
-        </p:txBody>
-      </p:sp>
-      <p:sp>
-        <p:nvSpPr>
-          <p:cNvPr id="63" name="Down Arrow 62"/>
+          <p:cNvPr id="62" name="Down Arrow 61"/>
           <p:cNvSpPr/>
           <p:nvPr/>
         </p:nvSpPr>
@@ -6953,7 +6864,7 @@
       </p:sp>
       <p:sp>
         <p:nvSpPr>
-          <p:cNvPr id="64" name="Down Arrow 63"/>
+          <p:cNvPr id="63" name="Down Arrow 62"/>
           <p:cNvSpPr/>
           <p:nvPr/>
         </p:nvSpPr>
@@ -6997,7 +6908,7 @@
       </p:sp>
       <p:sp>
         <p:nvSpPr>
-          <p:cNvPr id="65" name="TextBox 64"/>
+          <p:cNvPr id="64" name="TextBox 63"/>
           <p:cNvSpPr txBox="1"/>
           <p:nvPr/>
         </p:nvSpPr>

</xml_diff>

<commit_message>
docs: rename SMTP confirmation box to Email notification in architecture slide
</commit_message>
<xml_diff>
--- a/demo/Order-Creation-Orchestration-Architecture.pptx
+++ b/demo/Order-Creation-Orchestration-Architecture.pptx
@@ -6791,7 +6791,7 @@
                 </a:solidFill>
                 <a:latin typeface="Segoe UI"/>
               </a:rPr>
-              <a:t>SMTP</a:t>
+              <a:t>Email</a:t>
             </a:r>
           </a:p>
           <a:p>
@@ -6813,7 +6813,7 @@
                 </a:solidFill>
                 <a:latin typeface="Segoe UI"/>
               </a:rPr>
-              <a:t>confirmation</a:t>
+              <a:t>notification</a:t>
             </a:r>
           </a:p>
         </p:txBody>

</xml_diff>

<commit_message>
docs: simplify order creation heading (drop Order Execution Agent suffix)
</commit_message>
<xml_diff>
--- a/demo/Order-Creation-Orchestration-Architecture.pptx
+++ b/demo/Order-Creation-Orchestration-Architecture.pptx
@@ -6226,16 +6226,7 @@
                 </a:solidFill>
                 <a:latin typeface="Segoe UI"/>
               </a:rPr>
-              <a:t>ORDER CREATION &amp; DOWNSTREAM — the </a:t>
-            </a:r>
-            <a:r>
-              <a:rPr sz="800" b="1" i="0">
-                <a:solidFill>
-                  <a:srgbClr val="FFFFFF"/>
-                </a:solidFill>
-                <a:latin typeface="Segoe UI"/>
-              </a:rPr>
-              <a:t>🤖 Order Execution Agent</a:t>
+              <a:t>ORDER CREATION &amp; DOWNSTREAM</a:t>
             </a:r>
           </a:p>
         </p:txBody>

</xml_diff>

<commit_message>
docs: reword orchestrator caption to Agent Orchestration in architecture slide
</commit_message>
<xml_diff>
--- a/demo/Order-Creation-Orchestration-Architecture.pptx
+++ b/demo/Order-Creation-Orchestration-Architecture.pptx
@@ -3829,7 +3829,7 @@
                 </a:solidFill>
                 <a:latin typeface="Segoe UI"/>
               </a:rPr>
-              <a:t>🤖  ORCHESTRATOR  </a:t>
+              <a:t>🤖  AGENT ORCHESTRATION  </a:t>
             </a:r>
             <a:r>
               <a:rPr sz="800" b="0" i="0">
@@ -3838,7 +3838,7 @@
                 </a:solidFill>
                 <a:latin typeface="Segoe UI"/>
               </a:rPr>
-              <a:t>— coordinates the specialist AI agents over a shared context</a:t>
+              <a:t>— a team of specialist AI agents works together to process every order end-to-end</a:t>
             </a:r>
           </a:p>
         </p:txBody>

</xml_diff>

<commit_message>
docs: remove footer legend from architecture slide
</commit_message>
<xml_diff>
--- a/demo/Order-Creation-Orchestration-Architecture.pptx
+++ b/demo/Order-Creation-Orchestration-Architecture.pptx
@@ -6894,69 +6894,6 @@
           <a:lstStyle/>
           <a:p>
             <a:pPr algn="ctr"/>
-          </a:p>
-        </p:txBody>
-      </p:sp>
-      <p:sp>
-        <p:nvSpPr>
-          <p:cNvPr id="64" name="TextBox 63"/>
-          <p:cNvSpPr txBox="1"/>
-          <p:nvPr/>
-        </p:nvSpPr>
-        <p:spPr>
-          <a:xfrm>
-            <a:off x="320040" y="6089904"/>
-            <a:ext cx="11521440" cy="219456"/>
-          </a:xfrm>
-          <a:prstGeom prst="rect">
-            <a:avLst/>
-          </a:prstGeom>
-          <a:noFill/>
-        </p:spPr>
-        <p:txBody>
-          <a:bodyPr wrap="square" anchor="t" lIns="0" rIns="0" tIns="0" bIns="0">
-            <a:spAutoFit/>
-          </a:bodyPr>
-          <a:lstStyle/>
-          <a:p>
-            <a:pPr algn="l">
-              <a:lnSpc>
-                <a:spcPct val="100000"/>
-              </a:lnSpc>
-              <a:spcBef>
-                <a:spcPts val="0"/>
-              </a:spcBef>
-              <a:spcAft>
-                <a:spcPts val="0"/>
-              </a:spcAft>
-            </a:pPr>
-            <a:r>
-              <a:rPr sz="800" b="0" i="1">
-                <a:solidFill>
-                  <a:srgbClr val="FFFFFF"/>
-                </a:solidFill>
-                <a:latin typeface="Segoe UI"/>
-              </a:rPr>
-              <a:t>🤖 = specialist AI agent    ·    </a:t>
-            </a:r>
-            <a:r>
-              <a:rPr sz="800" b="0" i="1">
-                <a:solidFill>
-                  <a:srgbClr val="35C759"/>
-                </a:solidFill>
-                <a:latin typeface="Segoe UI"/>
-              </a:rPr>
-              <a:t>green = straight-through (autonomous)    ·    </a:t>
-            </a:r>
-            <a:r>
-              <a:rPr sz="800" b="0" i="1">
-                <a:solidFill>
-                  <a:srgbClr val="FFB020"/>
-                </a:solidFill>
-                <a:latin typeface="Segoe UI"/>
-              </a:rPr>
-              <a:t>amber = human-in-the-loop decision</a:t>
-            </a:r>
           </a:p>
         </p:txBody>
       </p:sp>

</xml_diff>

<commit_message>
feat: refine architecture diagram, add demo briefing, clean up mock-system labels
- Redesign orchestration architecture slide: agent-to-system mapping via
  color-coded tags plus straight dotted arrows to the legacy-data box; drop
  Intake link; rename Shipping to Shipping Provider; simplify section header.
- Add _build_demo_briefing.py generating the client demo briefing (business
  perspective, per-agent purpose, scale-up notes, 10-minute run sheet with
  talk-track).
- Remove "Mock" prefixes, mock.internal endpoints, CRM references, and ATP
  wording from UI/labels; rename integration dataset constants off .xlsx.

Co-authored-by: Cursor <cursoragent@cursor.com>
</commit_message>
<xml_diff>
--- a/demo/Order-Creation-Orchestration-Architecture.pptx
+++ b/demo/Order-Creation-Orchestration-Architecture.pptx
@@ -5,9 +5,9 @@
     <p:sldMasterId id="2147483648" r:id="rId1"/>
   </p:sldMasterIdLst>
   <p:sldIdLst>
-    <p:sldId id="256" r:id="rId2"/>
+    <p:sldId id="256" r:id="rId7"/>
   </p:sldIdLst>
-  <p:sldSz cx="12192000" cy="6858000"/>
+  <p:sldSz cx="12191695" cy="6858000" type="screen4x3"/>
   <p:notesSz cx="6858000" cy="9144000"/>
   <p:defaultTextStyle>
     <a:defPPr>
@@ -104,22 +104,6 @@
       </a:defRPr>
     </a:lvl9pPr>
   </p:defaultTextStyle>
-  <p:extLst>
-    <p:ext uri="{EFAFB233-063F-42B5-8137-9DF3F51BA10A}">
-      <p15:sldGuideLst xmlns:p15="http://schemas.microsoft.com/office/powerpoint/2012/main">
-        <p15:guide id="1" orient="horz" pos="2160">
-          <p15:clr>
-            <a:srgbClr val="A4A3A4"/>
-          </p15:clr>
-        </p15:guide>
-        <p15:guide id="2" pos="2880">
-          <p15:clr>
-            <a:srgbClr val="A4A3A4"/>
-          </p15:clr>
-        </p15:guide>
-      </p15:sldGuideLst>
-    </p:ext>
-  </p:extLst>
 </p:presentation>
 </file>
 
@@ -161,9 +145,10 @@
           <a:lstStyle/>
           <a:p>
             <a:r>
-              <a:rPr lang="en-US"/>
+              <a:rPr lang="en-US" smtClean="0"/>
               <a:t>Click to edit Master title style</a:t>
             </a:r>
+            <a:endParaRPr lang="en-US"/>
           </a:p>
         </p:txBody>
       </p:sp>
@@ -279,9 +264,10 @@
           </a:lstStyle>
           <a:p>
             <a:r>
-              <a:rPr lang="en-US"/>
+              <a:rPr lang="en-US" smtClean="0"/>
               <a:t>Click to edit Master subtitle style</a:t>
             </a:r>
+            <a:endParaRPr lang="en-US"/>
           </a:p>
         </p:txBody>
       </p:sp>
@@ -302,7 +288,7 @@
           <a:p>
             <a:fld id="{5BCAD085-E8A6-8845-BD4E-CB4CCA059FC4}" type="datetimeFigureOut">
               <a:rPr lang="en-US" smtClean="0"/>
-              <a:t>7/22/2026</a:t>
+              <a:t>1/27/13</a:t>
             </a:fld>
             <a:endParaRPr lang="en-US"/>
           </a:p>
@@ -396,9 +382,10 @@
           <a:lstStyle/>
           <a:p>
             <a:r>
-              <a:rPr lang="en-US"/>
+              <a:rPr lang="en-US" smtClean="0"/>
               <a:t>Click to edit Master title style</a:t>
             </a:r>
+            <a:endParaRPr lang="en-US"/>
           </a:p>
         </p:txBody>
       </p:sp>
@@ -419,37 +406,38 @@
           <a:p>
             <a:pPr lvl="0"/>
             <a:r>
-              <a:rPr lang="en-US"/>
+              <a:rPr lang="en-US" smtClean="0"/>
               <a:t>Click to edit Master text styles</a:t>
             </a:r>
           </a:p>
           <a:p>
             <a:pPr lvl="1"/>
             <a:r>
-              <a:rPr lang="en-US"/>
+              <a:rPr lang="en-US" smtClean="0"/>
               <a:t>Second level</a:t>
             </a:r>
           </a:p>
           <a:p>
             <a:pPr lvl="2"/>
             <a:r>
-              <a:rPr lang="en-US"/>
+              <a:rPr lang="en-US" smtClean="0"/>
               <a:t>Third level</a:t>
             </a:r>
           </a:p>
           <a:p>
             <a:pPr lvl="3"/>
             <a:r>
-              <a:rPr lang="en-US"/>
+              <a:rPr lang="en-US" smtClean="0"/>
               <a:t>Fourth level</a:t>
             </a:r>
           </a:p>
           <a:p>
             <a:pPr lvl="4"/>
             <a:r>
-              <a:rPr lang="en-US"/>
+              <a:rPr lang="en-US" smtClean="0"/>
               <a:t>Fifth level</a:t>
             </a:r>
+            <a:endParaRPr lang="en-US"/>
           </a:p>
         </p:txBody>
       </p:sp>
@@ -470,7 +458,7 @@
           <a:p>
             <a:fld id="{5BCAD085-E8A6-8845-BD4E-CB4CCA059FC4}" type="datetimeFigureOut">
               <a:rPr lang="en-US" smtClean="0"/>
-              <a:t>7/22/2026</a:t>
+              <a:t>1/27/13</a:t>
             </a:fld>
             <a:endParaRPr lang="en-US"/>
           </a:p>
@@ -569,9 +557,10 @@
           <a:lstStyle/>
           <a:p>
             <a:r>
-              <a:rPr lang="en-US"/>
+              <a:rPr lang="en-US" smtClean="0"/>
               <a:t>Click to edit Master title style</a:t>
             </a:r>
+            <a:endParaRPr lang="en-US"/>
           </a:p>
         </p:txBody>
       </p:sp>
@@ -597,37 +586,38 @@
           <a:p>
             <a:pPr lvl="0"/>
             <a:r>
-              <a:rPr lang="en-US"/>
+              <a:rPr lang="en-US" smtClean="0"/>
               <a:t>Click to edit Master text styles</a:t>
             </a:r>
           </a:p>
           <a:p>
             <a:pPr lvl="1"/>
             <a:r>
-              <a:rPr lang="en-US"/>
+              <a:rPr lang="en-US" smtClean="0"/>
               <a:t>Second level</a:t>
             </a:r>
           </a:p>
           <a:p>
             <a:pPr lvl="2"/>
             <a:r>
-              <a:rPr lang="en-US"/>
+              <a:rPr lang="en-US" smtClean="0"/>
               <a:t>Third level</a:t>
             </a:r>
           </a:p>
           <a:p>
             <a:pPr lvl="3"/>
             <a:r>
-              <a:rPr lang="en-US"/>
+              <a:rPr lang="en-US" smtClean="0"/>
               <a:t>Fourth level</a:t>
             </a:r>
           </a:p>
           <a:p>
             <a:pPr lvl="4"/>
             <a:r>
-              <a:rPr lang="en-US"/>
+              <a:rPr lang="en-US" smtClean="0"/>
               <a:t>Fifth level</a:t>
             </a:r>
+            <a:endParaRPr lang="en-US"/>
           </a:p>
         </p:txBody>
       </p:sp>
@@ -648,7 +638,7 @@
           <a:p>
             <a:fld id="{5BCAD085-E8A6-8845-BD4E-CB4CCA059FC4}" type="datetimeFigureOut">
               <a:rPr lang="en-US" smtClean="0"/>
-              <a:t>7/22/2026</a:t>
+              <a:t>1/27/13</a:t>
             </a:fld>
             <a:endParaRPr lang="en-US"/>
           </a:p>
@@ -742,9 +732,10 @@
           <a:lstStyle/>
           <a:p>
             <a:r>
-              <a:rPr lang="en-US"/>
+              <a:rPr lang="en-US" smtClean="0"/>
               <a:t>Click to edit Master title style</a:t>
             </a:r>
+            <a:endParaRPr lang="en-US"/>
           </a:p>
         </p:txBody>
       </p:sp>
@@ -765,37 +756,38 @@
           <a:p>
             <a:pPr lvl="0"/>
             <a:r>
-              <a:rPr lang="en-US"/>
+              <a:rPr lang="en-US" smtClean="0"/>
               <a:t>Click to edit Master text styles</a:t>
             </a:r>
           </a:p>
           <a:p>
             <a:pPr lvl="1"/>
             <a:r>
-              <a:rPr lang="en-US"/>
+              <a:rPr lang="en-US" smtClean="0"/>
               <a:t>Second level</a:t>
             </a:r>
           </a:p>
           <a:p>
             <a:pPr lvl="2"/>
             <a:r>
-              <a:rPr lang="en-US"/>
+              <a:rPr lang="en-US" smtClean="0"/>
               <a:t>Third level</a:t>
             </a:r>
           </a:p>
           <a:p>
             <a:pPr lvl="3"/>
             <a:r>
-              <a:rPr lang="en-US"/>
+              <a:rPr lang="en-US" smtClean="0"/>
               <a:t>Fourth level</a:t>
             </a:r>
           </a:p>
           <a:p>
             <a:pPr lvl="4"/>
             <a:r>
-              <a:rPr lang="en-US"/>
+              <a:rPr lang="en-US" smtClean="0"/>
               <a:t>Fifth level</a:t>
             </a:r>
+            <a:endParaRPr lang="en-US"/>
           </a:p>
         </p:txBody>
       </p:sp>
@@ -816,7 +808,7 @@
           <a:p>
             <a:fld id="{5BCAD085-E8A6-8845-BD4E-CB4CCA059FC4}" type="datetimeFigureOut">
               <a:rPr lang="en-US" smtClean="0"/>
-              <a:t>7/22/2026</a:t>
+              <a:t>1/27/13</a:t>
             </a:fld>
             <a:endParaRPr lang="en-US"/>
           </a:p>
@@ -919,9 +911,10 @@
           </a:lstStyle>
           <a:p>
             <a:r>
-              <a:rPr lang="en-US"/>
+              <a:rPr lang="en-US" smtClean="0"/>
               <a:t>Click to edit Master title style</a:t>
             </a:r>
+            <a:endParaRPr lang="en-US"/>
           </a:p>
         </p:txBody>
       </p:sp>
@@ -1038,7 +1031,7 @@
           <a:p>
             <a:pPr lvl="0"/>
             <a:r>
-              <a:rPr lang="en-US"/>
+              <a:rPr lang="en-US" smtClean="0"/>
               <a:t>Click to edit Master text styles</a:t>
             </a:r>
           </a:p>
@@ -1061,7 +1054,7 @@
           <a:p>
             <a:fld id="{5BCAD085-E8A6-8845-BD4E-CB4CCA059FC4}" type="datetimeFigureOut">
               <a:rPr lang="en-US" smtClean="0"/>
-              <a:t>7/22/2026</a:t>
+              <a:t>1/27/13</a:t>
             </a:fld>
             <a:endParaRPr lang="en-US"/>
           </a:p>
@@ -1155,9 +1148,10 @@
           <a:lstStyle/>
           <a:p>
             <a:r>
-              <a:rPr lang="en-US"/>
+              <a:rPr lang="en-US" smtClean="0"/>
               <a:t>Click to edit Master title style</a:t>
             </a:r>
+            <a:endParaRPr lang="en-US"/>
           </a:p>
         </p:txBody>
       </p:sp>
@@ -1211,37 +1205,38 @@
           <a:p>
             <a:pPr lvl="0"/>
             <a:r>
-              <a:rPr lang="en-US"/>
+              <a:rPr lang="en-US" smtClean="0"/>
               <a:t>Click to edit Master text styles</a:t>
             </a:r>
           </a:p>
           <a:p>
             <a:pPr lvl="1"/>
             <a:r>
-              <a:rPr lang="en-US"/>
+              <a:rPr lang="en-US" smtClean="0"/>
               <a:t>Second level</a:t>
             </a:r>
           </a:p>
           <a:p>
             <a:pPr lvl="2"/>
             <a:r>
-              <a:rPr lang="en-US"/>
+              <a:rPr lang="en-US" smtClean="0"/>
               <a:t>Third level</a:t>
             </a:r>
           </a:p>
           <a:p>
             <a:pPr lvl="3"/>
             <a:r>
-              <a:rPr lang="en-US"/>
+              <a:rPr lang="en-US" smtClean="0"/>
               <a:t>Fourth level</a:t>
             </a:r>
           </a:p>
           <a:p>
             <a:pPr lvl="4"/>
             <a:r>
-              <a:rPr lang="en-US"/>
+              <a:rPr lang="en-US" smtClean="0"/>
               <a:t>Fifth level</a:t>
             </a:r>
+            <a:endParaRPr lang="en-US"/>
           </a:p>
         </p:txBody>
       </p:sp>
@@ -1295,37 +1290,38 @@
           <a:p>
             <a:pPr lvl="0"/>
             <a:r>
-              <a:rPr lang="en-US"/>
+              <a:rPr lang="en-US" smtClean="0"/>
               <a:t>Click to edit Master text styles</a:t>
             </a:r>
           </a:p>
           <a:p>
             <a:pPr lvl="1"/>
             <a:r>
-              <a:rPr lang="en-US"/>
+              <a:rPr lang="en-US" smtClean="0"/>
               <a:t>Second level</a:t>
             </a:r>
           </a:p>
           <a:p>
             <a:pPr lvl="2"/>
             <a:r>
-              <a:rPr lang="en-US"/>
+              <a:rPr lang="en-US" smtClean="0"/>
               <a:t>Third level</a:t>
             </a:r>
           </a:p>
           <a:p>
             <a:pPr lvl="3"/>
             <a:r>
-              <a:rPr lang="en-US"/>
+              <a:rPr lang="en-US" smtClean="0"/>
               <a:t>Fourth level</a:t>
             </a:r>
           </a:p>
           <a:p>
             <a:pPr lvl="4"/>
             <a:r>
-              <a:rPr lang="en-US"/>
+              <a:rPr lang="en-US" smtClean="0"/>
               <a:t>Fifth level</a:t>
             </a:r>
+            <a:endParaRPr lang="en-US"/>
           </a:p>
         </p:txBody>
       </p:sp>
@@ -1346,7 +1342,7 @@
           <a:p>
             <a:fld id="{5BCAD085-E8A6-8845-BD4E-CB4CCA059FC4}" type="datetimeFigureOut">
               <a:rPr lang="en-US" smtClean="0"/>
-              <a:t>7/22/2026</a:t>
+              <a:t>1/27/13</a:t>
             </a:fld>
             <a:endParaRPr lang="en-US"/>
           </a:p>
@@ -1444,9 +1440,10 @@
           </a:lstStyle>
           <a:p>
             <a:r>
-              <a:rPr lang="en-US"/>
+              <a:rPr lang="en-US" smtClean="0"/>
               <a:t>Click to edit Master title style</a:t>
             </a:r>
+            <a:endParaRPr lang="en-US"/>
           </a:p>
         </p:txBody>
       </p:sp>
@@ -1509,7 +1506,7 @@
           <a:p>
             <a:pPr lvl="0"/>
             <a:r>
-              <a:rPr lang="en-US"/>
+              <a:rPr lang="en-US" smtClean="0"/>
               <a:t>Click to edit Master text styles</a:t>
             </a:r>
           </a:p>
@@ -1565,37 +1562,38 @@
           <a:p>
             <a:pPr lvl="0"/>
             <a:r>
-              <a:rPr lang="en-US"/>
+              <a:rPr lang="en-US" smtClean="0"/>
               <a:t>Click to edit Master text styles</a:t>
             </a:r>
           </a:p>
           <a:p>
             <a:pPr lvl="1"/>
             <a:r>
-              <a:rPr lang="en-US"/>
+              <a:rPr lang="en-US" smtClean="0"/>
               <a:t>Second level</a:t>
             </a:r>
           </a:p>
           <a:p>
             <a:pPr lvl="2"/>
             <a:r>
-              <a:rPr lang="en-US"/>
+              <a:rPr lang="en-US" smtClean="0"/>
               <a:t>Third level</a:t>
             </a:r>
           </a:p>
           <a:p>
             <a:pPr lvl="3"/>
             <a:r>
-              <a:rPr lang="en-US"/>
+              <a:rPr lang="en-US" smtClean="0"/>
               <a:t>Fourth level</a:t>
             </a:r>
           </a:p>
           <a:p>
             <a:pPr lvl="4"/>
             <a:r>
-              <a:rPr lang="en-US"/>
+              <a:rPr lang="en-US" smtClean="0"/>
               <a:t>Fifth level</a:t>
             </a:r>
+            <a:endParaRPr lang="en-US"/>
           </a:p>
         </p:txBody>
       </p:sp>
@@ -1658,7 +1656,7 @@
           <a:p>
             <a:pPr lvl="0"/>
             <a:r>
-              <a:rPr lang="en-US"/>
+              <a:rPr lang="en-US" smtClean="0"/>
               <a:t>Click to edit Master text styles</a:t>
             </a:r>
           </a:p>
@@ -1714,37 +1712,38 @@
           <a:p>
             <a:pPr lvl="0"/>
             <a:r>
-              <a:rPr lang="en-US"/>
+              <a:rPr lang="en-US" smtClean="0"/>
               <a:t>Click to edit Master text styles</a:t>
             </a:r>
           </a:p>
           <a:p>
             <a:pPr lvl="1"/>
             <a:r>
-              <a:rPr lang="en-US"/>
+              <a:rPr lang="en-US" smtClean="0"/>
               <a:t>Second level</a:t>
             </a:r>
           </a:p>
           <a:p>
             <a:pPr lvl="2"/>
             <a:r>
-              <a:rPr lang="en-US"/>
+              <a:rPr lang="en-US" smtClean="0"/>
               <a:t>Third level</a:t>
             </a:r>
           </a:p>
           <a:p>
             <a:pPr lvl="3"/>
             <a:r>
-              <a:rPr lang="en-US"/>
+              <a:rPr lang="en-US" smtClean="0"/>
               <a:t>Fourth level</a:t>
             </a:r>
           </a:p>
           <a:p>
             <a:pPr lvl="4"/>
             <a:r>
-              <a:rPr lang="en-US"/>
+              <a:rPr lang="en-US" smtClean="0"/>
               <a:t>Fifth level</a:t>
             </a:r>
+            <a:endParaRPr lang="en-US"/>
           </a:p>
         </p:txBody>
       </p:sp>
@@ -1765,7 +1764,7 @@
           <a:p>
             <a:fld id="{5BCAD085-E8A6-8845-BD4E-CB4CCA059FC4}" type="datetimeFigureOut">
               <a:rPr lang="en-US" smtClean="0"/>
-              <a:t>7/22/2026</a:t>
+              <a:t>1/27/13</a:t>
             </a:fld>
             <a:endParaRPr lang="en-US"/>
           </a:p>
@@ -1859,9 +1858,10 @@
           <a:lstStyle/>
           <a:p>
             <a:r>
-              <a:rPr lang="en-US"/>
+              <a:rPr lang="en-US" smtClean="0"/>
               <a:t>Click to edit Master title style</a:t>
             </a:r>
+            <a:endParaRPr lang="en-US"/>
           </a:p>
         </p:txBody>
       </p:sp>
@@ -1882,7 +1882,7 @@
           <a:p>
             <a:fld id="{5BCAD085-E8A6-8845-BD4E-CB4CCA059FC4}" type="datetimeFigureOut">
               <a:rPr lang="en-US" smtClean="0"/>
-              <a:t>7/22/2026</a:t>
+              <a:t>1/27/13</a:t>
             </a:fld>
             <a:endParaRPr lang="en-US"/>
           </a:p>
@@ -1977,7 +1977,7 @@
           <a:p>
             <a:fld id="{5BCAD085-E8A6-8845-BD4E-CB4CCA059FC4}" type="datetimeFigureOut">
               <a:rPr lang="en-US" smtClean="0"/>
-              <a:t>7/22/2026</a:t>
+              <a:t>1/27/13</a:t>
             </a:fld>
             <a:endParaRPr lang="en-US"/>
           </a:p>
@@ -2080,9 +2080,10 @@
           </a:lstStyle>
           <a:p>
             <a:r>
-              <a:rPr lang="en-US"/>
+              <a:rPr lang="en-US" smtClean="0"/>
               <a:t>Click to edit Master title style</a:t>
             </a:r>
+            <a:endParaRPr lang="en-US"/>
           </a:p>
         </p:txBody>
       </p:sp>
@@ -2136,37 +2137,38 @@
           <a:p>
             <a:pPr lvl="0"/>
             <a:r>
-              <a:rPr lang="en-US"/>
+              <a:rPr lang="en-US" smtClean="0"/>
               <a:t>Click to edit Master text styles</a:t>
             </a:r>
           </a:p>
           <a:p>
             <a:pPr lvl="1"/>
             <a:r>
-              <a:rPr lang="en-US"/>
+              <a:rPr lang="en-US" smtClean="0"/>
               <a:t>Second level</a:t>
             </a:r>
           </a:p>
           <a:p>
             <a:pPr lvl="2"/>
             <a:r>
-              <a:rPr lang="en-US"/>
+              <a:rPr lang="en-US" smtClean="0"/>
               <a:t>Third level</a:t>
             </a:r>
           </a:p>
           <a:p>
             <a:pPr lvl="3"/>
             <a:r>
-              <a:rPr lang="en-US"/>
+              <a:rPr lang="en-US" smtClean="0"/>
               <a:t>Fourth level</a:t>
             </a:r>
           </a:p>
           <a:p>
             <a:pPr lvl="4"/>
             <a:r>
-              <a:rPr lang="en-US"/>
+              <a:rPr lang="en-US" smtClean="0"/>
               <a:t>Fifth level</a:t>
             </a:r>
+            <a:endParaRPr lang="en-US"/>
           </a:p>
         </p:txBody>
       </p:sp>
@@ -2229,7 +2231,7 @@
           <a:p>
             <a:pPr lvl="0"/>
             <a:r>
-              <a:rPr lang="en-US"/>
+              <a:rPr lang="en-US" smtClean="0"/>
               <a:t>Click to edit Master text styles</a:t>
             </a:r>
           </a:p>
@@ -2252,7 +2254,7 @@
           <a:p>
             <a:fld id="{5BCAD085-E8A6-8845-BD4E-CB4CCA059FC4}" type="datetimeFigureOut">
               <a:rPr lang="en-US" smtClean="0"/>
-              <a:t>7/22/2026</a:t>
+              <a:t>1/27/13</a:t>
             </a:fld>
             <a:endParaRPr lang="en-US"/>
           </a:p>
@@ -2355,9 +2357,10 @@
           </a:lstStyle>
           <a:p>
             <a:r>
-              <a:rPr lang="en-US"/>
+              <a:rPr lang="en-US" smtClean="0"/>
               <a:t>Click to edit Master title style</a:t>
             </a:r>
+            <a:endParaRPr lang="en-US"/>
           </a:p>
         </p:txBody>
       </p:sp>
@@ -2481,7 +2484,7 @@
           <a:p>
             <a:pPr lvl="0"/>
             <a:r>
-              <a:rPr lang="en-US"/>
+              <a:rPr lang="en-US" smtClean="0"/>
               <a:t>Click to edit Master text styles</a:t>
             </a:r>
           </a:p>
@@ -2504,7 +2507,7 @@
           <a:p>
             <a:fld id="{5BCAD085-E8A6-8845-BD4E-CB4CCA059FC4}" type="datetimeFigureOut">
               <a:rPr lang="en-US" smtClean="0"/>
-              <a:t>7/22/2026</a:t>
+              <a:t>1/27/13</a:t>
             </a:fld>
             <a:endParaRPr lang="en-US"/>
           </a:p>
@@ -2613,9 +2616,10 @@
           <a:lstStyle/>
           <a:p>
             <a:r>
-              <a:rPr lang="en-US"/>
+              <a:rPr lang="en-US" smtClean="0"/>
               <a:t>Click to edit Master title style</a:t>
             </a:r>
+            <a:endParaRPr lang="en-US"/>
           </a:p>
         </p:txBody>
       </p:sp>
@@ -2646,37 +2650,38 @@
           <a:p>
             <a:pPr lvl="0"/>
             <a:r>
-              <a:rPr lang="en-US"/>
+              <a:rPr lang="en-US" smtClean="0"/>
               <a:t>Click to edit Master text styles</a:t>
             </a:r>
           </a:p>
           <a:p>
             <a:pPr lvl="1"/>
             <a:r>
-              <a:rPr lang="en-US"/>
+              <a:rPr lang="en-US" smtClean="0"/>
               <a:t>Second level</a:t>
             </a:r>
           </a:p>
           <a:p>
             <a:pPr lvl="2"/>
             <a:r>
-              <a:rPr lang="en-US"/>
+              <a:rPr lang="en-US" smtClean="0"/>
               <a:t>Third level</a:t>
             </a:r>
           </a:p>
           <a:p>
             <a:pPr lvl="3"/>
             <a:r>
-              <a:rPr lang="en-US"/>
+              <a:rPr lang="en-US" smtClean="0"/>
               <a:t>Fourth level</a:t>
             </a:r>
           </a:p>
           <a:p>
             <a:pPr lvl="4"/>
             <a:r>
-              <a:rPr lang="en-US"/>
+              <a:rPr lang="en-US" smtClean="0"/>
               <a:t>Fifth level</a:t>
             </a:r>
+            <a:endParaRPr lang="en-US"/>
           </a:p>
         </p:txBody>
       </p:sp>
@@ -2715,7 +2720,7 @@
           <a:p>
             <a:fld id="{5BCAD085-E8A6-8845-BD4E-CB4CCA059FC4}" type="datetimeFigureOut">
               <a:rPr lang="en-US" smtClean="0"/>
-              <a:t>7/22/2026</a:t>
+              <a:t>1/27/13</a:t>
             </a:fld>
             <a:endParaRPr lang="en-US"/>
           </a:p>
@@ -3074,7 +3079,7 @@
 </file>
 
 <file path=ppt/slides/slide1.xml><?xml version="1.0" encoding="utf-8"?>
-<p:sld xmlns:a="http://schemas.openxmlformats.org/drawingml/2006/main" xmlns:r="http://schemas.openxmlformats.org/officeDocument/2006/relationships" xmlns:p="http://schemas.openxmlformats.org/presentationml/2006/main">
+<p:sld xmlns:a="http://schemas.openxmlformats.org/drawingml/2006/main" xmlns:p="http://schemas.openxmlformats.org/presentationml/2006/main" xmlns:r="http://schemas.openxmlformats.org/officeDocument/2006/relationships">
   <p:cSld>
     <p:spTree>
       <p:nvGrpSpPr>
@@ -3082,14 +3087,7 @@
         <p:cNvGrpSpPr/>
         <p:nvPr/>
       </p:nvGrpSpPr>
-      <p:grpSpPr>
-        <a:xfrm>
-          <a:off x="0" y="0"/>
-          <a:ext cx="0" cy="0"/>
-          <a:chOff x="0" y="0"/>
-          <a:chExt cx="0" cy="0"/>
-        </a:xfrm>
-      </p:grpSpPr>
+      <p:grpSpPr/>
       <p:sp>
         <p:nvSpPr>
           <p:cNvPr id="2" name="Rectangle 1"/>
@@ -3131,7 +3129,6 @@
           <a:lstStyle/>
           <a:p>
             <a:pPr algn="ctr"/>
-            <a:endParaRPr/>
           </a:p>
         </p:txBody>
       </p:sp>
@@ -3172,11 +3169,10 @@
           </a:fontRef>
         </p:style>
         <p:txBody>
-          <a:bodyPr wrap="square" rtlCol="0" anchor="ctr"/>
+          <a:bodyPr rtlCol="0" anchor="ctr" wrap="square"/>
           <a:lstStyle/>
           <a:p>
             <a:pPr algn="ctr"/>
-            <a:endParaRPr/>
           </a:p>
         </p:txBody>
       </p:sp>
@@ -3197,7 +3193,7 @@
           <a:noFill/>
         </p:spPr>
         <p:txBody>
-          <a:bodyPr wrap="square" lIns="0" tIns="0" rIns="0" bIns="0" anchor="t">
+          <a:bodyPr wrap="square" anchor="t" lIns="0" rIns="0" tIns="0" bIns="0">
             <a:spAutoFit/>
           </a:bodyPr>
           <a:lstStyle/>
@@ -3242,7 +3238,7 @@
           <a:noFill/>
         </p:spPr>
         <p:txBody>
-          <a:bodyPr wrap="square" lIns="0" tIns="0" rIns="0" bIns="0" anchor="t">
+          <a:bodyPr wrap="square" anchor="t" lIns="0" rIns="0" tIns="0" bIns="0">
             <a:spAutoFit/>
           </a:bodyPr>
           <a:lstStyle/>
@@ -3318,7 +3314,7 @@
           </a:fontRef>
         </p:style>
         <p:txBody>
-          <a:bodyPr wrap="square" lIns="27432" tIns="9144" rIns="27432" bIns="9144" rtlCol="0" anchor="ctr"/>
+          <a:bodyPr rtlCol="0" anchor="ctr" wrap="square" lIns="27432" rIns="27432" tIns="9144" bIns="9144"/>
           <a:lstStyle/>
           <a:p>
             <a:pPr algn="ctr">
@@ -3425,11 +3421,10 @@
           </a:fontRef>
         </p:style>
         <p:txBody>
-          <a:bodyPr wrap="square" rtlCol="0" anchor="ctr"/>
+          <a:bodyPr rtlCol="0" anchor="ctr" wrap="square"/>
           <a:lstStyle/>
           <a:p>
             <a:pPr algn="ctr"/>
-            <a:endParaRPr/>
           </a:p>
         </p:txBody>
       </p:sp>
@@ -3472,7 +3467,7 @@
           </a:fontRef>
         </p:style>
         <p:txBody>
-          <a:bodyPr wrap="square" lIns="27432" tIns="9144" rIns="27432" bIns="9144" rtlCol="0" anchor="ctr"/>
+          <a:bodyPr rtlCol="0" anchor="ctr" wrap="square" lIns="27432" rIns="27432" tIns="9144" bIns="9144"/>
           <a:lstStyle/>
           <a:p>
             <a:pPr algn="ctr">
@@ -3557,11 +3552,10 @@
           </a:fontRef>
         </p:style>
         <p:txBody>
-          <a:bodyPr wrap="square" rtlCol="0" anchor="ctr"/>
+          <a:bodyPr rtlCol="0" anchor="ctr" wrap="square"/>
           <a:lstStyle/>
           <a:p>
             <a:pPr algn="ctr"/>
-            <a:endParaRPr/>
           </a:p>
         </p:txBody>
       </p:sp>
@@ -3606,11 +3600,10 @@
           </a:fontRef>
         </p:style>
         <p:txBody>
-          <a:bodyPr wrap="square" rtlCol="0" anchor="ctr"/>
+          <a:bodyPr rtlCol="0" anchor="ctr" wrap="square"/>
           <a:lstStyle/>
           <a:p>
             <a:pPr algn="ctr"/>
-            <a:endParaRPr/>
           </a:p>
         </p:txBody>
       </p:sp>
@@ -3651,11 +3644,10 @@
           </a:fontRef>
         </p:style>
         <p:txBody>
-          <a:bodyPr wrap="square" rtlCol="0" anchor="ctr"/>
+          <a:bodyPr rtlCol="0" anchor="ctr" wrap="square"/>
           <a:lstStyle/>
           <a:p>
             <a:pPr algn="ctr"/>
-            <a:endParaRPr/>
           </a:p>
         </p:txBody>
       </p:sp>
@@ -3676,7 +3668,7 @@
           <a:noFill/>
         </p:spPr>
         <p:txBody>
-          <a:bodyPr wrap="square" lIns="0" tIns="0" rIns="0" bIns="0" anchor="t">
+          <a:bodyPr wrap="square" anchor="t" lIns="0" rIns="0" tIns="0" bIns="0">
             <a:spAutoFit/>
           </a:bodyPr>
           <a:lstStyle/>
@@ -3721,7 +3713,7 @@
           <a:noFill/>
         </p:spPr>
         <p:txBody>
-          <a:bodyPr wrap="square" lIns="0" tIns="0" rIns="0" bIns="0" anchor="t">
+          <a:bodyPr wrap="square" anchor="t" lIns="0" rIns="0" tIns="0" bIns="0">
             <a:spAutoFit/>
           </a:bodyPr>
           <a:lstStyle/>
@@ -3790,11 +3782,10 @@
           </a:fontRef>
         </p:style>
         <p:txBody>
-          <a:bodyPr wrap="square" rtlCol="0" anchor="ctr"/>
+          <a:bodyPr rtlCol="0" anchor="ctr" wrap="square"/>
           <a:lstStyle/>
           <a:p>
             <a:pPr algn="ctr"/>
-            <a:endParaRPr/>
           </a:p>
         </p:txBody>
       </p:sp>
@@ -3807,7 +3798,7 @@
         <p:spPr>
           <a:xfrm>
             <a:off x="1700784" y="1572768"/>
-            <a:ext cx="10058400" cy="147733"/>
+            <a:ext cx="10058400" cy="219456"/>
           </a:xfrm>
           <a:prstGeom prst="rect">
             <a:avLst/>
@@ -3815,7 +3806,7 @@
           <a:noFill/>
         </p:spPr>
         <p:txBody>
-          <a:bodyPr wrap="square" lIns="0" tIns="0" rIns="0" bIns="0" anchor="t">
+          <a:bodyPr wrap="square" anchor="t" lIns="0" rIns="0" tIns="0" bIns="0">
             <a:spAutoFit/>
           </a:bodyPr>
           <a:lstStyle/>
@@ -3832,34 +3823,16 @@
               </a:spcAft>
             </a:pPr>
             <a:r>
-              <a:rPr sz="960" b="1" i="0" dirty="0">
+              <a:rPr sz="960" b="1" i="0">
                 <a:solidFill>
                   <a:srgbClr val="FFE600"/>
                 </a:solidFill>
                 <a:latin typeface="Segoe UI"/>
               </a:rPr>
-              <a:t>🤖  AGENT</a:t>
-            </a:r>
-            <a:r>
-              <a:rPr lang="en-US" sz="960" b="1" i="0" dirty="0">
-                <a:solidFill>
-                  <a:srgbClr val="FFE600"/>
-                </a:solidFill>
-                <a:latin typeface="Segoe UI"/>
-              </a:rPr>
-              <a:t>S</a:t>
-            </a:r>
-            <a:r>
-              <a:rPr sz="960" b="1" i="0" dirty="0">
-                <a:solidFill>
-                  <a:srgbClr val="FFE600"/>
-                </a:solidFill>
-                <a:latin typeface="Segoe UI"/>
-              </a:rPr>
-              <a:t> ORCHESTRATION  </a:t>
-            </a:r>
-            <a:r>
-              <a:rPr sz="800" b="0" i="0" dirty="0">
+              <a:t>🤖  AGENT ORCHESTRATION  </a:t>
+            </a:r>
+            <a:r>
+              <a:rPr sz="800" b="0" i="0">
                 <a:solidFill>
                   <a:srgbClr val="C2C2D0"/>
                 </a:solidFill>
@@ -3911,7 +3884,7 @@
           </a:fontRef>
         </p:style>
         <p:txBody>
-          <a:bodyPr wrap="square" lIns="27432" tIns="9144" rIns="27432" bIns="9144" rtlCol="0" anchor="ctr"/>
+          <a:bodyPr rtlCol="0" anchor="ctr" wrap="square" lIns="27432" rIns="27432" tIns="9144" bIns="9144"/>
           <a:lstStyle/>
           <a:p>
             <a:pPr algn="ctr">
@@ -3983,11 +3956,10 @@
           </a:fontRef>
         </p:style>
         <p:txBody>
-          <a:bodyPr wrap="square" rtlCol="0" anchor="ctr"/>
+          <a:bodyPr rtlCol="0" anchor="ctr" wrap="square"/>
           <a:lstStyle/>
           <a:p>
             <a:pPr algn="ctr"/>
-            <a:endParaRPr/>
           </a:p>
         </p:txBody>
       </p:sp>
@@ -3999,8 +3971,8 @@
         </p:nvSpPr>
         <p:spPr>
           <a:xfrm>
-            <a:off x="1700784" y="2706624"/>
-            <a:ext cx="1052575" cy="1060704"/>
+            <a:off x="1700784" y="2487168"/>
+            <a:ext cx="1052575" cy="1042415"/>
           </a:xfrm>
           <a:prstGeom prst="roundRect">
             <a:avLst>
@@ -4032,12 +4004,12 @@
           </a:fontRef>
         </p:style>
         <p:txBody>
-          <a:bodyPr wrap="square" lIns="27432" tIns="9144" rIns="27432" bIns="9144" rtlCol="0" anchor="ctr"/>
+          <a:bodyPr rtlCol="0" anchor="ctr" wrap="square" lIns="27432" rIns="27432" tIns="9144" bIns="9144"/>
           <a:lstStyle/>
           <a:p>
             <a:pPr algn="ctr">
               <a:lnSpc>
-                <a:spcPct val="116000"/>
+                <a:spcPct val="118000"/>
               </a:lnSpc>
               <a:spcBef>
                 <a:spcPts val="0"/>
@@ -4047,7 +4019,7 @@
               </a:spcAft>
             </a:pPr>
             <a:r>
-              <a:rPr sz="830" b="1" i="0">
+              <a:rPr sz="840" b="1" i="0">
                 <a:solidFill>
                   <a:srgbClr val="FFE600"/>
                 </a:solidFill>
@@ -4056,7 +4028,7 @@
               <a:t>🤖 </a:t>
             </a:r>
             <a:r>
-              <a:rPr sz="680" b="1" i="0">
+              <a:rPr sz="700" b="1" i="0">
                 <a:solidFill>
                   <a:srgbClr val="FFFFFF"/>
                 </a:solidFill>
@@ -4068,7 +4040,7 @@
           <a:p>
             <a:pPr algn="ctr">
               <a:lnSpc>
-                <a:spcPct val="116000"/>
+                <a:spcPct val="118000"/>
               </a:lnSpc>
               <a:spcBef>
                 <a:spcPts val="0"/>
@@ -4078,7 +4050,7 @@
               </a:spcAft>
             </a:pPr>
             <a:r>
-              <a:rPr sz="680" b="1" i="0">
+              <a:rPr sz="700" b="1" i="0">
                 <a:solidFill>
                   <a:srgbClr val="FFFFFF"/>
                 </a:solidFill>
@@ -4090,7 +4062,7 @@
           <a:p>
             <a:pPr algn="ctr">
               <a:lnSpc>
-                <a:spcPct val="116000"/>
+                <a:spcPct val="118000"/>
               </a:lnSpc>
               <a:spcBef>
                 <a:spcPts val="0"/>
@@ -4100,13 +4072,13 @@
               </a:spcAft>
             </a:pPr>
             <a:r>
-              <a:rPr sz="560" b="0" i="0">
-                <a:solidFill>
-                  <a:srgbClr val="C2C2D0"/>
-                </a:solidFill>
-                <a:latin typeface="Segoe UI"/>
-              </a:rPr>
-              <a:t>reads PO · extracts fields</a:t>
+              <a:rPr sz="560" b="0" i="1">
+                <a:solidFill>
+                  <a:srgbClr val="8C8C9B"/>
+                </a:solidFill>
+                <a:latin typeface="Segoe UI"/>
+              </a:rPr>
+              <a:t>PO document only</a:t>
             </a:r>
           </a:p>
         </p:txBody>
@@ -4119,7 +4091,7 @@
         </p:nvSpPr>
         <p:spPr>
           <a:xfrm>
-            <a:off x="1700784" y="2706624"/>
+            <a:off x="1700784" y="2487168"/>
             <a:ext cx="1052575" cy="45720"/>
           </a:xfrm>
           <a:prstGeom prst="rect">
@@ -4148,11 +4120,10 @@
           </a:fontRef>
         </p:style>
         <p:txBody>
-          <a:bodyPr wrap="square" rtlCol="0" anchor="ctr"/>
+          <a:bodyPr rtlCol="0" anchor="ctr" wrap="square"/>
           <a:lstStyle/>
           <a:p>
             <a:pPr algn="ctr"/>
-            <a:endParaRPr/>
           </a:p>
         </p:txBody>
       </p:sp>
@@ -4164,7 +4135,7 @@
         </p:nvSpPr>
         <p:spPr>
           <a:xfrm>
-            <a:off x="2735072" y="3154680"/>
+            <a:off x="2735072" y="2926079"/>
             <a:ext cx="128016" cy="164592"/>
           </a:xfrm>
           <a:prstGeom prst="chevron">
@@ -4197,7 +4168,6 @@
           <a:lstStyle/>
           <a:p>
             <a:pPr algn="ctr"/>
-            <a:endParaRPr/>
           </a:p>
         </p:txBody>
       </p:sp>
@@ -4209,8 +4179,8 @@
         </p:nvSpPr>
         <p:spPr>
           <a:xfrm>
-            <a:off x="2826512" y="2706624"/>
-            <a:ext cx="1052575" cy="1060704"/>
+            <a:off x="2826512" y="2487168"/>
+            <a:ext cx="1052575" cy="1042415"/>
           </a:xfrm>
           <a:prstGeom prst="roundRect">
             <a:avLst>
@@ -4242,12 +4212,12 @@
           </a:fontRef>
         </p:style>
         <p:txBody>
-          <a:bodyPr wrap="square" lIns="27432" tIns="9144" rIns="27432" bIns="9144" rtlCol="0" anchor="ctr"/>
+          <a:bodyPr rtlCol="0" anchor="ctr" wrap="square" lIns="27432" rIns="27432" tIns="9144" bIns="9144"/>
           <a:lstStyle/>
           <a:p>
             <a:pPr algn="ctr">
               <a:lnSpc>
-                <a:spcPct val="116000"/>
+                <a:spcPct val="118000"/>
               </a:lnSpc>
               <a:spcBef>
                 <a:spcPts val="0"/>
@@ -4257,7 +4227,7 @@
               </a:spcAft>
             </a:pPr>
             <a:r>
-              <a:rPr sz="830" b="1" i="0">
+              <a:rPr sz="840" b="1" i="0">
                 <a:solidFill>
                   <a:srgbClr val="FFE600"/>
                 </a:solidFill>
@@ -4266,7 +4236,7 @@
               <a:t>🤖 </a:t>
             </a:r>
             <a:r>
-              <a:rPr sz="680" b="1" i="0">
+              <a:rPr sz="700" b="1" i="0">
                 <a:solidFill>
                   <a:srgbClr val="FFFFFF"/>
                 </a:solidFill>
@@ -4278,7 +4248,7 @@
           <a:p>
             <a:pPr algn="ctr">
               <a:lnSpc>
-                <a:spcPct val="116000"/>
+                <a:spcPct val="118000"/>
               </a:lnSpc>
               <a:spcBef>
                 <a:spcPts val="0"/>
@@ -4288,7 +4258,7 @@
               </a:spcAft>
             </a:pPr>
             <a:r>
-              <a:rPr sz="680" b="1" i="0">
+              <a:rPr sz="700" b="1" i="0">
                 <a:solidFill>
                   <a:srgbClr val="FFFFFF"/>
                 </a:solidFill>
@@ -4300,7 +4270,7 @@
           <a:p>
             <a:pPr algn="ctr">
               <a:lnSpc>
-                <a:spcPct val="116000"/>
+                <a:spcPct val="118000"/>
               </a:lnSpc>
               <a:spcBef>
                 <a:spcPts val="0"/>
@@ -4310,13 +4280,49 @@
               </a:spcAft>
             </a:pPr>
             <a:r>
-              <a:rPr sz="560" b="0" i="0">
-                <a:solidFill>
-                  <a:srgbClr val="C2C2D0"/>
-                </a:solidFill>
-                <a:latin typeface="Segoe UI"/>
-              </a:rPr>
-              <a:t>account · buyer auth · ship-to</a:t>
+              <a:rPr sz="620" b="1" i="0">
+                <a:solidFill>
+                  <a:srgbClr val="35C759"/>
+                </a:solidFill>
+                <a:latin typeface="Segoe UI"/>
+              </a:rPr>
+              <a:t>Commerce</a:t>
+            </a:r>
+            <a:r>
+              <a:rPr sz="580" b="0" i="0">
+                <a:solidFill>
+                  <a:srgbClr val="8C8C9B"/>
+                </a:solidFill>
+                <a:latin typeface="Segoe UI"/>
+              </a:rPr>
+              <a:t> · </a:t>
+            </a:r>
+            <a:r>
+              <a:rPr sz="620" b="1" i="0">
+                <a:solidFill>
+                  <a:srgbClr val="FF8A3D"/>
+                </a:solidFill>
+                <a:latin typeface="Segoe UI"/>
+              </a:rPr>
+              <a:t>OMS</a:t>
+            </a:r>
+            <a:r>
+              <a:rPr sz="580" b="0" i="0">
+                <a:solidFill>
+                  <a:srgbClr val="8C8C9B"/>
+                </a:solidFill>
+                <a:latin typeface="Segoe UI"/>
+              </a:rPr>
+              <a:t> · </a:t>
+            </a:r>
+            <a:r>
+              <a:rPr sz="620" b="1" i="0">
+                <a:solidFill>
+                  <a:srgbClr val="A97BFF"/>
+                </a:solidFill>
+                <a:latin typeface="Segoe UI"/>
+              </a:rPr>
+              <a:t>PIM</a:t>
             </a:r>
           </a:p>
         </p:txBody>
@@ -4329,7 +4335,7 @@
         </p:nvSpPr>
         <p:spPr>
           <a:xfrm>
-            <a:off x="2826512" y="2706624"/>
+            <a:off x="2826512" y="2487168"/>
             <a:ext cx="1052575" cy="45720"/>
           </a:xfrm>
           <a:prstGeom prst="rect">
@@ -4358,11 +4364,10 @@
           </a:fontRef>
         </p:style>
         <p:txBody>
-          <a:bodyPr wrap="square" rtlCol="0" anchor="ctr"/>
+          <a:bodyPr rtlCol="0" anchor="ctr" wrap="square"/>
           <a:lstStyle/>
           <a:p>
             <a:pPr algn="ctr"/>
-            <a:endParaRPr/>
           </a:p>
         </p:txBody>
       </p:sp>
@@ -4374,7 +4379,7 @@
         </p:nvSpPr>
         <p:spPr>
           <a:xfrm>
-            <a:off x="3860800" y="3154680"/>
+            <a:off x="3860800" y="2926079"/>
             <a:ext cx="128016" cy="164592"/>
           </a:xfrm>
           <a:prstGeom prst="chevron">
@@ -4407,7 +4412,6 @@
           <a:lstStyle/>
           <a:p>
             <a:pPr algn="ctr"/>
-            <a:endParaRPr/>
           </a:p>
         </p:txBody>
       </p:sp>
@@ -4419,8 +4423,8 @@
         </p:nvSpPr>
         <p:spPr>
           <a:xfrm>
-            <a:off x="3952239" y="2706624"/>
-            <a:ext cx="1052575" cy="1060704"/>
+            <a:off x="3952239" y="2487168"/>
+            <a:ext cx="1052575" cy="1042415"/>
           </a:xfrm>
           <a:prstGeom prst="roundRect">
             <a:avLst>
@@ -4452,12 +4456,12 @@
           </a:fontRef>
         </p:style>
         <p:txBody>
-          <a:bodyPr wrap="square" lIns="27432" tIns="9144" rIns="27432" bIns="9144" rtlCol="0" anchor="ctr"/>
+          <a:bodyPr rtlCol="0" anchor="ctr" wrap="square" lIns="27432" rIns="27432" tIns="9144" bIns="9144"/>
           <a:lstStyle/>
           <a:p>
             <a:pPr algn="ctr">
               <a:lnSpc>
-                <a:spcPct val="116000"/>
+                <a:spcPct val="118000"/>
               </a:lnSpc>
               <a:spcBef>
                 <a:spcPts val="0"/>
@@ -4467,7 +4471,7 @@
               </a:spcAft>
             </a:pPr>
             <a:r>
-              <a:rPr sz="830" b="1" i="0">
+              <a:rPr sz="840" b="1" i="0">
                 <a:solidFill>
                   <a:srgbClr val="FFE600"/>
                 </a:solidFill>
@@ -4476,7 +4480,7 @@
               <a:t>🤖 </a:t>
             </a:r>
             <a:r>
-              <a:rPr sz="680" b="1" i="0">
+              <a:rPr sz="700" b="1" i="0">
                 <a:solidFill>
                   <a:srgbClr val="FFFFFF"/>
                 </a:solidFill>
@@ -4488,7 +4492,7 @@
           <a:p>
             <a:pPr algn="ctr">
               <a:lnSpc>
-                <a:spcPct val="116000"/>
+                <a:spcPct val="118000"/>
               </a:lnSpc>
               <a:spcBef>
                 <a:spcPts val="0"/>
@@ -4498,7 +4502,7 @@
               </a:spcAft>
             </a:pPr>
             <a:r>
-              <a:rPr sz="680" b="1" i="0">
+              <a:rPr sz="700" b="1" i="0">
                 <a:solidFill>
                   <a:srgbClr val="FFFFFF"/>
                 </a:solidFill>
@@ -4510,7 +4514,7 @@
           <a:p>
             <a:pPr algn="ctr">
               <a:lnSpc>
-                <a:spcPct val="116000"/>
+                <a:spcPct val="118000"/>
               </a:lnSpc>
               <a:spcBef>
                 <a:spcPts val="0"/>
@@ -4520,13 +4524,31 @@
               </a:spcAft>
             </a:pPr>
             <a:r>
-              <a:rPr sz="560" b="0" i="0">
-                <a:solidFill>
-                  <a:srgbClr val="C2C2D0"/>
-                </a:solidFill>
-                <a:latin typeface="Segoe UI"/>
-              </a:rPr>
-              <a:t>catalog · compliance</a:t>
+              <a:rPr sz="620" b="1" i="0">
+                <a:solidFill>
+                  <a:srgbClr val="A97BFF"/>
+                </a:solidFill>
+                <a:latin typeface="Segoe UI"/>
+              </a:rPr>
+              <a:t>PIM</a:t>
+            </a:r>
+            <a:r>
+              <a:rPr sz="580" b="0" i="0">
+                <a:solidFill>
+                  <a:srgbClr val="8C8C9B"/>
+                </a:solidFill>
+                <a:latin typeface="Segoe UI"/>
+              </a:rPr>
+              <a:t> · </a:t>
+            </a:r>
+            <a:r>
+              <a:rPr sz="620" b="1" i="0">
+                <a:solidFill>
+                  <a:srgbClr val="4A9EFF"/>
+                </a:solidFill>
+                <a:latin typeface="Segoe UI"/>
+              </a:rPr>
+              <a:t>ERP</a:t>
             </a:r>
           </a:p>
         </p:txBody>
@@ -4539,7 +4561,7 @@
         </p:nvSpPr>
         <p:spPr>
           <a:xfrm>
-            <a:off x="3952239" y="2706624"/>
+            <a:off x="3952239" y="2487168"/>
             <a:ext cx="1052575" cy="45720"/>
           </a:xfrm>
           <a:prstGeom prst="rect">
@@ -4568,11 +4590,10 @@
           </a:fontRef>
         </p:style>
         <p:txBody>
-          <a:bodyPr wrap="square" rtlCol="0" anchor="ctr"/>
+          <a:bodyPr rtlCol="0" anchor="ctr" wrap="square"/>
           <a:lstStyle/>
           <a:p>
             <a:pPr algn="ctr"/>
-            <a:endParaRPr/>
           </a:p>
         </p:txBody>
       </p:sp>
@@ -4584,7 +4605,7 @@
         </p:nvSpPr>
         <p:spPr>
           <a:xfrm>
-            <a:off x="4986528" y="3154680"/>
+            <a:off x="4986528" y="2926079"/>
             <a:ext cx="128016" cy="164592"/>
           </a:xfrm>
           <a:prstGeom prst="chevron">
@@ -4617,7 +4638,6 @@
           <a:lstStyle/>
           <a:p>
             <a:pPr algn="ctr"/>
-            <a:endParaRPr/>
           </a:p>
         </p:txBody>
       </p:sp>
@@ -4629,8 +4649,8 @@
         </p:nvSpPr>
         <p:spPr>
           <a:xfrm>
-            <a:off x="5077967" y="2706624"/>
-            <a:ext cx="1052575" cy="1060704"/>
+            <a:off x="5077967" y="2487168"/>
+            <a:ext cx="1052575" cy="1042415"/>
           </a:xfrm>
           <a:prstGeom prst="roundRect">
             <a:avLst>
@@ -4662,12 +4682,12 @@
           </a:fontRef>
         </p:style>
         <p:txBody>
-          <a:bodyPr wrap="square" lIns="27432" tIns="9144" rIns="27432" bIns="9144" rtlCol="0" anchor="ctr"/>
+          <a:bodyPr rtlCol="0" anchor="ctr" wrap="square" lIns="27432" rIns="27432" tIns="9144" bIns="9144"/>
           <a:lstStyle/>
           <a:p>
             <a:pPr algn="ctr">
               <a:lnSpc>
-                <a:spcPct val="116000"/>
+                <a:spcPct val="118000"/>
               </a:lnSpc>
               <a:spcBef>
                 <a:spcPts val="0"/>
@@ -4677,7 +4697,7 @@
               </a:spcAft>
             </a:pPr>
             <a:r>
-              <a:rPr sz="830" b="1" i="0">
+              <a:rPr sz="840" b="1" i="0">
                 <a:solidFill>
                   <a:srgbClr val="FFE600"/>
                 </a:solidFill>
@@ -4686,7 +4706,7 @@
               <a:t>🤖 </a:t>
             </a:r>
             <a:r>
-              <a:rPr sz="680" b="1" i="0">
+              <a:rPr sz="700" b="1" i="0">
                 <a:solidFill>
                   <a:srgbClr val="FFFFFF"/>
                 </a:solidFill>
@@ -4698,7 +4718,7 @@
           <a:p>
             <a:pPr algn="ctr">
               <a:lnSpc>
-                <a:spcPct val="116000"/>
+                <a:spcPct val="118000"/>
               </a:lnSpc>
               <a:spcBef>
                 <a:spcPts val="0"/>
@@ -4708,7 +4728,7 @@
               </a:spcAft>
             </a:pPr>
             <a:r>
-              <a:rPr sz="680" b="1" i="0">
+              <a:rPr sz="700" b="1" i="0">
                 <a:solidFill>
                   <a:srgbClr val="FFFFFF"/>
                 </a:solidFill>
@@ -4720,7 +4740,7 @@
           <a:p>
             <a:pPr algn="ctr">
               <a:lnSpc>
-                <a:spcPct val="116000"/>
+                <a:spcPct val="118000"/>
               </a:lnSpc>
               <a:spcBef>
                 <a:spcPts val="0"/>
@@ -4730,13 +4750,13 @@
               </a:spcAft>
             </a:pPr>
             <a:r>
-              <a:rPr sz="560" b="0" i="0">
-                <a:solidFill>
-                  <a:srgbClr val="C2C2D0"/>
-                </a:solidFill>
-                <a:latin typeface="Segoe UI"/>
-              </a:rPr>
-              <a:t>contract · promo · margin</a:t>
+              <a:rPr sz="620" b="1" i="0">
+                <a:solidFill>
+                  <a:srgbClr val="35C759"/>
+                </a:solidFill>
+                <a:latin typeface="Segoe UI"/>
+              </a:rPr>
+              <a:t>Commerce</a:t>
             </a:r>
           </a:p>
         </p:txBody>
@@ -4749,7 +4769,7 @@
         </p:nvSpPr>
         <p:spPr>
           <a:xfrm>
-            <a:off x="5077967" y="2706624"/>
+            <a:off x="5077967" y="2487168"/>
             <a:ext cx="1052575" cy="45720"/>
           </a:xfrm>
           <a:prstGeom prst="rect">
@@ -4778,11 +4798,10 @@
           </a:fontRef>
         </p:style>
         <p:txBody>
-          <a:bodyPr wrap="square" rtlCol="0" anchor="ctr"/>
+          <a:bodyPr rtlCol="0" anchor="ctr" wrap="square"/>
           <a:lstStyle/>
           <a:p>
             <a:pPr algn="ctr"/>
-            <a:endParaRPr/>
           </a:p>
         </p:txBody>
       </p:sp>
@@ -4794,7 +4813,7 @@
         </p:nvSpPr>
         <p:spPr>
           <a:xfrm>
-            <a:off x="6112256" y="3154680"/>
+            <a:off x="6112256" y="2926079"/>
             <a:ext cx="128016" cy="164592"/>
           </a:xfrm>
           <a:prstGeom prst="chevron">
@@ -4827,7 +4846,6 @@
           <a:lstStyle/>
           <a:p>
             <a:pPr algn="ctr"/>
-            <a:endParaRPr/>
           </a:p>
         </p:txBody>
       </p:sp>
@@ -4839,8 +4857,8 @@
         </p:nvSpPr>
         <p:spPr>
           <a:xfrm>
-            <a:off x="6203696" y="2706624"/>
-            <a:ext cx="1052575" cy="1060704"/>
+            <a:off x="6203696" y="2487168"/>
+            <a:ext cx="1052575" cy="1042415"/>
           </a:xfrm>
           <a:prstGeom prst="roundRect">
             <a:avLst>
@@ -4872,12 +4890,12 @@
           </a:fontRef>
         </p:style>
         <p:txBody>
-          <a:bodyPr wrap="square" lIns="27432" tIns="9144" rIns="27432" bIns="9144" rtlCol="0" anchor="ctr"/>
+          <a:bodyPr rtlCol="0" anchor="ctr" wrap="square" lIns="27432" rIns="27432" tIns="9144" bIns="9144"/>
           <a:lstStyle/>
           <a:p>
             <a:pPr algn="ctr">
               <a:lnSpc>
-                <a:spcPct val="116000"/>
+                <a:spcPct val="118000"/>
               </a:lnSpc>
               <a:spcBef>
                 <a:spcPts val="0"/>
@@ -4887,7 +4905,7 @@
               </a:spcAft>
             </a:pPr>
             <a:r>
-              <a:rPr sz="830" b="1" i="0">
+              <a:rPr sz="840" b="1" i="0">
                 <a:solidFill>
                   <a:srgbClr val="FFE600"/>
                 </a:solidFill>
@@ -4896,7 +4914,7 @@
               <a:t>🤖 </a:t>
             </a:r>
             <a:r>
-              <a:rPr sz="680" b="1" i="0">
+              <a:rPr sz="700" b="1" i="0">
                 <a:solidFill>
                   <a:srgbClr val="FFFFFF"/>
                 </a:solidFill>
@@ -4908,7 +4926,7 @@
           <a:p>
             <a:pPr algn="ctr">
               <a:lnSpc>
-                <a:spcPct val="116000"/>
+                <a:spcPct val="118000"/>
               </a:lnSpc>
               <a:spcBef>
                 <a:spcPts val="0"/>
@@ -4918,7 +4936,7 @@
               </a:spcAft>
             </a:pPr>
             <a:r>
-              <a:rPr sz="680" b="1" i="0">
+              <a:rPr sz="700" b="1" i="0">
                 <a:solidFill>
                   <a:srgbClr val="FFFFFF"/>
                 </a:solidFill>
@@ -4930,7 +4948,7 @@
           <a:p>
             <a:pPr algn="ctr">
               <a:lnSpc>
-                <a:spcPct val="116000"/>
+                <a:spcPct val="118000"/>
               </a:lnSpc>
               <a:spcBef>
                 <a:spcPts val="0"/>
@@ -4940,13 +4958,13 @@
               </a:spcAft>
             </a:pPr>
             <a:r>
-              <a:rPr sz="560" b="0" i="0">
-                <a:solidFill>
-                  <a:srgbClr val="C2C2D0"/>
-                </a:solidFill>
-                <a:latin typeface="Segoe UI"/>
-              </a:rPr>
-              <a:t>limit · terms · risk</a:t>
+              <a:rPr sz="620" b="1" i="0">
+                <a:solidFill>
+                  <a:srgbClr val="4A9EFF"/>
+                </a:solidFill>
+                <a:latin typeface="Segoe UI"/>
+              </a:rPr>
+              <a:t>ERP</a:t>
             </a:r>
           </a:p>
         </p:txBody>
@@ -4959,7 +4977,7 @@
         </p:nvSpPr>
         <p:spPr>
           <a:xfrm>
-            <a:off x="6203696" y="2706624"/>
+            <a:off x="6203696" y="2487168"/>
             <a:ext cx="1052575" cy="45720"/>
           </a:xfrm>
           <a:prstGeom prst="rect">
@@ -4988,11 +5006,10 @@
           </a:fontRef>
         </p:style>
         <p:txBody>
-          <a:bodyPr wrap="square" rtlCol="0" anchor="ctr"/>
+          <a:bodyPr rtlCol="0" anchor="ctr" wrap="square"/>
           <a:lstStyle/>
           <a:p>
             <a:pPr algn="ctr"/>
-            <a:endParaRPr/>
           </a:p>
         </p:txBody>
       </p:sp>
@@ -5004,7 +5021,7 @@
         </p:nvSpPr>
         <p:spPr>
           <a:xfrm>
-            <a:off x="7237984" y="3154680"/>
+            <a:off x="7237984" y="2926079"/>
             <a:ext cx="128016" cy="164592"/>
           </a:xfrm>
           <a:prstGeom prst="chevron">
@@ -5037,7 +5054,6 @@
           <a:lstStyle/>
           <a:p>
             <a:pPr algn="ctr"/>
-            <a:endParaRPr/>
           </a:p>
         </p:txBody>
       </p:sp>
@@ -5049,8 +5065,8 @@
         </p:nvSpPr>
         <p:spPr>
           <a:xfrm>
-            <a:off x="7329423" y="2706624"/>
-            <a:ext cx="1052575" cy="1060704"/>
+            <a:off x="7329423" y="2487168"/>
+            <a:ext cx="1052575" cy="1042415"/>
           </a:xfrm>
           <a:prstGeom prst="roundRect">
             <a:avLst>
@@ -5082,12 +5098,12 @@
           </a:fontRef>
         </p:style>
         <p:txBody>
-          <a:bodyPr wrap="square" lIns="27432" tIns="9144" rIns="27432" bIns="9144" rtlCol="0" anchor="ctr"/>
+          <a:bodyPr rtlCol="0" anchor="ctr" wrap="square" lIns="27432" rIns="27432" tIns="9144" bIns="9144"/>
           <a:lstStyle/>
           <a:p>
             <a:pPr algn="ctr">
               <a:lnSpc>
-                <a:spcPct val="116000"/>
+                <a:spcPct val="118000"/>
               </a:lnSpc>
               <a:spcBef>
                 <a:spcPts val="0"/>
@@ -5097,7 +5113,7 @@
               </a:spcAft>
             </a:pPr>
             <a:r>
-              <a:rPr sz="830" b="1" i="0">
+              <a:rPr sz="840" b="1" i="0">
                 <a:solidFill>
                   <a:srgbClr val="FFE600"/>
                 </a:solidFill>
@@ -5106,7 +5122,7 @@
               <a:t>🤖 </a:t>
             </a:r>
             <a:r>
-              <a:rPr sz="680" b="1" i="0">
+              <a:rPr sz="700" b="1" i="0">
                 <a:solidFill>
                   <a:srgbClr val="FFFFFF"/>
                 </a:solidFill>
@@ -5118,7 +5134,7 @@
           <a:p>
             <a:pPr algn="ctr">
               <a:lnSpc>
-                <a:spcPct val="116000"/>
+                <a:spcPct val="118000"/>
               </a:lnSpc>
               <a:spcBef>
                 <a:spcPts val="0"/>
@@ -5128,7 +5144,7 @@
               </a:spcAft>
             </a:pPr>
             <a:r>
-              <a:rPr sz="680" b="1" i="0">
+              <a:rPr sz="700" b="1" i="0">
                 <a:solidFill>
                   <a:srgbClr val="FFFFFF"/>
                 </a:solidFill>
@@ -5140,7 +5156,7 @@
           <a:p>
             <a:pPr algn="ctr">
               <a:lnSpc>
-                <a:spcPct val="116000"/>
+                <a:spcPct val="118000"/>
               </a:lnSpc>
               <a:spcBef>
                 <a:spcPts val="0"/>
@@ -5150,13 +5166,13 @@
               </a:spcAft>
             </a:pPr>
             <a:r>
-              <a:rPr sz="560" b="0" i="0">
-                <a:solidFill>
-                  <a:srgbClr val="C2C2D0"/>
-                </a:solidFill>
-                <a:latin typeface="Segoe UI"/>
-              </a:rPr>
-              <a:t>DC stock · ATP · alloc</a:t>
+              <a:rPr sz="620" b="1" i="0">
+                <a:solidFill>
+                  <a:srgbClr val="4A9EFF"/>
+                </a:solidFill>
+                <a:latin typeface="Segoe UI"/>
+              </a:rPr>
+              <a:t>ERP</a:t>
             </a:r>
           </a:p>
         </p:txBody>
@@ -5169,7 +5185,7 @@
         </p:nvSpPr>
         <p:spPr>
           <a:xfrm>
-            <a:off x="7329423" y="2706624"/>
+            <a:off x="7329423" y="2487168"/>
             <a:ext cx="1052575" cy="45720"/>
           </a:xfrm>
           <a:prstGeom prst="rect">
@@ -5198,11 +5214,10 @@
           </a:fontRef>
         </p:style>
         <p:txBody>
-          <a:bodyPr wrap="square" rtlCol="0" anchor="ctr"/>
+          <a:bodyPr rtlCol="0" anchor="ctr" wrap="square"/>
           <a:lstStyle/>
           <a:p>
             <a:pPr algn="ctr"/>
-            <a:endParaRPr/>
           </a:p>
         </p:txBody>
       </p:sp>
@@ -5214,7 +5229,7 @@
         </p:nvSpPr>
         <p:spPr>
           <a:xfrm>
-            <a:off x="8363712" y="3154680"/>
+            <a:off x="8363712" y="2926079"/>
             <a:ext cx="128016" cy="164592"/>
           </a:xfrm>
           <a:prstGeom prst="chevron">
@@ -5247,7 +5262,6 @@
           <a:lstStyle/>
           <a:p>
             <a:pPr algn="ctr"/>
-            <a:endParaRPr/>
           </a:p>
         </p:txBody>
       </p:sp>
@@ -5259,8 +5273,8 @@
         </p:nvSpPr>
         <p:spPr>
           <a:xfrm>
-            <a:off x="8455152" y="2706624"/>
-            <a:ext cx="1052575" cy="1060704"/>
+            <a:off x="8455152" y="2487168"/>
+            <a:ext cx="1052575" cy="1042415"/>
           </a:xfrm>
           <a:prstGeom prst="roundRect">
             <a:avLst>
@@ -5292,12 +5306,12 @@
           </a:fontRef>
         </p:style>
         <p:txBody>
-          <a:bodyPr wrap="square" lIns="27432" tIns="9144" rIns="27432" bIns="9144" rtlCol="0" anchor="ctr"/>
+          <a:bodyPr rtlCol="0" anchor="ctr" wrap="square" lIns="27432" rIns="27432" tIns="9144" bIns="9144"/>
           <a:lstStyle/>
           <a:p>
             <a:pPr algn="ctr">
               <a:lnSpc>
-                <a:spcPct val="116000"/>
+                <a:spcPct val="118000"/>
               </a:lnSpc>
               <a:spcBef>
                 <a:spcPts val="0"/>
@@ -5307,7 +5321,7 @@
               </a:spcAft>
             </a:pPr>
             <a:r>
-              <a:rPr sz="830" b="1" i="0">
+              <a:rPr sz="840" b="1" i="0">
                 <a:solidFill>
                   <a:srgbClr val="FFE600"/>
                 </a:solidFill>
@@ -5316,7 +5330,7 @@
               <a:t>🤖 </a:t>
             </a:r>
             <a:r>
-              <a:rPr sz="680" b="1" i="0">
+              <a:rPr sz="700" b="1" i="0">
                 <a:solidFill>
                   <a:srgbClr val="FFFFFF"/>
                 </a:solidFill>
@@ -5328,7 +5342,7 @@
           <a:p>
             <a:pPr algn="ctr">
               <a:lnSpc>
-                <a:spcPct val="116000"/>
+                <a:spcPct val="118000"/>
               </a:lnSpc>
               <a:spcBef>
                 <a:spcPts val="0"/>
@@ -5338,7 +5352,7 @@
               </a:spcAft>
             </a:pPr>
             <a:r>
-              <a:rPr sz="680" b="1" i="0">
+              <a:rPr sz="700" b="1" i="0">
                 <a:solidFill>
                   <a:srgbClr val="FFFFFF"/>
                 </a:solidFill>
@@ -5350,7 +5364,7 @@
           <a:p>
             <a:pPr algn="ctr">
               <a:lnSpc>
-                <a:spcPct val="116000"/>
+                <a:spcPct val="118000"/>
               </a:lnSpc>
               <a:spcBef>
                 <a:spcPts val="0"/>
@@ -5360,13 +5374,31 @@
               </a:spcAft>
             </a:pPr>
             <a:r>
-              <a:rPr sz="560" b="0" i="0">
-                <a:solidFill>
-                  <a:srgbClr val="C2C2D0"/>
-                </a:solidFill>
-                <a:latin typeface="Segoe UI"/>
-              </a:rPr>
-              <a:t>carrier · service · SLA</a:t>
+              <a:rPr sz="620" b="1" i="0">
+                <a:solidFill>
+                  <a:srgbClr val="33C9C9"/>
+                </a:solidFill>
+                <a:latin typeface="Segoe UI"/>
+              </a:rPr>
+              <a:t>Shipping Provider</a:t>
+            </a:r>
+            <a:r>
+              <a:rPr sz="580" b="0" i="0">
+                <a:solidFill>
+                  <a:srgbClr val="8C8C9B"/>
+                </a:solidFill>
+                <a:latin typeface="Segoe UI"/>
+              </a:rPr>
+              <a:t> · </a:t>
+            </a:r>
+            <a:r>
+              <a:rPr sz="620" b="1" i="0">
+                <a:solidFill>
+                  <a:srgbClr val="4A9EFF"/>
+                </a:solidFill>
+                <a:latin typeface="Segoe UI"/>
+              </a:rPr>
+              <a:t>ERP</a:t>
             </a:r>
           </a:p>
         </p:txBody>
@@ -5379,7 +5411,7 @@
         </p:nvSpPr>
         <p:spPr>
           <a:xfrm>
-            <a:off x="8455152" y="2706624"/>
+            <a:off x="8455152" y="2487168"/>
             <a:ext cx="1052575" cy="45720"/>
           </a:xfrm>
           <a:prstGeom prst="rect">
@@ -5408,11 +5440,10 @@
           </a:fontRef>
         </p:style>
         <p:txBody>
-          <a:bodyPr wrap="square" rtlCol="0" anchor="ctr"/>
+          <a:bodyPr rtlCol="0" anchor="ctr" wrap="square"/>
           <a:lstStyle/>
           <a:p>
             <a:pPr algn="ctr"/>
-            <a:endParaRPr/>
           </a:p>
         </p:txBody>
       </p:sp>
@@ -5424,7 +5455,7 @@
         </p:nvSpPr>
         <p:spPr>
           <a:xfrm>
-            <a:off x="9489440" y="3154680"/>
+            <a:off x="9489440" y="2926079"/>
             <a:ext cx="128016" cy="164592"/>
           </a:xfrm>
           <a:prstGeom prst="chevron">
@@ -5457,7 +5488,6 @@
           <a:lstStyle/>
           <a:p>
             <a:pPr algn="ctr"/>
-            <a:endParaRPr/>
           </a:p>
         </p:txBody>
       </p:sp>
@@ -5469,8 +5499,8 @@
         </p:nvSpPr>
         <p:spPr>
           <a:xfrm>
-            <a:off x="9580879" y="2706624"/>
-            <a:ext cx="1052575" cy="1060704"/>
+            <a:off x="9580879" y="2487168"/>
+            <a:ext cx="1052575" cy="1042415"/>
           </a:xfrm>
           <a:prstGeom prst="roundRect">
             <a:avLst>
@@ -5502,12 +5532,12 @@
           </a:fontRef>
         </p:style>
         <p:txBody>
-          <a:bodyPr wrap="square" lIns="27432" tIns="9144" rIns="27432" bIns="9144" rtlCol="0" anchor="ctr"/>
+          <a:bodyPr rtlCol="0" anchor="ctr" wrap="square" lIns="27432" rIns="27432" tIns="9144" bIns="9144"/>
           <a:lstStyle/>
           <a:p>
             <a:pPr algn="ctr">
               <a:lnSpc>
-                <a:spcPct val="116000"/>
+                <a:spcPct val="118000"/>
               </a:lnSpc>
               <a:spcBef>
                 <a:spcPts val="0"/>
@@ -5517,7 +5547,7 @@
               </a:spcAft>
             </a:pPr>
             <a:r>
-              <a:rPr sz="830" b="1" i="0">
+              <a:rPr sz="840" b="1" i="0">
                 <a:solidFill>
                   <a:srgbClr val="FFE600"/>
                 </a:solidFill>
@@ -5526,7 +5556,7 @@
               <a:t>🤖 </a:t>
             </a:r>
             <a:r>
-              <a:rPr sz="680" b="1" i="0">
+              <a:rPr sz="700" b="1" i="0">
                 <a:solidFill>
                   <a:srgbClr val="FFFFFF"/>
                 </a:solidFill>
@@ -5538,7 +5568,7 @@
           <a:p>
             <a:pPr algn="ctr">
               <a:lnSpc>
-                <a:spcPct val="116000"/>
+                <a:spcPct val="118000"/>
               </a:lnSpc>
               <a:spcBef>
                 <a:spcPts val="0"/>
@@ -5548,7 +5578,7 @@
               </a:spcAft>
             </a:pPr>
             <a:r>
-              <a:rPr sz="680" b="1" i="0">
+              <a:rPr sz="700" b="1" i="0">
                 <a:solidFill>
                   <a:srgbClr val="FFFFFF"/>
                 </a:solidFill>
@@ -5560,7 +5590,7 @@
           <a:p>
             <a:pPr algn="ctr">
               <a:lnSpc>
-                <a:spcPct val="116000"/>
+                <a:spcPct val="118000"/>
               </a:lnSpc>
               <a:spcBef>
                 <a:spcPts val="0"/>
@@ -5570,13 +5600,31 @@
               </a:spcAft>
             </a:pPr>
             <a:r>
-              <a:rPr sz="560" b="0" i="0">
-                <a:solidFill>
-                  <a:srgbClr val="C2C2D0"/>
-                </a:solidFill>
-                <a:latin typeface="Segoe UI"/>
-              </a:rPr>
-              <a:t>plan A/B/C · freight</a:t>
+              <a:rPr sz="620" b="1" i="0">
+                <a:solidFill>
+                  <a:srgbClr val="33C9C9"/>
+                </a:solidFill>
+                <a:latin typeface="Segoe UI"/>
+              </a:rPr>
+              <a:t>Shipping Provider</a:t>
+            </a:r>
+            <a:r>
+              <a:rPr sz="580" b="0" i="0">
+                <a:solidFill>
+                  <a:srgbClr val="8C8C9B"/>
+                </a:solidFill>
+                <a:latin typeface="Segoe UI"/>
+              </a:rPr>
+              <a:t> · </a:t>
+            </a:r>
+            <a:r>
+              <a:rPr sz="620" b="1" i="0">
+                <a:solidFill>
+                  <a:srgbClr val="4A9EFF"/>
+                </a:solidFill>
+                <a:latin typeface="Segoe UI"/>
+              </a:rPr>
+              <a:t>ERP</a:t>
             </a:r>
           </a:p>
         </p:txBody>
@@ -5589,7 +5637,7 @@
         </p:nvSpPr>
         <p:spPr>
           <a:xfrm>
-            <a:off x="9580879" y="2706624"/>
+            <a:off x="9580879" y="2487168"/>
             <a:ext cx="1052575" cy="45720"/>
           </a:xfrm>
           <a:prstGeom prst="rect">
@@ -5618,11 +5666,10 @@
           </a:fontRef>
         </p:style>
         <p:txBody>
-          <a:bodyPr wrap="square" rtlCol="0" anchor="ctr"/>
+          <a:bodyPr rtlCol="0" anchor="ctr" wrap="square"/>
           <a:lstStyle/>
           <a:p>
             <a:pPr algn="ctr"/>
-            <a:endParaRPr/>
           </a:p>
         </p:txBody>
       </p:sp>
@@ -5634,7 +5681,7 @@
         </p:nvSpPr>
         <p:spPr>
           <a:xfrm>
-            <a:off x="10615168" y="3154680"/>
+            <a:off x="10615168" y="2926079"/>
             <a:ext cx="128016" cy="164592"/>
           </a:xfrm>
           <a:prstGeom prst="chevron">
@@ -5667,7 +5714,6 @@
           <a:lstStyle/>
           <a:p>
             <a:pPr algn="ctr"/>
-            <a:endParaRPr/>
           </a:p>
         </p:txBody>
       </p:sp>
@@ -5679,8 +5725,8 @@
         </p:nvSpPr>
         <p:spPr>
           <a:xfrm>
-            <a:off x="10706607" y="2706624"/>
-            <a:ext cx="1052575" cy="1060704"/>
+            <a:off x="10706607" y="2487168"/>
+            <a:ext cx="1052575" cy="1042415"/>
           </a:xfrm>
           <a:prstGeom prst="roundRect">
             <a:avLst>
@@ -5712,12 +5758,12 @@
           </a:fontRef>
         </p:style>
         <p:txBody>
-          <a:bodyPr wrap="square" lIns="27432" tIns="9144" rIns="27432" bIns="9144" rtlCol="0" anchor="ctr"/>
+          <a:bodyPr rtlCol="0" anchor="ctr" wrap="square" lIns="27432" rIns="27432" tIns="9144" bIns="9144"/>
           <a:lstStyle/>
           <a:p>
             <a:pPr algn="ctr">
               <a:lnSpc>
-                <a:spcPct val="116000"/>
+                <a:spcPct val="118000"/>
               </a:lnSpc>
               <a:spcBef>
                 <a:spcPts val="0"/>
@@ -5727,7 +5773,7 @@
               </a:spcAft>
             </a:pPr>
             <a:r>
-              <a:rPr sz="830" b="1" i="0">
+              <a:rPr sz="840" b="1" i="0">
                 <a:solidFill>
                   <a:srgbClr val="FFE600"/>
                 </a:solidFill>
@@ -5736,7 +5782,7 @@
               <a:t>🤖 </a:t>
             </a:r>
             <a:r>
-              <a:rPr sz="680" b="1" i="0">
+              <a:rPr sz="700" b="1" i="0">
                 <a:solidFill>
                   <a:srgbClr val="FFFFFF"/>
                 </a:solidFill>
@@ -5748,7 +5794,7 @@
           <a:p>
             <a:pPr algn="ctr">
               <a:lnSpc>
-                <a:spcPct val="116000"/>
+                <a:spcPct val="118000"/>
               </a:lnSpc>
               <a:spcBef>
                 <a:spcPts val="0"/>
@@ -5758,7 +5804,7 @@
               </a:spcAft>
             </a:pPr>
             <a:r>
-              <a:rPr sz="680" b="1" i="0">
+              <a:rPr sz="700" b="1" i="0">
                 <a:solidFill>
                   <a:srgbClr val="FFFFFF"/>
                 </a:solidFill>
@@ -5770,7 +5816,7 @@
           <a:p>
             <a:pPr algn="ctr">
               <a:lnSpc>
-                <a:spcPct val="116000"/>
+                <a:spcPct val="118000"/>
               </a:lnSpc>
               <a:spcBef>
                 <a:spcPts val="0"/>
@@ -5780,13 +5826,13 @@
               </a:spcAft>
             </a:pPr>
             <a:r>
-              <a:rPr sz="560" b="0" i="0">
-                <a:solidFill>
-                  <a:srgbClr val="C2C2D0"/>
-                </a:solidFill>
-                <a:latin typeface="Segoe UI"/>
-              </a:rPr>
-              <a:t>budget · matrix (last)</a:t>
+              <a:rPr sz="620" b="1" i="0">
+                <a:solidFill>
+                  <a:srgbClr val="4A9EFF"/>
+                </a:solidFill>
+                <a:latin typeface="Segoe UI"/>
+              </a:rPr>
+              <a:t>ERP</a:t>
             </a:r>
           </a:p>
         </p:txBody>
@@ -5799,7 +5845,7 @@
         </p:nvSpPr>
         <p:spPr>
           <a:xfrm>
-            <a:off x="10706607" y="2706624"/>
+            <a:off x="10706607" y="2487168"/>
             <a:ext cx="1052575" cy="45720"/>
           </a:xfrm>
           <a:prstGeom prst="rect">
@@ -5828,24 +5874,374 @@
           </a:fontRef>
         </p:style>
         <p:txBody>
-          <a:bodyPr wrap="square" rtlCol="0" anchor="ctr"/>
+          <a:bodyPr rtlCol="0" anchor="ctr" wrap="square"/>
           <a:lstStyle/>
           <a:p>
             <a:pPr algn="ctr"/>
-            <a:endParaRPr/>
-          </a:p>
-        </p:txBody>
-      </p:sp>
-      <p:sp>
-        <p:nvSpPr>
-          <p:cNvPr id="44" name="Rounded Rectangle 43"/>
+          </a:p>
+        </p:txBody>
+      </p:sp>
+      <p:cxnSp>
+        <p:nvCxnSpPr>
+          <p:cNvPr id="44" name="Connector 43"/>
+          <p:cNvCxnSpPr/>
+          <p:nvPr/>
+        </p:nvCxnSpPr>
+        <p:spPr>
+          <a:xfrm flipV="1">
+            <a:off x="2227071" y="2377440"/>
+            <a:ext cx="0" cy="109728"/>
+          </a:xfrm>
+          <a:prstGeom prst="line">
+            <a:avLst/>
+          </a:prstGeom>
+          <a:ln w="12700">
+            <a:solidFill>
+              <a:srgbClr val="FFB020"/>
+            </a:solidFill>
+            <a:prstDash val="dash"/>
+            <a:headEnd type="triangle" w="med" len="med"/>
+            <a:tailEnd type="triangle" w="med" len="med"/>
+          </a:ln>
+          <a:effectLst/>
+        </p:spPr>
+        <p:style>
+          <a:lnRef idx="2">
+            <a:schemeClr val="accent1"/>
+          </a:lnRef>
+          <a:fillRef idx="0">
+            <a:schemeClr val="accent1"/>
+          </a:fillRef>
+          <a:effectRef idx="1">
+            <a:schemeClr val="accent1"/>
+          </a:effectRef>
+          <a:fontRef idx="minor">
+            <a:schemeClr val="tx1"/>
+          </a:fontRef>
+        </p:style>
+      </p:cxnSp>
+      <p:cxnSp>
+        <p:nvCxnSpPr>
+          <p:cNvPr id="45" name="Connector 44"/>
+          <p:cNvCxnSpPr/>
+          <p:nvPr/>
+        </p:nvCxnSpPr>
+        <p:spPr>
+          <a:xfrm flipV="1">
+            <a:off x="3352800" y="2377440"/>
+            <a:ext cx="0" cy="109728"/>
+          </a:xfrm>
+          <a:prstGeom prst="line">
+            <a:avLst/>
+          </a:prstGeom>
+          <a:ln w="12700">
+            <a:solidFill>
+              <a:srgbClr val="FFB020"/>
+            </a:solidFill>
+            <a:prstDash val="dash"/>
+            <a:headEnd type="triangle" w="med" len="med"/>
+            <a:tailEnd type="triangle" w="med" len="med"/>
+          </a:ln>
+          <a:effectLst/>
+        </p:spPr>
+        <p:style>
+          <a:lnRef idx="2">
+            <a:schemeClr val="accent1"/>
+          </a:lnRef>
+          <a:fillRef idx="0">
+            <a:schemeClr val="accent1"/>
+          </a:fillRef>
+          <a:effectRef idx="1">
+            <a:schemeClr val="accent1"/>
+          </a:effectRef>
+          <a:fontRef idx="minor">
+            <a:schemeClr val="tx1"/>
+          </a:fontRef>
+        </p:style>
+      </p:cxnSp>
+      <p:cxnSp>
+        <p:nvCxnSpPr>
+          <p:cNvPr id="46" name="Connector 45"/>
+          <p:cNvCxnSpPr/>
+          <p:nvPr/>
+        </p:nvCxnSpPr>
+        <p:spPr>
+          <a:xfrm flipV="1">
+            <a:off x="4478528" y="2377440"/>
+            <a:ext cx="0" cy="109728"/>
+          </a:xfrm>
+          <a:prstGeom prst="line">
+            <a:avLst/>
+          </a:prstGeom>
+          <a:ln w="12700">
+            <a:solidFill>
+              <a:srgbClr val="FFB020"/>
+            </a:solidFill>
+            <a:prstDash val="dash"/>
+            <a:headEnd type="triangle" w="med" len="med"/>
+            <a:tailEnd type="triangle" w="med" len="med"/>
+          </a:ln>
+          <a:effectLst/>
+        </p:spPr>
+        <p:style>
+          <a:lnRef idx="2">
+            <a:schemeClr val="accent1"/>
+          </a:lnRef>
+          <a:fillRef idx="0">
+            <a:schemeClr val="accent1"/>
+          </a:fillRef>
+          <a:effectRef idx="1">
+            <a:schemeClr val="accent1"/>
+          </a:effectRef>
+          <a:fontRef idx="minor">
+            <a:schemeClr val="tx1"/>
+          </a:fontRef>
+        </p:style>
+      </p:cxnSp>
+      <p:cxnSp>
+        <p:nvCxnSpPr>
+          <p:cNvPr id="47" name="Connector 46"/>
+          <p:cNvCxnSpPr/>
+          <p:nvPr/>
+        </p:nvCxnSpPr>
+        <p:spPr>
+          <a:xfrm flipV="1">
+            <a:off x="5604256" y="2377440"/>
+            <a:ext cx="0" cy="109728"/>
+          </a:xfrm>
+          <a:prstGeom prst="line">
+            <a:avLst/>
+          </a:prstGeom>
+          <a:ln w="12700">
+            <a:solidFill>
+              <a:srgbClr val="FFB020"/>
+            </a:solidFill>
+            <a:prstDash val="dash"/>
+            <a:headEnd type="triangle" w="med" len="med"/>
+            <a:tailEnd type="triangle" w="med" len="med"/>
+          </a:ln>
+          <a:effectLst/>
+        </p:spPr>
+        <p:style>
+          <a:lnRef idx="2">
+            <a:schemeClr val="accent1"/>
+          </a:lnRef>
+          <a:fillRef idx="0">
+            <a:schemeClr val="accent1"/>
+          </a:fillRef>
+          <a:effectRef idx="1">
+            <a:schemeClr val="accent1"/>
+          </a:effectRef>
+          <a:fontRef idx="minor">
+            <a:schemeClr val="tx1"/>
+          </a:fontRef>
+        </p:style>
+      </p:cxnSp>
+      <p:cxnSp>
+        <p:nvCxnSpPr>
+          <p:cNvPr id="48" name="Connector 47"/>
+          <p:cNvCxnSpPr/>
+          <p:nvPr/>
+        </p:nvCxnSpPr>
+        <p:spPr>
+          <a:xfrm flipV="1">
+            <a:off x="6729984" y="2377440"/>
+            <a:ext cx="0" cy="109728"/>
+          </a:xfrm>
+          <a:prstGeom prst="line">
+            <a:avLst/>
+          </a:prstGeom>
+          <a:ln w="12700">
+            <a:solidFill>
+              <a:srgbClr val="FFB020"/>
+            </a:solidFill>
+            <a:prstDash val="dash"/>
+            <a:headEnd type="triangle" w="med" len="med"/>
+            <a:tailEnd type="triangle" w="med" len="med"/>
+          </a:ln>
+          <a:effectLst/>
+        </p:spPr>
+        <p:style>
+          <a:lnRef idx="2">
+            <a:schemeClr val="accent1"/>
+          </a:lnRef>
+          <a:fillRef idx="0">
+            <a:schemeClr val="accent1"/>
+          </a:fillRef>
+          <a:effectRef idx="1">
+            <a:schemeClr val="accent1"/>
+          </a:effectRef>
+          <a:fontRef idx="minor">
+            <a:schemeClr val="tx1"/>
+          </a:fontRef>
+        </p:style>
+      </p:cxnSp>
+      <p:cxnSp>
+        <p:nvCxnSpPr>
+          <p:cNvPr id="49" name="Connector 48"/>
+          <p:cNvCxnSpPr/>
+          <p:nvPr/>
+        </p:nvCxnSpPr>
+        <p:spPr>
+          <a:xfrm flipV="1">
+            <a:off x="7855711" y="2377440"/>
+            <a:ext cx="0" cy="109728"/>
+          </a:xfrm>
+          <a:prstGeom prst="line">
+            <a:avLst/>
+          </a:prstGeom>
+          <a:ln w="12700">
+            <a:solidFill>
+              <a:srgbClr val="FFB020"/>
+            </a:solidFill>
+            <a:prstDash val="dash"/>
+            <a:headEnd type="triangle" w="med" len="med"/>
+            <a:tailEnd type="triangle" w="med" len="med"/>
+          </a:ln>
+          <a:effectLst/>
+        </p:spPr>
+        <p:style>
+          <a:lnRef idx="2">
+            <a:schemeClr val="accent1"/>
+          </a:lnRef>
+          <a:fillRef idx="0">
+            <a:schemeClr val="accent1"/>
+          </a:fillRef>
+          <a:effectRef idx="1">
+            <a:schemeClr val="accent1"/>
+          </a:effectRef>
+          <a:fontRef idx="minor">
+            <a:schemeClr val="tx1"/>
+          </a:fontRef>
+        </p:style>
+      </p:cxnSp>
+      <p:cxnSp>
+        <p:nvCxnSpPr>
+          <p:cNvPr id="50" name="Connector 49"/>
+          <p:cNvCxnSpPr/>
+          <p:nvPr/>
+        </p:nvCxnSpPr>
+        <p:spPr>
+          <a:xfrm flipV="1">
+            <a:off x="8981439" y="2377440"/>
+            <a:ext cx="0" cy="109728"/>
+          </a:xfrm>
+          <a:prstGeom prst="line">
+            <a:avLst/>
+          </a:prstGeom>
+          <a:ln w="12700">
+            <a:solidFill>
+              <a:srgbClr val="FFB020"/>
+            </a:solidFill>
+            <a:prstDash val="dash"/>
+            <a:headEnd type="triangle" w="med" len="med"/>
+            <a:tailEnd type="triangle" w="med" len="med"/>
+          </a:ln>
+          <a:effectLst/>
+        </p:spPr>
+        <p:style>
+          <a:lnRef idx="2">
+            <a:schemeClr val="accent1"/>
+          </a:lnRef>
+          <a:fillRef idx="0">
+            <a:schemeClr val="accent1"/>
+          </a:fillRef>
+          <a:effectRef idx="1">
+            <a:schemeClr val="accent1"/>
+          </a:effectRef>
+          <a:fontRef idx="minor">
+            <a:schemeClr val="tx1"/>
+          </a:fontRef>
+        </p:style>
+      </p:cxnSp>
+      <p:cxnSp>
+        <p:nvCxnSpPr>
+          <p:cNvPr id="51" name="Connector 50"/>
+          <p:cNvCxnSpPr/>
+          <p:nvPr/>
+        </p:nvCxnSpPr>
+        <p:spPr>
+          <a:xfrm flipV="1">
+            <a:off x="10107167" y="2377440"/>
+            <a:ext cx="0" cy="109728"/>
+          </a:xfrm>
+          <a:prstGeom prst="line">
+            <a:avLst/>
+          </a:prstGeom>
+          <a:ln w="12700">
+            <a:solidFill>
+              <a:srgbClr val="FFB020"/>
+            </a:solidFill>
+            <a:prstDash val="dash"/>
+            <a:headEnd type="triangle" w="med" len="med"/>
+            <a:tailEnd type="triangle" w="med" len="med"/>
+          </a:ln>
+          <a:effectLst/>
+        </p:spPr>
+        <p:style>
+          <a:lnRef idx="2">
+            <a:schemeClr val="accent1"/>
+          </a:lnRef>
+          <a:fillRef idx="0">
+            <a:schemeClr val="accent1"/>
+          </a:fillRef>
+          <a:effectRef idx="1">
+            <a:schemeClr val="accent1"/>
+          </a:effectRef>
+          <a:fontRef idx="minor">
+            <a:schemeClr val="tx1"/>
+          </a:fontRef>
+        </p:style>
+      </p:cxnSp>
+      <p:cxnSp>
+        <p:nvCxnSpPr>
+          <p:cNvPr id="52" name="Connector 51"/>
+          <p:cNvCxnSpPr/>
+          <p:nvPr/>
+        </p:nvCxnSpPr>
+        <p:spPr>
+          <a:xfrm flipV="1">
+            <a:off x="11232895" y="2377440"/>
+            <a:ext cx="0" cy="109728"/>
+          </a:xfrm>
+          <a:prstGeom prst="line">
+            <a:avLst/>
+          </a:prstGeom>
+          <a:ln w="12700">
+            <a:solidFill>
+              <a:srgbClr val="FFB020"/>
+            </a:solidFill>
+            <a:prstDash val="dash"/>
+            <a:headEnd type="triangle" w="med" len="med"/>
+            <a:tailEnd type="triangle" w="med" len="med"/>
+          </a:ln>
+          <a:effectLst/>
+        </p:spPr>
+        <p:style>
+          <a:lnRef idx="2">
+            <a:schemeClr val="accent1"/>
+          </a:lnRef>
+          <a:fillRef idx="0">
+            <a:schemeClr val="accent1"/>
+          </a:fillRef>
+          <a:effectRef idx="1">
+            <a:schemeClr val="accent1"/>
+          </a:effectRef>
+          <a:fontRef idx="minor">
+            <a:schemeClr val="tx1"/>
+          </a:fontRef>
+        </p:style>
+      </p:cxnSp>
+      <p:sp>
+        <p:nvSpPr>
+          <p:cNvPr id="53" name="Rounded Rectangle 52"/>
           <p:cNvSpPr/>
           <p:nvPr/>
         </p:nvSpPr>
         <p:spPr>
           <a:xfrm>
-            <a:off x="1700784" y="4096512"/>
-            <a:ext cx="10058400" cy="987552"/>
+            <a:off x="1700784" y="3913632"/>
+            <a:ext cx="10058400" cy="1188720"/>
           </a:xfrm>
           <a:prstGeom prst="roundRect">
             <a:avLst>
@@ -5877,23 +6273,22 @@
           </a:fontRef>
         </p:style>
         <p:txBody>
-          <a:bodyPr wrap="square" rtlCol="0" anchor="ctr"/>
+          <a:bodyPr rtlCol="0" anchor="ctr" wrap="square"/>
           <a:lstStyle/>
           <a:p>
             <a:pPr algn="ctr"/>
-            <a:endParaRPr/>
-          </a:p>
-        </p:txBody>
-      </p:sp>
-      <p:sp>
-        <p:nvSpPr>
-          <p:cNvPr id="45" name="Rectangle 44"/>
+          </a:p>
+        </p:txBody>
+      </p:sp>
+      <p:sp>
+        <p:nvSpPr>
+          <p:cNvPr id="54" name="Rectangle 53"/>
           <p:cNvSpPr/>
           <p:nvPr/>
         </p:nvSpPr>
         <p:spPr>
           <a:xfrm>
-            <a:off x="1700784" y="4096512"/>
+            <a:off x="1700784" y="3913632"/>
             <a:ext cx="10058400" cy="54864"/>
           </a:xfrm>
           <a:prstGeom prst="rect">
@@ -5922,23 +6317,22 @@
           </a:fontRef>
         </p:style>
         <p:txBody>
-          <a:bodyPr wrap="square" rtlCol="0" anchor="ctr"/>
+          <a:bodyPr rtlCol="0" anchor="ctr" wrap="square"/>
           <a:lstStyle/>
           <a:p>
             <a:pPr algn="ctr"/>
-            <a:endParaRPr/>
-          </a:p>
-        </p:txBody>
-      </p:sp>
-      <p:sp>
-        <p:nvSpPr>
-          <p:cNvPr id="46" name="TextBox 45"/>
+          </a:p>
+        </p:txBody>
+      </p:sp>
+      <p:sp>
+        <p:nvSpPr>
+          <p:cNvPr id="55" name="TextBox 54"/>
           <p:cNvSpPr txBox="1"/>
           <p:nvPr/>
         </p:nvSpPr>
         <p:spPr>
           <a:xfrm>
-            <a:off x="1792224" y="4197096"/>
+            <a:off x="1792224" y="4005072"/>
             <a:ext cx="9875519" cy="182880"/>
           </a:xfrm>
           <a:prstGeom prst="rect">
@@ -5947,7 +6341,7 @@
           <a:noFill/>
         </p:spPr>
         <p:txBody>
-          <a:bodyPr wrap="square" lIns="0" tIns="0" rIns="0" bIns="0" anchor="t">
+          <a:bodyPr wrap="square" anchor="t" lIns="0" rIns="0" tIns="0" bIns="0">
             <a:spAutoFit/>
           </a:bodyPr>
           <a:lstStyle/>
@@ -5970,30 +6364,21 @@
                 </a:solidFill>
                 <a:latin typeface="Segoe UI"/>
               </a:rPr>
-              <a:t>LEGACY DATA SOURCE SYSTEMS   </a:t>
-            </a:r>
-            <a:r>
-              <a:rPr sz="740" b="0" i="0">
-                <a:solidFill>
-                  <a:srgbClr val="C2C2D0"/>
-                </a:solidFill>
-                <a:latin typeface="Segoe UI"/>
-              </a:rPr>
-              <a:t>— every agent validates against these systems of record (ERP / CRM / legacy DBs)</a:t>
-            </a:r>
-          </a:p>
-        </p:txBody>
-      </p:sp>
-      <p:sp>
-        <p:nvSpPr>
-          <p:cNvPr id="47" name="Rounded Rectangle 46"/>
+              <a:t>LEGACY DATA SOURCE SYSTEMS</a:t>
+            </a:r>
+          </a:p>
+        </p:txBody>
+      </p:sp>
+      <p:sp>
+        <p:nvSpPr>
+          <p:cNvPr id="56" name="Rounded Rectangle 55"/>
           <p:cNvSpPr/>
           <p:nvPr/>
         </p:nvSpPr>
         <p:spPr>
           <a:xfrm>
-            <a:off x="1792224" y="4480560"/>
-            <a:ext cx="1569720" cy="475488"/>
+            <a:off x="1792224" y="4261104"/>
+            <a:ext cx="1872691" cy="768096"/>
           </a:xfrm>
           <a:prstGeom prst="roundRect">
             <a:avLst>
@@ -6003,9 +6388,9 @@
           <a:solidFill>
             <a:srgbClr val="2E2E40"/>
           </a:solidFill>
-          <a:ln w="8890">
+          <a:ln w="17780">
             <a:solidFill>
-              <a:srgbClr val="3C3C4E"/>
+              <a:srgbClr val="A97BFF"/>
             </a:solidFill>
           </a:ln>
           <a:effectLst/>
@@ -6025,12 +6410,12 @@
           </a:fontRef>
         </p:style>
         <p:txBody>
-          <a:bodyPr wrap="square" lIns="27432" tIns="9144" rIns="27432" bIns="9144" rtlCol="0" anchor="ctr"/>
+          <a:bodyPr rtlCol="0" anchor="ctr" wrap="square" lIns="27432" rIns="27432" tIns="9144" bIns="9144"/>
           <a:lstStyle/>
           <a:p>
             <a:pPr algn="ctr">
               <a:lnSpc>
-                <a:spcPct val="95000"/>
+                <a:spcPct val="102000"/>
               </a:lnSpc>
               <a:spcBef>
                 <a:spcPts val="0"/>
@@ -6040,40 +6425,102 @@
               </a:spcAft>
             </a:pPr>
             <a:r>
-              <a:rPr sz="720" b="0" i="0">
-                <a:solidFill>
-                  <a:srgbClr val="FFFFFF"/>
-                </a:solidFill>
-                <a:latin typeface="Segoe UI"/>
-              </a:rPr>
-              <a:t>Master data</a:t>
-            </a:r>
-          </a:p>
-        </p:txBody>
-      </p:sp>
-      <p:sp>
-        <p:nvSpPr>
-          <p:cNvPr id="48" name="Rounded Rectangle 47"/>
+              <a:rPr sz="950" b="1" i="0">
+                <a:solidFill>
+                  <a:srgbClr val="A97BFF"/>
+                </a:solidFill>
+                <a:latin typeface="Segoe UI"/>
+              </a:rPr>
+              <a:t>PIM</a:t>
+            </a:r>
+          </a:p>
+          <a:p>
+            <a:pPr algn="ctr">
+              <a:lnSpc>
+                <a:spcPct val="102000"/>
+              </a:lnSpc>
+              <a:spcBef>
+                <a:spcPts val="0"/>
+              </a:spcBef>
+              <a:spcAft>
+                <a:spcPts val="0"/>
+              </a:spcAft>
+            </a:pPr>
+            <a:r>
+              <a:rPr sz="600" b="0" i="0">
+                <a:solidFill>
+                  <a:srgbClr val="C2C2D0"/>
+                </a:solidFill>
+                <a:latin typeface="Segoe UI"/>
+              </a:rPr>
+              <a:t>Product catalog,</a:t>
+            </a:r>
+          </a:p>
+          <a:p>
+            <a:pPr algn="ctr">
+              <a:lnSpc>
+                <a:spcPct val="102000"/>
+              </a:lnSpc>
+              <a:spcBef>
+                <a:spcPts val="0"/>
+              </a:spcBef>
+              <a:spcAft>
+                <a:spcPts val="0"/>
+              </a:spcAft>
+            </a:pPr>
+            <a:r>
+              <a:rPr sz="600" b="0" i="0">
+                <a:solidFill>
+                  <a:srgbClr val="C2C2D0"/>
+                </a:solidFill>
+                <a:latin typeface="Segoe UI"/>
+              </a:rPr>
+              <a:t>attributes, UOM,</a:t>
+            </a:r>
+          </a:p>
+          <a:p>
+            <a:pPr algn="ctr">
+              <a:lnSpc>
+                <a:spcPct val="102000"/>
+              </a:lnSpc>
+              <a:spcBef>
+                <a:spcPts val="0"/>
+              </a:spcBef>
+              <a:spcAft>
+                <a:spcPts val="0"/>
+              </a:spcAft>
+            </a:pPr>
+            <a:r>
+              <a:rPr sz="600" b="0" i="0">
+                <a:solidFill>
+                  <a:srgbClr val="C2C2D0"/>
+                </a:solidFill>
+                <a:latin typeface="Segoe UI"/>
+              </a:rPr>
+              <a:t>compliance</a:t>
+            </a:r>
+          </a:p>
+        </p:txBody>
+      </p:sp>
+      <p:sp>
+        <p:nvSpPr>
+          <p:cNvPr id="57" name="Rectangle 56"/>
           <p:cNvSpPr/>
           <p:nvPr/>
         </p:nvSpPr>
         <p:spPr>
           <a:xfrm>
-            <a:off x="3453383" y="4480560"/>
-            <a:ext cx="1569720" cy="475488"/>
-          </a:xfrm>
-          <a:prstGeom prst="roundRect">
-            <a:avLst>
-              <a:gd name="adj" fmla="val 6000"/>
-            </a:avLst>
+            <a:off x="1792224" y="4261104"/>
+            <a:ext cx="1872691" cy="54864"/>
+          </a:xfrm>
+          <a:prstGeom prst="rect">
+            <a:avLst/>
           </a:prstGeom>
           <a:solidFill>
-            <a:srgbClr val="2E2E40"/>
+            <a:srgbClr val="A97BFF"/>
           </a:solidFill>
-          <a:ln w="8890">
-            <a:solidFill>
-              <a:srgbClr val="3C3C4E"/>
-            </a:solidFill>
+          <a:ln>
+            <a:noFill/>
           </a:ln>
           <a:effectLst/>
         </p:spPr>
@@ -6092,64 +6539,23 @@
           </a:fontRef>
         </p:style>
         <p:txBody>
-          <a:bodyPr wrap="square" lIns="27432" tIns="9144" rIns="27432" bIns="9144" rtlCol="0" anchor="ctr"/>
-          <a:lstStyle/>
-          <a:p>
-            <a:pPr algn="ctr">
-              <a:lnSpc>
-                <a:spcPct val="95000"/>
-              </a:lnSpc>
-              <a:spcBef>
-                <a:spcPts val="0"/>
-              </a:spcBef>
-              <a:spcAft>
-                <a:spcPts val="0"/>
-              </a:spcAft>
-            </a:pPr>
-            <a:r>
-              <a:rPr sz="720" b="0" i="0">
-                <a:solidFill>
-                  <a:srgbClr val="FFFFFF"/>
-                </a:solidFill>
-                <a:latin typeface="Segoe UI"/>
-              </a:rPr>
-              <a:t>Pricing &amp;</a:t>
-            </a:r>
-          </a:p>
-          <a:p>
-            <a:pPr algn="ctr">
-              <a:lnSpc>
-                <a:spcPct val="95000"/>
-              </a:lnSpc>
-              <a:spcBef>
-                <a:spcPts val="0"/>
-              </a:spcBef>
-              <a:spcAft>
-                <a:spcPts val="0"/>
-              </a:spcAft>
-            </a:pPr>
-            <a:r>
-              <a:rPr sz="720" b="0" i="0">
-                <a:solidFill>
-                  <a:srgbClr val="FFFFFF"/>
-                </a:solidFill>
-                <a:latin typeface="Segoe UI"/>
-              </a:rPr>
-              <a:t>contracts</a:t>
-            </a:r>
-          </a:p>
-        </p:txBody>
-      </p:sp>
-      <p:sp>
-        <p:nvSpPr>
-          <p:cNvPr id="49" name="Rounded Rectangle 48"/>
+          <a:bodyPr rtlCol="0" anchor="ctr" wrap="square"/>
+          <a:lstStyle/>
+          <a:p>
+            <a:pPr algn="ctr"/>
+          </a:p>
+        </p:txBody>
+      </p:sp>
+      <p:sp>
+        <p:nvSpPr>
+          <p:cNvPr id="58" name="Rounded Rectangle 57"/>
           <p:cNvSpPr/>
           <p:nvPr/>
         </p:nvSpPr>
         <p:spPr>
           <a:xfrm>
-            <a:off x="5114544" y="4480560"/>
-            <a:ext cx="1569720" cy="475488"/>
+            <a:off x="3792931" y="4261104"/>
+            <a:ext cx="1872691" cy="768096"/>
           </a:xfrm>
           <a:prstGeom prst="roundRect">
             <a:avLst>
@@ -6159,9 +6565,9 @@
           <a:solidFill>
             <a:srgbClr val="2E2E40"/>
           </a:solidFill>
-          <a:ln w="8890">
+          <a:ln w="17780">
             <a:solidFill>
-              <a:srgbClr val="3C3C4E"/>
+              <a:srgbClr val="4A9EFF"/>
             </a:solidFill>
           </a:ln>
           <a:effectLst/>
@@ -6181,12 +6587,12 @@
           </a:fontRef>
         </p:style>
         <p:txBody>
-          <a:bodyPr wrap="square" lIns="27432" tIns="9144" rIns="27432" bIns="9144" rtlCol="0" anchor="ctr"/>
+          <a:bodyPr rtlCol="0" anchor="ctr" wrap="square" lIns="27432" rIns="27432" tIns="9144" bIns="9144"/>
           <a:lstStyle/>
           <a:p>
             <a:pPr algn="ctr">
               <a:lnSpc>
-                <a:spcPct val="95000"/>
+                <a:spcPct val="102000"/>
               </a:lnSpc>
               <a:spcBef>
                 <a:spcPts val="0"/>
@@ -6196,19 +6602,19 @@
               </a:spcAft>
             </a:pPr>
             <a:r>
-              <a:rPr sz="720" b="0" i="0">
-                <a:solidFill>
-                  <a:srgbClr val="FFFFFF"/>
-                </a:solidFill>
-                <a:latin typeface="Segoe UI"/>
-              </a:rPr>
-              <a:t>Credit &amp;</a:t>
+              <a:rPr sz="950" b="1" i="0">
+                <a:solidFill>
+                  <a:srgbClr val="4A9EFF"/>
+                </a:solidFill>
+                <a:latin typeface="Segoe UI"/>
+              </a:rPr>
+              <a:t>ERP</a:t>
             </a:r>
           </a:p>
           <a:p>
             <a:pPr algn="ctr">
               <a:lnSpc>
-                <a:spcPct val="95000"/>
+                <a:spcPct val="102000"/>
               </a:lnSpc>
               <a:spcBef>
                 <a:spcPts val="0"/>
@@ -6218,40 +6624,80 @@
               </a:spcAft>
             </a:pPr>
             <a:r>
-              <a:rPr sz="720" b="0" i="0">
-                <a:solidFill>
-                  <a:srgbClr val="FFFFFF"/>
-                </a:solidFill>
-                <a:latin typeface="Segoe UI"/>
-              </a:rPr>
-              <a:t>terms</a:t>
-            </a:r>
-          </a:p>
-        </p:txBody>
-      </p:sp>
-      <p:sp>
-        <p:nvSpPr>
-          <p:cNvPr id="50" name="Rounded Rectangle 49"/>
+              <a:rPr sz="600" b="0" i="0">
+                <a:solidFill>
+                  <a:srgbClr val="C2C2D0"/>
+                </a:solidFill>
+                <a:latin typeface="Segoe UI"/>
+              </a:rPr>
+              <a:t>Inventory,</a:t>
+            </a:r>
+          </a:p>
+          <a:p>
+            <a:pPr algn="ctr">
+              <a:lnSpc>
+                <a:spcPct val="102000"/>
+              </a:lnSpc>
+              <a:spcBef>
+                <a:spcPts val="0"/>
+              </a:spcBef>
+              <a:spcAft>
+                <a:spcPts val="0"/>
+              </a:spcAft>
+            </a:pPr>
+            <a:r>
+              <a:rPr sz="600" b="0" i="0">
+                <a:solidFill>
+                  <a:srgbClr val="C2C2D0"/>
+                </a:solidFill>
+                <a:latin typeface="Segoe UI"/>
+              </a:rPr>
+              <a:t>credit, budget</a:t>
+            </a:r>
+          </a:p>
+          <a:p>
+            <a:pPr algn="ctr">
+              <a:lnSpc>
+                <a:spcPct val="102000"/>
+              </a:lnSpc>
+              <a:spcBef>
+                <a:spcPts val="0"/>
+              </a:spcBef>
+              <a:spcAft>
+                <a:spcPts val="0"/>
+              </a:spcAft>
+            </a:pPr>
+            <a:r>
+              <a:rPr sz="600" b="0" i="0">
+                <a:solidFill>
+                  <a:srgbClr val="C2C2D0"/>
+                </a:solidFill>
+                <a:latin typeface="Segoe UI"/>
+              </a:rPr>
+              <a:t>&amp; approvals</a:t>
+            </a:r>
+          </a:p>
+        </p:txBody>
+      </p:sp>
+      <p:sp>
+        <p:nvSpPr>
+          <p:cNvPr id="59" name="Rectangle 58"/>
           <p:cNvSpPr/>
           <p:nvPr/>
         </p:nvSpPr>
         <p:spPr>
           <a:xfrm>
-            <a:off x="6775704" y="4480560"/>
-            <a:ext cx="1569720" cy="475488"/>
-          </a:xfrm>
-          <a:prstGeom prst="roundRect">
-            <a:avLst>
-              <a:gd name="adj" fmla="val 6000"/>
-            </a:avLst>
+            <a:off x="3792931" y="4261104"/>
+            <a:ext cx="1872691" cy="54864"/>
+          </a:xfrm>
+          <a:prstGeom prst="rect">
+            <a:avLst/>
           </a:prstGeom>
           <a:solidFill>
-            <a:srgbClr val="2E2E40"/>
+            <a:srgbClr val="4A9EFF"/>
           </a:solidFill>
-          <a:ln w="8890">
-            <a:solidFill>
-              <a:srgbClr val="3C3C4E"/>
-            </a:solidFill>
+          <a:ln>
+            <a:noFill/>
           </a:ln>
           <a:effectLst/>
         </p:spPr>
@@ -6270,64 +6716,23 @@
           </a:fontRef>
         </p:style>
         <p:txBody>
-          <a:bodyPr wrap="square" lIns="27432" tIns="9144" rIns="27432" bIns="9144" rtlCol="0" anchor="ctr"/>
-          <a:lstStyle/>
-          <a:p>
-            <a:pPr algn="ctr">
-              <a:lnSpc>
-                <a:spcPct val="95000"/>
-              </a:lnSpc>
-              <a:spcBef>
-                <a:spcPts val="0"/>
-              </a:spcBef>
-              <a:spcAft>
-                <a:spcPts val="0"/>
-              </a:spcAft>
-            </a:pPr>
-            <a:r>
-              <a:rPr sz="720" b="0" i="0">
-                <a:solidFill>
-                  <a:srgbClr val="FFFFFF"/>
-                </a:solidFill>
-                <a:latin typeface="Segoe UI"/>
-              </a:rPr>
-              <a:t>Inventory</a:t>
-            </a:r>
-          </a:p>
-          <a:p>
-            <a:pPr algn="ctr">
-              <a:lnSpc>
-                <a:spcPct val="95000"/>
-              </a:lnSpc>
-              <a:spcBef>
-                <a:spcPts val="0"/>
-              </a:spcBef>
-              <a:spcAft>
-                <a:spcPts val="0"/>
-              </a:spcAft>
-            </a:pPr>
-            <a:r>
-              <a:rPr sz="720" b="0" i="0">
-                <a:solidFill>
-                  <a:srgbClr val="FFFFFF"/>
-                </a:solidFill>
-                <a:latin typeface="Segoe UI"/>
-              </a:rPr>
-              <a:t>/ ATP</a:t>
-            </a:r>
-          </a:p>
-        </p:txBody>
-      </p:sp>
-      <p:sp>
-        <p:nvSpPr>
-          <p:cNvPr id="51" name="Rounded Rectangle 50"/>
+          <a:bodyPr rtlCol="0" anchor="ctr" wrap="square"/>
+          <a:lstStyle/>
+          <a:p>
+            <a:pPr algn="ctr"/>
+          </a:p>
+        </p:txBody>
+      </p:sp>
+      <p:sp>
+        <p:nvSpPr>
+          <p:cNvPr id="60" name="Rounded Rectangle 59"/>
           <p:cNvSpPr/>
           <p:nvPr/>
         </p:nvSpPr>
         <p:spPr>
           <a:xfrm>
-            <a:off x="8436864" y="4480560"/>
-            <a:ext cx="1569720" cy="475488"/>
+            <a:off x="5793638" y="4261104"/>
+            <a:ext cx="1872691" cy="768096"/>
           </a:xfrm>
           <a:prstGeom prst="roundRect">
             <a:avLst>
@@ -6337,9 +6742,9 @@
           <a:solidFill>
             <a:srgbClr val="2E2E40"/>
           </a:solidFill>
-          <a:ln w="8890">
+          <a:ln w="17780">
             <a:solidFill>
-              <a:srgbClr val="3C3C4E"/>
+              <a:srgbClr val="35C759"/>
             </a:solidFill>
           </a:ln>
           <a:effectLst/>
@@ -6359,12 +6764,12 @@
           </a:fontRef>
         </p:style>
         <p:txBody>
-          <a:bodyPr wrap="square" lIns="27432" tIns="9144" rIns="27432" bIns="9144" rtlCol="0" anchor="ctr"/>
+          <a:bodyPr rtlCol="0" anchor="ctr" wrap="square" lIns="27432" rIns="27432" tIns="9144" bIns="9144"/>
           <a:lstStyle/>
           <a:p>
             <a:pPr algn="ctr">
               <a:lnSpc>
-                <a:spcPct val="95000"/>
+                <a:spcPct val="102000"/>
               </a:lnSpc>
               <a:spcBef>
                 <a:spcPts val="0"/>
@@ -6374,19 +6779,19 @@
               </a:spcAft>
             </a:pPr>
             <a:r>
-              <a:rPr sz="720" b="0" i="0">
-                <a:solidFill>
-                  <a:srgbClr val="FFFFFF"/>
-                </a:solidFill>
-                <a:latin typeface="Segoe UI"/>
-              </a:rPr>
-              <a:t>Logistics</a:t>
+              <a:rPr sz="950" b="1" i="0">
+                <a:solidFill>
+                  <a:srgbClr val="35C759"/>
+                </a:solidFill>
+                <a:latin typeface="Segoe UI"/>
+              </a:rPr>
+              <a:t>Commerce</a:t>
             </a:r>
           </a:p>
           <a:p>
             <a:pPr algn="ctr">
               <a:lnSpc>
-                <a:spcPct val="95000"/>
+                <a:spcPct val="102000"/>
               </a:lnSpc>
               <a:spcBef>
                 <a:spcPts val="0"/>
@@ -6396,40 +6801,80 @@
               </a:spcAft>
             </a:pPr>
             <a:r>
-              <a:rPr sz="720" b="0" i="0">
-                <a:solidFill>
-                  <a:srgbClr val="FFFFFF"/>
-                </a:solidFill>
-                <a:latin typeface="Segoe UI"/>
-              </a:rPr>
-              <a:t>&amp; carriers</a:t>
-            </a:r>
-          </a:p>
-        </p:txBody>
-      </p:sp>
-      <p:sp>
-        <p:nvSpPr>
-          <p:cNvPr id="52" name="Rounded Rectangle 51"/>
+              <a:rPr sz="600" b="0" i="0">
+                <a:solidFill>
+                  <a:srgbClr val="C2C2D0"/>
+                </a:solidFill>
+                <a:latin typeface="Segoe UI"/>
+              </a:rPr>
+              <a:t>Pricing &amp; promos,</a:t>
+            </a:r>
+          </a:p>
+          <a:p>
+            <a:pPr algn="ctr">
+              <a:lnSpc>
+                <a:spcPct val="102000"/>
+              </a:lnSpc>
+              <a:spcBef>
+                <a:spcPts val="0"/>
+              </a:spcBef>
+              <a:spcAft>
+                <a:spcPts val="0"/>
+              </a:spcAft>
+            </a:pPr>
+            <a:r>
+              <a:rPr sz="600" b="0" i="0">
+                <a:solidFill>
+                  <a:srgbClr val="C2C2D0"/>
+                </a:solidFill>
+                <a:latin typeface="Segoe UI"/>
+              </a:rPr>
+              <a:t>customer &amp;</a:t>
+            </a:r>
+          </a:p>
+          <a:p>
+            <a:pPr algn="ctr">
+              <a:lnSpc>
+                <a:spcPct val="102000"/>
+              </a:lnSpc>
+              <a:spcBef>
+                <a:spcPts val="0"/>
+              </a:spcBef>
+              <a:spcAft>
+                <a:spcPts val="0"/>
+              </a:spcAft>
+            </a:pPr>
+            <a:r>
+              <a:rPr sz="600" b="0" i="0">
+                <a:solidFill>
+                  <a:srgbClr val="C2C2D0"/>
+                </a:solidFill>
+                <a:latin typeface="Segoe UI"/>
+              </a:rPr>
+              <a:t>buyer master</a:t>
+            </a:r>
+          </a:p>
+        </p:txBody>
+      </p:sp>
+      <p:sp>
+        <p:nvSpPr>
+          <p:cNvPr id="61" name="Rectangle 60"/>
           <p:cNvSpPr/>
           <p:nvPr/>
         </p:nvSpPr>
         <p:spPr>
           <a:xfrm>
-            <a:off x="10098024" y="4480560"/>
-            <a:ext cx="1569720" cy="475488"/>
-          </a:xfrm>
-          <a:prstGeom prst="roundRect">
-            <a:avLst>
-              <a:gd name="adj" fmla="val 6000"/>
-            </a:avLst>
+            <a:off x="5793638" y="4261104"/>
+            <a:ext cx="1872691" cy="54864"/>
+          </a:xfrm>
+          <a:prstGeom prst="rect">
+            <a:avLst/>
           </a:prstGeom>
           <a:solidFill>
-            <a:srgbClr val="2E2E40"/>
+            <a:srgbClr val="35C759"/>
           </a:solidFill>
-          <a:ln w="8890">
-            <a:solidFill>
-              <a:srgbClr val="3C3C4E"/>
-            </a:solidFill>
+          <a:ln>
+            <a:noFill/>
           </a:ln>
           <a:effectLst/>
         </p:spPr>
@@ -6448,12 +6893,60 @@
           </a:fontRef>
         </p:style>
         <p:txBody>
-          <a:bodyPr wrap="square" lIns="27432" tIns="9144" rIns="27432" bIns="9144" rtlCol="0" anchor="ctr"/>
+          <a:bodyPr rtlCol="0" anchor="ctr" wrap="square"/>
+          <a:lstStyle/>
+          <a:p>
+            <a:pPr algn="ctr"/>
+          </a:p>
+        </p:txBody>
+      </p:sp>
+      <p:sp>
+        <p:nvSpPr>
+          <p:cNvPr id="62" name="Rounded Rectangle 61"/>
+          <p:cNvSpPr/>
+          <p:nvPr/>
+        </p:nvSpPr>
+        <p:spPr>
+          <a:xfrm>
+            <a:off x="7794345" y="4261104"/>
+            <a:ext cx="1872691" cy="768096"/>
+          </a:xfrm>
+          <a:prstGeom prst="roundRect">
+            <a:avLst>
+              <a:gd name="adj" fmla="val 6000"/>
+            </a:avLst>
+          </a:prstGeom>
+          <a:solidFill>
+            <a:srgbClr val="2E2E40"/>
+          </a:solidFill>
+          <a:ln w="17780">
+            <a:solidFill>
+              <a:srgbClr val="FF8A3D"/>
+            </a:solidFill>
+          </a:ln>
+          <a:effectLst/>
+        </p:spPr>
+        <p:style>
+          <a:lnRef idx="1">
+            <a:schemeClr val="accent1"/>
+          </a:lnRef>
+          <a:fillRef idx="3">
+            <a:schemeClr val="accent1"/>
+          </a:fillRef>
+          <a:effectRef idx="2">
+            <a:schemeClr val="accent1"/>
+          </a:effectRef>
+          <a:fontRef idx="minor">
+            <a:schemeClr val="lt1"/>
+          </a:fontRef>
+        </p:style>
+        <p:txBody>
+          <a:bodyPr rtlCol="0" anchor="ctr" wrap="square" lIns="27432" rIns="27432" tIns="9144" bIns="9144"/>
           <a:lstStyle/>
           <a:p>
             <a:pPr algn="ctr">
               <a:lnSpc>
-                <a:spcPct val="95000"/>
+                <a:spcPct val="102000"/>
               </a:lnSpc>
               <a:spcBef>
                 <a:spcPts val="0"/>
@@ -6463,19 +6956,19 @@
               </a:spcAft>
             </a:pPr>
             <a:r>
-              <a:rPr sz="720" b="0" i="0">
-                <a:solidFill>
-                  <a:srgbClr val="FFFFFF"/>
-                </a:solidFill>
-                <a:latin typeface="Segoe UI"/>
-              </a:rPr>
-              <a:t>Approvals matrix</a:t>
+              <a:rPr sz="950" b="1" i="0">
+                <a:solidFill>
+                  <a:srgbClr val="FF8A3D"/>
+                </a:solidFill>
+                <a:latin typeface="Segoe UI"/>
+              </a:rPr>
+              <a:t>OMS</a:t>
             </a:r>
           </a:p>
           <a:p>
             <a:pPr algn="ctr">
               <a:lnSpc>
-                <a:spcPct val="95000"/>
+                <a:spcPct val="102000"/>
               </a:lnSpc>
               <a:spcBef>
                 <a:spcPts val="0"/>
@@ -6485,524 +6978,260 @@
               </a:spcAft>
             </a:pPr>
             <a:r>
-              <a:rPr sz="720" b="0" i="0">
-                <a:solidFill>
-                  <a:srgbClr val="FFFFFF"/>
-                </a:solidFill>
-                <a:latin typeface="Segoe UI"/>
-              </a:rPr>
-              <a:t>&amp; budget</a:t>
-            </a:r>
-          </a:p>
-        </p:txBody>
-      </p:sp>
-      <p:cxnSp>
-        <p:nvCxnSpPr>
-          <p:cNvPr id="53" name="Connector 52"/>
-          <p:cNvCxnSpPr/>
+              <a:rPr sz="600" b="0" i="0">
+                <a:solidFill>
+                  <a:srgbClr val="C2C2D0"/>
+                </a:solidFill>
+                <a:latin typeface="Segoe UI"/>
+              </a:rPr>
+              <a:t>Order &amp;</a:t>
+            </a:r>
+          </a:p>
+          <a:p>
+            <a:pPr algn="ctr">
+              <a:lnSpc>
+                <a:spcPct val="102000"/>
+              </a:lnSpc>
+              <a:spcBef>
+                <a:spcPts val="0"/>
+              </a:spcBef>
+              <a:spcAft>
+                <a:spcPts val="0"/>
+              </a:spcAft>
+            </a:pPr>
+            <a:r>
+              <a:rPr sz="600" b="0" i="0">
+                <a:solidFill>
+                  <a:srgbClr val="C2C2D0"/>
+                </a:solidFill>
+                <a:latin typeface="Segoe UI"/>
+              </a:rPr>
+              <a:t>buying history</a:t>
+            </a:r>
+          </a:p>
+        </p:txBody>
+      </p:sp>
+      <p:sp>
+        <p:nvSpPr>
+          <p:cNvPr id="63" name="Rectangle 62"/>
+          <p:cNvSpPr/>
           <p:nvPr/>
-        </p:nvCxnSpPr>
-        <p:spPr>
-          <a:xfrm flipV="1">
-            <a:off x="2227071" y="2377440"/>
-            <a:ext cx="0" cy="329184"/>
-          </a:xfrm>
-          <a:prstGeom prst="line">
+        </p:nvSpPr>
+        <p:spPr>
+          <a:xfrm>
+            <a:off x="7794345" y="4261104"/>
+            <a:ext cx="1872691" cy="54864"/>
+          </a:xfrm>
+          <a:prstGeom prst="rect">
             <a:avLst/>
           </a:prstGeom>
-          <a:ln w="12700">
-            <a:solidFill>
-              <a:srgbClr val="FFB020"/>
-            </a:solidFill>
-            <a:prstDash val="dash"/>
-            <a:headEnd type="triangle" w="med" len="med"/>
-            <a:tailEnd type="triangle" w="med" len="med"/>
+          <a:solidFill>
+            <a:srgbClr val="FF8A3D"/>
+          </a:solidFill>
+          <a:ln>
+            <a:noFill/>
           </a:ln>
           <a:effectLst/>
         </p:spPr>
         <p:style>
-          <a:lnRef idx="2">
+          <a:lnRef idx="1">
             <a:schemeClr val="accent1"/>
           </a:lnRef>
-          <a:fillRef idx="0">
+          <a:fillRef idx="3">
             <a:schemeClr val="accent1"/>
           </a:fillRef>
-          <a:effectRef idx="1">
+          <a:effectRef idx="2">
             <a:schemeClr val="accent1"/>
           </a:effectRef>
           <a:fontRef idx="minor">
-            <a:schemeClr val="tx1"/>
+            <a:schemeClr val="lt1"/>
           </a:fontRef>
         </p:style>
-      </p:cxnSp>
-      <p:cxnSp>
-        <p:nvCxnSpPr>
-          <p:cNvPr id="54" name="Connector 53"/>
-          <p:cNvCxnSpPr/>
+        <p:txBody>
+          <a:bodyPr rtlCol="0" anchor="ctr" wrap="square"/>
+          <a:lstStyle/>
+          <a:p>
+            <a:pPr algn="ctr"/>
+          </a:p>
+        </p:txBody>
+      </p:sp>
+      <p:sp>
+        <p:nvSpPr>
+          <p:cNvPr id="64" name="Rounded Rectangle 63"/>
+          <p:cNvSpPr/>
           <p:nvPr/>
-        </p:nvCxnSpPr>
-        <p:spPr>
-          <a:xfrm>
-            <a:off x="2227071" y="3767328"/>
-            <a:ext cx="0" cy="329184"/>
-          </a:xfrm>
-          <a:prstGeom prst="line">
-            <a:avLst/>
-          </a:prstGeom>
-          <a:ln w="12700">
+        </p:nvSpPr>
+        <p:spPr>
+          <a:xfrm>
+            <a:off x="9795052" y="4261104"/>
+            <a:ext cx="1872691" cy="768096"/>
+          </a:xfrm>
+          <a:prstGeom prst="roundRect">
+            <a:avLst>
+              <a:gd name="adj" fmla="val 6000"/>
+            </a:avLst>
+          </a:prstGeom>
+          <a:solidFill>
+            <a:srgbClr val="2E2E40"/>
+          </a:solidFill>
+          <a:ln w="17780">
             <a:solidFill>
               <a:srgbClr val="33C9C9"/>
             </a:solidFill>
-            <a:prstDash val="dash"/>
-            <a:headEnd type="triangle" w="med" len="med"/>
-            <a:tailEnd type="triangle" w="med" len="med"/>
           </a:ln>
           <a:effectLst/>
         </p:spPr>
         <p:style>
-          <a:lnRef idx="2">
+          <a:lnRef idx="1">
             <a:schemeClr val="accent1"/>
           </a:lnRef>
-          <a:fillRef idx="0">
+          <a:fillRef idx="3">
             <a:schemeClr val="accent1"/>
           </a:fillRef>
-          <a:effectRef idx="1">
+          <a:effectRef idx="2">
             <a:schemeClr val="accent1"/>
           </a:effectRef>
           <a:fontRef idx="minor">
-            <a:schemeClr val="tx1"/>
+            <a:schemeClr val="lt1"/>
           </a:fontRef>
         </p:style>
-      </p:cxnSp>
-      <p:cxnSp>
-        <p:nvCxnSpPr>
-          <p:cNvPr id="55" name="Connector 54"/>
-          <p:cNvCxnSpPr/>
+        <p:txBody>
+          <a:bodyPr rtlCol="0" anchor="ctr" wrap="square" lIns="27432" rIns="27432" tIns="9144" bIns="9144"/>
+          <a:lstStyle/>
+          <a:p>
+            <a:pPr algn="ctr">
+              <a:lnSpc>
+                <a:spcPct val="102000"/>
+              </a:lnSpc>
+              <a:spcBef>
+                <a:spcPts val="0"/>
+              </a:spcBef>
+              <a:spcAft>
+                <a:spcPts val="0"/>
+              </a:spcAft>
+            </a:pPr>
+            <a:r>
+              <a:rPr sz="950" b="1" i="0">
+                <a:solidFill>
+                  <a:srgbClr val="33C9C9"/>
+                </a:solidFill>
+                <a:latin typeface="Segoe UI"/>
+              </a:rPr>
+              <a:t>Shipping Provider</a:t>
+            </a:r>
+          </a:p>
+          <a:p>
+            <a:pPr algn="ctr">
+              <a:lnSpc>
+                <a:spcPct val="102000"/>
+              </a:lnSpc>
+              <a:spcBef>
+                <a:spcPts val="0"/>
+              </a:spcBef>
+              <a:spcAft>
+                <a:spcPts val="0"/>
+              </a:spcAft>
+            </a:pPr>
+            <a:r>
+              <a:rPr sz="600" b="0" i="0">
+                <a:solidFill>
+                  <a:srgbClr val="C2C2D0"/>
+                </a:solidFill>
+                <a:latin typeface="Segoe UI"/>
+              </a:rPr>
+              <a:t>Carrier coverage,</a:t>
+            </a:r>
+          </a:p>
+          <a:p>
+            <a:pPr algn="ctr">
+              <a:lnSpc>
+                <a:spcPct val="102000"/>
+              </a:lnSpc>
+              <a:spcBef>
+                <a:spcPts val="0"/>
+              </a:spcBef>
+              <a:spcAft>
+                <a:spcPts val="0"/>
+              </a:spcAft>
+            </a:pPr>
+            <a:r>
+              <a:rPr sz="600" b="0" i="0">
+                <a:solidFill>
+                  <a:srgbClr val="C2C2D0"/>
+                </a:solidFill>
+                <a:latin typeface="Segoe UI"/>
+              </a:rPr>
+              <a:t>freight &amp;</a:t>
+            </a:r>
+          </a:p>
+          <a:p>
+            <a:pPr algn="ctr">
+              <a:lnSpc>
+                <a:spcPct val="102000"/>
+              </a:lnSpc>
+              <a:spcBef>
+                <a:spcPts val="0"/>
+              </a:spcBef>
+              <a:spcAft>
+                <a:spcPts val="0"/>
+              </a:spcAft>
+            </a:pPr>
+            <a:r>
+              <a:rPr sz="600" b="0" i="0">
+                <a:solidFill>
+                  <a:srgbClr val="C2C2D0"/>
+                </a:solidFill>
+                <a:latin typeface="Segoe UI"/>
+              </a:rPr>
+              <a:t>delivery SLA</a:t>
+            </a:r>
+          </a:p>
+        </p:txBody>
+      </p:sp>
+      <p:sp>
+        <p:nvSpPr>
+          <p:cNvPr id="65" name="Rectangle 64"/>
+          <p:cNvSpPr/>
           <p:nvPr/>
-        </p:nvCxnSpPr>
-        <p:spPr>
-          <a:xfrm flipV="1">
-            <a:off x="3352800" y="2377440"/>
-            <a:ext cx="0" cy="329184"/>
-          </a:xfrm>
-          <a:prstGeom prst="line">
+        </p:nvSpPr>
+        <p:spPr>
+          <a:xfrm>
+            <a:off x="9795052" y="4261104"/>
+            <a:ext cx="1872691" cy="54864"/>
+          </a:xfrm>
+          <a:prstGeom prst="rect">
             <a:avLst/>
           </a:prstGeom>
-          <a:ln w="12700">
-            <a:solidFill>
-              <a:srgbClr val="FFB020"/>
-            </a:solidFill>
-            <a:prstDash val="dash"/>
-            <a:headEnd type="triangle" w="med" len="med"/>
-            <a:tailEnd type="triangle" w="med" len="med"/>
+          <a:solidFill>
+            <a:srgbClr val="33C9C9"/>
+          </a:solidFill>
+          <a:ln>
+            <a:noFill/>
           </a:ln>
           <a:effectLst/>
         </p:spPr>
         <p:style>
-          <a:lnRef idx="2">
+          <a:lnRef idx="1">
             <a:schemeClr val="accent1"/>
           </a:lnRef>
-          <a:fillRef idx="0">
+          <a:fillRef idx="3">
             <a:schemeClr val="accent1"/>
           </a:fillRef>
-          <a:effectRef idx="1">
+          <a:effectRef idx="2">
             <a:schemeClr val="accent1"/>
           </a:effectRef>
           <a:fontRef idx="minor">
-            <a:schemeClr val="tx1"/>
+            <a:schemeClr val="lt1"/>
           </a:fontRef>
         </p:style>
-      </p:cxnSp>
-      <p:cxnSp>
-        <p:nvCxnSpPr>
-          <p:cNvPr id="56" name="Connector 55"/>
-          <p:cNvCxnSpPr/>
-          <p:nvPr/>
-        </p:nvCxnSpPr>
-        <p:spPr>
-          <a:xfrm>
-            <a:off x="3352800" y="3767328"/>
-            <a:ext cx="0" cy="329184"/>
-          </a:xfrm>
-          <a:prstGeom prst="line">
-            <a:avLst/>
-          </a:prstGeom>
-          <a:ln w="12700">
-            <a:solidFill>
-              <a:srgbClr val="33C9C9"/>
-            </a:solidFill>
-            <a:prstDash val="dash"/>
-            <a:headEnd type="triangle" w="med" len="med"/>
-            <a:tailEnd type="triangle" w="med" len="med"/>
-          </a:ln>
-          <a:effectLst/>
-        </p:spPr>
-        <p:style>
-          <a:lnRef idx="2">
-            <a:schemeClr val="accent1"/>
-          </a:lnRef>
-          <a:fillRef idx="0">
-            <a:schemeClr val="accent1"/>
-          </a:fillRef>
-          <a:effectRef idx="1">
-            <a:schemeClr val="accent1"/>
-          </a:effectRef>
-          <a:fontRef idx="minor">
-            <a:schemeClr val="tx1"/>
-          </a:fontRef>
-        </p:style>
-      </p:cxnSp>
-      <p:cxnSp>
-        <p:nvCxnSpPr>
-          <p:cNvPr id="57" name="Connector 56"/>
-          <p:cNvCxnSpPr/>
-          <p:nvPr/>
-        </p:nvCxnSpPr>
-        <p:spPr>
-          <a:xfrm flipV="1">
-            <a:off x="4478528" y="2377440"/>
-            <a:ext cx="0" cy="329184"/>
-          </a:xfrm>
-          <a:prstGeom prst="line">
-            <a:avLst/>
-          </a:prstGeom>
-          <a:ln w="12700">
-            <a:solidFill>
-              <a:srgbClr val="FFB020"/>
-            </a:solidFill>
-            <a:prstDash val="dash"/>
-            <a:headEnd type="triangle" w="med" len="med"/>
-            <a:tailEnd type="triangle" w="med" len="med"/>
-          </a:ln>
-          <a:effectLst/>
-        </p:spPr>
-        <p:style>
-          <a:lnRef idx="2">
-            <a:schemeClr val="accent1"/>
-          </a:lnRef>
-          <a:fillRef idx="0">
-            <a:schemeClr val="accent1"/>
-          </a:fillRef>
-          <a:effectRef idx="1">
-            <a:schemeClr val="accent1"/>
-          </a:effectRef>
-          <a:fontRef idx="minor">
-            <a:schemeClr val="tx1"/>
-          </a:fontRef>
-        </p:style>
-      </p:cxnSp>
-      <p:cxnSp>
-        <p:nvCxnSpPr>
-          <p:cNvPr id="58" name="Connector 57"/>
-          <p:cNvCxnSpPr/>
-          <p:nvPr/>
-        </p:nvCxnSpPr>
-        <p:spPr>
-          <a:xfrm>
-            <a:off x="4478528" y="3767328"/>
-            <a:ext cx="0" cy="329184"/>
-          </a:xfrm>
-          <a:prstGeom prst="line">
-            <a:avLst/>
-          </a:prstGeom>
-          <a:ln w="12700">
-            <a:solidFill>
-              <a:srgbClr val="33C9C9"/>
-            </a:solidFill>
-            <a:prstDash val="dash"/>
-            <a:headEnd type="triangle" w="med" len="med"/>
-            <a:tailEnd type="triangle" w="med" len="med"/>
-          </a:ln>
-          <a:effectLst/>
-        </p:spPr>
-        <p:style>
-          <a:lnRef idx="2">
-            <a:schemeClr val="accent1"/>
-          </a:lnRef>
-          <a:fillRef idx="0">
-            <a:schemeClr val="accent1"/>
-          </a:fillRef>
-          <a:effectRef idx="1">
-            <a:schemeClr val="accent1"/>
-          </a:effectRef>
-          <a:fontRef idx="minor">
-            <a:schemeClr val="tx1"/>
-          </a:fontRef>
-        </p:style>
-      </p:cxnSp>
-      <p:cxnSp>
-        <p:nvCxnSpPr>
-          <p:cNvPr id="59" name="Connector 58"/>
-          <p:cNvCxnSpPr/>
-          <p:nvPr/>
-        </p:nvCxnSpPr>
-        <p:spPr>
-          <a:xfrm flipV="1">
-            <a:off x="5604256" y="2377440"/>
-            <a:ext cx="0" cy="329184"/>
-          </a:xfrm>
-          <a:prstGeom prst="line">
-            <a:avLst/>
-          </a:prstGeom>
-          <a:ln w="12700">
-            <a:solidFill>
-              <a:srgbClr val="FFB020"/>
-            </a:solidFill>
-            <a:prstDash val="dash"/>
-            <a:headEnd type="triangle" w="med" len="med"/>
-            <a:tailEnd type="triangle" w="med" len="med"/>
-          </a:ln>
-          <a:effectLst/>
-        </p:spPr>
-        <p:style>
-          <a:lnRef idx="2">
-            <a:schemeClr val="accent1"/>
-          </a:lnRef>
-          <a:fillRef idx="0">
-            <a:schemeClr val="accent1"/>
-          </a:fillRef>
-          <a:effectRef idx="1">
-            <a:schemeClr val="accent1"/>
-          </a:effectRef>
-          <a:fontRef idx="minor">
-            <a:schemeClr val="tx1"/>
-          </a:fontRef>
-        </p:style>
-      </p:cxnSp>
-      <p:cxnSp>
-        <p:nvCxnSpPr>
-          <p:cNvPr id="60" name="Connector 59"/>
-          <p:cNvCxnSpPr/>
-          <p:nvPr/>
-        </p:nvCxnSpPr>
-        <p:spPr>
-          <a:xfrm>
-            <a:off x="5604256" y="3767328"/>
-            <a:ext cx="0" cy="329184"/>
-          </a:xfrm>
-          <a:prstGeom prst="line">
-            <a:avLst/>
-          </a:prstGeom>
-          <a:ln w="12700">
-            <a:solidFill>
-              <a:srgbClr val="33C9C9"/>
-            </a:solidFill>
-            <a:prstDash val="dash"/>
-            <a:headEnd type="triangle" w="med" len="med"/>
-            <a:tailEnd type="triangle" w="med" len="med"/>
-          </a:ln>
-          <a:effectLst/>
-        </p:spPr>
-        <p:style>
-          <a:lnRef idx="2">
-            <a:schemeClr val="accent1"/>
-          </a:lnRef>
-          <a:fillRef idx="0">
-            <a:schemeClr val="accent1"/>
-          </a:fillRef>
-          <a:effectRef idx="1">
-            <a:schemeClr val="accent1"/>
-          </a:effectRef>
-          <a:fontRef idx="minor">
-            <a:schemeClr val="tx1"/>
-          </a:fontRef>
-        </p:style>
-      </p:cxnSp>
-      <p:cxnSp>
-        <p:nvCxnSpPr>
-          <p:cNvPr id="61" name="Connector 60"/>
-          <p:cNvCxnSpPr/>
-          <p:nvPr/>
-        </p:nvCxnSpPr>
-        <p:spPr>
-          <a:xfrm flipV="1">
-            <a:off x="6729984" y="2377440"/>
-            <a:ext cx="0" cy="329184"/>
-          </a:xfrm>
-          <a:prstGeom prst="line">
-            <a:avLst/>
-          </a:prstGeom>
-          <a:ln w="12700">
-            <a:solidFill>
-              <a:srgbClr val="FFB020"/>
-            </a:solidFill>
-            <a:prstDash val="dash"/>
-            <a:headEnd type="triangle" w="med" len="med"/>
-            <a:tailEnd type="triangle" w="med" len="med"/>
-          </a:ln>
-          <a:effectLst/>
-        </p:spPr>
-        <p:style>
-          <a:lnRef idx="2">
-            <a:schemeClr val="accent1"/>
-          </a:lnRef>
-          <a:fillRef idx="0">
-            <a:schemeClr val="accent1"/>
-          </a:fillRef>
-          <a:effectRef idx="1">
-            <a:schemeClr val="accent1"/>
-          </a:effectRef>
-          <a:fontRef idx="minor">
-            <a:schemeClr val="tx1"/>
-          </a:fontRef>
-        </p:style>
-      </p:cxnSp>
-      <p:cxnSp>
-        <p:nvCxnSpPr>
-          <p:cNvPr id="62" name="Connector 61"/>
-          <p:cNvCxnSpPr/>
-          <p:nvPr/>
-        </p:nvCxnSpPr>
-        <p:spPr>
-          <a:xfrm>
-            <a:off x="6729984" y="3767328"/>
-            <a:ext cx="0" cy="329184"/>
-          </a:xfrm>
-          <a:prstGeom prst="line">
-            <a:avLst/>
-          </a:prstGeom>
-          <a:ln w="12700">
-            <a:solidFill>
-              <a:srgbClr val="33C9C9"/>
-            </a:solidFill>
-            <a:prstDash val="dash"/>
-            <a:headEnd type="triangle" w="med" len="med"/>
-            <a:tailEnd type="triangle" w="med" len="med"/>
-          </a:ln>
-          <a:effectLst/>
-        </p:spPr>
-        <p:style>
-          <a:lnRef idx="2">
-            <a:schemeClr val="accent1"/>
-          </a:lnRef>
-          <a:fillRef idx="0">
-            <a:schemeClr val="accent1"/>
-          </a:fillRef>
-          <a:effectRef idx="1">
-            <a:schemeClr val="accent1"/>
-          </a:effectRef>
-          <a:fontRef idx="minor">
-            <a:schemeClr val="tx1"/>
-          </a:fontRef>
-        </p:style>
-      </p:cxnSp>
-      <p:cxnSp>
-        <p:nvCxnSpPr>
-          <p:cNvPr id="63" name="Connector 62"/>
-          <p:cNvCxnSpPr/>
-          <p:nvPr/>
-        </p:nvCxnSpPr>
-        <p:spPr>
-          <a:xfrm flipV="1">
-            <a:off x="7855711" y="2377440"/>
-            <a:ext cx="0" cy="329184"/>
-          </a:xfrm>
-          <a:prstGeom prst="line">
-            <a:avLst/>
-          </a:prstGeom>
-          <a:ln w="12700">
-            <a:solidFill>
-              <a:srgbClr val="FFB020"/>
-            </a:solidFill>
-            <a:prstDash val="dash"/>
-            <a:headEnd type="triangle" w="med" len="med"/>
-            <a:tailEnd type="triangle" w="med" len="med"/>
-          </a:ln>
-          <a:effectLst/>
-        </p:spPr>
-        <p:style>
-          <a:lnRef idx="2">
-            <a:schemeClr val="accent1"/>
-          </a:lnRef>
-          <a:fillRef idx="0">
-            <a:schemeClr val="accent1"/>
-          </a:fillRef>
-          <a:effectRef idx="1">
-            <a:schemeClr val="accent1"/>
-          </a:effectRef>
-          <a:fontRef idx="minor">
-            <a:schemeClr val="tx1"/>
-          </a:fontRef>
-        </p:style>
-      </p:cxnSp>
-      <p:cxnSp>
-        <p:nvCxnSpPr>
-          <p:cNvPr id="64" name="Connector 63"/>
-          <p:cNvCxnSpPr/>
-          <p:nvPr/>
-        </p:nvCxnSpPr>
-        <p:spPr>
-          <a:xfrm>
-            <a:off x="7855711" y="3767328"/>
-            <a:ext cx="0" cy="329184"/>
-          </a:xfrm>
-          <a:prstGeom prst="line">
-            <a:avLst/>
-          </a:prstGeom>
-          <a:ln w="12700">
-            <a:solidFill>
-              <a:srgbClr val="33C9C9"/>
-            </a:solidFill>
-            <a:prstDash val="dash"/>
-            <a:headEnd type="triangle" w="med" len="med"/>
-            <a:tailEnd type="triangle" w="med" len="med"/>
-          </a:ln>
-          <a:effectLst/>
-        </p:spPr>
-        <p:style>
-          <a:lnRef idx="2">
-            <a:schemeClr val="accent1"/>
-          </a:lnRef>
-          <a:fillRef idx="0">
-            <a:schemeClr val="accent1"/>
-          </a:fillRef>
-          <a:effectRef idx="1">
-            <a:schemeClr val="accent1"/>
-          </a:effectRef>
-          <a:fontRef idx="minor">
-            <a:schemeClr val="tx1"/>
-          </a:fontRef>
-        </p:style>
-      </p:cxnSp>
-      <p:cxnSp>
-        <p:nvCxnSpPr>
-          <p:cNvPr id="65" name="Connector 64"/>
-          <p:cNvCxnSpPr/>
-          <p:nvPr/>
-        </p:nvCxnSpPr>
-        <p:spPr>
-          <a:xfrm flipV="1">
-            <a:off x="8981439" y="2377440"/>
-            <a:ext cx="0" cy="329184"/>
-          </a:xfrm>
-          <a:prstGeom prst="line">
-            <a:avLst/>
-          </a:prstGeom>
-          <a:ln w="12700">
-            <a:solidFill>
-              <a:srgbClr val="FFB020"/>
-            </a:solidFill>
-            <a:prstDash val="dash"/>
-            <a:headEnd type="triangle" w="med" len="med"/>
-            <a:tailEnd type="triangle" w="med" len="med"/>
-          </a:ln>
-          <a:effectLst/>
-        </p:spPr>
-        <p:style>
-          <a:lnRef idx="2">
-            <a:schemeClr val="accent1"/>
-          </a:lnRef>
-          <a:fillRef idx="0">
-            <a:schemeClr val="accent1"/>
-          </a:fillRef>
-          <a:effectRef idx="1">
-            <a:schemeClr val="accent1"/>
-          </a:effectRef>
-          <a:fontRef idx="minor">
-            <a:schemeClr val="tx1"/>
-          </a:fontRef>
-        </p:style>
-      </p:cxnSp>
+        <p:txBody>
+          <a:bodyPr rtlCol="0" anchor="ctr" wrap="square"/>
+          <a:lstStyle/>
+          <a:p>
+            <a:pPr algn="ctr"/>
+          </a:p>
+        </p:txBody>
+      </p:sp>
       <p:cxnSp>
         <p:nvCxnSpPr>
           <p:cNvPr id="66" name="Connector 65"/>
@@ -7011,18 +7240,17 @@
         </p:nvCxnSpPr>
         <p:spPr>
           <a:xfrm>
-            <a:off x="8981439" y="3767328"/>
-            <a:ext cx="0" cy="329184"/>
+            <a:off x="3352800" y="3529583"/>
+            <a:ext cx="0" cy="384049"/>
           </a:xfrm>
           <a:prstGeom prst="line">
             <a:avLst/>
           </a:prstGeom>
-          <a:ln w="12700">
+          <a:ln w="11430">
             <a:solidFill>
               <a:srgbClr val="33C9C9"/>
             </a:solidFill>
-            <a:prstDash val="dash"/>
-            <a:headEnd type="triangle" w="med" len="med"/>
+            <a:prstDash val="sysDot"/>
             <a:tailEnd type="triangle" w="med" len="med"/>
           </a:ln>
           <a:effectLst/>
@@ -7049,19 +7277,18 @@
           <p:nvPr/>
         </p:nvCxnSpPr>
         <p:spPr>
-          <a:xfrm flipV="1">
-            <a:off x="10107167" y="2377440"/>
-            <a:ext cx="0" cy="329184"/>
+          <a:xfrm>
+            <a:off x="4478528" y="3529583"/>
+            <a:ext cx="0" cy="384049"/>
           </a:xfrm>
           <a:prstGeom prst="line">
             <a:avLst/>
           </a:prstGeom>
-          <a:ln w="12700">
+          <a:ln w="11430">
             <a:solidFill>
-              <a:srgbClr val="FFB020"/>
+              <a:srgbClr val="33C9C9"/>
             </a:solidFill>
-            <a:prstDash val="dash"/>
-            <a:headEnd type="triangle" w="med" len="med"/>
+            <a:prstDash val="sysDot"/>
             <a:tailEnd type="triangle" w="med" len="med"/>
           </a:ln>
           <a:effectLst/>
@@ -7089,18 +7316,17 @@
         </p:nvCxnSpPr>
         <p:spPr>
           <a:xfrm>
-            <a:off x="10107167" y="3767328"/>
-            <a:ext cx="0" cy="329184"/>
+            <a:off x="5604256" y="3529583"/>
+            <a:ext cx="0" cy="384049"/>
           </a:xfrm>
           <a:prstGeom prst="line">
             <a:avLst/>
           </a:prstGeom>
-          <a:ln w="12700">
+          <a:ln w="11430">
             <a:solidFill>
               <a:srgbClr val="33C9C9"/>
             </a:solidFill>
-            <a:prstDash val="dash"/>
-            <a:headEnd type="triangle" w="med" len="med"/>
+            <a:prstDash val="sysDot"/>
             <a:tailEnd type="triangle" w="med" len="med"/>
           </a:ln>
           <a:effectLst/>
@@ -7127,19 +7353,18 @@
           <p:nvPr/>
         </p:nvCxnSpPr>
         <p:spPr>
-          <a:xfrm flipV="1">
-            <a:off x="11232895" y="2377440"/>
-            <a:ext cx="0" cy="329184"/>
+          <a:xfrm>
+            <a:off x="6729984" y="3529583"/>
+            <a:ext cx="0" cy="384049"/>
           </a:xfrm>
           <a:prstGeom prst="line">
             <a:avLst/>
           </a:prstGeom>
-          <a:ln w="12700">
+          <a:ln w="11430">
             <a:solidFill>
-              <a:srgbClr val="FFB020"/>
+              <a:srgbClr val="33C9C9"/>
             </a:solidFill>
-            <a:prstDash val="dash"/>
-            <a:headEnd type="triangle" w="med" len="med"/>
+            <a:prstDash val="sysDot"/>
             <a:tailEnd type="triangle" w="med" len="med"/>
           </a:ln>
           <a:effectLst/>
@@ -7167,18 +7392,17 @@
         </p:nvCxnSpPr>
         <p:spPr>
           <a:xfrm>
-            <a:off x="11232895" y="3767328"/>
-            <a:ext cx="0" cy="329184"/>
+            <a:off x="7855711" y="3529583"/>
+            <a:ext cx="0" cy="384049"/>
           </a:xfrm>
           <a:prstGeom prst="line">
             <a:avLst/>
           </a:prstGeom>
-          <a:ln w="12700">
+          <a:ln w="11430">
             <a:solidFill>
               <a:srgbClr val="33C9C9"/>
             </a:solidFill>
-            <a:prstDash val="dash"/>
-            <a:headEnd type="triangle" w="med" len="med"/>
+            <a:prstDash val="sysDot"/>
             <a:tailEnd type="triangle" w="med" len="med"/>
           </a:ln>
           <a:effectLst/>
@@ -7198,9 +7422,123 @@
           </a:fontRef>
         </p:style>
       </p:cxnSp>
-      <p:sp>
-        <p:nvSpPr>
-          <p:cNvPr id="71" name="TextBox 70"/>
+      <p:cxnSp>
+        <p:nvCxnSpPr>
+          <p:cNvPr id="71" name="Connector 70"/>
+          <p:cNvCxnSpPr/>
+          <p:nvPr/>
+        </p:nvCxnSpPr>
+        <p:spPr>
+          <a:xfrm>
+            <a:off x="8981439" y="3529583"/>
+            <a:ext cx="0" cy="384049"/>
+          </a:xfrm>
+          <a:prstGeom prst="line">
+            <a:avLst/>
+          </a:prstGeom>
+          <a:ln w="11430">
+            <a:solidFill>
+              <a:srgbClr val="33C9C9"/>
+            </a:solidFill>
+            <a:prstDash val="sysDot"/>
+            <a:tailEnd type="triangle" w="med" len="med"/>
+          </a:ln>
+          <a:effectLst/>
+        </p:spPr>
+        <p:style>
+          <a:lnRef idx="2">
+            <a:schemeClr val="accent1"/>
+          </a:lnRef>
+          <a:fillRef idx="0">
+            <a:schemeClr val="accent1"/>
+          </a:fillRef>
+          <a:effectRef idx="1">
+            <a:schemeClr val="accent1"/>
+          </a:effectRef>
+          <a:fontRef idx="minor">
+            <a:schemeClr val="tx1"/>
+          </a:fontRef>
+        </p:style>
+      </p:cxnSp>
+      <p:cxnSp>
+        <p:nvCxnSpPr>
+          <p:cNvPr id="72" name="Connector 71"/>
+          <p:cNvCxnSpPr/>
+          <p:nvPr/>
+        </p:nvCxnSpPr>
+        <p:spPr>
+          <a:xfrm>
+            <a:off x="10107167" y="3529583"/>
+            <a:ext cx="0" cy="384049"/>
+          </a:xfrm>
+          <a:prstGeom prst="line">
+            <a:avLst/>
+          </a:prstGeom>
+          <a:ln w="11430">
+            <a:solidFill>
+              <a:srgbClr val="33C9C9"/>
+            </a:solidFill>
+            <a:prstDash val="sysDot"/>
+            <a:tailEnd type="triangle" w="med" len="med"/>
+          </a:ln>
+          <a:effectLst/>
+        </p:spPr>
+        <p:style>
+          <a:lnRef idx="2">
+            <a:schemeClr val="accent1"/>
+          </a:lnRef>
+          <a:fillRef idx="0">
+            <a:schemeClr val="accent1"/>
+          </a:fillRef>
+          <a:effectRef idx="1">
+            <a:schemeClr val="accent1"/>
+          </a:effectRef>
+          <a:fontRef idx="minor">
+            <a:schemeClr val="tx1"/>
+          </a:fontRef>
+        </p:style>
+      </p:cxnSp>
+      <p:cxnSp>
+        <p:nvCxnSpPr>
+          <p:cNvPr id="73" name="Connector 72"/>
+          <p:cNvCxnSpPr/>
+          <p:nvPr/>
+        </p:nvCxnSpPr>
+        <p:spPr>
+          <a:xfrm>
+            <a:off x="11232895" y="3529583"/>
+            <a:ext cx="0" cy="384049"/>
+          </a:xfrm>
+          <a:prstGeom prst="line">
+            <a:avLst/>
+          </a:prstGeom>
+          <a:ln w="11430">
+            <a:solidFill>
+              <a:srgbClr val="33C9C9"/>
+            </a:solidFill>
+            <a:prstDash val="sysDot"/>
+            <a:tailEnd type="triangle" w="med" len="med"/>
+          </a:ln>
+          <a:effectLst/>
+        </p:spPr>
+        <p:style>
+          <a:lnRef idx="2">
+            <a:schemeClr val="accent1"/>
+          </a:lnRef>
+          <a:fillRef idx="0">
+            <a:schemeClr val="accent1"/>
+          </a:fillRef>
+          <a:effectRef idx="1">
+            <a:schemeClr val="accent1"/>
+          </a:effectRef>
+          <a:fontRef idx="minor">
+            <a:schemeClr val="tx1"/>
+          </a:fontRef>
+        </p:style>
+      </p:cxnSp>
+      <p:sp>
+        <p:nvSpPr>
+          <p:cNvPr id="74" name="TextBox 73"/>
           <p:cNvSpPr txBox="1"/>
           <p:nvPr/>
         </p:nvSpPr>
@@ -7215,7 +7553,7 @@
           <a:noFill/>
         </p:spPr>
         <p:txBody>
-          <a:bodyPr wrap="square" lIns="0" tIns="0" rIns="0" bIns="0" anchor="t">
+          <a:bodyPr wrap="square" anchor="t" lIns="0" rIns="0" tIns="0" bIns="0">
             <a:spAutoFit/>
           </a:bodyPr>
           <a:lstStyle/>
@@ -7245,7 +7583,7 @@
       </p:sp>
       <p:sp>
         <p:nvSpPr>
-          <p:cNvPr id="72" name="Rounded Rectangle 71"/>
+          <p:cNvPr id="75" name="Rounded Rectangle 74"/>
           <p:cNvSpPr/>
           <p:nvPr/>
         </p:nvSpPr>
@@ -7284,7 +7622,7 @@
           </a:fontRef>
         </p:style>
         <p:txBody>
-          <a:bodyPr wrap="square" lIns="27432" tIns="9144" rIns="27432" bIns="9144" rtlCol="0" anchor="ctr"/>
+          <a:bodyPr rtlCol="0" anchor="ctr" wrap="square" lIns="27432" rIns="27432" tIns="9144" bIns="9144"/>
           <a:lstStyle/>
           <a:p>
             <a:pPr algn="ctr">
@@ -7334,7 +7672,7 @@
       </p:sp>
       <p:sp>
         <p:nvSpPr>
-          <p:cNvPr id="73" name="Chevron 72"/>
+          <p:cNvPr id="76" name="Chevron 75"/>
           <p:cNvSpPr/>
           <p:nvPr/>
         </p:nvSpPr>
@@ -7373,13 +7711,12 @@
           <a:lstStyle/>
           <a:p>
             <a:pPr algn="ctr"/>
-            <a:endParaRPr/>
-          </a:p>
-        </p:txBody>
-      </p:sp>
-      <p:sp>
-        <p:nvSpPr>
-          <p:cNvPr id="74" name="Rounded Rectangle 73"/>
+          </a:p>
+        </p:txBody>
+      </p:sp>
+      <p:sp>
+        <p:nvSpPr>
+          <p:cNvPr id="77" name="Rounded Rectangle 76"/>
           <p:cNvSpPr/>
           <p:nvPr/>
         </p:nvSpPr>
@@ -7418,7 +7755,7 @@
           </a:fontRef>
         </p:style>
         <p:txBody>
-          <a:bodyPr wrap="square" lIns="27432" tIns="9144" rIns="27432" bIns="9144" rtlCol="0" anchor="ctr"/>
+          <a:bodyPr rtlCol="0" anchor="ctr" wrap="square" lIns="27432" rIns="27432" tIns="9144" bIns="9144"/>
           <a:lstStyle/>
           <a:p>
             <a:pPr algn="ctr">
@@ -7468,7 +7805,7 @@
       </p:sp>
       <p:sp>
         <p:nvSpPr>
-          <p:cNvPr id="75" name="Rounded Rectangle 74"/>
+          <p:cNvPr id="78" name="Rounded Rectangle 77"/>
           <p:cNvSpPr/>
           <p:nvPr/>
         </p:nvSpPr>
@@ -7507,7 +7844,7 @@
           </a:fontRef>
         </p:style>
         <p:txBody>
-          <a:bodyPr wrap="square" lIns="27432" tIns="9144" rIns="27432" bIns="9144" rtlCol="0" anchor="ctr"/>
+          <a:bodyPr rtlCol="0" anchor="ctr" wrap="square" lIns="27432" rIns="27432" tIns="9144" bIns="9144"/>
           <a:lstStyle/>
           <a:p>
             <a:pPr algn="ctr">
@@ -7557,7 +7894,7 @@
       </p:sp>
       <p:sp>
         <p:nvSpPr>
-          <p:cNvPr id="76" name="Rounded Rectangle 75"/>
+          <p:cNvPr id="79" name="Rounded Rectangle 78"/>
           <p:cNvSpPr/>
           <p:nvPr/>
         </p:nvSpPr>
@@ -7596,7 +7933,7 @@
           </a:fontRef>
         </p:style>
         <p:txBody>
-          <a:bodyPr wrap="square" lIns="27432" tIns="9144" rIns="27432" bIns="9144" rtlCol="0" anchor="ctr"/>
+          <a:bodyPr rtlCol="0" anchor="ctr" wrap="square" lIns="27432" rIns="27432" tIns="9144" bIns="9144"/>
           <a:lstStyle/>
           <a:p>
             <a:pPr algn="ctr">
@@ -7646,7 +7983,7 @@
       </p:sp>
       <p:sp>
         <p:nvSpPr>
-          <p:cNvPr id="77" name="Rounded Rectangle 76"/>
+          <p:cNvPr id="80" name="Rounded Rectangle 79"/>
           <p:cNvSpPr/>
           <p:nvPr/>
         </p:nvSpPr>
@@ -7685,7 +8022,7 @@
           </a:fontRef>
         </p:style>
         <p:txBody>
-          <a:bodyPr wrap="square" lIns="27432" tIns="9144" rIns="27432" bIns="9144" rtlCol="0" anchor="ctr"/>
+          <a:bodyPr rtlCol="0" anchor="ctr" wrap="square" lIns="27432" rIns="27432" tIns="9144" bIns="9144"/>
           <a:lstStyle/>
           <a:p>
             <a:pPr algn="ctr">
@@ -7735,7 +8072,7 @@
       </p:sp>
       <p:sp>
         <p:nvSpPr>
-          <p:cNvPr id="78" name="Rounded Rectangle 77"/>
+          <p:cNvPr id="81" name="Rounded Rectangle 80"/>
           <p:cNvSpPr/>
           <p:nvPr/>
         </p:nvSpPr>
@@ -7774,7 +8111,7 @@
           </a:fontRef>
         </p:style>
         <p:txBody>
-          <a:bodyPr wrap="square" lIns="27432" tIns="9144" rIns="27432" bIns="9144" rtlCol="0" anchor="ctr"/>
+          <a:bodyPr rtlCol="0" anchor="ctr" wrap="square" lIns="27432" rIns="27432" tIns="9144" bIns="9144"/>
           <a:lstStyle/>
           <a:p>
             <a:pPr algn="ctr">
@@ -7824,7 +8161,7 @@
       </p:sp>
       <p:sp>
         <p:nvSpPr>
-          <p:cNvPr id="79" name="Down Arrow 78"/>
+          <p:cNvPr id="82" name="Down Arrow 81"/>
           <p:cNvSpPr/>
           <p:nvPr/>
         </p:nvSpPr>
@@ -7863,13 +8200,12 @@
           <a:lstStyle/>
           <a:p>
             <a:pPr algn="ctr"/>
-            <a:endParaRPr/>
-          </a:p>
-        </p:txBody>
-      </p:sp>
-      <p:sp>
-        <p:nvSpPr>
-          <p:cNvPr id="80" name="Down Arrow 79"/>
+          </a:p>
+        </p:txBody>
+      </p:sp>
+      <p:sp>
+        <p:nvSpPr>
+          <p:cNvPr id="83" name="Down Arrow 82"/>
           <p:cNvSpPr/>
           <p:nvPr/>
         </p:nvSpPr>
@@ -7908,7 +8244,6 @@
           <a:lstStyle/>
           <a:p>
             <a:pPr algn="ctr"/>
-            <a:endParaRPr/>
           </a:p>
         </p:txBody>
       </p:sp>

</xml_diff>